<commit_message>
docs: keep the DDR-swap slides to lengths that actually spill
Pages 7 and 8 now list only inputs whose decode KV enters the pool.
The zero-swap rows stay on the length sweep, and later decks keep this filter.

Co-authored-by: 69515164-rgb <69515164-rgb@users.noreply.github.com>
</commit_message>
<xml_diff>
--- a/docs/deepseek-96g-slo.pptx
+++ b/docs/deepseek-96g-slo.pptx
@@ -929,7 +929,7 @@
           <a:lstStyle/>
           <a:p>
             <a:r>
-              <a:t>4K，BS=231：权重 29.485 GB，allreduce 22.96 MB，EP 6.20 MB，HBM KV 44.63 MB，池 0。t=9.984 ms。BS=6583：权重 42.894 GB，allreduce 630.51 MB，EP 269.85 MB，HBM KV 1271.84 MB，池 0。t=29.167 ms。BS=6584：ue=0.500，cm=17.060 ms，t=32.823 ms。</a:t>
+              <a:t>第 7、8 页只统计 decode KV 溢出到 DDR 池的输入长度。全在 HBM 的长度留在第 6 页，不在这里记 0。256K BS=6583 pool=3145.0 MB t=9.828 ms ar=15.763 ca=14.768 step=29.167。512K BS=4163 pool=5308.1 MB t=16.588 ms step=29.992。10 毫秒曲线在本档没有溢出长度。</a:t>
             </a:r>
           </a:p>
         </p:txBody>
@@ -999,7 +999,7 @@
           <a:lstStyle/>
           <a:p>
             <a:r>
-              <a:t>池上字节 = spill × 每卡稀疏读。稀疏读 = bs × n_csa_read(S) / 128。n_csa_read = 30×(S/4)×64 + 31×(S/128)×576 + 30×min(1024,S/4)×576 + 61×128×576。带宽 320 GB/s。256K 每卡 3145.0 MB，合计 402.56 GB，时间 9.828 ms。512K 每卡 5308.1 MB，1M 每卡 5309.2 MB。10 毫秒在 256K、512K、1M 的 spill 都是 0。</a:t>
+              <a:t>池上字节 = spill × bs × n_csa_read(S) / 128。带宽 320 GB/s。n_csa_read = 30×(S/4)×64 + 31×(S/128)×576 + 30×min(1024,S/4)×576 + 61×128×576。256K bs=6583 spill=33.13% pool=3145.0MB t=9.828ms step=29.167ms 512K bs=4163 spill=47.04% pool=5308.1MB t=16.588ms step=29.992ms 1M bs=2115 spill=47.83% pool=5309.2MB t=16.591ms step=29.996ms 1.67×10^6 bs=1333 spill=48.12% pool=5307.5MB t=16.586ms step=29.990ms 口径已固化：第 7、8 页不收录换入为 0 的输入长度。</a:t>
             </a:r>
           </a:p>
         </p:txBody>
@@ -26257,7 +26257,7 @@
                 <a:ea typeface="Microsoft YaHei"/>
                 <a:cs typeface="Microsoft YaHei"/>
               </a:rPr>
-              <a:t>Decode    ·    短输入一步里的每一笔</a:t>
+              <a:t>Decode    ·    只统计进了 DDR 池的长度</a:t>
             </a:r>
           </a:p>
         </p:txBody>
@@ -26299,7 +26299,7 @@
                 <a:ea typeface="Microsoft YaHei"/>
                 <a:cs typeface="Microsoft YaHei"/>
               </a:rPr>
-              <a:t>4K 上，10 毫秒读到 9.98 毫秒，30 毫秒读到 29.17 毫秒</a:t>
+              <a:t>256K 每卡换入 3.15 GB，512K 换入成为最长的一笔</a:t>
             </a:r>
           </a:p>
         </p:txBody>
@@ -26511,7 +26511,7 @@
                 <a:ea typeface="Microsoft YaHei"/>
                 <a:cs typeface="Microsoft YaHei"/>
               </a:rPr>
-              <a:t>一步先取注意力侧最长的一笔，再加专家侧最长的一笔。4K 的这两档换入都是 0，存量全在 HBM。</a:t>
+              <a:t>这两页只列 KV 换进 DDR 池的输入。一步仍是注意力侧最长的一笔，加上专家侧最长的一笔。</a:t>
             </a:r>
           </a:p>
         </p:txBody>
@@ -26526,18 +26526,18 @@
         </p:nvGraphicFramePr>
         <p:xfrm>
           <a:off x="384048" y="1353312"/>
-          <a:ext cx="11430000" cy="3236976"/>
+          <a:ext cx="11430000" cy="3200400"/>
         </p:xfrm>
         <a:graphic>
           <a:graphicData uri="http://schemas.openxmlformats.org/drawingml/2006/table">
             <a:tbl>
               <a:tblPr firstRow="1"/>
               <a:tblGrid>
-                <a:gridCol w="2103120"/>
-                <a:gridCol w="4572000"/>
-                <a:gridCol w="4754880"/>
+                <a:gridCol w="2011680"/>
+                <a:gridCol w="4617720"/>
+                <a:gridCol w="4800600"/>
               </a:tblGrid>
-              <a:tr h="274320">
+              <a:tr h="329184">
                 <a:tc>
                   <a:txBody>
                     <a:bodyPr wrap="square"/>
@@ -26618,7 +26618,7 @@
                           <a:ea typeface="Microsoft YaHei"/>
                           <a:cs typeface="Microsoft YaHei"/>
                         </a:rPr>
-                        <a:t>10 毫秒 · 全局批 231</a:t>
+                        <a:t>256K · 批 6583 · 溢出 33.1%</a:t>
                       </a:r>
                     </a:p>
                   </a:txBody>
@@ -26673,7 +26673,7 @@
                           <a:ea typeface="Microsoft YaHei"/>
                           <a:cs typeface="Microsoft YaHei"/>
                         </a:rPr>
-                        <a:t>30 毫秒 · 全局批 6583</a:t>
+                        <a:t>512K · 批 4163 · 溢出 47.0%</a:t>
                       </a:r>
                     </a:p>
                   </a:txBody>
@@ -26704,7 +26704,7 @@
                   </a:tcPr>
                 </a:tc>
               </a:tr>
-              <a:tr h="329184">
+              <a:tr h="310896">
                 <a:tc>
                   <a:txBody>
                     <a:bodyPr wrap="square"/>
@@ -26724,7 +26724,7 @@
                       <a:r>
                         <a:rPr sz="1300" b="1">
                           <a:solidFill>
-                            <a:srgbClr val="0E7A76"/>
+                            <a:srgbClr val="0E2A47"/>
                           </a:solidFill>
                           <a:latin typeface="Microsoft YaHei"/>
                           <a:ea typeface="Microsoft YaHei"/>
@@ -26777,44 +26777,268 @@
                         </a:lnSpc>
                       </a:pPr>
                       <a:r>
+                        <a:rPr sz="1300" b="0">
+                          <a:solidFill>
+                            <a:srgbClr val="1C242E"/>
+                          </a:solidFill>
+                          <a:latin typeface="Microsoft YaHei"/>
+                          <a:ea typeface="Microsoft YaHei"/>
+                          <a:cs typeface="Microsoft YaHei"/>
+                        </a:rPr>
+                        <a:t>42.89 GB · 13.40 毫秒</a:t>
+                      </a:r>
+                    </a:p>
+                  </a:txBody>
+                  <a:tcPr marL="54864" marR="54864" marT="27432" marB="18288" anchor="ctr">
+                    <a:solidFill>
+                      <a:srgbClr val="FFFFFF"/>
+                    </a:solidFill>
+                    <a:lnL w="6350">
+                      <a:solidFill>
+                        <a:srgbClr val="D6DCE2"/>
+                      </a:solidFill>
+                    </a:lnL>
+                    <a:lnR w="6350">
+                      <a:solidFill>
+                        <a:srgbClr val="D6DCE2"/>
+                      </a:solidFill>
+                    </a:lnR>
+                    <a:lnT w="6350">
+                      <a:solidFill>
+                        <a:srgbClr val="D6DCE2"/>
+                      </a:solidFill>
+                    </a:lnT>
+                    <a:lnB w="6350">
+                      <a:solidFill>
+                        <a:srgbClr val="D6DCE2"/>
+                      </a:solidFill>
+                    </a:lnB>
+                  </a:tcPr>
+                </a:tc>
+                <a:tc>
+                  <a:txBody>
+                    <a:bodyPr wrap="square"/>
+                    <a:lstStyle/>
+                    <a:p>
+                      <a:pPr algn="l">
+                        <a:spcBef>
+                          <a:spcPts val="0"/>
+                        </a:spcBef>
+                        <a:spcAft>
+                          <a:spcPts val="0"/>
+                        </a:spcAft>
+                        <a:lnSpc>
+                          <a:spcPct val="100000"/>
+                        </a:lnSpc>
+                      </a:pPr>
+                      <a:r>
+                        <a:rPr sz="1300" b="0">
+                          <a:solidFill>
+                            <a:srgbClr val="1C242E"/>
+                          </a:solidFill>
+                          <a:latin typeface="Microsoft YaHei"/>
+                          <a:ea typeface="Microsoft YaHei"/>
+                          <a:cs typeface="Microsoft YaHei"/>
+                        </a:rPr>
+                        <a:t>42.89 GB · 13.40 毫秒</a:t>
+                      </a:r>
+                    </a:p>
+                  </a:txBody>
+                  <a:tcPr marL="54864" marR="54864" marT="27432" marB="18288" anchor="ctr">
+                    <a:solidFill>
+                      <a:srgbClr val="FFFFFF"/>
+                    </a:solidFill>
+                    <a:lnL w="6350">
+                      <a:solidFill>
+                        <a:srgbClr val="D6DCE2"/>
+                      </a:solidFill>
+                    </a:lnL>
+                    <a:lnR w="6350">
+                      <a:solidFill>
+                        <a:srgbClr val="D6DCE2"/>
+                      </a:solidFill>
+                    </a:lnR>
+                    <a:lnT w="6350">
+                      <a:solidFill>
+                        <a:srgbClr val="D6DCE2"/>
+                      </a:solidFill>
+                    </a:lnT>
+                    <a:lnB w="6350">
+                      <a:solidFill>
+                        <a:srgbClr val="D6DCE2"/>
+                      </a:solidFill>
+                    </a:lnB>
+                  </a:tcPr>
+                </a:tc>
+              </a:tr>
+              <a:tr h="310896">
+                <a:tc>
+                  <a:txBody>
+                    <a:bodyPr wrap="square"/>
+                    <a:lstStyle/>
+                    <a:p>
+                      <a:pPr algn="l">
+                        <a:spcBef>
+                          <a:spcPts val="0"/>
+                        </a:spcBef>
+                        <a:spcAft>
+                          <a:spcPts val="0"/>
+                        </a:spcAft>
+                        <a:lnSpc>
+                          <a:spcPct val="100000"/>
+                        </a:lnSpc>
+                      </a:pPr>
+                      <a:r>
                         <a:rPr sz="1300" b="1">
                           <a:solidFill>
-                            <a:srgbClr val="0E7A76"/>
-                          </a:solidFill>
-                          <a:latin typeface="Microsoft YaHei"/>
-                          <a:ea typeface="Microsoft YaHei"/>
-                          <a:cs typeface="Microsoft YaHei"/>
-                        </a:rPr>
-                        <a:t>29.49 GB · 9.21 毫秒</a:t>
-                      </a:r>
-                    </a:p>
-                  </a:txBody>
-                  <a:tcPr marL="54864" marR="54864" marT="27432" marB="18288" anchor="ctr">
-                    <a:solidFill>
-                      <a:srgbClr val="E7F3F2"/>
-                    </a:solidFill>
-                    <a:lnL w="6350">
-                      <a:solidFill>
-                        <a:srgbClr val="D6DCE2"/>
-                      </a:solidFill>
-                    </a:lnL>
-                    <a:lnR w="6350">
-                      <a:solidFill>
-                        <a:srgbClr val="D6DCE2"/>
-                      </a:solidFill>
-                    </a:lnR>
-                    <a:lnT w="6350">
-                      <a:solidFill>
-                        <a:srgbClr val="D6DCE2"/>
-                      </a:solidFill>
-                    </a:lnT>
-                    <a:lnB w="6350">
-                      <a:solidFill>
-                        <a:srgbClr val="D6DCE2"/>
-                      </a:solidFill>
-                    </a:lnB>
-                  </a:tcPr>
-                </a:tc>
+                            <a:srgbClr val="0E2A47"/>
+                          </a:solidFill>
+                          <a:latin typeface="Microsoft YaHei"/>
+                          <a:ea typeface="Microsoft YaHei"/>
+                          <a:cs typeface="Microsoft YaHei"/>
+                        </a:rPr>
+                        <a:t>机内 allreduce</a:t>
+                      </a:r>
+                    </a:p>
+                  </a:txBody>
+                  <a:tcPr marL="54864" marR="54864" marT="27432" marB="18288" anchor="ctr">
+                    <a:solidFill>
+                      <a:srgbClr val="F4F7FA"/>
+                    </a:solidFill>
+                    <a:lnL w="6350">
+                      <a:solidFill>
+                        <a:srgbClr val="D6DCE2"/>
+                      </a:solidFill>
+                    </a:lnL>
+                    <a:lnR w="6350">
+                      <a:solidFill>
+                        <a:srgbClr val="D6DCE2"/>
+                      </a:solidFill>
+                    </a:lnR>
+                    <a:lnT w="6350">
+                      <a:solidFill>
+                        <a:srgbClr val="D6DCE2"/>
+                      </a:solidFill>
+                    </a:lnT>
+                    <a:lnB w="6350">
+                      <a:solidFill>
+                        <a:srgbClr val="D6DCE2"/>
+                      </a:solidFill>
+                    </a:lnB>
+                  </a:tcPr>
+                </a:tc>
+                <a:tc>
+                  <a:txBody>
+                    <a:bodyPr wrap="square"/>
+                    <a:lstStyle/>
+                    <a:p>
+                      <a:pPr algn="l">
+                        <a:spcBef>
+                          <a:spcPts val="0"/>
+                        </a:spcBef>
+                        <a:spcAft>
+                          <a:spcPts val="0"/>
+                        </a:spcAft>
+                        <a:lnSpc>
+                          <a:spcPct val="100000"/>
+                        </a:lnSpc>
+                      </a:pPr>
+                      <a:r>
+                        <a:rPr sz="1300" b="0">
+                          <a:solidFill>
+                            <a:srgbClr val="1C242E"/>
+                          </a:solidFill>
+                          <a:latin typeface="Microsoft YaHei"/>
+                          <a:ea typeface="Microsoft YaHei"/>
+                          <a:cs typeface="Microsoft YaHei"/>
+                        </a:rPr>
+                        <a:t>630.5 MB · 15.76 毫秒</a:t>
+                      </a:r>
+                    </a:p>
+                  </a:txBody>
+                  <a:tcPr marL="54864" marR="54864" marT="27432" marB="18288" anchor="ctr">
+                    <a:solidFill>
+                      <a:srgbClr val="FFFFFF"/>
+                    </a:solidFill>
+                    <a:lnL w="6350">
+                      <a:solidFill>
+                        <a:srgbClr val="D6DCE2"/>
+                      </a:solidFill>
+                    </a:lnL>
+                    <a:lnR w="6350">
+                      <a:solidFill>
+                        <a:srgbClr val="D6DCE2"/>
+                      </a:solidFill>
+                    </a:lnR>
+                    <a:lnT w="6350">
+                      <a:solidFill>
+                        <a:srgbClr val="D6DCE2"/>
+                      </a:solidFill>
+                    </a:lnT>
+                    <a:lnB w="6350">
+                      <a:solidFill>
+                        <a:srgbClr val="D6DCE2"/>
+                      </a:solidFill>
+                    </a:lnB>
+                  </a:tcPr>
+                </a:tc>
+                <a:tc>
+                  <a:txBody>
+                    <a:bodyPr wrap="square"/>
+                    <a:lstStyle/>
+                    <a:p>
+                      <a:pPr algn="l">
+                        <a:spcBef>
+                          <a:spcPts val="0"/>
+                        </a:spcBef>
+                        <a:spcAft>
+                          <a:spcPts val="0"/>
+                        </a:spcAft>
+                        <a:lnSpc>
+                          <a:spcPct val="100000"/>
+                        </a:lnSpc>
+                      </a:pPr>
+                      <a:r>
+                        <a:rPr sz="1300" b="0">
+                          <a:solidFill>
+                            <a:srgbClr val="1C242E"/>
+                          </a:solidFill>
+                          <a:latin typeface="Microsoft YaHei"/>
+                          <a:ea typeface="Microsoft YaHei"/>
+                          <a:cs typeface="Microsoft YaHei"/>
+                        </a:rPr>
+                        <a:t>399.4 MB · 9.99 毫秒</a:t>
+                      </a:r>
+                    </a:p>
+                  </a:txBody>
+                  <a:tcPr marL="54864" marR="54864" marT="27432" marB="18288" anchor="ctr">
+                    <a:solidFill>
+                      <a:srgbClr val="FFFFFF"/>
+                    </a:solidFill>
+                    <a:lnL w="6350">
+                      <a:solidFill>
+                        <a:srgbClr val="D6DCE2"/>
+                      </a:solidFill>
+                    </a:lnL>
+                    <a:lnR w="6350">
+                      <a:solidFill>
+                        <a:srgbClr val="D6DCE2"/>
+                      </a:solidFill>
+                    </a:lnR>
+                    <a:lnT w="6350">
+                      <a:solidFill>
+                        <a:srgbClr val="D6DCE2"/>
+                      </a:solidFill>
+                    </a:lnT>
+                    <a:lnB w="6350">
+                      <a:solidFill>
+                        <a:srgbClr val="D6DCE2"/>
+                      </a:solidFill>
+                    </a:lnB>
+                  </a:tcPr>
+                </a:tc>
+              </a:tr>
+              <a:tr h="310896">
                 <a:tc>
                   <a:txBody>
                     <a:bodyPr wrap="square"/>
@@ -26834,19 +27058,129 @@
                       <a:r>
                         <a:rPr sz="1300" b="1">
                           <a:solidFill>
-                            <a:srgbClr val="0E7A76"/>
-                          </a:solidFill>
-                          <a:latin typeface="Microsoft YaHei"/>
-                          <a:ea typeface="Microsoft YaHei"/>
-                          <a:cs typeface="Microsoft YaHei"/>
-                        </a:rPr>
-                        <a:t>42.89 GB · 13.40 毫秒</a:t>
-                      </a:r>
-                    </a:p>
-                  </a:txBody>
-                  <a:tcPr marL="54864" marR="54864" marT="27432" marB="18288" anchor="ctr">
-                    <a:solidFill>
-                      <a:srgbClr val="E7F3F2"/>
+                            <a:srgbClr val="0E2A47"/>
+                          </a:solidFill>
+                          <a:latin typeface="Microsoft YaHei"/>
+                          <a:ea typeface="Microsoft YaHei"/>
+                          <a:cs typeface="Microsoft YaHei"/>
+                        </a:rPr>
+                        <a:t>专家 GEMM</a:t>
+                      </a:r>
+                    </a:p>
+                  </a:txBody>
+                  <a:tcPr marL="54864" marR="54864" marT="27432" marB="18288" anchor="ctr">
+                    <a:solidFill>
+                      <a:srgbClr val="F4F7FA"/>
+                    </a:solidFill>
+                    <a:lnL w="6350">
+                      <a:solidFill>
+                        <a:srgbClr val="D6DCE2"/>
+                      </a:solidFill>
+                    </a:lnL>
+                    <a:lnR w="6350">
+                      <a:solidFill>
+                        <a:srgbClr val="D6DCE2"/>
+                      </a:solidFill>
+                    </a:lnR>
+                    <a:lnT w="6350">
+                      <a:solidFill>
+                        <a:srgbClr val="D6DCE2"/>
+                      </a:solidFill>
+                    </a:lnT>
+                    <a:lnB w="6350">
+                      <a:solidFill>
+                        <a:srgbClr val="D6DCE2"/>
+                      </a:solidFill>
+                    </a:lnB>
+                  </a:tcPr>
+                </a:tc>
+                <a:tc>
+                  <a:txBody>
+                    <a:bodyPr wrap="square"/>
+                    <a:lstStyle/>
+                    <a:p>
+                      <a:pPr algn="l">
+                        <a:spcBef>
+                          <a:spcPts val="0"/>
+                        </a:spcBef>
+                        <a:spcAft>
+                          <a:spcPts val="0"/>
+                        </a:spcAft>
+                        <a:lnSpc>
+                          <a:spcPct val="100000"/>
+                        </a:lnSpc>
+                      </a:pPr>
+                      <a:r>
+                        <a:rPr sz="1300" b="0">
+                          <a:solidFill>
+                            <a:srgbClr val="1C242E"/>
+                          </a:solidFill>
+                          <a:latin typeface="Microsoft YaHei"/>
+                          <a:ea typeface="Microsoft YaHei"/>
+                          <a:cs typeface="Microsoft YaHei"/>
+                        </a:rPr>
+                        <a:t>效率 100% · 8.53 毫秒</a:t>
+                      </a:r>
+                    </a:p>
+                  </a:txBody>
+                  <a:tcPr marL="54864" marR="54864" marT="27432" marB="18288" anchor="ctr">
+                    <a:solidFill>
+                      <a:srgbClr val="FFFFFF"/>
+                    </a:solidFill>
+                    <a:lnL w="6350">
+                      <a:solidFill>
+                        <a:srgbClr val="D6DCE2"/>
+                      </a:solidFill>
+                    </a:lnL>
+                    <a:lnR w="6350">
+                      <a:solidFill>
+                        <a:srgbClr val="D6DCE2"/>
+                      </a:solidFill>
+                    </a:lnR>
+                    <a:lnT w="6350">
+                      <a:solidFill>
+                        <a:srgbClr val="D6DCE2"/>
+                      </a:solidFill>
+                    </a:lnT>
+                    <a:lnB w="6350">
+                      <a:solidFill>
+                        <a:srgbClr val="D6DCE2"/>
+                      </a:solidFill>
+                    </a:lnB>
+                  </a:tcPr>
+                </a:tc>
+                <a:tc>
+                  <a:txBody>
+                    <a:bodyPr wrap="square"/>
+                    <a:lstStyle/>
+                    <a:p>
+                      <a:pPr algn="l">
+                        <a:spcBef>
+                          <a:spcPts val="0"/>
+                        </a:spcBef>
+                        <a:spcAft>
+                          <a:spcPts val="0"/>
+                        </a:spcAft>
+                        <a:lnSpc>
+                          <a:spcPct val="100000"/>
+                        </a:lnSpc>
+                      </a:pPr>
+                      <a:r>
+                        <a:rPr sz="1300" b="0">
+                          <a:solidFill>
+                            <a:srgbClr val="1C242E"/>
+                          </a:solidFill>
+                          <a:latin typeface="Microsoft YaHei"/>
+                          <a:ea typeface="Microsoft YaHei"/>
+                          <a:cs typeface="Microsoft YaHei"/>
+                        </a:rPr>
+                        <a:t>效率 63% · 8.53 毫秒</a:t>
+                      </a:r>
+                    </a:p>
+                  </a:txBody>
+                  <a:tcPr marL="54864" marR="54864" marT="27432" marB="18288" anchor="ctr">
+                    <a:solidFill>
+                      <a:srgbClr val="FFFFFF"/>
                     </a:solidFill>
                     <a:lnL w="6350">
                       <a:solidFill>
@@ -26871,7 +27205,7 @@
                   </a:tcPr>
                 </a:tc>
               </a:tr>
-              <a:tr h="329184">
+              <a:tr h="310896">
                 <a:tc>
                   <a:txBody>
                     <a:bodyPr wrap="square"/>
@@ -26891,13 +27225,13 @@
                       <a:r>
                         <a:rPr sz="1300" b="1">
                           <a:solidFill>
-                            <a:srgbClr val="0E7A76"/>
-                          </a:solidFill>
-                          <a:latin typeface="Microsoft YaHei"/>
-                          <a:ea typeface="Microsoft YaHei"/>
-                          <a:cs typeface="Microsoft YaHei"/>
-                        </a:rPr>
-                        <a:t>机内 allreduce</a:t>
+                            <a:srgbClr val="0E2A47"/>
+                          </a:solidFill>
+                          <a:latin typeface="Microsoft YaHei"/>
+                          <a:ea typeface="Microsoft YaHei"/>
+                          <a:cs typeface="Microsoft YaHei"/>
+                        </a:rPr>
+                        <a:t>专家 combine</a:t>
                       </a:r>
                     </a:p>
                   </a:txBody>
@@ -26944,173 +27278,6 @@
                         </a:lnSpc>
                       </a:pPr>
                       <a:r>
-                        <a:rPr sz="1300" b="1">
-                          <a:solidFill>
-                            <a:srgbClr val="0E7A76"/>
-                          </a:solidFill>
-                          <a:latin typeface="Microsoft YaHei"/>
-                          <a:ea typeface="Microsoft YaHei"/>
-                          <a:cs typeface="Microsoft YaHei"/>
-                        </a:rPr>
-                        <a:t>23.0 MB · 0.57 毫秒</a:t>
-                      </a:r>
-                    </a:p>
-                  </a:txBody>
-                  <a:tcPr marL="54864" marR="54864" marT="27432" marB="18288" anchor="ctr">
-                    <a:solidFill>
-                      <a:srgbClr val="E7F3F2"/>
-                    </a:solidFill>
-                    <a:lnL w="6350">
-                      <a:solidFill>
-                        <a:srgbClr val="D6DCE2"/>
-                      </a:solidFill>
-                    </a:lnL>
-                    <a:lnR w="6350">
-                      <a:solidFill>
-                        <a:srgbClr val="D6DCE2"/>
-                      </a:solidFill>
-                    </a:lnR>
-                    <a:lnT w="6350">
-                      <a:solidFill>
-                        <a:srgbClr val="D6DCE2"/>
-                      </a:solidFill>
-                    </a:lnT>
-                    <a:lnB w="6350">
-                      <a:solidFill>
-                        <a:srgbClr val="D6DCE2"/>
-                      </a:solidFill>
-                    </a:lnB>
-                  </a:tcPr>
-                </a:tc>
-                <a:tc>
-                  <a:txBody>
-                    <a:bodyPr wrap="square"/>
-                    <a:lstStyle/>
-                    <a:p>
-                      <a:pPr algn="l">
-                        <a:spcBef>
-                          <a:spcPts val="0"/>
-                        </a:spcBef>
-                        <a:spcAft>
-                          <a:spcPts val="0"/>
-                        </a:spcAft>
-                        <a:lnSpc>
-                          <a:spcPct val="100000"/>
-                        </a:lnSpc>
-                      </a:pPr>
-                      <a:r>
-                        <a:rPr sz="1300" b="1">
-                          <a:solidFill>
-                            <a:srgbClr val="0E7A76"/>
-                          </a:solidFill>
-                          <a:latin typeface="Microsoft YaHei"/>
-                          <a:ea typeface="Microsoft YaHei"/>
-                          <a:cs typeface="Microsoft YaHei"/>
-                        </a:rPr>
-                        <a:t>630.5 MB · 15.76 毫秒</a:t>
-                      </a:r>
-                    </a:p>
-                  </a:txBody>
-                  <a:tcPr marL="54864" marR="54864" marT="27432" marB="18288" anchor="ctr">
-                    <a:solidFill>
-                      <a:srgbClr val="E7F3F2"/>
-                    </a:solidFill>
-                    <a:lnL w="6350">
-                      <a:solidFill>
-                        <a:srgbClr val="D6DCE2"/>
-                      </a:solidFill>
-                    </a:lnL>
-                    <a:lnR w="6350">
-                      <a:solidFill>
-                        <a:srgbClr val="D6DCE2"/>
-                      </a:solidFill>
-                    </a:lnR>
-                    <a:lnT w="6350">
-                      <a:solidFill>
-                        <a:srgbClr val="D6DCE2"/>
-                      </a:solidFill>
-                    </a:lnT>
-                    <a:lnB w="6350">
-                      <a:solidFill>
-                        <a:srgbClr val="D6DCE2"/>
-                      </a:solidFill>
-                    </a:lnB>
-                  </a:tcPr>
-                </a:tc>
-              </a:tr>
-              <a:tr h="329184">
-                <a:tc>
-                  <a:txBody>
-                    <a:bodyPr wrap="square"/>
-                    <a:lstStyle/>
-                    <a:p>
-                      <a:pPr algn="l">
-                        <a:spcBef>
-                          <a:spcPts val="0"/>
-                        </a:spcBef>
-                        <a:spcAft>
-                          <a:spcPts val="0"/>
-                        </a:spcAft>
-                        <a:lnSpc>
-                          <a:spcPct val="100000"/>
-                        </a:lnSpc>
-                      </a:pPr>
-                      <a:r>
-                        <a:rPr sz="1300" b="1">
-                          <a:solidFill>
-                            <a:srgbClr val="0E2A47"/>
-                          </a:solidFill>
-                          <a:latin typeface="Microsoft YaHei"/>
-                          <a:ea typeface="Microsoft YaHei"/>
-                          <a:cs typeface="Microsoft YaHei"/>
-                        </a:rPr>
-                        <a:t>专家 GEMM</a:t>
-                      </a:r>
-                    </a:p>
-                  </a:txBody>
-                  <a:tcPr marL="54864" marR="54864" marT="27432" marB="18288" anchor="ctr">
-                    <a:solidFill>
-                      <a:srgbClr val="F4F7FA"/>
-                    </a:solidFill>
-                    <a:lnL w="6350">
-                      <a:solidFill>
-                        <a:srgbClr val="D6DCE2"/>
-                      </a:solidFill>
-                    </a:lnL>
-                    <a:lnR w="6350">
-                      <a:solidFill>
-                        <a:srgbClr val="D6DCE2"/>
-                      </a:solidFill>
-                    </a:lnR>
-                    <a:lnT w="6350">
-                      <a:solidFill>
-                        <a:srgbClr val="D6DCE2"/>
-                      </a:solidFill>
-                    </a:lnT>
-                    <a:lnB w="6350">
-                      <a:solidFill>
-                        <a:srgbClr val="D6DCE2"/>
-                      </a:solidFill>
-                    </a:lnB>
-                  </a:tcPr>
-                </a:tc>
-                <a:tc>
-                  <a:txBody>
-                    <a:bodyPr wrap="square"/>
-                    <a:lstStyle/>
-                    <a:p>
-                      <a:pPr algn="l">
-                        <a:spcBef>
-                          <a:spcPts val="0"/>
-                        </a:spcBef>
-                        <a:spcAft>
-                          <a:spcPts val="0"/>
-                        </a:spcAft>
-                        <a:lnSpc>
-                          <a:spcPct val="100000"/>
-                        </a:lnSpc>
-                      </a:pPr>
-                      <a:r>
                         <a:rPr sz="1300" b="0">
                           <a:solidFill>
                             <a:srgbClr val="1C242E"/>
@@ -27119,7 +27286,7 @@
                           <a:ea typeface="Microsoft YaHei"/>
                           <a:cs typeface="Microsoft YaHei"/>
                         </a:rPr>
-                        <a:t>效率 8% · 3.66 毫秒</a:t>
+                        <a:t>269.9 MB · 0.84 毫秒</a:t>
                       </a:r>
                     </a:p>
                   </a:txBody>
@@ -27174,174 +27341,7 @@
                           <a:ea typeface="Microsoft YaHei"/>
                           <a:cs typeface="Microsoft YaHei"/>
                         </a:rPr>
-                        <a:t>效率 100% · 8.53 毫秒</a:t>
-                      </a:r>
-                    </a:p>
-                  </a:txBody>
-                  <a:tcPr marL="54864" marR="54864" marT="27432" marB="18288" anchor="ctr">
-                    <a:solidFill>
-                      <a:srgbClr val="FFFFFF"/>
-                    </a:solidFill>
-                    <a:lnL w="6350">
-                      <a:solidFill>
-                        <a:srgbClr val="D6DCE2"/>
-                      </a:solidFill>
-                    </a:lnL>
-                    <a:lnR w="6350">
-                      <a:solidFill>
-                        <a:srgbClr val="D6DCE2"/>
-                      </a:solidFill>
-                    </a:lnR>
-                    <a:lnT w="6350">
-                      <a:solidFill>
-                        <a:srgbClr val="D6DCE2"/>
-                      </a:solidFill>
-                    </a:lnT>
-                    <a:lnB w="6350">
-                      <a:solidFill>
-                        <a:srgbClr val="D6DCE2"/>
-                      </a:solidFill>
-                    </a:lnB>
-                  </a:tcPr>
-                </a:tc>
-              </a:tr>
-              <a:tr h="329184">
-                <a:tc>
-                  <a:txBody>
-                    <a:bodyPr wrap="square"/>
-                    <a:lstStyle/>
-                    <a:p>
-                      <a:pPr algn="l">
-                        <a:spcBef>
-                          <a:spcPts val="0"/>
-                        </a:spcBef>
-                        <a:spcAft>
-                          <a:spcPts val="0"/>
-                        </a:spcAft>
-                        <a:lnSpc>
-                          <a:spcPct val="100000"/>
-                        </a:lnSpc>
-                      </a:pPr>
-                      <a:r>
-                        <a:rPr sz="1300" b="1">
-                          <a:solidFill>
-                            <a:srgbClr val="0E2A47"/>
-                          </a:solidFill>
-                          <a:latin typeface="Microsoft YaHei"/>
-                          <a:ea typeface="Microsoft YaHei"/>
-                          <a:cs typeface="Microsoft YaHei"/>
-                        </a:rPr>
-                        <a:t>专家 combine</a:t>
-                      </a:r>
-                    </a:p>
-                  </a:txBody>
-                  <a:tcPr marL="54864" marR="54864" marT="27432" marB="18288" anchor="ctr">
-                    <a:solidFill>
-                      <a:srgbClr val="F4F7FA"/>
-                    </a:solidFill>
-                    <a:lnL w="6350">
-                      <a:solidFill>
-                        <a:srgbClr val="D6DCE2"/>
-                      </a:solidFill>
-                    </a:lnL>
-                    <a:lnR w="6350">
-                      <a:solidFill>
-                        <a:srgbClr val="D6DCE2"/>
-                      </a:solidFill>
-                    </a:lnR>
-                    <a:lnT w="6350">
-                      <a:solidFill>
-                        <a:srgbClr val="D6DCE2"/>
-                      </a:solidFill>
-                    </a:lnT>
-                    <a:lnB w="6350">
-                      <a:solidFill>
-                        <a:srgbClr val="D6DCE2"/>
-                      </a:solidFill>
-                    </a:lnB>
-                  </a:tcPr>
-                </a:tc>
-                <a:tc>
-                  <a:txBody>
-                    <a:bodyPr wrap="square"/>
-                    <a:lstStyle/>
-                    <a:p>
-                      <a:pPr algn="l">
-                        <a:spcBef>
-                          <a:spcPts val="0"/>
-                        </a:spcBef>
-                        <a:spcAft>
-                          <a:spcPts val="0"/>
-                        </a:spcAft>
-                        <a:lnSpc>
-                          <a:spcPct val="100000"/>
-                        </a:lnSpc>
-                      </a:pPr>
-                      <a:r>
-                        <a:rPr sz="1300" b="0">
-                          <a:solidFill>
-                            <a:srgbClr val="1C242E"/>
-                          </a:solidFill>
-                          <a:latin typeface="Microsoft YaHei"/>
-                          <a:ea typeface="Microsoft YaHei"/>
-                          <a:cs typeface="Microsoft YaHei"/>
-                        </a:rPr>
-                        <a:t>6.2 MB · 0.02 毫秒</a:t>
-                      </a:r>
-                    </a:p>
-                  </a:txBody>
-                  <a:tcPr marL="54864" marR="54864" marT="27432" marB="18288" anchor="ctr">
-                    <a:solidFill>
-                      <a:srgbClr val="FFFFFF"/>
-                    </a:solidFill>
-                    <a:lnL w="6350">
-                      <a:solidFill>
-                        <a:srgbClr val="D6DCE2"/>
-                      </a:solidFill>
-                    </a:lnL>
-                    <a:lnR w="6350">
-                      <a:solidFill>
-                        <a:srgbClr val="D6DCE2"/>
-                      </a:solidFill>
-                    </a:lnR>
-                    <a:lnT w="6350">
-                      <a:solidFill>
-                        <a:srgbClr val="D6DCE2"/>
-                      </a:solidFill>
-                    </a:lnT>
-                    <a:lnB w="6350">
-                      <a:solidFill>
-                        <a:srgbClr val="D6DCE2"/>
-                      </a:solidFill>
-                    </a:lnB>
-                  </a:tcPr>
-                </a:tc>
-                <a:tc>
-                  <a:txBody>
-                    <a:bodyPr wrap="square"/>
-                    <a:lstStyle/>
-                    <a:p>
-                      <a:pPr algn="l">
-                        <a:spcBef>
-                          <a:spcPts val="0"/>
-                        </a:spcBef>
-                        <a:spcAft>
-                          <a:spcPts val="0"/>
-                        </a:spcAft>
-                        <a:lnSpc>
-                          <a:spcPct val="100000"/>
-                        </a:lnSpc>
-                      </a:pPr>
-                      <a:r>
-                        <a:rPr sz="1300" b="0">
-                          <a:solidFill>
-                            <a:srgbClr val="1C242E"/>
-                          </a:solidFill>
-                          <a:latin typeface="Microsoft YaHei"/>
-                          <a:ea typeface="Microsoft YaHei"/>
-                          <a:cs typeface="Microsoft YaHei"/>
-                        </a:rPr>
-                        <a:t>269.9 MB · 0.84 毫秒</a:t>
+                        <a:t>170.6 MB · 0.53 毫秒</a:t>
                       </a:r>
                     </a:p>
                   </a:txBody>
@@ -27453,7 +27453,7 @@
                           <a:ea typeface="Microsoft YaHei"/>
                           <a:cs typeface="Microsoft YaHei"/>
                         </a:rPr>
-                        <a:t>0.29 毫秒</a:t>
+                        <a:t>14.77 毫秒</a:t>
                       </a:r>
                     </a:p>
                   </a:txBody>
@@ -27508,7 +27508,7 @@
                           <a:ea typeface="Microsoft YaHei"/>
                           <a:cs typeface="Microsoft YaHei"/>
                         </a:rPr>
-                        <a:t>7.42 毫秒</a:t>
+                        <a:t>14.54 毫秒</a:t>
                       </a:r>
                     </a:p>
                   </a:txBody>
@@ -27539,7 +27539,7 @@
                   </a:tcPr>
                 </a:tc>
               </a:tr>
-              <a:tr h="329184">
+              <a:tr h="310896">
                 <a:tc>
                   <a:txBody>
                     <a:bodyPr wrap="square"/>
@@ -27706,7 +27706,7 @@
                   </a:tcPr>
                 </a:tc>
               </a:tr>
-              <a:tr h="329184">
+              <a:tr h="310896">
                 <a:tc>
                   <a:txBody>
                     <a:bodyPr wrap="square"/>
@@ -27787,7 +27787,7 @@
                           <a:ea typeface="Microsoft YaHei"/>
                           <a:cs typeface="Microsoft YaHei"/>
                         </a:rPr>
-                        <a:t>44.6 MB · 0.01 毫秒</a:t>
+                        <a:t>6.35 GB · 1.98 毫秒</a:t>
                       </a:r>
                     </a:p>
                   </a:txBody>
@@ -27842,7 +27842,7 @@
                           <a:ea typeface="Microsoft YaHei"/>
                           <a:cs typeface="Microsoft YaHei"/>
                         </a:rPr>
-                        <a:t>1.27 GB · 0.40 毫秒</a:t>
+                        <a:t>5.98 GB · 1.87 毫秒</a:t>
                       </a:r>
                     </a:p>
                   </a:txBody>
@@ -27873,7 +27873,7 @@
                   </a:tcPr>
                 </a:tc>
               </a:tr>
-              <a:tr h="329184">
+              <a:tr h="347472">
                 <a:tc>
                   <a:txBody>
                     <a:bodyPr wrap="square"/>
@@ -27893,7 +27893,7 @@
                       <a:r>
                         <a:rPr sz="1300" b="1">
                           <a:solidFill>
-                            <a:srgbClr val="0E2A47"/>
+                            <a:srgbClr val="0E7A76"/>
                           </a:solidFill>
                           <a:latin typeface="Microsoft YaHei"/>
                           <a:ea typeface="Microsoft YaHei"/>
@@ -27946,76 +27946,76 @@
                         </a:lnSpc>
                       </a:pPr>
                       <a:r>
-                        <a:rPr sz="1300" b="0">
-                          <a:solidFill>
-                            <a:srgbClr val="1C242E"/>
-                          </a:solidFill>
-                          <a:latin typeface="Microsoft YaHei"/>
-                          <a:ea typeface="Microsoft YaHei"/>
-                          <a:cs typeface="Microsoft YaHei"/>
-                        </a:rPr>
-                        <a:t>0 · 0.00 毫秒</a:t>
-                      </a:r>
-                    </a:p>
-                  </a:txBody>
-                  <a:tcPr marL="54864" marR="54864" marT="27432" marB="18288" anchor="ctr">
-                    <a:solidFill>
-                      <a:srgbClr val="FFFFFF"/>
-                    </a:solidFill>
-                    <a:lnL w="6350">
-                      <a:solidFill>
-                        <a:srgbClr val="D6DCE2"/>
-                      </a:solidFill>
-                    </a:lnL>
-                    <a:lnR w="6350">
-                      <a:solidFill>
-                        <a:srgbClr val="D6DCE2"/>
-                      </a:solidFill>
-                    </a:lnR>
-                    <a:lnT w="6350">
-                      <a:solidFill>
-                        <a:srgbClr val="D6DCE2"/>
-                      </a:solidFill>
-                    </a:lnT>
-                    <a:lnB w="6350">
-                      <a:solidFill>
-                        <a:srgbClr val="D6DCE2"/>
-                      </a:solidFill>
-                    </a:lnB>
-                  </a:tcPr>
-                </a:tc>
-                <a:tc>
-                  <a:txBody>
-                    <a:bodyPr wrap="square"/>
-                    <a:lstStyle/>
-                    <a:p>
-                      <a:pPr algn="l">
-                        <a:spcBef>
-                          <a:spcPts val="0"/>
-                        </a:spcBef>
-                        <a:spcAft>
-                          <a:spcPts val="0"/>
-                        </a:spcAft>
-                        <a:lnSpc>
-                          <a:spcPct val="100000"/>
-                        </a:lnSpc>
-                      </a:pPr>
-                      <a:r>
-                        <a:rPr sz="1300" b="0">
-                          <a:solidFill>
-                            <a:srgbClr val="1C242E"/>
-                          </a:solidFill>
-                          <a:latin typeface="Microsoft YaHei"/>
-                          <a:ea typeface="Microsoft YaHei"/>
-                          <a:cs typeface="Microsoft YaHei"/>
-                        </a:rPr>
-                        <a:t>0 · 0.00 毫秒</a:t>
-                      </a:r>
-                    </a:p>
-                  </a:txBody>
-                  <a:tcPr marL="54864" marR="54864" marT="27432" marB="18288" anchor="ctr">
-                    <a:solidFill>
-                      <a:srgbClr val="FFFFFF"/>
+                        <a:rPr sz="1300" b="1">
+                          <a:solidFill>
+                            <a:srgbClr val="0E7A76"/>
+                          </a:solidFill>
+                          <a:latin typeface="Microsoft YaHei"/>
+                          <a:ea typeface="Microsoft YaHei"/>
+                          <a:cs typeface="Microsoft YaHei"/>
+                        </a:rPr>
+                        <a:t>3.15 GB · 9.83 毫秒</a:t>
+                      </a:r>
+                    </a:p>
+                  </a:txBody>
+                  <a:tcPr marL="54864" marR="54864" marT="27432" marB="18288" anchor="ctr">
+                    <a:solidFill>
+                      <a:srgbClr val="E7F3F2"/>
+                    </a:solidFill>
+                    <a:lnL w="6350">
+                      <a:solidFill>
+                        <a:srgbClr val="D6DCE2"/>
+                      </a:solidFill>
+                    </a:lnL>
+                    <a:lnR w="6350">
+                      <a:solidFill>
+                        <a:srgbClr val="D6DCE2"/>
+                      </a:solidFill>
+                    </a:lnR>
+                    <a:lnT w="6350">
+                      <a:solidFill>
+                        <a:srgbClr val="D6DCE2"/>
+                      </a:solidFill>
+                    </a:lnT>
+                    <a:lnB w="6350">
+                      <a:solidFill>
+                        <a:srgbClr val="D6DCE2"/>
+                      </a:solidFill>
+                    </a:lnB>
+                  </a:tcPr>
+                </a:tc>
+                <a:tc>
+                  <a:txBody>
+                    <a:bodyPr wrap="square"/>
+                    <a:lstStyle/>
+                    <a:p>
+                      <a:pPr algn="l">
+                        <a:spcBef>
+                          <a:spcPts val="0"/>
+                        </a:spcBef>
+                        <a:spcAft>
+                          <a:spcPts val="0"/>
+                        </a:spcAft>
+                        <a:lnSpc>
+                          <a:spcPct val="100000"/>
+                        </a:lnSpc>
+                      </a:pPr>
+                      <a:r>
+                        <a:rPr sz="1300" b="1">
+                          <a:solidFill>
+                            <a:srgbClr val="0E7A76"/>
+                          </a:solidFill>
+                          <a:latin typeface="Microsoft YaHei"/>
+                          <a:ea typeface="Microsoft YaHei"/>
+                          <a:cs typeface="Microsoft YaHei"/>
+                        </a:rPr>
+                        <a:t>5.31 GB · 16.59 毫秒</a:t>
+                      </a:r>
+                    </a:p>
+                  </a:txBody>
+                  <a:tcPr marL="54864" marR="54864" marT="27432" marB="18288" anchor="ctr">
+                    <a:solidFill>
+                      <a:srgbClr val="E7F3F2"/>
                     </a:solidFill>
                     <a:lnL w="6350">
                       <a:solidFill>
@@ -28121,7 +28121,7 @@
                           <a:ea typeface="Microsoft YaHei"/>
                           <a:cs typeface="Microsoft YaHei"/>
                         </a:rPr>
-                        <a:t>读专家 + allreduce · 9.98 毫秒</a:t>
+                        <a:t>allreduce + 读专家 · 29.17 毫秒</a:t>
                       </a:r>
                     </a:p>
                   </a:txBody>
@@ -28176,7 +28176,7 @@
                           <a:ea typeface="Microsoft YaHei"/>
                           <a:cs typeface="Microsoft YaHei"/>
                         </a:rPr>
-                        <a:t>读专家 + allreduce · 29.17 毫秒</a:t>
+                        <a:t>换入 + 读专家 · 29.99 毫秒</a:t>
                       </a:r>
                     </a:p>
                   </a:txBody>
@@ -28219,8 +28219,8 @@
         </p:nvSpPr>
         <p:spPr>
           <a:xfrm>
-            <a:off x="384048" y="4828032"/>
-            <a:ext cx="11430000" cy="1444752"/>
+            <a:off x="384048" y="4846320"/>
+            <a:ext cx="11430000" cy="1426464"/>
           </a:xfrm>
           <a:prstGeom prst="roundRect">
             <a:avLst/>
@@ -28262,8 +28262,8 @@
         </p:nvSpPr>
         <p:spPr>
           <a:xfrm>
-            <a:off x="530352" y="4882896"/>
-            <a:ext cx="11137392" cy="1335024"/>
+            <a:off x="530352" y="4901184"/>
+            <a:ext cx="11137392" cy="1316736"/>
           </a:xfrm>
           <a:prstGeom prst="rect">
             <a:avLst/>
@@ -28291,7 +28291,7 @@
                 <a:ea typeface="Microsoft YaHei"/>
                 <a:cs typeface="Microsoft YaHei"/>
               </a:rPr>
-              <a:t>字节都按每卡。10 毫秒醒了 12.6 个专家，读 29.49 GB。整卡 19.3 个加共享要 13.40 毫秒，这一档放不下。再加一条是 10.00 毫秒。</a:t>
+              <a:t>字节按每卡。256K 溢出 33.1%，换入 3.15 GB / 320 GB/s = 9.83 毫秒，短于 allreduce 15.76 毫秒，批保持 6583。128 卡合计 402.56 GB。</a:t>
             </a:r>
           </a:p>
           <a:p>
@@ -28312,7 +28312,7 @@
                 <a:ea typeface="Microsoft YaHei"/>
                 <a:cs typeface="Microsoft YaHei"/>
               </a:rPr>
-              <a:t>30 毫秒把 19.3 个专家读满，42.89 GB，13.40 毫秒；allreduce 630.5 MB，15.76 毫秒。每个专家 16.00 个 token，砖效率 100%。再加一条跨过 16，效率掉到 50%，专家 GEMM 变成 17.06 毫秒，一步到 32.82 毫秒。</a:t>
+              <a:t>512K 换入 5.31 GB、16.59 毫秒，长过 allreduce 和注意力计算，和读专家 13.40 毫秒相加，批降到 4163。128 卡合计 679.44 GB。</a:t>
             </a:r>
           </a:p>
           <a:p>
@@ -28333,7 +28333,7 @@
                 <a:ea typeface="Microsoft YaHei"/>
                 <a:cs typeface="Microsoft YaHei"/>
               </a:rPr>
-              <a:t>专家 combine 走 320 GB/s。池上的换入也是这条口，但 4K 的存量还在 HBM 里，下一页才出现非零换入。</a:t>
+              <a:t>10 毫秒到 1.67×10^6 仍全在 HBM，没有进池的长度，不进这两页。后面的分析沿用这个口径。</a:t>
             </a:r>
           </a:p>
         </p:txBody>
@@ -28478,7 +28478,7 @@
                 <a:ea typeface="Microsoft YaHei"/>
                 <a:cs typeface="Microsoft YaHei"/>
               </a:rPr>
-              <a:t>256K 每卡换入 3.15 GB，30 毫秒的批仍是 6583</a:t>
+              <a:t>进池的长度从 256K 起，批从 6583 降到 1333</a:t>
             </a:r>
           </a:p>
         </p:txBody>
@@ -28682,7 +28682,7 @@
               </a:spcAft>
             </a:pPr>
             <a:r>
-              <a:rPr sz="1300" b="1">
+              <a:rPr sz="1400" b="1">
                 <a:solidFill>
                   <a:srgbClr val="0E7A76"/>
                 </a:solidFill>
@@ -28690,7 +28690,7 @@
                 <a:ea typeface="Microsoft YaHei"/>
                 <a:cs typeface="Microsoft YaHei"/>
               </a:rPr>
-              <a:t>换入量是溢出比例乘这一步真正读的稀疏 KV。每卡带宽 320 GB/s，即 min(480 GB/s, 400 GB/s) 的 80%。10 毫秒在这些长度上换入为 0。</a:t>
+              <a:t>只统计 KV 换进 DDR 池的输入。换入量 = 溢出比例 × 这一步的稀疏读，每卡带宽 320 GB/s。</a:t>
             </a:r>
           </a:p>
         </p:txBody>
@@ -28704,24 +28704,24 @@
           <p:nvPr/>
         </p:nvGraphicFramePr>
         <p:xfrm>
-          <a:off x="384048" y="1371600"/>
-          <a:ext cx="11430000" cy="1792224"/>
+          <a:off x="384048" y="1353312"/>
+          <a:ext cx="11247120" cy="1883664"/>
         </p:xfrm>
         <a:graphic>
           <a:graphicData uri="http://schemas.openxmlformats.org/drawingml/2006/table">
             <a:tbl>
               <a:tblPr firstRow="1"/>
               <a:tblGrid>
-                <a:gridCol w="1051560"/>
+                <a:gridCol w="1234440"/>
+                <a:gridCol w="1143000"/>
+                <a:gridCol w="822960"/>
+                <a:gridCol w="960120"/>
+                <a:gridCol w="1371600"/>
+                <a:gridCol w="1508760"/>
                 <a:gridCol w="1325880"/>
-                <a:gridCol w="1280160"/>
-                <a:gridCol w="1051560"/>
-                <a:gridCol w="1325880"/>
-                <a:gridCol w="1554480"/>
-                <a:gridCol w="1325880"/>
-                <a:gridCol w="2514600"/>
+                <a:gridCol w="2880360"/>
               </a:tblGrid>
-              <a:tr h="365760">
+              <a:tr h="347472">
                 <a:tc>
                   <a:txBody>
                     <a:bodyPr wrap="square"/>
@@ -28857,7 +28857,7 @@
                           <a:ea typeface="Microsoft YaHei"/>
                           <a:cs typeface="Microsoft YaHei"/>
                         </a:rPr>
-                        <a:t>每条存量</a:t>
+                        <a:t>每卡</a:t>
                       </a:r>
                     </a:p>
                   </a:txBody>
@@ -29132,7 +29132,7 @@
                           <a:ea typeface="Microsoft YaHei"/>
                           <a:cs typeface="Microsoft YaHei"/>
                         </a:rPr>
-                        <a:t>这一笔的位置</a:t>
+                        <a:t>注意力侧取</a:t>
                       </a:r>
                     </a:p>
                   </a:txBody>
@@ -29163,7 +29163,7 @@
                   </a:tcPr>
                 </a:tc>
               </a:tr>
-              <a:tr h="475488">
+              <a:tr h="384048">
                 <a:tc>
                   <a:txBody>
                     <a:bodyPr wrap="square"/>
@@ -29299,7 +29299,7 @@
                           <a:ea typeface="Microsoft YaHei"/>
                           <a:cs typeface="Microsoft YaHei"/>
                         </a:rPr>
-                        <a:t>1.30 GB</a:t>
+                        <a:t>51.4</a:t>
                       </a:r>
                     </a:p>
                   </a:txBody>
@@ -29574,7 +29574,7 @@
                           <a:ea typeface="Microsoft YaHei"/>
                           <a:cs typeface="Microsoft YaHei"/>
                         </a:rPr>
-                        <a:t>短于 allreduce</a:t>
+                        <a:t>allreduce 15.76 毫秒</a:t>
                       </a:r>
                     </a:p>
                   </a:txBody>
@@ -29605,7 +29605,7 @@
                   </a:tcPr>
                 </a:tc>
               </a:tr>
-              <a:tr h="475488">
+              <a:tr h="384048">
                 <a:tc>
                   <a:txBody>
                     <a:bodyPr wrap="square"/>
@@ -29625,7 +29625,7 @@
                       <a:r>
                         <a:rPr sz="1200" b="1">
                           <a:solidFill>
-                            <a:srgbClr val="0E2A47"/>
+                            <a:srgbClr val="0E7A76"/>
                           </a:solidFill>
                           <a:latin typeface="Microsoft YaHei"/>
                           <a:ea typeface="Microsoft YaHei"/>
@@ -29678,9 +29678,9 @@
                         </a:lnSpc>
                       </a:pPr>
                       <a:r>
-                        <a:rPr sz="1200" b="0">
-                          <a:solidFill>
-                            <a:srgbClr val="1C242E"/>
+                        <a:rPr sz="1200" b="1">
+                          <a:solidFill>
+                            <a:srgbClr val="0E7A76"/>
                           </a:solidFill>
                           <a:latin typeface="Microsoft YaHei"/>
                           <a:ea typeface="Microsoft YaHei"/>
@@ -29692,105 +29692,105 @@
                   </a:txBody>
                   <a:tcPr marL="54864" marR="54864" marT="27432" marB="18288" anchor="ctr">
                     <a:solidFill>
-                      <a:srgbClr val="FFFFFF"/>
-                    </a:solidFill>
-                    <a:lnL w="6350">
-                      <a:solidFill>
-                        <a:srgbClr val="D6DCE2"/>
-                      </a:solidFill>
-                    </a:lnL>
-                    <a:lnR w="6350">
-                      <a:solidFill>
-                        <a:srgbClr val="D6DCE2"/>
-                      </a:solidFill>
-                    </a:lnR>
-                    <a:lnT w="6350">
-                      <a:solidFill>
-                        <a:srgbClr val="D6DCE2"/>
-                      </a:solidFill>
-                    </a:lnT>
-                    <a:lnB w="6350">
-                      <a:solidFill>
-                        <a:srgbClr val="D6DCE2"/>
-                      </a:solidFill>
-                    </a:lnB>
-                  </a:tcPr>
-                </a:tc>
-                <a:tc>
-                  <a:txBody>
-                    <a:bodyPr wrap="square"/>
-                    <a:lstStyle/>
-                    <a:p>
-                      <a:pPr algn="l">
-                        <a:spcBef>
-                          <a:spcPts val="0"/>
-                        </a:spcBef>
-                        <a:spcAft>
-                          <a:spcPts val="0"/>
-                        </a:spcAft>
-                        <a:lnSpc>
-                          <a:spcPct val="100000"/>
-                        </a:lnSpc>
-                      </a:pPr>
-                      <a:r>
-                        <a:rPr sz="1200" b="0">
-                          <a:solidFill>
-                            <a:srgbClr val="1C242E"/>
-                          </a:solidFill>
-                          <a:latin typeface="Microsoft YaHei"/>
-                          <a:ea typeface="Microsoft YaHei"/>
-                          <a:cs typeface="Microsoft YaHei"/>
-                        </a:rPr>
-                        <a:t>2.59 GB</a:t>
-                      </a:r>
-                    </a:p>
-                  </a:txBody>
-                  <a:tcPr marL="54864" marR="54864" marT="27432" marB="18288" anchor="ctr">
-                    <a:solidFill>
-                      <a:srgbClr val="FFFFFF"/>
-                    </a:solidFill>
-                    <a:lnL w="6350">
-                      <a:solidFill>
-                        <a:srgbClr val="D6DCE2"/>
-                      </a:solidFill>
-                    </a:lnL>
-                    <a:lnR w="6350">
-                      <a:solidFill>
-                        <a:srgbClr val="D6DCE2"/>
-                      </a:solidFill>
-                    </a:lnR>
-                    <a:lnT w="6350">
-                      <a:solidFill>
-                        <a:srgbClr val="D6DCE2"/>
-                      </a:solidFill>
-                    </a:lnT>
-                    <a:lnB w="6350">
-                      <a:solidFill>
-                        <a:srgbClr val="D6DCE2"/>
-                      </a:solidFill>
-                    </a:lnB>
-                  </a:tcPr>
-                </a:tc>
-                <a:tc>
-                  <a:txBody>
-                    <a:bodyPr wrap="square"/>
-                    <a:lstStyle/>
-                    <a:p>
-                      <a:pPr algn="l">
-                        <a:spcBef>
-                          <a:spcPts val="0"/>
-                        </a:spcBef>
-                        <a:spcAft>
-                          <a:spcPts val="0"/>
-                        </a:spcAft>
-                        <a:lnSpc>
-                          <a:spcPct val="100000"/>
-                        </a:lnSpc>
-                      </a:pPr>
-                      <a:r>
-                        <a:rPr sz="1200" b="0">
-                          <a:solidFill>
-                            <a:srgbClr val="1C242E"/>
+                      <a:srgbClr val="E7F3F2"/>
+                    </a:solidFill>
+                    <a:lnL w="6350">
+                      <a:solidFill>
+                        <a:srgbClr val="D6DCE2"/>
+                      </a:solidFill>
+                    </a:lnL>
+                    <a:lnR w="6350">
+                      <a:solidFill>
+                        <a:srgbClr val="D6DCE2"/>
+                      </a:solidFill>
+                    </a:lnR>
+                    <a:lnT w="6350">
+                      <a:solidFill>
+                        <a:srgbClr val="D6DCE2"/>
+                      </a:solidFill>
+                    </a:lnT>
+                    <a:lnB w="6350">
+                      <a:solidFill>
+                        <a:srgbClr val="D6DCE2"/>
+                      </a:solidFill>
+                    </a:lnB>
+                  </a:tcPr>
+                </a:tc>
+                <a:tc>
+                  <a:txBody>
+                    <a:bodyPr wrap="square"/>
+                    <a:lstStyle/>
+                    <a:p>
+                      <a:pPr algn="l">
+                        <a:spcBef>
+                          <a:spcPts val="0"/>
+                        </a:spcBef>
+                        <a:spcAft>
+                          <a:spcPts val="0"/>
+                        </a:spcAft>
+                        <a:lnSpc>
+                          <a:spcPct val="100000"/>
+                        </a:lnSpc>
+                      </a:pPr>
+                      <a:r>
+                        <a:rPr sz="1200" b="1">
+                          <a:solidFill>
+                            <a:srgbClr val="0E7A76"/>
+                          </a:solidFill>
+                          <a:latin typeface="Microsoft YaHei"/>
+                          <a:ea typeface="Microsoft YaHei"/>
+                          <a:cs typeface="Microsoft YaHei"/>
+                        </a:rPr>
+                        <a:t>32.5</a:t>
+                      </a:r>
+                    </a:p>
+                  </a:txBody>
+                  <a:tcPr marL="54864" marR="54864" marT="27432" marB="18288" anchor="ctr">
+                    <a:solidFill>
+                      <a:srgbClr val="E7F3F2"/>
+                    </a:solidFill>
+                    <a:lnL w="6350">
+                      <a:solidFill>
+                        <a:srgbClr val="D6DCE2"/>
+                      </a:solidFill>
+                    </a:lnL>
+                    <a:lnR w="6350">
+                      <a:solidFill>
+                        <a:srgbClr val="D6DCE2"/>
+                      </a:solidFill>
+                    </a:lnR>
+                    <a:lnT w="6350">
+                      <a:solidFill>
+                        <a:srgbClr val="D6DCE2"/>
+                      </a:solidFill>
+                    </a:lnT>
+                    <a:lnB w="6350">
+                      <a:solidFill>
+                        <a:srgbClr val="D6DCE2"/>
+                      </a:solidFill>
+                    </a:lnB>
+                  </a:tcPr>
+                </a:tc>
+                <a:tc>
+                  <a:txBody>
+                    <a:bodyPr wrap="square"/>
+                    <a:lstStyle/>
+                    <a:p>
+                      <a:pPr algn="l">
+                        <a:spcBef>
+                          <a:spcPts val="0"/>
+                        </a:spcBef>
+                        <a:spcAft>
+                          <a:spcPts val="0"/>
+                        </a:spcAft>
+                        <a:lnSpc>
+                          <a:spcPct val="100000"/>
+                        </a:lnSpc>
+                      </a:pPr>
+                      <a:r>
+                        <a:rPr sz="1200" b="1">
+                          <a:solidFill>
+                            <a:srgbClr val="0E7A76"/>
                           </a:solidFill>
                           <a:latin typeface="Microsoft YaHei"/>
                           <a:ea typeface="Microsoft YaHei"/>
@@ -29802,50 +29802,50 @@
                   </a:txBody>
                   <a:tcPr marL="54864" marR="54864" marT="27432" marB="18288" anchor="ctr">
                     <a:solidFill>
-                      <a:srgbClr val="FFFFFF"/>
-                    </a:solidFill>
-                    <a:lnL w="6350">
-                      <a:solidFill>
-                        <a:srgbClr val="D6DCE2"/>
-                      </a:solidFill>
-                    </a:lnL>
-                    <a:lnR w="6350">
-                      <a:solidFill>
-                        <a:srgbClr val="D6DCE2"/>
-                      </a:solidFill>
-                    </a:lnR>
-                    <a:lnT w="6350">
-                      <a:solidFill>
-                        <a:srgbClr val="D6DCE2"/>
-                      </a:solidFill>
-                    </a:lnT>
-                    <a:lnB w="6350">
-                      <a:solidFill>
-                        <a:srgbClr val="D6DCE2"/>
-                      </a:solidFill>
-                    </a:lnB>
-                  </a:tcPr>
-                </a:tc>
-                <a:tc>
-                  <a:txBody>
-                    <a:bodyPr wrap="square"/>
-                    <a:lstStyle/>
-                    <a:p>
-                      <a:pPr algn="l">
-                        <a:spcBef>
-                          <a:spcPts val="0"/>
-                        </a:spcBef>
-                        <a:spcAft>
-                          <a:spcPts val="0"/>
-                        </a:spcAft>
-                        <a:lnSpc>
-                          <a:spcPct val="100000"/>
-                        </a:lnSpc>
-                      </a:pPr>
-                      <a:r>
-                        <a:rPr sz="1200" b="0">
-                          <a:solidFill>
-                            <a:srgbClr val="1C242E"/>
+                      <a:srgbClr val="E7F3F2"/>
+                    </a:solidFill>
+                    <a:lnL w="6350">
+                      <a:solidFill>
+                        <a:srgbClr val="D6DCE2"/>
+                      </a:solidFill>
+                    </a:lnL>
+                    <a:lnR w="6350">
+                      <a:solidFill>
+                        <a:srgbClr val="D6DCE2"/>
+                      </a:solidFill>
+                    </a:lnR>
+                    <a:lnT w="6350">
+                      <a:solidFill>
+                        <a:srgbClr val="D6DCE2"/>
+                      </a:solidFill>
+                    </a:lnT>
+                    <a:lnB w="6350">
+                      <a:solidFill>
+                        <a:srgbClr val="D6DCE2"/>
+                      </a:solidFill>
+                    </a:lnB>
+                  </a:tcPr>
+                </a:tc>
+                <a:tc>
+                  <a:txBody>
+                    <a:bodyPr wrap="square"/>
+                    <a:lstStyle/>
+                    <a:p>
+                      <a:pPr algn="l">
+                        <a:spcBef>
+                          <a:spcPts val="0"/>
+                        </a:spcBef>
+                        <a:spcAft>
+                          <a:spcPts val="0"/>
+                        </a:spcAft>
+                        <a:lnSpc>
+                          <a:spcPct val="100000"/>
+                        </a:lnSpc>
+                      </a:pPr>
+                      <a:r>
+                        <a:rPr sz="1200" b="1">
+                          <a:solidFill>
+                            <a:srgbClr val="0E7A76"/>
                           </a:solidFill>
                           <a:latin typeface="Microsoft YaHei"/>
                           <a:ea typeface="Microsoft YaHei"/>
@@ -29857,50 +29857,50 @@
                   </a:txBody>
                   <a:tcPr marL="54864" marR="54864" marT="27432" marB="18288" anchor="ctr">
                     <a:solidFill>
-                      <a:srgbClr val="FFFFFF"/>
-                    </a:solidFill>
-                    <a:lnL w="6350">
-                      <a:solidFill>
-                        <a:srgbClr val="D6DCE2"/>
-                      </a:solidFill>
-                    </a:lnL>
-                    <a:lnR w="6350">
-                      <a:solidFill>
-                        <a:srgbClr val="D6DCE2"/>
-                      </a:solidFill>
-                    </a:lnR>
-                    <a:lnT w="6350">
-                      <a:solidFill>
-                        <a:srgbClr val="D6DCE2"/>
-                      </a:solidFill>
-                    </a:lnT>
-                    <a:lnB w="6350">
-                      <a:solidFill>
-                        <a:srgbClr val="D6DCE2"/>
-                      </a:solidFill>
-                    </a:lnB>
-                  </a:tcPr>
-                </a:tc>
-                <a:tc>
-                  <a:txBody>
-                    <a:bodyPr wrap="square"/>
-                    <a:lstStyle/>
-                    <a:p>
-                      <a:pPr algn="l">
-                        <a:spcBef>
-                          <a:spcPts val="0"/>
-                        </a:spcBef>
-                        <a:spcAft>
-                          <a:spcPts val="0"/>
-                        </a:spcAft>
-                        <a:lnSpc>
-                          <a:spcPct val="100000"/>
-                        </a:lnSpc>
-                      </a:pPr>
-                      <a:r>
-                        <a:rPr sz="1200" b="0">
-                          <a:solidFill>
-                            <a:srgbClr val="1C242E"/>
+                      <a:srgbClr val="E7F3F2"/>
+                    </a:solidFill>
+                    <a:lnL w="6350">
+                      <a:solidFill>
+                        <a:srgbClr val="D6DCE2"/>
+                      </a:solidFill>
+                    </a:lnL>
+                    <a:lnR w="6350">
+                      <a:solidFill>
+                        <a:srgbClr val="D6DCE2"/>
+                      </a:solidFill>
+                    </a:lnR>
+                    <a:lnT w="6350">
+                      <a:solidFill>
+                        <a:srgbClr val="D6DCE2"/>
+                      </a:solidFill>
+                    </a:lnT>
+                    <a:lnB w="6350">
+                      <a:solidFill>
+                        <a:srgbClr val="D6DCE2"/>
+                      </a:solidFill>
+                    </a:lnB>
+                  </a:tcPr>
+                </a:tc>
+                <a:tc>
+                  <a:txBody>
+                    <a:bodyPr wrap="square"/>
+                    <a:lstStyle/>
+                    <a:p>
+                      <a:pPr algn="l">
+                        <a:spcBef>
+                          <a:spcPts val="0"/>
+                        </a:spcBef>
+                        <a:spcAft>
+                          <a:spcPts val="0"/>
+                        </a:spcAft>
+                        <a:lnSpc>
+                          <a:spcPct val="100000"/>
+                        </a:lnSpc>
+                      </a:pPr>
+                      <a:r>
+                        <a:rPr sz="1200" b="1">
+                          <a:solidFill>
+                            <a:srgbClr val="0E7A76"/>
                           </a:solidFill>
                           <a:latin typeface="Microsoft YaHei"/>
                           <a:ea typeface="Microsoft YaHei"/>
@@ -29912,50 +29912,50 @@
                   </a:txBody>
                   <a:tcPr marL="54864" marR="54864" marT="27432" marB="18288" anchor="ctr">
                     <a:solidFill>
-                      <a:srgbClr val="FFFFFF"/>
-                    </a:solidFill>
-                    <a:lnL w="6350">
-                      <a:solidFill>
-                        <a:srgbClr val="D6DCE2"/>
-                      </a:solidFill>
-                    </a:lnL>
-                    <a:lnR w="6350">
-                      <a:solidFill>
-                        <a:srgbClr val="D6DCE2"/>
-                      </a:solidFill>
-                    </a:lnR>
-                    <a:lnT w="6350">
-                      <a:solidFill>
-                        <a:srgbClr val="D6DCE2"/>
-                      </a:solidFill>
-                    </a:lnT>
-                    <a:lnB w="6350">
-                      <a:solidFill>
-                        <a:srgbClr val="D6DCE2"/>
-                      </a:solidFill>
-                    </a:lnB>
-                  </a:tcPr>
-                </a:tc>
-                <a:tc>
-                  <a:txBody>
-                    <a:bodyPr wrap="square"/>
-                    <a:lstStyle/>
-                    <a:p>
-                      <a:pPr algn="l">
-                        <a:spcBef>
-                          <a:spcPts val="0"/>
-                        </a:spcBef>
-                        <a:spcAft>
-                          <a:spcPts val="0"/>
-                        </a:spcAft>
-                        <a:lnSpc>
-                          <a:spcPct val="100000"/>
-                        </a:lnSpc>
-                      </a:pPr>
-                      <a:r>
-                        <a:rPr sz="1200" b="0">
-                          <a:solidFill>
-                            <a:srgbClr val="1C242E"/>
+                      <a:srgbClr val="E7F3F2"/>
+                    </a:solidFill>
+                    <a:lnL w="6350">
+                      <a:solidFill>
+                        <a:srgbClr val="D6DCE2"/>
+                      </a:solidFill>
+                    </a:lnL>
+                    <a:lnR w="6350">
+                      <a:solidFill>
+                        <a:srgbClr val="D6DCE2"/>
+                      </a:solidFill>
+                    </a:lnR>
+                    <a:lnT w="6350">
+                      <a:solidFill>
+                        <a:srgbClr val="D6DCE2"/>
+                      </a:solidFill>
+                    </a:lnT>
+                    <a:lnB w="6350">
+                      <a:solidFill>
+                        <a:srgbClr val="D6DCE2"/>
+                      </a:solidFill>
+                    </a:lnB>
+                  </a:tcPr>
+                </a:tc>
+                <a:tc>
+                  <a:txBody>
+                    <a:bodyPr wrap="square"/>
+                    <a:lstStyle/>
+                    <a:p>
+                      <a:pPr algn="l">
+                        <a:spcBef>
+                          <a:spcPts val="0"/>
+                        </a:spcBef>
+                        <a:spcAft>
+                          <a:spcPts val="0"/>
+                        </a:spcAft>
+                        <a:lnSpc>
+                          <a:spcPct val="100000"/>
+                        </a:lnSpc>
+                      </a:pPr>
+                      <a:r>
+                        <a:rPr sz="1200" b="1">
+                          <a:solidFill>
+                            <a:srgbClr val="0E7A76"/>
                           </a:solidFill>
                           <a:latin typeface="Microsoft YaHei"/>
                           <a:ea typeface="Microsoft YaHei"/>
@@ -29967,62 +29967,62 @@
                   </a:txBody>
                   <a:tcPr marL="54864" marR="54864" marT="27432" marB="18288" anchor="ctr">
                     <a:solidFill>
-                      <a:srgbClr val="FFFFFF"/>
-                    </a:solidFill>
-                    <a:lnL w="6350">
-                      <a:solidFill>
-                        <a:srgbClr val="D6DCE2"/>
-                      </a:solidFill>
-                    </a:lnL>
-                    <a:lnR w="6350">
-                      <a:solidFill>
-                        <a:srgbClr val="D6DCE2"/>
-                      </a:solidFill>
-                    </a:lnR>
-                    <a:lnT w="6350">
-                      <a:solidFill>
-                        <a:srgbClr val="D6DCE2"/>
-                      </a:solidFill>
-                    </a:lnT>
-                    <a:lnB w="6350">
-                      <a:solidFill>
-                        <a:srgbClr val="D6DCE2"/>
-                      </a:solidFill>
-                    </a:lnB>
-                  </a:tcPr>
-                </a:tc>
-                <a:tc>
-                  <a:txBody>
-                    <a:bodyPr wrap="square"/>
-                    <a:lstStyle/>
-                    <a:p>
-                      <a:pPr algn="l">
-                        <a:spcBef>
-                          <a:spcPts val="0"/>
-                        </a:spcBef>
-                        <a:spcAft>
-                          <a:spcPts val="0"/>
-                        </a:spcAft>
-                        <a:lnSpc>
-                          <a:spcPct val="100000"/>
-                        </a:lnSpc>
-                      </a:pPr>
-                      <a:r>
-                        <a:rPr sz="1200" b="0">
-                          <a:solidFill>
-                            <a:srgbClr val="1C242E"/>
-                          </a:solidFill>
-                          <a:latin typeface="Microsoft YaHei"/>
-                          <a:ea typeface="Microsoft YaHei"/>
-                          <a:cs typeface="Microsoft YaHei"/>
-                        </a:rPr>
-                        <a:t>长于 allreduce，和读权重相加</a:t>
-                      </a:r>
-                    </a:p>
-                  </a:txBody>
-                  <a:tcPr marL="54864" marR="54864" marT="27432" marB="18288" anchor="ctr">
-                    <a:solidFill>
-                      <a:srgbClr val="FFFFFF"/>
+                      <a:srgbClr val="E7F3F2"/>
+                    </a:solidFill>
+                    <a:lnL w="6350">
+                      <a:solidFill>
+                        <a:srgbClr val="D6DCE2"/>
+                      </a:solidFill>
+                    </a:lnL>
+                    <a:lnR w="6350">
+                      <a:solidFill>
+                        <a:srgbClr val="D6DCE2"/>
+                      </a:solidFill>
+                    </a:lnR>
+                    <a:lnT w="6350">
+                      <a:solidFill>
+                        <a:srgbClr val="D6DCE2"/>
+                      </a:solidFill>
+                    </a:lnT>
+                    <a:lnB w="6350">
+                      <a:solidFill>
+                        <a:srgbClr val="D6DCE2"/>
+                      </a:solidFill>
+                    </a:lnB>
+                  </a:tcPr>
+                </a:tc>
+                <a:tc>
+                  <a:txBody>
+                    <a:bodyPr wrap="square"/>
+                    <a:lstStyle/>
+                    <a:p>
+                      <a:pPr algn="l">
+                        <a:spcBef>
+                          <a:spcPts val="0"/>
+                        </a:spcBef>
+                        <a:spcAft>
+                          <a:spcPts val="0"/>
+                        </a:spcAft>
+                        <a:lnSpc>
+                          <a:spcPct val="100000"/>
+                        </a:lnSpc>
+                      </a:pPr>
+                      <a:r>
+                        <a:rPr sz="1200" b="1">
+                          <a:solidFill>
+                            <a:srgbClr val="0E7A76"/>
+                          </a:solidFill>
+                          <a:latin typeface="Microsoft YaHei"/>
+                          <a:ea typeface="Microsoft YaHei"/>
+                          <a:cs typeface="Microsoft YaHei"/>
+                        </a:rPr>
+                        <a:t>换入 16.59 毫秒</a:t>
+                      </a:r>
+                    </a:p>
+                  </a:txBody>
+                  <a:tcPr marL="54864" marR="54864" marT="27432" marB="18288" anchor="ctr">
+                    <a:solidFill>
+                      <a:srgbClr val="E7F3F2"/>
                     </a:solidFill>
                     <a:lnL w="6350">
                       <a:solidFill>
@@ -30047,7 +30047,7 @@
                   </a:tcPr>
                 </a:tc>
               </a:tr>
-              <a:tr h="475488">
+              <a:tr h="384048">
                 <a:tc>
                   <a:txBody>
                     <a:bodyPr wrap="square"/>
@@ -30067,7 +30067,7 @@
                       <a:r>
                         <a:rPr sz="1200" b="1">
                           <a:solidFill>
-                            <a:srgbClr val="0E2A47"/>
+                            <a:srgbClr val="0E7A76"/>
                           </a:solidFill>
                           <a:latin typeface="Microsoft YaHei"/>
                           <a:ea typeface="Microsoft YaHei"/>
@@ -30120,9 +30120,9 @@
                         </a:lnSpc>
                       </a:pPr>
                       <a:r>
-                        <a:rPr sz="1200" b="0">
-                          <a:solidFill>
-                            <a:srgbClr val="1C242E"/>
+                        <a:rPr sz="1200" b="1">
+                          <a:solidFill>
+                            <a:srgbClr val="0E7A76"/>
                           </a:solidFill>
                           <a:latin typeface="Microsoft YaHei"/>
                           <a:ea typeface="Microsoft YaHei"/>
@@ -30134,105 +30134,105 @@
                   </a:txBody>
                   <a:tcPr marL="54864" marR="54864" marT="27432" marB="18288" anchor="ctr">
                     <a:solidFill>
-                      <a:srgbClr val="FFFFFF"/>
-                    </a:solidFill>
-                    <a:lnL w="6350">
-                      <a:solidFill>
-                        <a:srgbClr val="D6DCE2"/>
-                      </a:solidFill>
-                    </a:lnL>
-                    <a:lnR w="6350">
-                      <a:solidFill>
-                        <a:srgbClr val="D6DCE2"/>
-                      </a:solidFill>
-                    </a:lnR>
-                    <a:lnT w="6350">
-                      <a:solidFill>
-                        <a:srgbClr val="D6DCE2"/>
-                      </a:solidFill>
-                    </a:lnT>
-                    <a:lnB w="6350">
-                      <a:solidFill>
-                        <a:srgbClr val="D6DCE2"/>
-                      </a:solidFill>
-                    </a:lnB>
-                  </a:tcPr>
-                </a:tc>
-                <a:tc>
-                  <a:txBody>
-                    <a:bodyPr wrap="square"/>
-                    <a:lstStyle/>
-                    <a:p>
-                      <a:pPr algn="l">
-                        <a:spcBef>
-                          <a:spcPts val="0"/>
-                        </a:spcBef>
-                        <a:spcAft>
-                          <a:spcPts val="0"/>
-                        </a:spcAft>
-                        <a:lnSpc>
-                          <a:spcPct val="100000"/>
-                        </a:lnSpc>
-                      </a:pPr>
-                      <a:r>
-                        <a:rPr sz="1200" b="0">
-                          <a:solidFill>
-                            <a:srgbClr val="1C242E"/>
-                          </a:solidFill>
-                          <a:latin typeface="Microsoft YaHei"/>
-                          <a:ea typeface="Microsoft YaHei"/>
-                          <a:cs typeface="Microsoft YaHei"/>
-                        </a:rPr>
-                        <a:t>5.18 GB</a:t>
-                      </a:r>
-                    </a:p>
-                  </a:txBody>
-                  <a:tcPr marL="54864" marR="54864" marT="27432" marB="18288" anchor="ctr">
-                    <a:solidFill>
-                      <a:srgbClr val="FFFFFF"/>
-                    </a:solidFill>
-                    <a:lnL w="6350">
-                      <a:solidFill>
-                        <a:srgbClr val="D6DCE2"/>
-                      </a:solidFill>
-                    </a:lnL>
-                    <a:lnR w="6350">
-                      <a:solidFill>
-                        <a:srgbClr val="D6DCE2"/>
-                      </a:solidFill>
-                    </a:lnR>
-                    <a:lnT w="6350">
-                      <a:solidFill>
-                        <a:srgbClr val="D6DCE2"/>
-                      </a:solidFill>
-                    </a:lnT>
-                    <a:lnB w="6350">
-                      <a:solidFill>
-                        <a:srgbClr val="D6DCE2"/>
-                      </a:solidFill>
-                    </a:lnB>
-                  </a:tcPr>
-                </a:tc>
-                <a:tc>
-                  <a:txBody>
-                    <a:bodyPr wrap="square"/>
-                    <a:lstStyle/>
-                    <a:p>
-                      <a:pPr algn="l">
-                        <a:spcBef>
-                          <a:spcPts val="0"/>
-                        </a:spcBef>
-                        <a:spcAft>
-                          <a:spcPts val="0"/>
-                        </a:spcAft>
-                        <a:lnSpc>
-                          <a:spcPct val="100000"/>
-                        </a:lnSpc>
-                      </a:pPr>
-                      <a:r>
-                        <a:rPr sz="1200" b="0">
-                          <a:solidFill>
-                            <a:srgbClr val="1C242E"/>
+                      <a:srgbClr val="E7F3F2"/>
+                    </a:solidFill>
+                    <a:lnL w="6350">
+                      <a:solidFill>
+                        <a:srgbClr val="D6DCE2"/>
+                      </a:solidFill>
+                    </a:lnL>
+                    <a:lnR w="6350">
+                      <a:solidFill>
+                        <a:srgbClr val="D6DCE2"/>
+                      </a:solidFill>
+                    </a:lnR>
+                    <a:lnT w="6350">
+                      <a:solidFill>
+                        <a:srgbClr val="D6DCE2"/>
+                      </a:solidFill>
+                    </a:lnT>
+                    <a:lnB w="6350">
+                      <a:solidFill>
+                        <a:srgbClr val="D6DCE2"/>
+                      </a:solidFill>
+                    </a:lnB>
+                  </a:tcPr>
+                </a:tc>
+                <a:tc>
+                  <a:txBody>
+                    <a:bodyPr wrap="square"/>
+                    <a:lstStyle/>
+                    <a:p>
+                      <a:pPr algn="l">
+                        <a:spcBef>
+                          <a:spcPts val="0"/>
+                        </a:spcBef>
+                        <a:spcAft>
+                          <a:spcPts val="0"/>
+                        </a:spcAft>
+                        <a:lnSpc>
+                          <a:spcPct val="100000"/>
+                        </a:lnSpc>
+                      </a:pPr>
+                      <a:r>
+                        <a:rPr sz="1200" b="1">
+                          <a:solidFill>
+                            <a:srgbClr val="0E7A76"/>
+                          </a:solidFill>
+                          <a:latin typeface="Microsoft YaHei"/>
+                          <a:ea typeface="Microsoft YaHei"/>
+                          <a:cs typeface="Microsoft YaHei"/>
+                        </a:rPr>
+                        <a:t>16.5</a:t>
+                      </a:r>
+                    </a:p>
+                  </a:txBody>
+                  <a:tcPr marL="54864" marR="54864" marT="27432" marB="18288" anchor="ctr">
+                    <a:solidFill>
+                      <a:srgbClr val="E7F3F2"/>
+                    </a:solidFill>
+                    <a:lnL w="6350">
+                      <a:solidFill>
+                        <a:srgbClr val="D6DCE2"/>
+                      </a:solidFill>
+                    </a:lnL>
+                    <a:lnR w="6350">
+                      <a:solidFill>
+                        <a:srgbClr val="D6DCE2"/>
+                      </a:solidFill>
+                    </a:lnR>
+                    <a:lnT w="6350">
+                      <a:solidFill>
+                        <a:srgbClr val="D6DCE2"/>
+                      </a:solidFill>
+                    </a:lnT>
+                    <a:lnB w="6350">
+                      <a:solidFill>
+                        <a:srgbClr val="D6DCE2"/>
+                      </a:solidFill>
+                    </a:lnB>
+                  </a:tcPr>
+                </a:tc>
+                <a:tc>
+                  <a:txBody>
+                    <a:bodyPr wrap="square"/>
+                    <a:lstStyle/>
+                    <a:p>
+                      <a:pPr algn="l">
+                        <a:spcBef>
+                          <a:spcPts val="0"/>
+                        </a:spcBef>
+                        <a:spcAft>
+                          <a:spcPts val="0"/>
+                        </a:spcAft>
+                        <a:lnSpc>
+                          <a:spcPct val="100000"/>
+                        </a:lnSpc>
+                      </a:pPr>
+                      <a:r>
+                        <a:rPr sz="1200" b="1">
+                          <a:solidFill>
+                            <a:srgbClr val="0E7A76"/>
                           </a:solidFill>
                           <a:latin typeface="Microsoft YaHei"/>
                           <a:ea typeface="Microsoft YaHei"/>
@@ -30244,50 +30244,50 @@
                   </a:txBody>
                   <a:tcPr marL="54864" marR="54864" marT="27432" marB="18288" anchor="ctr">
                     <a:solidFill>
-                      <a:srgbClr val="FFFFFF"/>
-                    </a:solidFill>
-                    <a:lnL w="6350">
-                      <a:solidFill>
-                        <a:srgbClr val="D6DCE2"/>
-                      </a:solidFill>
-                    </a:lnL>
-                    <a:lnR w="6350">
-                      <a:solidFill>
-                        <a:srgbClr val="D6DCE2"/>
-                      </a:solidFill>
-                    </a:lnR>
-                    <a:lnT w="6350">
-                      <a:solidFill>
-                        <a:srgbClr val="D6DCE2"/>
-                      </a:solidFill>
-                    </a:lnT>
-                    <a:lnB w="6350">
-                      <a:solidFill>
-                        <a:srgbClr val="D6DCE2"/>
-                      </a:solidFill>
-                    </a:lnB>
-                  </a:tcPr>
-                </a:tc>
-                <a:tc>
-                  <a:txBody>
-                    <a:bodyPr wrap="square"/>
-                    <a:lstStyle/>
-                    <a:p>
-                      <a:pPr algn="l">
-                        <a:spcBef>
-                          <a:spcPts val="0"/>
-                        </a:spcBef>
-                        <a:spcAft>
-                          <a:spcPts val="0"/>
-                        </a:spcAft>
-                        <a:lnSpc>
-                          <a:spcPct val="100000"/>
-                        </a:lnSpc>
-                      </a:pPr>
-                      <a:r>
-                        <a:rPr sz="1200" b="0">
-                          <a:solidFill>
-                            <a:srgbClr val="1C242E"/>
+                      <a:srgbClr val="E7F3F2"/>
+                    </a:solidFill>
+                    <a:lnL w="6350">
+                      <a:solidFill>
+                        <a:srgbClr val="D6DCE2"/>
+                      </a:solidFill>
+                    </a:lnL>
+                    <a:lnR w="6350">
+                      <a:solidFill>
+                        <a:srgbClr val="D6DCE2"/>
+                      </a:solidFill>
+                    </a:lnR>
+                    <a:lnT w="6350">
+                      <a:solidFill>
+                        <a:srgbClr val="D6DCE2"/>
+                      </a:solidFill>
+                    </a:lnT>
+                    <a:lnB w="6350">
+                      <a:solidFill>
+                        <a:srgbClr val="D6DCE2"/>
+                      </a:solidFill>
+                    </a:lnB>
+                  </a:tcPr>
+                </a:tc>
+                <a:tc>
+                  <a:txBody>
+                    <a:bodyPr wrap="square"/>
+                    <a:lstStyle/>
+                    <a:p>
+                      <a:pPr algn="l">
+                        <a:spcBef>
+                          <a:spcPts val="0"/>
+                        </a:spcBef>
+                        <a:spcAft>
+                          <a:spcPts val="0"/>
+                        </a:spcAft>
+                        <a:lnSpc>
+                          <a:spcPct val="100000"/>
+                        </a:lnSpc>
+                      </a:pPr>
+                      <a:r>
+                        <a:rPr sz="1200" b="1">
+                          <a:solidFill>
+                            <a:srgbClr val="0E7A76"/>
                           </a:solidFill>
                           <a:latin typeface="Microsoft YaHei"/>
                           <a:ea typeface="Microsoft YaHei"/>
@@ -30299,50 +30299,50 @@
                   </a:txBody>
                   <a:tcPr marL="54864" marR="54864" marT="27432" marB="18288" anchor="ctr">
                     <a:solidFill>
-                      <a:srgbClr val="FFFFFF"/>
-                    </a:solidFill>
-                    <a:lnL w="6350">
-                      <a:solidFill>
-                        <a:srgbClr val="D6DCE2"/>
-                      </a:solidFill>
-                    </a:lnL>
-                    <a:lnR w="6350">
-                      <a:solidFill>
-                        <a:srgbClr val="D6DCE2"/>
-                      </a:solidFill>
-                    </a:lnR>
-                    <a:lnT w="6350">
-                      <a:solidFill>
-                        <a:srgbClr val="D6DCE2"/>
-                      </a:solidFill>
-                    </a:lnT>
-                    <a:lnB w="6350">
-                      <a:solidFill>
-                        <a:srgbClr val="D6DCE2"/>
-                      </a:solidFill>
-                    </a:lnB>
-                  </a:tcPr>
-                </a:tc>
-                <a:tc>
-                  <a:txBody>
-                    <a:bodyPr wrap="square"/>
-                    <a:lstStyle/>
-                    <a:p>
-                      <a:pPr algn="l">
-                        <a:spcBef>
-                          <a:spcPts val="0"/>
-                        </a:spcBef>
-                        <a:spcAft>
-                          <a:spcPts val="0"/>
-                        </a:spcAft>
-                        <a:lnSpc>
-                          <a:spcPct val="100000"/>
-                        </a:lnSpc>
-                      </a:pPr>
-                      <a:r>
-                        <a:rPr sz="1200" b="0">
-                          <a:solidFill>
-                            <a:srgbClr val="1C242E"/>
+                      <a:srgbClr val="E7F3F2"/>
+                    </a:solidFill>
+                    <a:lnL w="6350">
+                      <a:solidFill>
+                        <a:srgbClr val="D6DCE2"/>
+                      </a:solidFill>
+                    </a:lnL>
+                    <a:lnR w="6350">
+                      <a:solidFill>
+                        <a:srgbClr val="D6DCE2"/>
+                      </a:solidFill>
+                    </a:lnR>
+                    <a:lnT w="6350">
+                      <a:solidFill>
+                        <a:srgbClr val="D6DCE2"/>
+                      </a:solidFill>
+                    </a:lnT>
+                    <a:lnB w="6350">
+                      <a:solidFill>
+                        <a:srgbClr val="D6DCE2"/>
+                      </a:solidFill>
+                    </a:lnB>
+                  </a:tcPr>
+                </a:tc>
+                <a:tc>
+                  <a:txBody>
+                    <a:bodyPr wrap="square"/>
+                    <a:lstStyle/>
+                    <a:p>
+                      <a:pPr algn="l">
+                        <a:spcBef>
+                          <a:spcPts val="0"/>
+                        </a:spcBef>
+                        <a:spcAft>
+                          <a:spcPts val="0"/>
+                        </a:spcAft>
+                        <a:lnSpc>
+                          <a:spcPct val="100000"/>
+                        </a:lnSpc>
+                      </a:pPr>
+                      <a:r>
+                        <a:rPr sz="1200" b="1">
+                          <a:solidFill>
+                            <a:srgbClr val="0E7A76"/>
                           </a:solidFill>
                           <a:latin typeface="Microsoft YaHei"/>
                           <a:ea typeface="Microsoft YaHei"/>
@@ -30354,50 +30354,50 @@
                   </a:txBody>
                   <a:tcPr marL="54864" marR="54864" marT="27432" marB="18288" anchor="ctr">
                     <a:solidFill>
-                      <a:srgbClr val="FFFFFF"/>
-                    </a:solidFill>
-                    <a:lnL w="6350">
-                      <a:solidFill>
-                        <a:srgbClr val="D6DCE2"/>
-                      </a:solidFill>
-                    </a:lnL>
-                    <a:lnR w="6350">
-                      <a:solidFill>
-                        <a:srgbClr val="D6DCE2"/>
-                      </a:solidFill>
-                    </a:lnR>
-                    <a:lnT w="6350">
-                      <a:solidFill>
-                        <a:srgbClr val="D6DCE2"/>
-                      </a:solidFill>
-                    </a:lnT>
-                    <a:lnB w="6350">
-                      <a:solidFill>
-                        <a:srgbClr val="D6DCE2"/>
-                      </a:solidFill>
-                    </a:lnB>
-                  </a:tcPr>
-                </a:tc>
-                <a:tc>
-                  <a:txBody>
-                    <a:bodyPr wrap="square"/>
-                    <a:lstStyle/>
-                    <a:p>
-                      <a:pPr algn="l">
-                        <a:spcBef>
-                          <a:spcPts val="0"/>
-                        </a:spcBef>
-                        <a:spcAft>
-                          <a:spcPts val="0"/>
-                        </a:spcAft>
-                        <a:lnSpc>
-                          <a:spcPct val="100000"/>
-                        </a:lnSpc>
-                      </a:pPr>
-                      <a:r>
-                        <a:rPr sz="1200" b="0">
-                          <a:solidFill>
-                            <a:srgbClr val="1C242E"/>
+                      <a:srgbClr val="E7F3F2"/>
+                    </a:solidFill>
+                    <a:lnL w="6350">
+                      <a:solidFill>
+                        <a:srgbClr val="D6DCE2"/>
+                      </a:solidFill>
+                    </a:lnL>
+                    <a:lnR w="6350">
+                      <a:solidFill>
+                        <a:srgbClr val="D6DCE2"/>
+                      </a:solidFill>
+                    </a:lnR>
+                    <a:lnT w="6350">
+                      <a:solidFill>
+                        <a:srgbClr val="D6DCE2"/>
+                      </a:solidFill>
+                    </a:lnT>
+                    <a:lnB w="6350">
+                      <a:solidFill>
+                        <a:srgbClr val="D6DCE2"/>
+                      </a:solidFill>
+                    </a:lnB>
+                  </a:tcPr>
+                </a:tc>
+                <a:tc>
+                  <a:txBody>
+                    <a:bodyPr wrap="square"/>
+                    <a:lstStyle/>
+                    <a:p>
+                      <a:pPr algn="l">
+                        <a:spcBef>
+                          <a:spcPts val="0"/>
+                        </a:spcBef>
+                        <a:spcAft>
+                          <a:spcPts val="0"/>
+                        </a:spcAft>
+                        <a:lnSpc>
+                          <a:spcPct val="100000"/>
+                        </a:lnSpc>
+                      </a:pPr>
+                      <a:r>
+                        <a:rPr sz="1200" b="1">
+                          <a:solidFill>
+                            <a:srgbClr val="0E7A76"/>
                           </a:solidFill>
                           <a:latin typeface="Microsoft YaHei"/>
                           <a:ea typeface="Microsoft YaHei"/>
@@ -30409,62 +30409,504 @@
                   </a:txBody>
                   <a:tcPr marL="54864" marR="54864" marT="27432" marB="18288" anchor="ctr">
                     <a:solidFill>
-                      <a:srgbClr val="FFFFFF"/>
-                    </a:solidFill>
-                    <a:lnL w="6350">
-                      <a:solidFill>
-                        <a:srgbClr val="D6DCE2"/>
-                      </a:solidFill>
-                    </a:lnL>
-                    <a:lnR w="6350">
-                      <a:solidFill>
-                        <a:srgbClr val="D6DCE2"/>
-                      </a:solidFill>
-                    </a:lnR>
-                    <a:lnT w="6350">
-                      <a:solidFill>
-                        <a:srgbClr val="D6DCE2"/>
-                      </a:solidFill>
-                    </a:lnT>
-                    <a:lnB w="6350">
-                      <a:solidFill>
-                        <a:srgbClr val="D6DCE2"/>
-                      </a:solidFill>
-                    </a:lnB>
-                  </a:tcPr>
-                </a:tc>
-                <a:tc>
-                  <a:txBody>
-                    <a:bodyPr wrap="square"/>
-                    <a:lstStyle/>
-                    <a:p>
-                      <a:pPr algn="l">
-                        <a:spcBef>
-                          <a:spcPts val="0"/>
-                        </a:spcBef>
-                        <a:spcAft>
-                          <a:spcPts val="0"/>
-                        </a:spcAft>
-                        <a:lnSpc>
-                          <a:spcPct val="100000"/>
-                        </a:lnSpc>
-                      </a:pPr>
-                      <a:r>
-                        <a:rPr sz="1200" b="0">
-                          <a:solidFill>
-                            <a:srgbClr val="1C242E"/>
-                          </a:solidFill>
-                          <a:latin typeface="Microsoft YaHei"/>
-                          <a:ea typeface="Microsoft YaHei"/>
-                          <a:cs typeface="Microsoft YaHei"/>
-                        </a:rPr>
-                        <a:t>长于 allreduce，和读权重相加</a:t>
-                      </a:r>
-                    </a:p>
-                  </a:txBody>
-                  <a:tcPr marL="54864" marR="54864" marT="27432" marB="18288" anchor="ctr">
-                    <a:solidFill>
-                      <a:srgbClr val="FFFFFF"/>
+                      <a:srgbClr val="E7F3F2"/>
+                    </a:solidFill>
+                    <a:lnL w="6350">
+                      <a:solidFill>
+                        <a:srgbClr val="D6DCE2"/>
+                      </a:solidFill>
+                    </a:lnL>
+                    <a:lnR w="6350">
+                      <a:solidFill>
+                        <a:srgbClr val="D6DCE2"/>
+                      </a:solidFill>
+                    </a:lnR>
+                    <a:lnT w="6350">
+                      <a:solidFill>
+                        <a:srgbClr val="D6DCE2"/>
+                      </a:solidFill>
+                    </a:lnT>
+                    <a:lnB w="6350">
+                      <a:solidFill>
+                        <a:srgbClr val="D6DCE2"/>
+                      </a:solidFill>
+                    </a:lnB>
+                  </a:tcPr>
+                </a:tc>
+                <a:tc>
+                  <a:txBody>
+                    <a:bodyPr wrap="square"/>
+                    <a:lstStyle/>
+                    <a:p>
+                      <a:pPr algn="l">
+                        <a:spcBef>
+                          <a:spcPts val="0"/>
+                        </a:spcBef>
+                        <a:spcAft>
+                          <a:spcPts val="0"/>
+                        </a:spcAft>
+                        <a:lnSpc>
+                          <a:spcPct val="100000"/>
+                        </a:lnSpc>
+                      </a:pPr>
+                      <a:r>
+                        <a:rPr sz="1200" b="1">
+                          <a:solidFill>
+                            <a:srgbClr val="0E7A76"/>
+                          </a:solidFill>
+                          <a:latin typeface="Microsoft YaHei"/>
+                          <a:ea typeface="Microsoft YaHei"/>
+                          <a:cs typeface="Microsoft YaHei"/>
+                        </a:rPr>
+                        <a:t>换入 16.59 毫秒</a:t>
+                      </a:r>
+                    </a:p>
+                  </a:txBody>
+                  <a:tcPr marL="54864" marR="54864" marT="27432" marB="18288" anchor="ctr">
+                    <a:solidFill>
+                      <a:srgbClr val="E7F3F2"/>
+                    </a:solidFill>
+                    <a:lnL w="6350">
+                      <a:solidFill>
+                        <a:srgbClr val="D6DCE2"/>
+                      </a:solidFill>
+                    </a:lnL>
+                    <a:lnR w="6350">
+                      <a:solidFill>
+                        <a:srgbClr val="D6DCE2"/>
+                      </a:solidFill>
+                    </a:lnR>
+                    <a:lnT w="6350">
+                      <a:solidFill>
+                        <a:srgbClr val="D6DCE2"/>
+                      </a:solidFill>
+                    </a:lnT>
+                    <a:lnB w="6350">
+                      <a:solidFill>
+                        <a:srgbClr val="D6DCE2"/>
+                      </a:solidFill>
+                    </a:lnB>
+                  </a:tcPr>
+                </a:tc>
+              </a:tr>
+              <a:tr h="384048">
+                <a:tc>
+                  <a:txBody>
+                    <a:bodyPr wrap="square"/>
+                    <a:lstStyle/>
+                    <a:p>
+                      <a:pPr algn="l">
+                        <a:spcBef>
+                          <a:spcPts val="0"/>
+                        </a:spcBef>
+                        <a:spcAft>
+                          <a:spcPts val="0"/>
+                        </a:spcAft>
+                        <a:lnSpc>
+                          <a:spcPct val="100000"/>
+                        </a:lnSpc>
+                      </a:pPr>
+                      <a:r>
+                        <a:rPr sz="1200" b="1">
+                          <a:solidFill>
+                            <a:srgbClr val="0E7A76"/>
+                          </a:solidFill>
+                          <a:latin typeface="Microsoft YaHei"/>
+                          <a:ea typeface="Microsoft YaHei"/>
+                          <a:cs typeface="Microsoft YaHei"/>
+                        </a:rPr>
+                        <a:t>1.67×10^6</a:t>
+                      </a:r>
+                    </a:p>
+                  </a:txBody>
+                  <a:tcPr marL="54864" marR="54864" marT="27432" marB="18288" anchor="ctr">
+                    <a:solidFill>
+                      <a:srgbClr val="F4F7FA"/>
+                    </a:solidFill>
+                    <a:lnL w="6350">
+                      <a:solidFill>
+                        <a:srgbClr val="D6DCE2"/>
+                      </a:solidFill>
+                    </a:lnL>
+                    <a:lnR w="6350">
+                      <a:solidFill>
+                        <a:srgbClr val="D6DCE2"/>
+                      </a:solidFill>
+                    </a:lnR>
+                    <a:lnT w="6350">
+                      <a:solidFill>
+                        <a:srgbClr val="D6DCE2"/>
+                      </a:solidFill>
+                    </a:lnT>
+                    <a:lnB w="6350">
+                      <a:solidFill>
+                        <a:srgbClr val="D6DCE2"/>
+                      </a:solidFill>
+                    </a:lnB>
+                  </a:tcPr>
+                </a:tc>
+                <a:tc>
+                  <a:txBody>
+                    <a:bodyPr wrap="square"/>
+                    <a:lstStyle/>
+                    <a:p>
+                      <a:pPr algn="l">
+                        <a:spcBef>
+                          <a:spcPts val="0"/>
+                        </a:spcBef>
+                        <a:spcAft>
+                          <a:spcPts val="0"/>
+                        </a:spcAft>
+                        <a:lnSpc>
+                          <a:spcPct val="100000"/>
+                        </a:lnSpc>
+                      </a:pPr>
+                      <a:r>
+                        <a:rPr sz="1200" b="1">
+                          <a:solidFill>
+                            <a:srgbClr val="0E7A76"/>
+                          </a:solidFill>
+                          <a:latin typeface="Microsoft YaHei"/>
+                          <a:ea typeface="Microsoft YaHei"/>
+                          <a:cs typeface="Microsoft YaHei"/>
+                        </a:rPr>
+                        <a:t>1333</a:t>
+                      </a:r>
+                    </a:p>
+                  </a:txBody>
+                  <a:tcPr marL="54864" marR="54864" marT="27432" marB="18288" anchor="ctr">
+                    <a:solidFill>
+                      <a:srgbClr val="E7F3F2"/>
+                    </a:solidFill>
+                    <a:lnL w="6350">
+                      <a:solidFill>
+                        <a:srgbClr val="D6DCE2"/>
+                      </a:solidFill>
+                    </a:lnL>
+                    <a:lnR w="6350">
+                      <a:solidFill>
+                        <a:srgbClr val="D6DCE2"/>
+                      </a:solidFill>
+                    </a:lnR>
+                    <a:lnT w="6350">
+                      <a:solidFill>
+                        <a:srgbClr val="D6DCE2"/>
+                      </a:solidFill>
+                    </a:lnT>
+                    <a:lnB w="6350">
+                      <a:solidFill>
+                        <a:srgbClr val="D6DCE2"/>
+                      </a:solidFill>
+                    </a:lnB>
+                  </a:tcPr>
+                </a:tc>
+                <a:tc>
+                  <a:txBody>
+                    <a:bodyPr wrap="square"/>
+                    <a:lstStyle/>
+                    <a:p>
+                      <a:pPr algn="l">
+                        <a:spcBef>
+                          <a:spcPts val="0"/>
+                        </a:spcBef>
+                        <a:spcAft>
+                          <a:spcPts val="0"/>
+                        </a:spcAft>
+                        <a:lnSpc>
+                          <a:spcPct val="100000"/>
+                        </a:lnSpc>
+                      </a:pPr>
+                      <a:r>
+                        <a:rPr sz="1200" b="1">
+                          <a:solidFill>
+                            <a:srgbClr val="0E7A76"/>
+                          </a:solidFill>
+                          <a:latin typeface="Microsoft YaHei"/>
+                          <a:ea typeface="Microsoft YaHei"/>
+                          <a:cs typeface="Microsoft YaHei"/>
+                        </a:rPr>
+                        <a:t>10.4</a:t>
+                      </a:r>
+                    </a:p>
+                  </a:txBody>
+                  <a:tcPr marL="54864" marR="54864" marT="27432" marB="18288" anchor="ctr">
+                    <a:solidFill>
+                      <a:srgbClr val="E7F3F2"/>
+                    </a:solidFill>
+                    <a:lnL w="6350">
+                      <a:solidFill>
+                        <a:srgbClr val="D6DCE2"/>
+                      </a:solidFill>
+                    </a:lnL>
+                    <a:lnR w="6350">
+                      <a:solidFill>
+                        <a:srgbClr val="D6DCE2"/>
+                      </a:solidFill>
+                    </a:lnR>
+                    <a:lnT w="6350">
+                      <a:solidFill>
+                        <a:srgbClr val="D6DCE2"/>
+                      </a:solidFill>
+                    </a:lnT>
+                    <a:lnB w="6350">
+                      <a:solidFill>
+                        <a:srgbClr val="D6DCE2"/>
+                      </a:solidFill>
+                    </a:lnB>
+                  </a:tcPr>
+                </a:tc>
+                <a:tc>
+                  <a:txBody>
+                    <a:bodyPr wrap="square"/>
+                    <a:lstStyle/>
+                    <a:p>
+                      <a:pPr algn="l">
+                        <a:spcBef>
+                          <a:spcPts val="0"/>
+                        </a:spcBef>
+                        <a:spcAft>
+                          <a:spcPts val="0"/>
+                        </a:spcAft>
+                        <a:lnSpc>
+                          <a:spcPct val="100000"/>
+                        </a:lnSpc>
+                      </a:pPr>
+                      <a:r>
+                        <a:rPr sz="1200" b="1">
+                          <a:solidFill>
+                            <a:srgbClr val="0E7A76"/>
+                          </a:solidFill>
+                          <a:latin typeface="Microsoft YaHei"/>
+                          <a:ea typeface="Microsoft YaHei"/>
+                          <a:cs typeface="Microsoft YaHei"/>
+                        </a:rPr>
+                        <a:t>48.1%</a:t>
+                      </a:r>
+                    </a:p>
+                  </a:txBody>
+                  <a:tcPr marL="54864" marR="54864" marT="27432" marB="18288" anchor="ctr">
+                    <a:solidFill>
+                      <a:srgbClr val="E7F3F2"/>
+                    </a:solidFill>
+                    <a:lnL w="6350">
+                      <a:solidFill>
+                        <a:srgbClr val="D6DCE2"/>
+                      </a:solidFill>
+                    </a:lnL>
+                    <a:lnR w="6350">
+                      <a:solidFill>
+                        <a:srgbClr val="D6DCE2"/>
+                      </a:solidFill>
+                    </a:lnR>
+                    <a:lnT w="6350">
+                      <a:solidFill>
+                        <a:srgbClr val="D6DCE2"/>
+                      </a:solidFill>
+                    </a:lnT>
+                    <a:lnB w="6350">
+                      <a:solidFill>
+                        <a:srgbClr val="D6DCE2"/>
+                      </a:solidFill>
+                    </a:lnB>
+                  </a:tcPr>
+                </a:tc>
+                <a:tc>
+                  <a:txBody>
+                    <a:bodyPr wrap="square"/>
+                    <a:lstStyle/>
+                    <a:p>
+                      <a:pPr algn="l">
+                        <a:spcBef>
+                          <a:spcPts val="0"/>
+                        </a:spcBef>
+                        <a:spcAft>
+                          <a:spcPts val="0"/>
+                        </a:spcAft>
+                        <a:lnSpc>
+                          <a:spcPct val="100000"/>
+                        </a:lnSpc>
+                      </a:pPr>
+                      <a:r>
+                        <a:rPr sz="1200" b="1">
+                          <a:solidFill>
+                            <a:srgbClr val="0E7A76"/>
+                          </a:solidFill>
+                          <a:latin typeface="Microsoft YaHei"/>
+                          <a:ea typeface="Microsoft YaHei"/>
+                          <a:cs typeface="Microsoft YaHei"/>
+                        </a:rPr>
+                        <a:t>5.31 GB</a:t>
+                      </a:r>
+                    </a:p>
+                  </a:txBody>
+                  <a:tcPr marL="54864" marR="54864" marT="27432" marB="18288" anchor="ctr">
+                    <a:solidFill>
+                      <a:srgbClr val="E7F3F2"/>
+                    </a:solidFill>
+                    <a:lnL w="6350">
+                      <a:solidFill>
+                        <a:srgbClr val="D6DCE2"/>
+                      </a:solidFill>
+                    </a:lnL>
+                    <a:lnR w="6350">
+                      <a:solidFill>
+                        <a:srgbClr val="D6DCE2"/>
+                      </a:solidFill>
+                    </a:lnR>
+                    <a:lnT w="6350">
+                      <a:solidFill>
+                        <a:srgbClr val="D6DCE2"/>
+                      </a:solidFill>
+                    </a:lnT>
+                    <a:lnB w="6350">
+                      <a:solidFill>
+                        <a:srgbClr val="D6DCE2"/>
+                      </a:solidFill>
+                    </a:lnB>
+                  </a:tcPr>
+                </a:tc>
+                <a:tc>
+                  <a:txBody>
+                    <a:bodyPr wrap="square"/>
+                    <a:lstStyle/>
+                    <a:p>
+                      <a:pPr algn="l">
+                        <a:spcBef>
+                          <a:spcPts val="0"/>
+                        </a:spcBef>
+                        <a:spcAft>
+                          <a:spcPts val="0"/>
+                        </a:spcAft>
+                        <a:lnSpc>
+                          <a:spcPct val="100000"/>
+                        </a:lnSpc>
+                      </a:pPr>
+                      <a:r>
+                        <a:rPr sz="1200" b="1">
+                          <a:solidFill>
+                            <a:srgbClr val="0E7A76"/>
+                          </a:solidFill>
+                          <a:latin typeface="Microsoft YaHei"/>
+                          <a:ea typeface="Microsoft YaHei"/>
+                          <a:cs typeface="Microsoft YaHei"/>
+                        </a:rPr>
+                        <a:t>679.36 GB</a:t>
+                      </a:r>
+                    </a:p>
+                  </a:txBody>
+                  <a:tcPr marL="54864" marR="54864" marT="27432" marB="18288" anchor="ctr">
+                    <a:solidFill>
+                      <a:srgbClr val="E7F3F2"/>
+                    </a:solidFill>
+                    <a:lnL w="6350">
+                      <a:solidFill>
+                        <a:srgbClr val="D6DCE2"/>
+                      </a:solidFill>
+                    </a:lnL>
+                    <a:lnR w="6350">
+                      <a:solidFill>
+                        <a:srgbClr val="D6DCE2"/>
+                      </a:solidFill>
+                    </a:lnR>
+                    <a:lnT w="6350">
+                      <a:solidFill>
+                        <a:srgbClr val="D6DCE2"/>
+                      </a:solidFill>
+                    </a:lnT>
+                    <a:lnB w="6350">
+                      <a:solidFill>
+                        <a:srgbClr val="D6DCE2"/>
+                      </a:solidFill>
+                    </a:lnB>
+                  </a:tcPr>
+                </a:tc>
+                <a:tc>
+                  <a:txBody>
+                    <a:bodyPr wrap="square"/>
+                    <a:lstStyle/>
+                    <a:p>
+                      <a:pPr algn="l">
+                        <a:spcBef>
+                          <a:spcPts val="0"/>
+                        </a:spcBef>
+                        <a:spcAft>
+                          <a:spcPts val="0"/>
+                        </a:spcAft>
+                        <a:lnSpc>
+                          <a:spcPct val="100000"/>
+                        </a:lnSpc>
+                      </a:pPr>
+                      <a:r>
+                        <a:rPr sz="1200" b="1">
+                          <a:solidFill>
+                            <a:srgbClr val="0E7A76"/>
+                          </a:solidFill>
+                          <a:latin typeface="Microsoft YaHei"/>
+                          <a:ea typeface="Microsoft YaHei"/>
+                          <a:cs typeface="Microsoft YaHei"/>
+                        </a:rPr>
+                        <a:t>16.59 毫秒</a:t>
+                      </a:r>
+                    </a:p>
+                  </a:txBody>
+                  <a:tcPr marL="54864" marR="54864" marT="27432" marB="18288" anchor="ctr">
+                    <a:solidFill>
+                      <a:srgbClr val="E7F3F2"/>
+                    </a:solidFill>
+                    <a:lnL w="6350">
+                      <a:solidFill>
+                        <a:srgbClr val="D6DCE2"/>
+                      </a:solidFill>
+                    </a:lnL>
+                    <a:lnR w="6350">
+                      <a:solidFill>
+                        <a:srgbClr val="D6DCE2"/>
+                      </a:solidFill>
+                    </a:lnR>
+                    <a:lnT w="6350">
+                      <a:solidFill>
+                        <a:srgbClr val="D6DCE2"/>
+                      </a:solidFill>
+                    </a:lnT>
+                    <a:lnB w="6350">
+                      <a:solidFill>
+                        <a:srgbClr val="D6DCE2"/>
+                      </a:solidFill>
+                    </a:lnB>
+                  </a:tcPr>
+                </a:tc>
+                <a:tc>
+                  <a:txBody>
+                    <a:bodyPr wrap="square"/>
+                    <a:lstStyle/>
+                    <a:p>
+                      <a:pPr algn="l">
+                        <a:spcBef>
+                          <a:spcPts val="0"/>
+                        </a:spcBef>
+                        <a:spcAft>
+                          <a:spcPts val="0"/>
+                        </a:spcAft>
+                        <a:lnSpc>
+                          <a:spcPct val="100000"/>
+                        </a:lnSpc>
+                      </a:pPr>
+                      <a:r>
+                        <a:rPr sz="1200" b="1">
+                          <a:solidFill>
+                            <a:srgbClr val="0E7A76"/>
+                          </a:solidFill>
+                          <a:latin typeface="Microsoft YaHei"/>
+                          <a:ea typeface="Microsoft YaHei"/>
+                          <a:cs typeface="Microsoft YaHei"/>
+                        </a:rPr>
+                        <a:t>换入 16.59 毫秒</a:t>
+                      </a:r>
+                    </a:p>
+                  </a:txBody>
+                  <a:tcPr marL="54864" marR="54864" marT="27432" marB="18288" anchor="ctr">
+                    <a:solidFill>
+                      <a:srgbClr val="E7F3F2"/>
                     </a:solidFill>
                     <a:lnL w="6350">
                       <a:solidFill>
@@ -30502,7 +30944,7 @@
         <p:spPr>
           <a:xfrm>
             <a:off x="384048" y="3383280"/>
-            <a:ext cx="11430000" cy="219456"/>
+            <a:ext cx="11430000" cy="201168"/>
           </a:xfrm>
           <a:prstGeom prst="rect">
             <a:avLst/>
@@ -30530,7 +30972,7 @@
                 <a:ea typeface="Microsoft YaHei"/>
                 <a:cs typeface="Microsoft YaHei"/>
               </a:rPr>
-              <a:t>同一长度上，10 毫秒的批仍全在 HBM</a:t>
+              <a:t>同一批长度上，换入和另外几笔的耗时</a:t>
             </a:r>
           </a:p>
         </p:txBody>
@@ -30544,23 +30986,23 @@
           <p:nvPr/>
         </p:nvGraphicFramePr>
         <p:xfrm>
-          <a:off x="384048" y="3675887"/>
-          <a:ext cx="11430000" cy="1298448"/>
+          <a:off x="384048" y="3712463"/>
+          <a:ext cx="11247120" cy="1645920"/>
         </p:xfrm>
         <a:graphic>
           <a:graphicData uri="http://schemas.openxmlformats.org/drawingml/2006/table">
             <a:tbl>
               <a:tblPr firstRow="1"/>
               <a:tblGrid>
-                <a:gridCol w="1097280"/>
-                <a:gridCol w="1463040"/>
-                <a:gridCol w="1097280"/>
+                <a:gridCol w="1325880"/>
                 <a:gridCol w="1554480"/>
+                <a:gridCol w="1645920"/>
+                <a:gridCol w="1737360"/>
+                <a:gridCol w="1645920"/>
                 <a:gridCol w="1554480"/>
-                <a:gridCol w="2194560"/>
-                <a:gridCol w="2468880"/>
+                <a:gridCol w="1783080"/>
               </a:tblGrid>
-              <a:tr h="310896">
+              <a:tr h="329184">
                 <a:tc>
                   <a:txBody>
                     <a:bodyPr wrap="square"/>
@@ -30641,7 +31083,7 @@
                           <a:ea typeface="Microsoft YaHei"/>
                           <a:cs typeface="Microsoft YaHei"/>
                         </a:rPr>
-                        <a:t>10 毫秒批</a:t>
+                        <a:t>换入</a:t>
                       </a:r>
                     </a:p>
                   </a:txBody>
@@ -30696,7 +31138,7 @@
                           <a:ea typeface="Microsoft YaHei"/>
                           <a:cs typeface="Microsoft YaHei"/>
                         </a:rPr>
-                        <a:t>每卡</a:t>
+                        <a:t>allreduce</a:t>
                       </a:r>
                     </a:p>
                   </a:txBody>
@@ -30751,7 +31193,7 @@
                           <a:ea typeface="Microsoft YaHei"/>
                           <a:cs typeface="Microsoft YaHei"/>
                         </a:rPr>
-                        <a:t>每条存量</a:t>
+                        <a:t>注意力计算</a:t>
                       </a:r>
                     </a:p>
                   </a:txBody>
@@ -30806,7 +31248,7 @@
                           <a:ea typeface="Microsoft YaHei"/>
                           <a:cs typeface="Microsoft YaHei"/>
                         </a:rPr>
-                        <a:t>HBM 能放</a:t>
+                        <a:t>HBM 上的 KV</a:t>
                       </a:r>
                     </a:p>
                   </a:txBody>
@@ -30861,7 +31303,7 @@
                           <a:ea typeface="Microsoft YaHei"/>
                           <a:cs typeface="Microsoft YaHei"/>
                         </a:rPr>
-                        <a:t>每卡换入</a:t>
+                        <a:t>读专家</a:t>
                       </a:r>
                     </a:p>
                   </a:txBody>
@@ -30916,7 +31358,7 @@
                           <a:ea typeface="Microsoft YaHei"/>
                           <a:cs typeface="Microsoft YaHei"/>
                         </a:rPr>
-                        <a:t>换入耗时</a:t>
+                        <a:t>一步</a:t>
                       </a:r>
                     </a:p>
                   </a:txBody>
@@ -31028,7 +31470,7 @@
                           <a:ea typeface="Microsoft YaHei"/>
                           <a:cs typeface="Microsoft YaHei"/>
                         </a:rPr>
-                        <a:t>226</a:t>
+                        <a:t>9.83 毫秒</a:t>
                       </a:r>
                     </a:p>
                   </a:txBody>
@@ -31083,7 +31525,7 @@
                           <a:ea typeface="Microsoft YaHei"/>
                           <a:cs typeface="Microsoft YaHei"/>
                         </a:rPr>
-                        <a:t>1.8</a:t>
+                        <a:t>15.76 毫秒</a:t>
                       </a:r>
                     </a:p>
                   </a:txBody>
@@ -31138,7 +31580,7 @@
                           <a:ea typeface="Microsoft YaHei"/>
                           <a:cs typeface="Microsoft YaHei"/>
                         </a:rPr>
-                        <a:t>1.30 GB</a:t>
+                        <a:t>14.77 毫秒</a:t>
                       </a:r>
                     </a:p>
                   </a:txBody>
@@ -31193,7 +31635,7 @@
                           <a:ea typeface="Microsoft YaHei"/>
                           <a:cs typeface="Microsoft YaHei"/>
                         </a:rPr>
-                        <a:t>4402</a:t>
+                        <a:t>1.98 毫秒</a:t>
                       </a:r>
                     </a:p>
                   </a:txBody>
@@ -31248,7 +31690,7 @@
                           <a:ea typeface="Microsoft YaHei"/>
                           <a:cs typeface="Microsoft YaHei"/>
                         </a:rPr>
-                        <a:t>0</a:t>
+                        <a:t>13.40 毫秒</a:t>
                       </a:r>
                     </a:p>
                   </a:txBody>
@@ -31303,7 +31745,7 @@
                           <a:ea typeface="Microsoft YaHei"/>
                           <a:cs typeface="Microsoft YaHei"/>
                         </a:rPr>
-                        <a:t>0.00 毫秒</a:t>
+                        <a:t>29.17 毫秒</a:t>
                       </a:r>
                     </a:p>
                   </a:txBody>
@@ -31354,7 +31796,7 @@
                       <a:r>
                         <a:rPr sz="1200" b="1">
                           <a:solidFill>
-                            <a:srgbClr val="0E2A47"/>
+                            <a:srgbClr val="0E7A76"/>
                           </a:solidFill>
                           <a:latin typeface="Microsoft YaHei"/>
                           <a:ea typeface="Microsoft YaHei"/>
@@ -31407,296 +31849,296 @@
                         </a:lnSpc>
                       </a:pPr>
                       <a:r>
-                        <a:rPr sz="1200" b="0">
-                          <a:solidFill>
-                            <a:srgbClr val="1C242E"/>
-                          </a:solidFill>
-                          <a:latin typeface="Microsoft YaHei"/>
-                          <a:ea typeface="Microsoft YaHei"/>
-                          <a:cs typeface="Microsoft YaHei"/>
-                        </a:rPr>
-                        <a:t>222</a:t>
-                      </a:r>
-                    </a:p>
-                  </a:txBody>
-                  <a:tcPr marL="54864" marR="54864" marT="27432" marB="18288" anchor="ctr">
-                    <a:solidFill>
-                      <a:srgbClr val="FFFFFF"/>
-                    </a:solidFill>
-                    <a:lnL w="6350">
-                      <a:solidFill>
-                        <a:srgbClr val="D6DCE2"/>
-                      </a:solidFill>
-                    </a:lnL>
-                    <a:lnR w="6350">
-                      <a:solidFill>
-                        <a:srgbClr val="D6DCE2"/>
-                      </a:solidFill>
-                    </a:lnR>
-                    <a:lnT w="6350">
-                      <a:solidFill>
-                        <a:srgbClr val="D6DCE2"/>
-                      </a:solidFill>
-                    </a:lnT>
-                    <a:lnB w="6350">
-                      <a:solidFill>
-                        <a:srgbClr val="D6DCE2"/>
-                      </a:solidFill>
-                    </a:lnB>
-                  </a:tcPr>
-                </a:tc>
-                <a:tc>
-                  <a:txBody>
-                    <a:bodyPr wrap="square"/>
-                    <a:lstStyle/>
-                    <a:p>
-                      <a:pPr algn="l">
-                        <a:spcBef>
-                          <a:spcPts val="0"/>
-                        </a:spcBef>
-                        <a:spcAft>
-                          <a:spcPts val="0"/>
-                        </a:spcAft>
-                        <a:lnSpc>
-                          <a:spcPct val="100000"/>
-                        </a:lnSpc>
-                      </a:pPr>
-                      <a:r>
-                        <a:rPr sz="1200" b="0">
-                          <a:solidFill>
-                            <a:srgbClr val="1C242E"/>
-                          </a:solidFill>
-                          <a:latin typeface="Microsoft YaHei"/>
-                          <a:ea typeface="Microsoft YaHei"/>
-                          <a:cs typeface="Microsoft YaHei"/>
-                        </a:rPr>
-                        <a:t>1.7</a:t>
-                      </a:r>
-                    </a:p>
-                  </a:txBody>
-                  <a:tcPr marL="54864" marR="54864" marT="27432" marB="18288" anchor="ctr">
-                    <a:solidFill>
-                      <a:srgbClr val="FFFFFF"/>
-                    </a:solidFill>
-                    <a:lnL w="6350">
-                      <a:solidFill>
-                        <a:srgbClr val="D6DCE2"/>
-                      </a:solidFill>
-                    </a:lnL>
-                    <a:lnR w="6350">
-                      <a:solidFill>
-                        <a:srgbClr val="D6DCE2"/>
-                      </a:solidFill>
-                    </a:lnR>
-                    <a:lnT w="6350">
-                      <a:solidFill>
-                        <a:srgbClr val="D6DCE2"/>
-                      </a:solidFill>
-                    </a:lnT>
-                    <a:lnB w="6350">
-                      <a:solidFill>
-                        <a:srgbClr val="D6DCE2"/>
-                      </a:solidFill>
-                    </a:lnB>
-                  </a:tcPr>
-                </a:tc>
-                <a:tc>
-                  <a:txBody>
-                    <a:bodyPr wrap="square"/>
-                    <a:lstStyle/>
-                    <a:p>
-                      <a:pPr algn="l">
-                        <a:spcBef>
-                          <a:spcPts val="0"/>
-                        </a:spcBef>
-                        <a:spcAft>
-                          <a:spcPts val="0"/>
-                        </a:spcAft>
-                        <a:lnSpc>
-                          <a:spcPct val="100000"/>
-                        </a:lnSpc>
-                      </a:pPr>
-                      <a:r>
-                        <a:rPr sz="1200" b="0">
-                          <a:solidFill>
-                            <a:srgbClr val="1C242E"/>
-                          </a:solidFill>
-                          <a:latin typeface="Microsoft YaHei"/>
-                          <a:ea typeface="Microsoft YaHei"/>
-                          <a:cs typeface="Microsoft YaHei"/>
-                        </a:rPr>
-                        <a:t>2.59 GB</a:t>
-                      </a:r>
-                    </a:p>
-                  </a:txBody>
-                  <a:tcPr marL="54864" marR="54864" marT="27432" marB="18288" anchor="ctr">
-                    <a:solidFill>
-                      <a:srgbClr val="FFFFFF"/>
-                    </a:solidFill>
-                    <a:lnL w="6350">
-                      <a:solidFill>
-                        <a:srgbClr val="D6DCE2"/>
-                      </a:solidFill>
-                    </a:lnL>
-                    <a:lnR w="6350">
-                      <a:solidFill>
-                        <a:srgbClr val="D6DCE2"/>
-                      </a:solidFill>
-                    </a:lnR>
-                    <a:lnT w="6350">
-                      <a:solidFill>
-                        <a:srgbClr val="D6DCE2"/>
-                      </a:solidFill>
-                    </a:lnT>
-                    <a:lnB w="6350">
-                      <a:solidFill>
-                        <a:srgbClr val="D6DCE2"/>
-                      </a:solidFill>
-                    </a:lnB>
-                  </a:tcPr>
-                </a:tc>
-                <a:tc>
-                  <a:txBody>
-                    <a:bodyPr wrap="square"/>
-                    <a:lstStyle/>
-                    <a:p>
-                      <a:pPr algn="l">
-                        <a:spcBef>
-                          <a:spcPts val="0"/>
-                        </a:spcBef>
-                        <a:spcAft>
-                          <a:spcPts val="0"/>
-                        </a:spcAft>
-                        <a:lnSpc>
-                          <a:spcPct val="100000"/>
-                        </a:lnSpc>
-                      </a:pPr>
-                      <a:r>
-                        <a:rPr sz="1200" b="0">
-                          <a:solidFill>
-                            <a:srgbClr val="1C242E"/>
-                          </a:solidFill>
-                          <a:latin typeface="Microsoft YaHei"/>
-                          <a:ea typeface="Microsoft YaHei"/>
-                          <a:cs typeface="Microsoft YaHei"/>
-                        </a:rPr>
-                        <a:t>2204</a:t>
-                      </a:r>
-                    </a:p>
-                  </a:txBody>
-                  <a:tcPr marL="54864" marR="54864" marT="27432" marB="18288" anchor="ctr">
-                    <a:solidFill>
-                      <a:srgbClr val="FFFFFF"/>
-                    </a:solidFill>
-                    <a:lnL w="6350">
-                      <a:solidFill>
-                        <a:srgbClr val="D6DCE2"/>
-                      </a:solidFill>
-                    </a:lnL>
-                    <a:lnR w="6350">
-                      <a:solidFill>
-                        <a:srgbClr val="D6DCE2"/>
-                      </a:solidFill>
-                    </a:lnR>
-                    <a:lnT w="6350">
-                      <a:solidFill>
-                        <a:srgbClr val="D6DCE2"/>
-                      </a:solidFill>
-                    </a:lnT>
-                    <a:lnB w="6350">
-                      <a:solidFill>
-                        <a:srgbClr val="D6DCE2"/>
-                      </a:solidFill>
-                    </a:lnB>
-                  </a:tcPr>
-                </a:tc>
-                <a:tc>
-                  <a:txBody>
-                    <a:bodyPr wrap="square"/>
-                    <a:lstStyle/>
-                    <a:p>
-                      <a:pPr algn="l">
-                        <a:spcBef>
-                          <a:spcPts val="0"/>
-                        </a:spcBef>
-                        <a:spcAft>
-                          <a:spcPts val="0"/>
-                        </a:spcAft>
-                        <a:lnSpc>
-                          <a:spcPct val="100000"/>
-                        </a:lnSpc>
-                      </a:pPr>
-                      <a:r>
-                        <a:rPr sz="1200" b="0">
-                          <a:solidFill>
-                            <a:srgbClr val="1C242E"/>
-                          </a:solidFill>
-                          <a:latin typeface="Microsoft YaHei"/>
-                          <a:ea typeface="Microsoft YaHei"/>
-                          <a:cs typeface="Microsoft YaHei"/>
-                        </a:rPr>
-                        <a:t>0</a:t>
-                      </a:r>
-                    </a:p>
-                  </a:txBody>
-                  <a:tcPr marL="54864" marR="54864" marT="27432" marB="18288" anchor="ctr">
-                    <a:solidFill>
-                      <a:srgbClr val="FFFFFF"/>
-                    </a:solidFill>
-                    <a:lnL w="6350">
-                      <a:solidFill>
-                        <a:srgbClr val="D6DCE2"/>
-                      </a:solidFill>
-                    </a:lnL>
-                    <a:lnR w="6350">
-                      <a:solidFill>
-                        <a:srgbClr val="D6DCE2"/>
-                      </a:solidFill>
-                    </a:lnR>
-                    <a:lnT w="6350">
-                      <a:solidFill>
-                        <a:srgbClr val="D6DCE2"/>
-                      </a:solidFill>
-                    </a:lnT>
-                    <a:lnB w="6350">
-                      <a:solidFill>
-                        <a:srgbClr val="D6DCE2"/>
-                      </a:solidFill>
-                    </a:lnB>
-                  </a:tcPr>
-                </a:tc>
-                <a:tc>
-                  <a:txBody>
-                    <a:bodyPr wrap="square"/>
-                    <a:lstStyle/>
-                    <a:p>
-                      <a:pPr algn="l">
-                        <a:spcBef>
-                          <a:spcPts val="0"/>
-                        </a:spcBef>
-                        <a:spcAft>
-                          <a:spcPts val="0"/>
-                        </a:spcAft>
-                        <a:lnSpc>
-                          <a:spcPct val="100000"/>
-                        </a:lnSpc>
-                      </a:pPr>
-                      <a:r>
-                        <a:rPr sz="1200" b="0">
-                          <a:solidFill>
-                            <a:srgbClr val="1C242E"/>
-                          </a:solidFill>
-                          <a:latin typeface="Microsoft YaHei"/>
-                          <a:ea typeface="Microsoft YaHei"/>
-                          <a:cs typeface="Microsoft YaHei"/>
-                        </a:rPr>
-                        <a:t>0.00 毫秒</a:t>
-                      </a:r>
-                    </a:p>
-                  </a:txBody>
-                  <a:tcPr marL="54864" marR="54864" marT="27432" marB="18288" anchor="ctr">
-                    <a:solidFill>
-                      <a:srgbClr val="FFFFFF"/>
+                        <a:rPr sz="1200" b="1">
+                          <a:solidFill>
+                            <a:srgbClr val="0E7A76"/>
+                          </a:solidFill>
+                          <a:latin typeface="Microsoft YaHei"/>
+                          <a:ea typeface="Microsoft YaHei"/>
+                          <a:cs typeface="Microsoft YaHei"/>
+                        </a:rPr>
+                        <a:t>16.59 毫秒</a:t>
+                      </a:r>
+                    </a:p>
+                  </a:txBody>
+                  <a:tcPr marL="54864" marR="54864" marT="27432" marB="18288" anchor="ctr">
+                    <a:solidFill>
+                      <a:srgbClr val="E7F3F2"/>
+                    </a:solidFill>
+                    <a:lnL w="6350">
+                      <a:solidFill>
+                        <a:srgbClr val="D6DCE2"/>
+                      </a:solidFill>
+                    </a:lnL>
+                    <a:lnR w="6350">
+                      <a:solidFill>
+                        <a:srgbClr val="D6DCE2"/>
+                      </a:solidFill>
+                    </a:lnR>
+                    <a:lnT w="6350">
+                      <a:solidFill>
+                        <a:srgbClr val="D6DCE2"/>
+                      </a:solidFill>
+                    </a:lnT>
+                    <a:lnB w="6350">
+                      <a:solidFill>
+                        <a:srgbClr val="D6DCE2"/>
+                      </a:solidFill>
+                    </a:lnB>
+                  </a:tcPr>
+                </a:tc>
+                <a:tc>
+                  <a:txBody>
+                    <a:bodyPr wrap="square"/>
+                    <a:lstStyle/>
+                    <a:p>
+                      <a:pPr algn="l">
+                        <a:spcBef>
+                          <a:spcPts val="0"/>
+                        </a:spcBef>
+                        <a:spcAft>
+                          <a:spcPts val="0"/>
+                        </a:spcAft>
+                        <a:lnSpc>
+                          <a:spcPct val="100000"/>
+                        </a:lnSpc>
+                      </a:pPr>
+                      <a:r>
+                        <a:rPr sz="1200" b="1">
+                          <a:solidFill>
+                            <a:srgbClr val="0E7A76"/>
+                          </a:solidFill>
+                          <a:latin typeface="Microsoft YaHei"/>
+                          <a:ea typeface="Microsoft YaHei"/>
+                          <a:cs typeface="Microsoft YaHei"/>
+                        </a:rPr>
+                        <a:t>9.99 毫秒</a:t>
+                      </a:r>
+                    </a:p>
+                  </a:txBody>
+                  <a:tcPr marL="54864" marR="54864" marT="27432" marB="18288" anchor="ctr">
+                    <a:solidFill>
+                      <a:srgbClr val="E7F3F2"/>
+                    </a:solidFill>
+                    <a:lnL w="6350">
+                      <a:solidFill>
+                        <a:srgbClr val="D6DCE2"/>
+                      </a:solidFill>
+                    </a:lnL>
+                    <a:lnR w="6350">
+                      <a:solidFill>
+                        <a:srgbClr val="D6DCE2"/>
+                      </a:solidFill>
+                    </a:lnR>
+                    <a:lnT w="6350">
+                      <a:solidFill>
+                        <a:srgbClr val="D6DCE2"/>
+                      </a:solidFill>
+                    </a:lnT>
+                    <a:lnB w="6350">
+                      <a:solidFill>
+                        <a:srgbClr val="D6DCE2"/>
+                      </a:solidFill>
+                    </a:lnB>
+                  </a:tcPr>
+                </a:tc>
+                <a:tc>
+                  <a:txBody>
+                    <a:bodyPr wrap="square"/>
+                    <a:lstStyle/>
+                    <a:p>
+                      <a:pPr algn="l">
+                        <a:spcBef>
+                          <a:spcPts val="0"/>
+                        </a:spcBef>
+                        <a:spcAft>
+                          <a:spcPts val="0"/>
+                        </a:spcAft>
+                        <a:lnSpc>
+                          <a:spcPct val="100000"/>
+                        </a:lnSpc>
+                      </a:pPr>
+                      <a:r>
+                        <a:rPr sz="1200" b="1">
+                          <a:solidFill>
+                            <a:srgbClr val="0E7A76"/>
+                          </a:solidFill>
+                          <a:latin typeface="Microsoft YaHei"/>
+                          <a:ea typeface="Microsoft YaHei"/>
+                          <a:cs typeface="Microsoft YaHei"/>
+                        </a:rPr>
+                        <a:t>14.54 毫秒</a:t>
+                      </a:r>
+                    </a:p>
+                  </a:txBody>
+                  <a:tcPr marL="54864" marR="54864" marT="27432" marB="18288" anchor="ctr">
+                    <a:solidFill>
+                      <a:srgbClr val="E7F3F2"/>
+                    </a:solidFill>
+                    <a:lnL w="6350">
+                      <a:solidFill>
+                        <a:srgbClr val="D6DCE2"/>
+                      </a:solidFill>
+                    </a:lnL>
+                    <a:lnR w="6350">
+                      <a:solidFill>
+                        <a:srgbClr val="D6DCE2"/>
+                      </a:solidFill>
+                    </a:lnR>
+                    <a:lnT w="6350">
+                      <a:solidFill>
+                        <a:srgbClr val="D6DCE2"/>
+                      </a:solidFill>
+                    </a:lnT>
+                    <a:lnB w="6350">
+                      <a:solidFill>
+                        <a:srgbClr val="D6DCE2"/>
+                      </a:solidFill>
+                    </a:lnB>
+                  </a:tcPr>
+                </a:tc>
+                <a:tc>
+                  <a:txBody>
+                    <a:bodyPr wrap="square"/>
+                    <a:lstStyle/>
+                    <a:p>
+                      <a:pPr algn="l">
+                        <a:spcBef>
+                          <a:spcPts val="0"/>
+                        </a:spcBef>
+                        <a:spcAft>
+                          <a:spcPts val="0"/>
+                        </a:spcAft>
+                        <a:lnSpc>
+                          <a:spcPct val="100000"/>
+                        </a:lnSpc>
+                      </a:pPr>
+                      <a:r>
+                        <a:rPr sz="1200" b="1">
+                          <a:solidFill>
+                            <a:srgbClr val="0E7A76"/>
+                          </a:solidFill>
+                          <a:latin typeface="Microsoft YaHei"/>
+                          <a:ea typeface="Microsoft YaHei"/>
+                          <a:cs typeface="Microsoft YaHei"/>
+                        </a:rPr>
+                        <a:t>1.87 毫秒</a:t>
+                      </a:r>
+                    </a:p>
+                  </a:txBody>
+                  <a:tcPr marL="54864" marR="54864" marT="27432" marB="18288" anchor="ctr">
+                    <a:solidFill>
+                      <a:srgbClr val="E7F3F2"/>
+                    </a:solidFill>
+                    <a:lnL w="6350">
+                      <a:solidFill>
+                        <a:srgbClr val="D6DCE2"/>
+                      </a:solidFill>
+                    </a:lnL>
+                    <a:lnR w="6350">
+                      <a:solidFill>
+                        <a:srgbClr val="D6DCE2"/>
+                      </a:solidFill>
+                    </a:lnR>
+                    <a:lnT w="6350">
+                      <a:solidFill>
+                        <a:srgbClr val="D6DCE2"/>
+                      </a:solidFill>
+                    </a:lnT>
+                    <a:lnB w="6350">
+                      <a:solidFill>
+                        <a:srgbClr val="D6DCE2"/>
+                      </a:solidFill>
+                    </a:lnB>
+                  </a:tcPr>
+                </a:tc>
+                <a:tc>
+                  <a:txBody>
+                    <a:bodyPr wrap="square"/>
+                    <a:lstStyle/>
+                    <a:p>
+                      <a:pPr algn="l">
+                        <a:spcBef>
+                          <a:spcPts val="0"/>
+                        </a:spcBef>
+                        <a:spcAft>
+                          <a:spcPts val="0"/>
+                        </a:spcAft>
+                        <a:lnSpc>
+                          <a:spcPct val="100000"/>
+                        </a:lnSpc>
+                      </a:pPr>
+                      <a:r>
+                        <a:rPr sz="1200" b="1">
+                          <a:solidFill>
+                            <a:srgbClr val="0E7A76"/>
+                          </a:solidFill>
+                          <a:latin typeface="Microsoft YaHei"/>
+                          <a:ea typeface="Microsoft YaHei"/>
+                          <a:cs typeface="Microsoft YaHei"/>
+                        </a:rPr>
+                        <a:t>13.40 毫秒</a:t>
+                      </a:r>
+                    </a:p>
+                  </a:txBody>
+                  <a:tcPr marL="54864" marR="54864" marT="27432" marB="18288" anchor="ctr">
+                    <a:solidFill>
+                      <a:srgbClr val="E7F3F2"/>
+                    </a:solidFill>
+                    <a:lnL w="6350">
+                      <a:solidFill>
+                        <a:srgbClr val="D6DCE2"/>
+                      </a:solidFill>
+                    </a:lnL>
+                    <a:lnR w="6350">
+                      <a:solidFill>
+                        <a:srgbClr val="D6DCE2"/>
+                      </a:solidFill>
+                    </a:lnR>
+                    <a:lnT w="6350">
+                      <a:solidFill>
+                        <a:srgbClr val="D6DCE2"/>
+                      </a:solidFill>
+                    </a:lnT>
+                    <a:lnB w="6350">
+                      <a:solidFill>
+                        <a:srgbClr val="D6DCE2"/>
+                      </a:solidFill>
+                    </a:lnB>
+                  </a:tcPr>
+                </a:tc>
+                <a:tc>
+                  <a:txBody>
+                    <a:bodyPr wrap="square"/>
+                    <a:lstStyle/>
+                    <a:p>
+                      <a:pPr algn="l">
+                        <a:spcBef>
+                          <a:spcPts val="0"/>
+                        </a:spcBef>
+                        <a:spcAft>
+                          <a:spcPts val="0"/>
+                        </a:spcAft>
+                        <a:lnSpc>
+                          <a:spcPct val="100000"/>
+                        </a:lnSpc>
+                      </a:pPr>
+                      <a:r>
+                        <a:rPr sz="1200" b="1">
+                          <a:solidFill>
+                            <a:srgbClr val="0E7A76"/>
+                          </a:solidFill>
+                          <a:latin typeface="Microsoft YaHei"/>
+                          <a:ea typeface="Microsoft YaHei"/>
+                          <a:cs typeface="Microsoft YaHei"/>
+                        </a:rPr>
+                        <a:t>29.99 毫秒</a:t>
+                      </a:r>
+                    </a:p>
+                  </a:txBody>
+                  <a:tcPr marL="54864" marR="54864" marT="27432" marB="18288" anchor="ctr">
+                    <a:solidFill>
+                      <a:srgbClr val="E7F3F2"/>
                     </a:solidFill>
                     <a:lnL w="6350">
                       <a:solidFill>
@@ -31741,7 +32183,7 @@
                       <a:r>
                         <a:rPr sz="1200" b="1">
                           <a:solidFill>
-                            <a:srgbClr val="0E2A47"/>
+                            <a:srgbClr val="0E7A76"/>
                           </a:solidFill>
                           <a:latin typeface="Microsoft YaHei"/>
                           <a:ea typeface="Microsoft YaHei"/>
@@ -31794,296 +32236,683 @@
                         </a:lnSpc>
                       </a:pPr>
                       <a:r>
-                        <a:rPr sz="1200" b="0">
-                          <a:solidFill>
-                            <a:srgbClr val="1C242E"/>
-                          </a:solidFill>
-                          <a:latin typeface="Microsoft YaHei"/>
-                          <a:ea typeface="Microsoft YaHei"/>
-                          <a:cs typeface="Microsoft YaHei"/>
-                        </a:rPr>
-                        <a:t>197</a:t>
-                      </a:r>
-                    </a:p>
-                  </a:txBody>
-                  <a:tcPr marL="54864" marR="54864" marT="27432" marB="18288" anchor="ctr">
-                    <a:solidFill>
-                      <a:srgbClr val="FFFFFF"/>
-                    </a:solidFill>
-                    <a:lnL w="6350">
-                      <a:solidFill>
-                        <a:srgbClr val="D6DCE2"/>
-                      </a:solidFill>
-                    </a:lnL>
-                    <a:lnR w="6350">
-                      <a:solidFill>
-                        <a:srgbClr val="D6DCE2"/>
-                      </a:solidFill>
-                    </a:lnR>
-                    <a:lnT w="6350">
-                      <a:solidFill>
-                        <a:srgbClr val="D6DCE2"/>
-                      </a:solidFill>
-                    </a:lnT>
-                    <a:lnB w="6350">
-                      <a:solidFill>
-                        <a:srgbClr val="D6DCE2"/>
-                      </a:solidFill>
-                    </a:lnB>
-                  </a:tcPr>
-                </a:tc>
-                <a:tc>
-                  <a:txBody>
-                    <a:bodyPr wrap="square"/>
-                    <a:lstStyle/>
-                    <a:p>
-                      <a:pPr algn="l">
-                        <a:spcBef>
-                          <a:spcPts val="0"/>
-                        </a:spcBef>
-                        <a:spcAft>
-                          <a:spcPts val="0"/>
-                        </a:spcAft>
-                        <a:lnSpc>
-                          <a:spcPct val="100000"/>
-                        </a:lnSpc>
-                      </a:pPr>
-                      <a:r>
-                        <a:rPr sz="1200" b="0">
-                          <a:solidFill>
-                            <a:srgbClr val="1C242E"/>
-                          </a:solidFill>
-                          <a:latin typeface="Microsoft YaHei"/>
-                          <a:ea typeface="Microsoft YaHei"/>
-                          <a:cs typeface="Microsoft YaHei"/>
-                        </a:rPr>
-                        <a:t>1.5</a:t>
-                      </a:r>
-                    </a:p>
-                  </a:txBody>
-                  <a:tcPr marL="54864" marR="54864" marT="27432" marB="18288" anchor="ctr">
-                    <a:solidFill>
-                      <a:srgbClr val="FFFFFF"/>
-                    </a:solidFill>
-                    <a:lnL w="6350">
-                      <a:solidFill>
-                        <a:srgbClr val="D6DCE2"/>
-                      </a:solidFill>
-                    </a:lnL>
-                    <a:lnR w="6350">
-                      <a:solidFill>
-                        <a:srgbClr val="D6DCE2"/>
-                      </a:solidFill>
-                    </a:lnR>
-                    <a:lnT w="6350">
-                      <a:solidFill>
-                        <a:srgbClr val="D6DCE2"/>
-                      </a:solidFill>
-                    </a:lnT>
-                    <a:lnB w="6350">
-                      <a:solidFill>
-                        <a:srgbClr val="D6DCE2"/>
-                      </a:solidFill>
-                    </a:lnB>
-                  </a:tcPr>
-                </a:tc>
-                <a:tc>
-                  <a:txBody>
-                    <a:bodyPr wrap="square"/>
-                    <a:lstStyle/>
-                    <a:p>
-                      <a:pPr algn="l">
-                        <a:spcBef>
-                          <a:spcPts val="0"/>
-                        </a:spcBef>
-                        <a:spcAft>
-                          <a:spcPts val="0"/>
-                        </a:spcAft>
-                        <a:lnSpc>
-                          <a:spcPct val="100000"/>
-                        </a:lnSpc>
-                      </a:pPr>
-                      <a:r>
-                        <a:rPr sz="1200" b="0">
-                          <a:solidFill>
-                            <a:srgbClr val="1C242E"/>
-                          </a:solidFill>
-                          <a:latin typeface="Microsoft YaHei"/>
-                          <a:ea typeface="Microsoft YaHei"/>
-                          <a:cs typeface="Microsoft YaHei"/>
-                        </a:rPr>
-                        <a:t>5.18 GB</a:t>
-                      </a:r>
-                    </a:p>
-                  </a:txBody>
-                  <a:tcPr marL="54864" marR="54864" marT="27432" marB="18288" anchor="ctr">
-                    <a:solidFill>
-                      <a:srgbClr val="FFFFFF"/>
-                    </a:solidFill>
-                    <a:lnL w="6350">
-                      <a:solidFill>
-                        <a:srgbClr val="D6DCE2"/>
-                      </a:solidFill>
-                    </a:lnL>
-                    <a:lnR w="6350">
-                      <a:solidFill>
-                        <a:srgbClr val="D6DCE2"/>
-                      </a:solidFill>
-                    </a:lnR>
-                    <a:lnT w="6350">
-                      <a:solidFill>
-                        <a:srgbClr val="D6DCE2"/>
-                      </a:solidFill>
-                    </a:lnT>
-                    <a:lnB w="6350">
-                      <a:solidFill>
-                        <a:srgbClr val="D6DCE2"/>
-                      </a:solidFill>
-                    </a:lnB>
-                  </a:tcPr>
-                </a:tc>
-                <a:tc>
-                  <a:txBody>
-                    <a:bodyPr wrap="square"/>
-                    <a:lstStyle/>
-                    <a:p>
-                      <a:pPr algn="l">
-                        <a:spcBef>
-                          <a:spcPts val="0"/>
-                        </a:spcBef>
-                        <a:spcAft>
-                          <a:spcPts val="0"/>
-                        </a:spcAft>
-                        <a:lnSpc>
-                          <a:spcPct val="100000"/>
-                        </a:lnSpc>
-                      </a:pPr>
-                      <a:r>
-                        <a:rPr sz="1200" b="0">
-                          <a:solidFill>
-                            <a:srgbClr val="1C242E"/>
-                          </a:solidFill>
-                          <a:latin typeface="Microsoft YaHei"/>
-                          <a:ea typeface="Microsoft YaHei"/>
-                          <a:cs typeface="Microsoft YaHei"/>
-                        </a:rPr>
-                        <a:t>1103</a:t>
-                      </a:r>
-                    </a:p>
-                  </a:txBody>
-                  <a:tcPr marL="54864" marR="54864" marT="27432" marB="18288" anchor="ctr">
-                    <a:solidFill>
-                      <a:srgbClr val="FFFFFF"/>
-                    </a:solidFill>
-                    <a:lnL w="6350">
-                      <a:solidFill>
-                        <a:srgbClr val="D6DCE2"/>
-                      </a:solidFill>
-                    </a:lnL>
-                    <a:lnR w="6350">
-                      <a:solidFill>
-                        <a:srgbClr val="D6DCE2"/>
-                      </a:solidFill>
-                    </a:lnR>
-                    <a:lnT w="6350">
-                      <a:solidFill>
-                        <a:srgbClr val="D6DCE2"/>
-                      </a:solidFill>
-                    </a:lnT>
-                    <a:lnB w="6350">
-                      <a:solidFill>
-                        <a:srgbClr val="D6DCE2"/>
-                      </a:solidFill>
-                    </a:lnB>
-                  </a:tcPr>
-                </a:tc>
-                <a:tc>
-                  <a:txBody>
-                    <a:bodyPr wrap="square"/>
-                    <a:lstStyle/>
-                    <a:p>
-                      <a:pPr algn="l">
-                        <a:spcBef>
-                          <a:spcPts val="0"/>
-                        </a:spcBef>
-                        <a:spcAft>
-                          <a:spcPts val="0"/>
-                        </a:spcAft>
-                        <a:lnSpc>
-                          <a:spcPct val="100000"/>
-                        </a:lnSpc>
-                      </a:pPr>
-                      <a:r>
-                        <a:rPr sz="1200" b="0">
-                          <a:solidFill>
-                            <a:srgbClr val="1C242E"/>
-                          </a:solidFill>
-                          <a:latin typeface="Microsoft YaHei"/>
-                          <a:ea typeface="Microsoft YaHei"/>
-                          <a:cs typeface="Microsoft YaHei"/>
-                        </a:rPr>
-                        <a:t>0</a:t>
-                      </a:r>
-                    </a:p>
-                  </a:txBody>
-                  <a:tcPr marL="54864" marR="54864" marT="27432" marB="18288" anchor="ctr">
-                    <a:solidFill>
-                      <a:srgbClr val="FFFFFF"/>
-                    </a:solidFill>
-                    <a:lnL w="6350">
-                      <a:solidFill>
-                        <a:srgbClr val="D6DCE2"/>
-                      </a:solidFill>
-                    </a:lnL>
-                    <a:lnR w="6350">
-                      <a:solidFill>
-                        <a:srgbClr val="D6DCE2"/>
-                      </a:solidFill>
-                    </a:lnR>
-                    <a:lnT w="6350">
-                      <a:solidFill>
-                        <a:srgbClr val="D6DCE2"/>
-                      </a:solidFill>
-                    </a:lnT>
-                    <a:lnB w="6350">
-                      <a:solidFill>
-                        <a:srgbClr val="D6DCE2"/>
-                      </a:solidFill>
-                    </a:lnB>
-                  </a:tcPr>
-                </a:tc>
-                <a:tc>
-                  <a:txBody>
-                    <a:bodyPr wrap="square"/>
-                    <a:lstStyle/>
-                    <a:p>
-                      <a:pPr algn="l">
-                        <a:spcBef>
-                          <a:spcPts val="0"/>
-                        </a:spcBef>
-                        <a:spcAft>
-                          <a:spcPts val="0"/>
-                        </a:spcAft>
-                        <a:lnSpc>
-                          <a:spcPct val="100000"/>
-                        </a:lnSpc>
-                      </a:pPr>
-                      <a:r>
-                        <a:rPr sz="1200" b="0">
-                          <a:solidFill>
-                            <a:srgbClr val="1C242E"/>
-                          </a:solidFill>
-                          <a:latin typeface="Microsoft YaHei"/>
-                          <a:ea typeface="Microsoft YaHei"/>
-                          <a:cs typeface="Microsoft YaHei"/>
-                        </a:rPr>
-                        <a:t>0.00 毫秒</a:t>
-                      </a:r>
-                    </a:p>
-                  </a:txBody>
-                  <a:tcPr marL="54864" marR="54864" marT="27432" marB="18288" anchor="ctr">
-                    <a:solidFill>
-                      <a:srgbClr val="FFFFFF"/>
+                        <a:rPr sz="1200" b="1">
+                          <a:solidFill>
+                            <a:srgbClr val="0E7A76"/>
+                          </a:solidFill>
+                          <a:latin typeface="Microsoft YaHei"/>
+                          <a:ea typeface="Microsoft YaHei"/>
+                          <a:cs typeface="Microsoft YaHei"/>
+                        </a:rPr>
+                        <a:t>16.59 毫秒</a:t>
+                      </a:r>
+                    </a:p>
+                  </a:txBody>
+                  <a:tcPr marL="54864" marR="54864" marT="27432" marB="18288" anchor="ctr">
+                    <a:solidFill>
+                      <a:srgbClr val="E7F3F2"/>
+                    </a:solidFill>
+                    <a:lnL w="6350">
+                      <a:solidFill>
+                        <a:srgbClr val="D6DCE2"/>
+                      </a:solidFill>
+                    </a:lnL>
+                    <a:lnR w="6350">
+                      <a:solidFill>
+                        <a:srgbClr val="D6DCE2"/>
+                      </a:solidFill>
+                    </a:lnR>
+                    <a:lnT w="6350">
+                      <a:solidFill>
+                        <a:srgbClr val="D6DCE2"/>
+                      </a:solidFill>
+                    </a:lnT>
+                    <a:lnB w="6350">
+                      <a:solidFill>
+                        <a:srgbClr val="D6DCE2"/>
+                      </a:solidFill>
+                    </a:lnB>
+                  </a:tcPr>
+                </a:tc>
+                <a:tc>
+                  <a:txBody>
+                    <a:bodyPr wrap="square"/>
+                    <a:lstStyle/>
+                    <a:p>
+                      <a:pPr algn="l">
+                        <a:spcBef>
+                          <a:spcPts val="0"/>
+                        </a:spcBef>
+                        <a:spcAft>
+                          <a:spcPts val="0"/>
+                        </a:spcAft>
+                        <a:lnSpc>
+                          <a:spcPct val="100000"/>
+                        </a:lnSpc>
+                      </a:pPr>
+                      <a:r>
+                        <a:rPr sz="1200" b="1">
+                          <a:solidFill>
+                            <a:srgbClr val="0E7A76"/>
+                          </a:solidFill>
+                          <a:latin typeface="Microsoft YaHei"/>
+                          <a:ea typeface="Microsoft YaHei"/>
+                          <a:cs typeface="Microsoft YaHei"/>
+                        </a:rPr>
+                        <a:t>5.09 毫秒</a:t>
+                      </a:r>
+                    </a:p>
+                  </a:txBody>
+                  <a:tcPr marL="54864" marR="54864" marT="27432" marB="18288" anchor="ctr">
+                    <a:solidFill>
+                      <a:srgbClr val="E7F3F2"/>
+                    </a:solidFill>
+                    <a:lnL w="6350">
+                      <a:solidFill>
+                        <a:srgbClr val="D6DCE2"/>
+                      </a:solidFill>
+                    </a:lnL>
+                    <a:lnR w="6350">
+                      <a:solidFill>
+                        <a:srgbClr val="D6DCE2"/>
+                      </a:solidFill>
+                    </a:lnR>
+                    <a:lnT w="6350">
+                      <a:solidFill>
+                        <a:srgbClr val="D6DCE2"/>
+                      </a:solidFill>
+                    </a:lnT>
+                    <a:lnB w="6350">
+                      <a:solidFill>
+                        <a:srgbClr val="D6DCE2"/>
+                      </a:solidFill>
+                    </a:lnB>
+                  </a:tcPr>
+                </a:tc>
+                <a:tc>
+                  <a:txBody>
+                    <a:bodyPr wrap="square"/>
+                    <a:lstStyle/>
+                    <a:p>
+                      <a:pPr algn="l">
+                        <a:spcBef>
+                          <a:spcPts val="0"/>
+                        </a:spcBef>
+                        <a:spcAft>
+                          <a:spcPts val="0"/>
+                        </a:spcAft>
+                        <a:lnSpc>
+                          <a:spcPct val="100000"/>
+                        </a:lnSpc>
+                      </a:pPr>
+                      <a:r>
+                        <a:rPr sz="1200" b="1">
+                          <a:solidFill>
+                            <a:srgbClr val="0E7A76"/>
+                          </a:solidFill>
+                          <a:latin typeface="Microsoft YaHei"/>
+                          <a:ea typeface="Microsoft YaHei"/>
+                          <a:cs typeface="Microsoft YaHei"/>
+                        </a:rPr>
+                        <a:t>12.87 毫秒</a:t>
+                      </a:r>
+                    </a:p>
+                  </a:txBody>
+                  <a:tcPr marL="54864" marR="54864" marT="27432" marB="18288" anchor="ctr">
+                    <a:solidFill>
+                      <a:srgbClr val="E7F3F2"/>
+                    </a:solidFill>
+                    <a:lnL w="6350">
+                      <a:solidFill>
+                        <a:srgbClr val="D6DCE2"/>
+                      </a:solidFill>
+                    </a:lnL>
+                    <a:lnR w="6350">
+                      <a:solidFill>
+                        <a:srgbClr val="D6DCE2"/>
+                      </a:solidFill>
+                    </a:lnR>
+                    <a:lnT w="6350">
+                      <a:solidFill>
+                        <a:srgbClr val="D6DCE2"/>
+                      </a:solidFill>
+                    </a:lnT>
+                    <a:lnB w="6350">
+                      <a:solidFill>
+                        <a:srgbClr val="D6DCE2"/>
+                      </a:solidFill>
+                    </a:lnB>
+                  </a:tcPr>
+                </a:tc>
+                <a:tc>
+                  <a:txBody>
+                    <a:bodyPr wrap="square"/>
+                    <a:lstStyle/>
+                    <a:p>
+                      <a:pPr algn="l">
+                        <a:spcBef>
+                          <a:spcPts val="0"/>
+                        </a:spcBef>
+                        <a:spcAft>
+                          <a:spcPts val="0"/>
+                        </a:spcAft>
+                        <a:lnSpc>
+                          <a:spcPct val="100000"/>
+                        </a:lnSpc>
+                      </a:pPr>
+                      <a:r>
+                        <a:rPr sz="1200" b="1">
+                          <a:solidFill>
+                            <a:srgbClr val="0E7A76"/>
+                          </a:solidFill>
+                          <a:latin typeface="Microsoft YaHei"/>
+                          <a:ea typeface="Microsoft YaHei"/>
+                          <a:cs typeface="Microsoft YaHei"/>
+                        </a:rPr>
+                        <a:t>1.81 毫秒</a:t>
+                      </a:r>
+                    </a:p>
+                  </a:txBody>
+                  <a:tcPr marL="54864" marR="54864" marT="27432" marB="18288" anchor="ctr">
+                    <a:solidFill>
+                      <a:srgbClr val="E7F3F2"/>
+                    </a:solidFill>
+                    <a:lnL w="6350">
+                      <a:solidFill>
+                        <a:srgbClr val="D6DCE2"/>
+                      </a:solidFill>
+                    </a:lnL>
+                    <a:lnR w="6350">
+                      <a:solidFill>
+                        <a:srgbClr val="D6DCE2"/>
+                      </a:solidFill>
+                    </a:lnR>
+                    <a:lnT w="6350">
+                      <a:solidFill>
+                        <a:srgbClr val="D6DCE2"/>
+                      </a:solidFill>
+                    </a:lnT>
+                    <a:lnB w="6350">
+                      <a:solidFill>
+                        <a:srgbClr val="D6DCE2"/>
+                      </a:solidFill>
+                    </a:lnB>
+                  </a:tcPr>
+                </a:tc>
+                <a:tc>
+                  <a:txBody>
+                    <a:bodyPr wrap="square"/>
+                    <a:lstStyle/>
+                    <a:p>
+                      <a:pPr algn="l">
+                        <a:spcBef>
+                          <a:spcPts val="0"/>
+                        </a:spcBef>
+                        <a:spcAft>
+                          <a:spcPts val="0"/>
+                        </a:spcAft>
+                        <a:lnSpc>
+                          <a:spcPct val="100000"/>
+                        </a:lnSpc>
+                      </a:pPr>
+                      <a:r>
+                        <a:rPr sz="1200" b="1">
+                          <a:solidFill>
+                            <a:srgbClr val="0E7A76"/>
+                          </a:solidFill>
+                          <a:latin typeface="Microsoft YaHei"/>
+                          <a:ea typeface="Microsoft YaHei"/>
+                          <a:cs typeface="Microsoft YaHei"/>
+                        </a:rPr>
+                        <a:t>13.40 毫秒</a:t>
+                      </a:r>
+                    </a:p>
+                  </a:txBody>
+                  <a:tcPr marL="54864" marR="54864" marT="27432" marB="18288" anchor="ctr">
+                    <a:solidFill>
+                      <a:srgbClr val="E7F3F2"/>
+                    </a:solidFill>
+                    <a:lnL w="6350">
+                      <a:solidFill>
+                        <a:srgbClr val="D6DCE2"/>
+                      </a:solidFill>
+                    </a:lnL>
+                    <a:lnR w="6350">
+                      <a:solidFill>
+                        <a:srgbClr val="D6DCE2"/>
+                      </a:solidFill>
+                    </a:lnR>
+                    <a:lnT w="6350">
+                      <a:solidFill>
+                        <a:srgbClr val="D6DCE2"/>
+                      </a:solidFill>
+                    </a:lnT>
+                    <a:lnB w="6350">
+                      <a:solidFill>
+                        <a:srgbClr val="D6DCE2"/>
+                      </a:solidFill>
+                    </a:lnB>
+                  </a:tcPr>
+                </a:tc>
+                <a:tc>
+                  <a:txBody>
+                    <a:bodyPr wrap="square"/>
+                    <a:lstStyle/>
+                    <a:p>
+                      <a:pPr algn="l">
+                        <a:spcBef>
+                          <a:spcPts val="0"/>
+                        </a:spcBef>
+                        <a:spcAft>
+                          <a:spcPts val="0"/>
+                        </a:spcAft>
+                        <a:lnSpc>
+                          <a:spcPct val="100000"/>
+                        </a:lnSpc>
+                      </a:pPr>
+                      <a:r>
+                        <a:rPr sz="1200" b="1">
+                          <a:solidFill>
+                            <a:srgbClr val="0E7A76"/>
+                          </a:solidFill>
+                          <a:latin typeface="Microsoft YaHei"/>
+                          <a:ea typeface="Microsoft YaHei"/>
+                          <a:cs typeface="Microsoft YaHei"/>
+                        </a:rPr>
+                        <a:t>30.00 毫秒</a:t>
+                      </a:r>
+                    </a:p>
+                  </a:txBody>
+                  <a:tcPr marL="54864" marR="54864" marT="27432" marB="18288" anchor="ctr">
+                    <a:solidFill>
+                      <a:srgbClr val="E7F3F2"/>
+                    </a:solidFill>
+                    <a:lnL w="6350">
+                      <a:solidFill>
+                        <a:srgbClr val="D6DCE2"/>
+                      </a:solidFill>
+                    </a:lnL>
+                    <a:lnR w="6350">
+                      <a:solidFill>
+                        <a:srgbClr val="D6DCE2"/>
+                      </a:solidFill>
+                    </a:lnR>
+                    <a:lnT w="6350">
+                      <a:solidFill>
+                        <a:srgbClr val="D6DCE2"/>
+                      </a:solidFill>
+                    </a:lnT>
+                    <a:lnB w="6350">
+                      <a:solidFill>
+                        <a:srgbClr val="D6DCE2"/>
+                      </a:solidFill>
+                    </a:lnB>
+                  </a:tcPr>
+                </a:tc>
+              </a:tr>
+              <a:tr h="329184">
+                <a:tc>
+                  <a:txBody>
+                    <a:bodyPr wrap="square"/>
+                    <a:lstStyle/>
+                    <a:p>
+                      <a:pPr algn="l">
+                        <a:spcBef>
+                          <a:spcPts val="0"/>
+                        </a:spcBef>
+                        <a:spcAft>
+                          <a:spcPts val="0"/>
+                        </a:spcAft>
+                        <a:lnSpc>
+                          <a:spcPct val="100000"/>
+                        </a:lnSpc>
+                      </a:pPr>
+                      <a:r>
+                        <a:rPr sz="1200" b="1">
+                          <a:solidFill>
+                            <a:srgbClr val="0E7A76"/>
+                          </a:solidFill>
+                          <a:latin typeface="Microsoft YaHei"/>
+                          <a:ea typeface="Microsoft YaHei"/>
+                          <a:cs typeface="Microsoft YaHei"/>
+                        </a:rPr>
+                        <a:t>1.67×10^6</a:t>
+                      </a:r>
+                    </a:p>
+                  </a:txBody>
+                  <a:tcPr marL="54864" marR="54864" marT="27432" marB="18288" anchor="ctr">
+                    <a:solidFill>
+                      <a:srgbClr val="F4F7FA"/>
+                    </a:solidFill>
+                    <a:lnL w="6350">
+                      <a:solidFill>
+                        <a:srgbClr val="D6DCE2"/>
+                      </a:solidFill>
+                    </a:lnL>
+                    <a:lnR w="6350">
+                      <a:solidFill>
+                        <a:srgbClr val="D6DCE2"/>
+                      </a:solidFill>
+                    </a:lnR>
+                    <a:lnT w="6350">
+                      <a:solidFill>
+                        <a:srgbClr val="D6DCE2"/>
+                      </a:solidFill>
+                    </a:lnT>
+                    <a:lnB w="6350">
+                      <a:solidFill>
+                        <a:srgbClr val="D6DCE2"/>
+                      </a:solidFill>
+                    </a:lnB>
+                  </a:tcPr>
+                </a:tc>
+                <a:tc>
+                  <a:txBody>
+                    <a:bodyPr wrap="square"/>
+                    <a:lstStyle/>
+                    <a:p>
+                      <a:pPr algn="l">
+                        <a:spcBef>
+                          <a:spcPts val="0"/>
+                        </a:spcBef>
+                        <a:spcAft>
+                          <a:spcPts val="0"/>
+                        </a:spcAft>
+                        <a:lnSpc>
+                          <a:spcPct val="100000"/>
+                        </a:lnSpc>
+                      </a:pPr>
+                      <a:r>
+                        <a:rPr sz="1200" b="1">
+                          <a:solidFill>
+                            <a:srgbClr val="0E7A76"/>
+                          </a:solidFill>
+                          <a:latin typeface="Microsoft YaHei"/>
+                          <a:ea typeface="Microsoft YaHei"/>
+                          <a:cs typeface="Microsoft YaHei"/>
+                        </a:rPr>
+                        <a:t>16.59 毫秒</a:t>
+                      </a:r>
+                    </a:p>
+                  </a:txBody>
+                  <a:tcPr marL="54864" marR="54864" marT="27432" marB="18288" anchor="ctr">
+                    <a:solidFill>
+                      <a:srgbClr val="E7F3F2"/>
+                    </a:solidFill>
+                    <a:lnL w="6350">
+                      <a:solidFill>
+                        <a:srgbClr val="D6DCE2"/>
+                      </a:solidFill>
+                    </a:lnL>
+                    <a:lnR w="6350">
+                      <a:solidFill>
+                        <a:srgbClr val="D6DCE2"/>
+                      </a:solidFill>
+                    </a:lnR>
+                    <a:lnT w="6350">
+                      <a:solidFill>
+                        <a:srgbClr val="D6DCE2"/>
+                      </a:solidFill>
+                    </a:lnT>
+                    <a:lnB w="6350">
+                      <a:solidFill>
+                        <a:srgbClr val="D6DCE2"/>
+                      </a:solidFill>
+                    </a:lnB>
+                  </a:tcPr>
+                </a:tc>
+                <a:tc>
+                  <a:txBody>
+                    <a:bodyPr wrap="square"/>
+                    <a:lstStyle/>
+                    <a:p>
+                      <a:pPr algn="l">
+                        <a:spcBef>
+                          <a:spcPts val="0"/>
+                        </a:spcBef>
+                        <a:spcAft>
+                          <a:spcPts val="0"/>
+                        </a:spcAft>
+                        <a:lnSpc>
+                          <a:spcPct val="100000"/>
+                        </a:lnSpc>
+                      </a:pPr>
+                      <a:r>
+                        <a:rPr sz="1200" b="1">
+                          <a:solidFill>
+                            <a:srgbClr val="0E7A76"/>
+                          </a:solidFill>
+                          <a:latin typeface="Microsoft YaHei"/>
+                          <a:ea typeface="Microsoft YaHei"/>
+                          <a:cs typeface="Microsoft YaHei"/>
+                        </a:rPr>
+                        <a:t>3.21 毫秒</a:t>
+                      </a:r>
+                    </a:p>
+                  </a:txBody>
+                  <a:tcPr marL="54864" marR="54864" marT="27432" marB="18288" anchor="ctr">
+                    <a:solidFill>
+                      <a:srgbClr val="E7F3F2"/>
+                    </a:solidFill>
+                    <a:lnL w="6350">
+                      <a:solidFill>
+                        <a:srgbClr val="D6DCE2"/>
+                      </a:solidFill>
+                    </a:lnL>
+                    <a:lnR w="6350">
+                      <a:solidFill>
+                        <a:srgbClr val="D6DCE2"/>
+                      </a:solidFill>
+                    </a:lnR>
+                    <a:lnT w="6350">
+                      <a:solidFill>
+                        <a:srgbClr val="D6DCE2"/>
+                      </a:solidFill>
+                    </a:lnT>
+                    <a:lnB w="6350">
+                      <a:solidFill>
+                        <a:srgbClr val="D6DCE2"/>
+                      </a:solidFill>
+                    </a:lnB>
+                  </a:tcPr>
+                </a:tc>
+                <a:tc>
+                  <a:txBody>
+                    <a:bodyPr wrap="square"/>
+                    <a:lstStyle/>
+                    <a:p>
+                      <a:pPr algn="l">
+                        <a:spcBef>
+                          <a:spcPts val="0"/>
+                        </a:spcBef>
+                        <a:spcAft>
+                          <a:spcPts val="0"/>
+                        </a:spcAft>
+                        <a:lnSpc>
+                          <a:spcPct val="100000"/>
+                        </a:lnSpc>
+                      </a:pPr>
+                      <a:r>
+                        <a:rPr sz="1200" b="1">
+                          <a:solidFill>
+                            <a:srgbClr val="0E7A76"/>
+                          </a:solidFill>
+                          <a:latin typeface="Microsoft YaHei"/>
+                          <a:ea typeface="Microsoft YaHei"/>
+                          <a:cs typeface="Microsoft YaHei"/>
+                        </a:rPr>
+                        <a:t>12.69 毫秒</a:t>
+                      </a:r>
+                    </a:p>
+                  </a:txBody>
+                  <a:tcPr marL="54864" marR="54864" marT="27432" marB="18288" anchor="ctr">
+                    <a:solidFill>
+                      <a:srgbClr val="E7F3F2"/>
+                    </a:solidFill>
+                    <a:lnL w="6350">
+                      <a:solidFill>
+                        <a:srgbClr val="D6DCE2"/>
+                      </a:solidFill>
+                    </a:lnL>
+                    <a:lnR w="6350">
+                      <a:solidFill>
+                        <a:srgbClr val="D6DCE2"/>
+                      </a:solidFill>
+                    </a:lnR>
+                    <a:lnT w="6350">
+                      <a:solidFill>
+                        <a:srgbClr val="D6DCE2"/>
+                      </a:solidFill>
+                    </a:lnT>
+                    <a:lnB w="6350">
+                      <a:solidFill>
+                        <a:srgbClr val="D6DCE2"/>
+                      </a:solidFill>
+                    </a:lnB>
+                  </a:tcPr>
+                </a:tc>
+                <a:tc>
+                  <a:txBody>
+                    <a:bodyPr wrap="square"/>
+                    <a:lstStyle/>
+                    <a:p>
+                      <a:pPr algn="l">
+                        <a:spcBef>
+                          <a:spcPts val="0"/>
+                        </a:spcBef>
+                        <a:spcAft>
+                          <a:spcPts val="0"/>
+                        </a:spcAft>
+                        <a:lnSpc>
+                          <a:spcPct val="100000"/>
+                        </a:lnSpc>
+                      </a:pPr>
+                      <a:r>
+                        <a:rPr sz="1200" b="1">
+                          <a:solidFill>
+                            <a:srgbClr val="0E7A76"/>
+                          </a:solidFill>
+                          <a:latin typeface="Microsoft YaHei"/>
+                          <a:ea typeface="Microsoft YaHei"/>
+                          <a:cs typeface="Microsoft YaHei"/>
+                        </a:rPr>
+                        <a:t>1.79 毫秒</a:t>
+                      </a:r>
+                    </a:p>
+                  </a:txBody>
+                  <a:tcPr marL="54864" marR="54864" marT="27432" marB="18288" anchor="ctr">
+                    <a:solidFill>
+                      <a:srgbClr val="E7F3F2"/>
+                    </a:solidFill>
+                    <a:lnL w="6350">
+                      <a:solidFill>
+                        <a:srgbClr val="D6DCE2"/>
+                      </a:solidFill>
+                    </a:lnL>
+                    <a:lnR w="6350">
+                      <a:solidFill>
+                        <a:srgbClr val="D6DCE2"/>
+                      </a:solidFill>
+                    </a:lnR>
+                    <a:lnT w="6350">
+                      <a:solidFill>
+                        <a:srgbClr val="D6DCE2"/>
+                      </a:solidFill>
+                    </a:lnT>
+                    <a:lnB w="6350">
+                      <a:solidFill>
+                        <a:srgbClr val="D6DCE2"/>
+                      </a:solidFill>
+                    </a:lnB>
+                  </a:tcPr>
+                </a:tc>
+                <a:tc>
+                  <a:txBody>
+                    <a:bodyPr wrap="square"/>
+                    <a:lstStyle/>
+                    <a:p>
+                      <a:pPr algn="l">
+                        <a:spcBef>
+                          <a:spcPts val="0"/>
+                        </a:spcBef>
+                        <a:spcAft>
+                          <a:spcPts val="0"/>
+                        </a:spcAft>
+                        <a:lnSpc>
+                          <a:spcPct val="100000"/>
+                        </a:lnSpc>
+                      </a:pPr>
+                      <a:r>
+                        <a:rPr sz="1200" b="1">
+                          <a:solidFill>
+                            <a:srgbClr val="0E7A76"/>
+                          </a:solidFill>
+                          <a:latin typeface="Microsoft YaHei"/>
+                          <a:ea typeface="Microsoft YaHei"/>
+                          <a:cs typeface="Microsoft YaHei"/>
+                        </a:rPr>
+                        <a:t>13.40 毫秒</a:t>
+                      </a:r>
+                    </a:p>
+                  </a:txBody>
+                  <a:tcPr marL="54864" marR="54864" marT="27432" marB="18288" anchor="ctr">
+                    <a:solidFill>
+                      <a:srgbClr val="E7F3F2"/>
+                    </a:solidFill>
+                    <a:lnL w="6350">
+                      <a:solidFill>
+                        <a:srgbClr val="D6DCE2"/>
+                      </a:solidFill>
+                    </a:lnL>
+                    <a:lnR w="6350">
+                      <a:solidFill>
+                        <a:srgbClr val="D6DCE2"/>
+                      </a:solidFill>
+                    </a:lnR>
+                    <a:lnT w="6350">
+                      <a:solidFill>
+                        <a:srgbClr val="D6DCE2"/>
+                      </a:solidFill>
+                    </a:lnT>
+                    <a:lnB w="6350">
+                      <a:solidFill>
+                        <a:srgbClr val="D6DCE2"/>
+                      </a:solidFill>
+                    </a:lnB>
+                  </a:tcPr>
+                </a:tc>
+                <a:tc>
+                  <a:txBody>
+                    <a:bodyPr wrap="square"/>
+                    <a:lstStyle/>
+                    <a:p>
+                      <a:pPr algn="l">
+                        <a:spcBef>
+                          <a:spcPts val="0"/>
+                        </a:spcBef>
+                        <a:spcAft>
+                          <a:spcPts val="0"/>
+                        </a:spcAft>
+                        <a:lnSpc>
+                          <a:spcPct val="100000"/>
+                        </a:lnSpc>
+                      </a:pPr>
+                      <a:r>
+                        <a:rPr sz="1200" b="1">
+                          <a:solidFill>
+                            <a:srgbClr val="0E7A76"/>
+                          </a:solidFill>
+                          <a:latin typeface="Microsoft YaHei"/>
+                          <a:ea typeface="Microsoft YaHei"/>
+                          <a:cs typeface="Microsoft YaHei"/>
+                        </a:rPr>
+                        <a:t>29.99 毫秒</a:t>
+                      </a:r>
+                    </a:p>
+                  </a:txBody>
+                  <a:tcPr marL="54864" marR="54864" marT="27432" marB="18288" anchor="ctr">
+                    <a:solidFill>
+                      <a:srgbClr val="E7F3F2"/>
                     </a:solidFill>
                     <a:lnL w="6350">
                       <a:solidFill>
@@ -32120,8 +32949,8 @@
         </p:nvSpPr>
         <p:spPr>
           <a:xfrm>
-            <a:off x="384048" y="5084064"/>
-            <a:ext cx="11430000" cy="1353312"/>
+            <a:off x="384048" y="5522976"/>
+            <a:ext cx="11430000" cy="914400"/>
           </a:xfrm>
           <a:prstGeom prst="roundRect">
             <a:avLst/>
@@ -32163,8 +32992,8 @@
         </p:nvSpPr>
         <p:spPr>
           <a:xfrm>
-            <a:off x="530352" y="5138928"/>
-            <a:ext cx="11137392" cy="1243584"/>
+            <a:off x="530352" y="5559552"/>
+            <a:ext cx="11137392" cy="841248"/>
           </a:xfrm>
           <a:prstGeom prst="rect">
             <a:avLst/>
@@ -32192,7 +33021,7 @@
                 <a:ea typeface="Microsoft YaHei"/>
                 <a:cs typeface="Microsoft YaHei"/>
               </a:rPr>
-              <a:t>每条这一步读的是 30 层压缩 indexer、31 层 HCA、最多 1024 条完整 latent，再加 4.50 MB 固定项，不是整段存量。256K、批 6583：每卡 3.15 GB / 320 GB/s = 9.83 毫秒，128 卡合计 402.56 GB。它短于 allreduce 15.76 毫秒，所以批还是 6583。</a:t>
+              <a:t>稀疏读不是整段存量：30 层压缩 indexer、31 层 HCA、最多 1024 条完整 latent，再加 4.50 MB。带宽 320 GB/s。</a:t>
             </a:r>
           </a:p>
           <a:p>
@@ -32213,7 +33042,7 @@
                 <a:ea typeface="Microsoft YaHei"/>
                 <a:cs typeface="Microsoft YaHei"/>
               </a:rPr>
-              <a:t>512K 的换入升到 16.59 毫秒，和读权重 13.40 毫秒相加，批降到 4163。1M 的换入仍是 16.59 毫秒，批 2115。</a:t>
+              <a:t>10 毫秒到 1.67×10^6 仍全在 HBM，128K 也全在 HBM。这两页只保留溢出大于 0 的长度，后面的分析沿用这个口径。</a:t>
             </a:r>
           </a:p>
         </p:txBody>

</xml_diff>

<commit_message>
docs: route prefix KV hits over the parameter plane
Co-authored-by: 69515164-rgb <69515164-rgb@users.noreply.github.com>
</commit_message>
<xml_diff>
--- a/docs/deepseek-96g-slo.pptx
+++ b/docs/deepseek-96g-slo.pptx
@@ -792,7 +792,7 @@
           <a:lstStyle/>
           <a:p>
             <a:r>
-              <a:t>这一页的批是 128 卡副本上的全局批，每卡条数 = 全局批 / 128。切分与上一页相同：注意力 TP=8、DP=16，MoE EP=128。KV 命中 90%，命中部分在主机 DDR，经每卡 51.2 GB/s 的 H2D 拉到 HBM。每条只现算 10%，这些 query 的平均上下文约为 95%S。Attention = max(prefix pull, HBM, compute, AR)。MoE = dispatch + max(weight, GEMM) + combine。Attention 与 MoE 相加。4K 全局批 6176：现算 2.5297e+06 token，allreduce 6.049s，注意力计算 2.817s，专家计算 3.950s，EP 双向 0.652s，读专家权重 13.40 ms，拉 prefix 17.2 ms，合计 9.999s。再加一条是 10.015s。1M 全局批 6：现算 6.2915e+05，allreduce 4.012s，注意力计算 8.993s（indexer 4.716s），MoE 0.989s，EP 双向 0.163s，拉 prefix 11.4 ms，合计 9.982s。P-D 完整 KV 分层发送：4K 24.41 ms，1M 16.19 ms；尾巴都是 0。固定开销未计入。</a:t>
+              <a:t>这一页的批是 128 卡副本上的全局批，每卡条数 = 全局批 / 128。切分与上一页相同：注意力 TP=8、DP=16，MoE EP=128。KV 命中 90%，命中部分经每卡 40 GB/s 的参数面拉到 HBM。每条只现算 10%，这些 query 的平均上下文约为 95%S。Attention = max(prefix pull, HBM, compute, AR)。MoE = dispatch + max(weight, GEMM) + combine。Attention 与 MoE 相加。4K 全局批 6176：现算 2.5297e+06 token，allreduce 6.049s，注意力计算 2.817s，专家计算 3.950s，EP 双向 0.652s，读专家权重 13.40 ms，拉 prefix 22.0 ms，合计 9.999s。再加一条是 10.015s。1M 全局批 6：现算 6.2915e+05，allreduce 4.012s，注意力计算 8.993s（indexer 4.716s），MoE 0.989s，EP 双向 0.163s，拉 prefix 14.6 ms，合计 9.982s。P-D 完整 KV 分层发送：4K 24.41 ms，1M 16.19 ms；尾巴都是 0。固定开销未计入。</a:t>
             </a:r>
           </a:p>
         </p:txBody>
@@ -7263,7 +7263,7 @@
                 <a:ea typeface="Microsoft YaHei"/>
                 <a:cs typeface="Microsoft YaHei"/>
               </a:rPr>
-              <a:t>本页所有时间已经包含完整 61 层。90% prefix 在主机 DDR，Decode 没有副本。</a:t>
+              <a:t>本页所有时间已经包含完整 61 层。90% prefix 经参数面拉取，Decode 没有副本。</a:t>
             </a:r>
           </a:p>
         </p:txBody>
@@ -7704,7 +7704,7 @@
                           <a:ea typeface="Microsoft YaHei"/>
                           <a:cs typeface="Microsoft YaHei"/>
                         </a:rPr>
-                        <a:t>⌈BS/16⌉ × 0.9S × 4939.5 / (8 × 51.2 GB/s)</a:t>
+                        <a:t>⌈BS/16⌉ × 0.9S × 4939.5 / (8 × 40 GB/s)</a:t>
                       </a:r>
                     </a:p>
                   </a:txBody>
@@ -7759,7 +7759,7 @@
                           <a:ea typeface="Microsoft YaHei"/>
                           <a:cs typeface="Microsoft YaHei"/>
                         </a:rPr>
-                        <a:t>DDR → H2D → HBM；写入后 kernel 还会读一次</a:t>
+                        <a:t>远端 KV → 参数面 → HBM；写入后 kernel 还会读一次</a:t>
                       </a:r>
                     </a:p>
                   </a:txBody>
@@ -14057,7 +14057,7 @@
                 <a:ea typeface="Microsoft YaHei"/>
                 <a:cs typeface="Microsoft YaHei"/>
               </a:rPr>
-              <a:t>90% prefix 从主机 DDR 经 H2D 拉入 HBM，只现算 10%。Attention 取拉取、融合 kernel、AR 的瓶颈，再加完整 MoE。</a:t>
+              <a:t>90% prefix 经参数面 40 GB/s 拉入 HBM，只现算 10%。Attention 取拉取、融合 kernel、AR 的瓶颈，再加完整 MoE。</a:t>
             </a:r>
           </a:p>
         </p:txBody>
@@ -16431,7 +16431,7 @@
                           <a:ea typeface="Microsoft YaHei"/>
                           <a:cs typeface="Microsoft YaHei"/>
                         </a:rPr>
-                        <a:t>17.2 毫秒</a:t>
+                        <a:t>22.0 毫秒</a:t>
                       </a:r>
                     </a:p>
                   </a:txBody>
@@ -16873,7 +16873,7 @@
                           <a:ea typeface="Microsoft YaHei"/>
                           <a:cs typeface="Microsoft YaHei"/>
                         </a:rPr>
-                        <a:t>17.2 毫秒</a:t>
+                        <a:t>22.0 毫秒</a:t>
                       </a:r>
                     </a:p>
                   </a:txBody>
@@ -17315,7 +17315,7 @@
                           <a:ea typeface="Microsoft YaHei"/>
                           <a:cs typeface="Microsoft YaHei"/>
                         </a:rPr>
-                        <a:t>17.1 毫秒</a:t>
+                        <a:t>21.9 毫秒</a:t>
                       </a:r>
                     </a:p>
                   </a:txBody>
@@ -17757,7 +17757,7 @@
                           <a:ea typeface="Microsoft YaHei"/>
                           <a:cs typeface="Microsoft YaHei"/>
                         </a:rPr>
-                        <a:t>17.1 毫秒</a:t>
+                        <a:t>21.9 毫秒</a:t>
                       </a:r>
                     </a:p>
                   </a:txBody>
@@ -18199,7 +18199,7 @@
                           <a:ea typeface="Microsoft YaHei"/>
                           <a:cs typeface="Microsoft YaHei"/>
                         </a:rPr>
-                        <a:t>17.1 毫秒</a:t>
+                        <a:t>21.9 毫秒</a:t>
                       </a:r>
                     </a:p>
                   </a:txBody>
@@ -18641,7 +18641,7 @@
                           <a:ea typeface="Microsoft YaHei"/>
                           <a:cs typeface="Microsoft YaHei"/>
                         </a:rPr>
-                        <a:t>11.4 毫秒</a:t>
+                        <a:t>14.6 毫秒</a:t>
                       </a:r>
                     </a:p>
                   </a:txBody>
@@ -19083,7 +19083,7 @@
                           <a:ea typeface="Microsoft YaHei"/>
                           <a:cs typeface="Microsoft YaHei"/>
                         </a:rPr>
-                        <a:t>11.4 毫秒</a:t>
+                        <a:t>14.6 毫秒</a:t>
                       </a:r>
                     </a:p>
                   </a:txBody>
@@ -19155,7 +19155,7 @@
                 <a:ea typeface="Microsoft YaHei"/>
                 <a:cs typeface="Microsoft YaHei"/>
               </a:rPr>
-              <a:t>90% prefix 走 H2D：4K 这一批拉取 17.2 毫秒，1M 拉取 11.4 毫秒；均短于 Attention 主瓶颈。</a:t>
+              <a:t>90% prefix 走参数面：4K 这一批拉取 22.0 毫秒，1M 拉取 14.6 毫秒；均短于 Attention 主瓶颈。</a:t>
             </a:r>
           </a:p>
         </p:txBody>
@@ -36239,7 +36239,7 @@
                           <a:ea typeface="Microsoft YaHei"/>
                           <a:cs typeface="Microsoft YaHei"/>
                         </a:rPr>
-                        <a:t>90% prefix 在主机 DDR；Decode 没有副本</a:t>
+                        <a:t>90% prefix 在远端 KV 缓存，经参数面拉取；Decode 没有副本</a:t>
                       </a:r>
                     </a:p>
                   </a:txBody>

</xml_diff>

<commit_message>
docs: add Prefill and Decode HBM occupancy pies
Co-authored-by: 69515164-rgb <69515164-rgb@users.noreply.github.com>
</commit_message>
<xml_diff>
--- a/docs/deepseek-96g-slo.pptx
+++ b/docs/deepseek-96g-slo.pptx
@@ -16,6 +16,8 @@
     <p:sldId id="264" r:id="rId16"/>
     <p:sldId id="265" r:id="rId17"/>
     <p:sldId id="266" r:id="rId18"/>
+    <p:sldId id="267" r:id="rId19"/>
+    <p:sldId id="268" r:id="rId20"/>
   </p:sldIdLst>
   <p:sldSz cx="12191695" cy="6858000" type="screen4x3"/>
   <p:notesSz cx="6858000" cy="9144000"/>
@@ -115,6 +117,972 @@
     </a:lvl9pPr>
   </p:defaultTextStyle>
 </p:presentation>
+</file>
+
+<file path=ppt/charts/chart1.xml><?xml version="1.0" encoding="utf-8"?>
+<c:chartSpace xmlns:c="http://schemas.openxmlformats.org/drawingml/2006/chart" xmlns:a="http://schemas.openxmlformats.org/drawingml/2006/main" xmlns:r="http://schemas.openxmlformats.org/officeDocument/2006/relationships">
+  <c:style val="10"/>
+  <c:chart>
+    <c:autoTitleDeleted val="0"/>
+    <c:plotArea>
+      <c:pieChart>
+        <c:varyColors val="1"/>
+        <c:ser>
+          <c:idx val="0"/>
+          <c:order val="0"/>
+          <c:tx>
+            <c:strRef>
+              <c:f>Sheet1!$B$1</c:f>
+              <c:strCache>
+                <c:ptCount val="1"/>
+                <c:pt idx="0">
+                  <c:v/>
+                </c:pt>
+              </c:strCache>
+            </c:strRef>
+          </c:tx>
+          <c:dPt>
+            <c:idx val="0"/>
+            <c:spPr>
+              <a:solidFill>
+                <a:srgbClr val="0E2A47"/>
+              </a:solidFill>
+              <a:ln>
+                <a:solidFill>
+                  <a:srgbClr val="FFFFFF"/>
+                </a:solidFill>
+              </a:ln>
+            </c:spPr>
+          </c:dPt>
+          <c:dPt>
+            <c:idx val="1"/>
+            <c:spPr>
+              <a:solidFill>
+                <a:srgbClr val="7A541C"/>
+              </a:solidFill>
+              <a:ln>
+                <a:solidFill>
+                  <a:srgbClr val="FFFFFF"/>
+                </a:solidFill>
+              </a:ln>
+            </c:spPr>
+          </c:dPt>
+          <c:dPt>
+            <c:idx val="2"/>
+            <c:spPr>
+              <a:solidFill>
+                <a:srgbClr val="0E7A76"/>
+              </a:solidFill>
+              <a:ln>
+                <a:solidFill>
+                  <a:srgbClr val="FFFFFF"/>
+                </a:solidFill>
+              </a:ln>
+            </c:spPr>
+          </c:dPt>
+          <c:dPt>
+            <c:idx val="3"/>
+            <c:spPr>
+              <a:solidFill>
+                <a:srgbClr val="DCE3E9"/>
+              </a:solidFill>
+              <a:ln>
+                <a:solidFill>
+                  <a:srgbClr val="FFFFFF"/>
+                </a:solidFill>
+              </a:ln>
+            </c:spPr>
+          </c:dPt>
+          <c:cat>
+            <c:strRef>
+              <c:f>Sheet1!$A$2:$A$5</c:f>
+              <c:strCache>
+                <c:ptCount val="4"/>
+                <c:pt idx="0">
+                  <c:v>模型权重</c:v>
+                </c:pt>
+                <c:pt idx="1">
+                  <c:v>系统预留</c:v>
+                </c:pt>
+                <c:pt idx="2">
+                  <c:v>KV cache</c:v>
+                </c:pt>
+                <c:pt idx="3">
+                  <c:v>空闲</c:v>
+                </c:pt>
+              </c:strCache>
+            </c:strRef>
+          </c:cat>
+          <c:val>
+            <c:numRef>
+              <c:f>Sheet1!$B$2:$B$5</c:f>
+              <c:numCache>
+                <c:formatCode>General</c:formatCode>
+                <c:ptCount val="4"/>
+                <c:pt idx="0">
+                  <c:v>45.3127788</c:v>
+                </c:pt>
+                <c:pt idx="1">
+                  <c:v>6.0</c:v>
+                </c:pt>
+                <c:pt idx="2">
+                  <c:v>1.1932032</c:v>
+                </c:pt>
+                <c:pt idx="3">
+                  <c:v>43.494018000000004</c:v>
+                </c:pt>
+              </c:numCache>
+            </c:numRef>
+          </c:val>
+        </c:ser>
+        <c:dLbls>
+          <c:numFmt formatCode="0.0%" sourceLinked="0"/>
+          <c:txPr>
+            <a:bodyPr/>
+            <a:lstStyle/>
+            <a:p>
+              <a:pPr>
+                <a:defRPr sz="900" b="1">
+                  <a:solidFill>
+                    <a:srgbClr val="1C242E"/>
+                  </a:solidFill>
+                  <a:latin typeface="Microsoft YaHei"/>
+                </a:defRPr>
+              </a:pPr>
+            </a:p>
+          </c:txPr>
+          <c:dLblPos val="outEnd"/>
+          <c:showLegendKey val="0"/>
+          <c:showVal val="0"/>
+          <c:showCatName val="1"/>
+          <c:showSerName val="0"/>
+          <c:showPercent val="1"/>
+          <c:showBubbleSize val="0"/>
+          <c:showLeaderLines val="1"/>
+        </c:dLbls>
+      </c:pieChart>
+    </c:plotArea>
+    <c:dispBlanksAs val="gap"/>
+  </c:chart>
+  <c:txPr>
+    <a:bodyPr/>
+    <a:lstStyle/>
+    <a:p>
+      <a:pPr>
+        <a:defRPr sz="1800"/>
+      </a:pPr>
+      <a:endParaRPr lang="en-US"/>
+    </a:p>
+  </c:txPr>
+  <c:externalData r:id="rId1">
+    <c:autoUpdate val="0"/>
+  </c:externalData>
+</c:chartSpace>
+</file>
+
+<file path=ppt/charts/chart2.xml><?xml version="1.0" encoding="utf-8"?>
+<c:chartSpace xmlns:c="http://schemas.openxmlformats.org/drawingml/2006/chart" xmlns:a="http://schemas.openxmlformats.org/drawingml/2006/main" xmlns:r="http://schemas.openxmlformats.org/officeDocument/2006/relationships">
+  <c:style val="10"/>
+  <c:chart>
+    <c:autoTitleDeleted val="0"/>
+    <c:plotArea>
+      <c:pieChart>
+        <c:varyColors val="1"/>
+        <c:ser>
+          <c:idx val="0"/>
+          <c:order val="0"/>
+          <c:tx>
+            <c:strRef>
+              <c:f>Sheet1!$B$1</c:f>
+              <c:strCache>
+                <c:ptCount val="1"/>
+                <c:pt idx="0">
+                  <c:v/>
+                </c:pt>
+              </c:strCache>
+            </c:strRef>
+          </c:tx>
+          <c:dPt>
+            <c:idx val="0"/>
+            <c:spPr>
+              <a:solidFill>
+                <a:srgbClr val="0E2A47"/>
+              </a:solidFill>
+              <a:ln>
+                <a:solidFill>
+                  <a:srgbClr val="FFFFFF"/>
+                </a:solidFill>
+              </a:ln>
+            </c:spPr>
+          </c:dPt>
+          <c:dPt>
+            <c:idx val="1"/>
+            <c:spPr>
+              <a:solidFill>
+                <a:srgbClr val="7A541C"/>
+              </a:solidFill>
+              <a:ln>
+                <a:solidFill>
+                  <a:srgbClr val="FFFFFF"/>
+                </a:solidFill>
+              </a:ln>
+            </c:spPr>
+          </c:dPt>
+          <c:dPt>
+            <c:idx val="2"/>
+            <c:spPr>
+              <a:solidFill>
+                <a:srgbClr val="0E7A76"/>
+              </a:solidFill>
+              <a:ln>
+                <a:solidFill>
+                  <a:srgbClr val="FFFFFF"/>
+                </a:solidFill>
+              </a:ln>
+            </c:spPr>
+          </c:dPt>
+          <c:dPt>
+            <c:idx val="3"/>
+            <c:spPr>
+              <a:solidFill>
+                <a:srgbClr val="DCE3E9"/>
+              </a:solidFill>
+              <a:ln>
+                <a:solidFill>
+                  <a:srgbClr val="FFFFFF"/>
+                </a:solidFill>
+              </a:ln>
+            </c:spPr>
+          </c:dPt>
+          <c:cat>
+            <c:strRef>
+              <c:f>Sheet1!$A$2:$A$5</c:f>
+              <c:strCache>
+                <c:ptCount val="4"/>
+                <c:pt idx="0">
+                  <c:v>模型权重</c:v>
+                </c:pt>
+                <c:pt idx="1">
+                  <c:v>系统预留</c:v>
+                </c:pt>
+                <c:pt idx="2">
+                  <c:v>KV cache</c:v>
+                </c:pt>
+                <c:pt idx="3">
+                  <c:v>空闲</c:v>
+                </c:pt>
+              </c:strCache>
+            </c:strRef>
+          </c:cat>
+          <c:val>
+            <c:numRef>
+              <c:f>Sheet1!$B$2:$B$5</c:f>
+              <c:numCache>
+                <c:formatCode>General</c:formatCode>
+                <c:ptCount val="4"/>
+                <c:pt idx="0">
+                  <c:v>45.3127788</c:v>
+                </c:pt>
+                <c:pt idx="1">
+                  <c:v>6.0</c:v>
+                </c:pt>
+                <c:pt idx="2">
+                  <c:v>0.974518272</c:v>
+                </c:pt>
+                <c:pt idx="3">
+                  <c:v>43.712702928000006</c:v>
+                </c:pt>
+              </c:numCache>
+            </c:numRef>
+          </c:val>
+        </c:ser>
+        <c:dLbls>
+          <c:numFmt formatCode="0.0%" sourceLinked="0"/>
+          <c:txPr>
+            <a:bodyPr/>
+            <a:lstStyle/>
+            <a:p>
+              <a:pPr>
+                <a:defRPr sz="900" b="1">
+                  <a:solidFill>
+                    <a:srgbClr val="1C242E"/>
+                  </a:solidFill>
+                  <a:latin typeface="Microsoft YaHei"/>
+                </a:defRPr>
+              </a:pPr>
+            </a:p>
+          </c:txPr>
+          <c:dLblPos val="outEnd"/>
+          <c:showLegendKey val="0"/>
+          <c:showVal val="0"/>
+          <c:showCatName val="1"/>
+          <c:showSerName val="0"/>
+          <c:showPercent val="1"/>
+          <c:showBubbleSize val="0"/>
+          <c:showLeaderLines val="1"/>
+        </c:dLbls>
+      </c:pieChart>
+    </c:plotArea>
+    <c:dispBlanksAs val="gap"/>
+  </c:chart>
+  <c:txPr>
+    <a:bodyPr/>
+    <a:lstStyle/>
+    <a:p>
+      <a:pPr>
+        <a:defRPr sz="1800"/>
+      </a:pPr>
+      <a:endParaRPr lang="en-US"/>
+    </a:p>
+  </c:txPr>
+  <c:externalData r:id="rId1">
+    <c:autoUpdate val="0"/>
+  </c:externalData>
+</c:chartSpace>
+</file>
+
+<file path=ppt/charts/chart3.xml><?xml version="1.0" encoding="utf-8"?>
+<c:chartSpace xmlns:c="http://schemas.openxmlformats.org/drawingml/2006/chart" xmlns:a="http://schemas.openxmlformats.org/drawingml/2006/main" xmlns:r="http://schemas.openxmlformats.org/officeDocument/2006/relationships">
+  <c:style val="10"/>
+  <c:chart>
+    <c:autoTitleDeleted val="0"/>
+    <c:plotArea>
+      <c:pieChart>
+        <c:varyColors val="1"/>
+        <c:ser>
+          <c:idx val="0"/>
+          <c:order val="0"/>
+          <c:tx>
+            <c:strRef>
+              <c:f>Sheet1!$B$1</c:f>
+              <c:strCache>
+                <c:ptCount val="1"/>
+                <c:pt idx="0">
+                  <c:v/>
+                </c:pt>
+              </c:strCache>
+            </c:strRef>
+          </c:tx>
+          <c:dPt>
+            <c:idx val="0"/>
+            <c:spPr>
+              <a:solidFill>
+                <a:srgbClr val="0E2A47"/>
+              </a:solidFill>
+              <a:ln>
+                <a:solidFill>
+                  <a:srgbClr val="FFFFFF"/>
+                </a:solidFill>
+              </a:ln>
+            </c:spPr>
+          </c:dPt>
+          <c:dPt>
+            <c:idx val="1"/>
+            <c:spPr>
+              <a:solidFill>
+                <a:srgbClr val="7A541C"/>
+              </a:solidFill>
+              <a:ln>
+                <a:solidFill>
+                  <a:srgbClr val="FFFFFF"/>
+                </a:solidFill>
+              </a:ln>
+            </c:spPr>
+          </c:dPt>
+          <c:dPt>
+            <c:idx val="2"/>
+            <c:spPr>
+              <a:solidFill>
+                <a:srgbClr val="0E7A76"/>
+              </a:solidFill>
+              <a:ln>
+                <a:solidFill>
+                  <a:srgbClr val="FFFFFF"/>
+                </a:solidFill>
+              </a:ln>
+            </c:spPr>
+          </c:dPt>
+          <c:dPt>
+            <c:idx val="3"/>
+            <c:spPr>
+              <a:solidFill>
+                <a:srgbClr val="DCE3E9"/>
+              </a:solidFill>
+              <a:ln>
+                <a:solidFill>
+                  <a:srgbClr val="FFFFFF"/>
+                </a:solidFill>
+              </a:ln>
+            </c:spPr>
+          </c:dPt>
+          <c:cat>
+            <c:strRef>
+              <c:f>Sheet1!$A$2:$A$5</c:f>
+              <c:strCache>
+                <c:ptCount val="4"/>
+                <c:pt idx="0">
+                  <c:v>模型权重</c:v>
+                </c:pt>
+                <c:pt idx="1">
+                  <c:v>系统预留</c:v>
+                </c:pt>
+                <c:pt idx="2">
+                  <c:v>KV cache</c:v>
+                </c:pt>
+                <c:pt idx="3">
+                  <c:v>空闲</c:v>
+                </c:pt>
+              </c:strCache>
+            </c:strRef>
+          </c:cat>
+          <c:val>
+            <c:numRef>
+              <c:f>Sheet1!$B$2:$B$5</c:f>
+              <c:numCache>
+                <c:formatCode>General</c:formatCode>
+                <c:ptCount val="4"/>
+                <c:pt idx="0">
+                  <c:v>45.3127788</c:v>
+                </c:pt>
+                <c:pt idx="1">
+                  <c:v>6.0</c:v>
+                </c:pt>
+                <c:pt idx="2">
+                  <c:v>0.64799232</c:v>
+                </c:pt>
+                <c:pt idx="3">
+                  <c:v>44.03922888</c:v>
+                </c:pt>
+              </c:numCache>
+            </c:numRef>
+          </c:val>
+        </c:ser>
+        <c:dLbls>
+          <c:numFmt formatCode="0.0%" sourceLinked="0"/>
+          <c:txPr>
+            <a:bodyPr/>
+            <a:lstStyle/>
+            <a:p>
+              <a:pPr>
+                <a:defRPr sz="900" b="1">
+                  <a:solidFill>
+                    <a:srgbClr val="1C242E"/>
+                  </a:solidFill>
+                  <a:latin typeface="Microsoft YaHei"/>
+                </a:defRPr>
+              </a:pPr>
+            </a:p>
+          </c:txPr>
+          <c:dLblPos val="outEnd"/>
+          <c:showLegendKey val="0"/>
+          <c:showVal val="0"/>
+          <c:showCatName val="1"/>
+          <c:showSerName val="0"/>
+          <c:showPercent val="1"/>
+          <c:showBubbleSize val="0"/>
+          <c:showLeaderLines val="1"/>
+        </c:dLbls>
+      </c:pieChart>
+    </c:plotArea>
+    <c:dispBlanksAs val="gap"/>
+  </c:chart>
+  <c:txPr>
+    <a:bodyPr/>
+    <a:lstStyle/>
+    <a:p>
+      <a:pPr>
+        <a:defRPr sz="1800"/>
+      </a:pPr>
+      <a:endParaRPr lang="en-US"/>
+    </a:p>
+  </c:txPr>
+  <c:externalData r:id="rId1">
+    <c:autoUpdate val="0"/>
+  </c:externalData>
+</c:chartSpace>
+</file>
+
+<file path=ppt/charts/chart4.xml><?xml version="1.0" encoding="utf-8"?>
+<c:chartSpace xmlns:c="http://schemas.openxmlformats.org/drawingml/2006/chart" xmlns:a="http://schemas.openxmlformats.org/drawingml/2006/main" xmlns:r="http://schemas.openxmlformats.org/officeDocument/2006/relationships">
+  <c:style val="10"/>
+  <c:chart>
+    <c:autoTitleDeleted val="0"/>
+    <c:plotArea>
+      <c:pieChart>
+        <c:varyColors val="1"/>
+        <c:ser>
+          <c:idx val="0"/>
+          <c:order val="0"/>
+          <c:tx>
+            <c:strRef>
+              <c:f>Sheet1!$B$1</c:f>
+              <c:strCache>
+                <c:ptCount val="1"/>
+                <c:pt idx="0">
+                  <c:v/>
+                </c:pt>
+              </c:strCache>
+            </c:strRef>
+          </c:tx>
+          <c:dPt>
+            <c:idx val="0"/>
+            <c:spPr>
+              <a:solidFill>
+                <a:srgbClr val="0E2A47"/>
+              </a:solidFill>
+              <a:ln>
+                <a:solidFill>
+                  <a:srgbClr val="FFFFFF"/>
+                </a:solidFill>
+              </a:ln>
+            </c:spPr>
+          </c:dPt>
+          <c:dPt>
+            <c:idx val="1"/>
+            <c:spPr>
+              <a:solidFill>
+                <a:srgbClr val="7A541C"/>
+              </a:solidFill>
+              <a:ln>
+                <a:solidFill>
+                  <a:srgbClr val="FFFFFF"/>
+                </a:solidFill>
+              </a:ln>
+            </c:spPr>
+          </c:dPt>
+          <c:dPt>
+            <c:idx val="2"/>
+            <c:spPr>
+              <a:solidFill>
+                <a:srgbClr val="0E7A76"/>
+              </a:solidFill>
+              <a:ln>
+                <a:solidFill>
+                  <a:srgbClr val="FFFFFF"/>
+                </a:solidFill>
+              </a:ln>
+            </c:spPr>
+          </c:dPt>
+          <c:dPt>
+            <c:idx val="3"/>
+            <c:spPr>
+              <a:solidFill>
+                <a:srgbClr val="DCE3E9"/>
+              </a:solidFill>
+              <a:ln>
+                <a:solidFill>
+                  <a:srgbClr val="FFFFFF"/>
+                </a:solidFill>
+              </a:ln>
+            </c:spPr>
+          </c:dPt>
+          <c:cat>
+            <c:strRef>
+              <c:f>Sheet1!$A$2:$A$5</c:f>
+              <c:strCache>
+                <c:ptCount val="4"/>
+                <c:pt idx="0">
+                  <c:v>模型权重</c:v>
+                </c:pt>
+                <c:pt idx="1">
+                  <c:v>系统预留</c:v>
+                </c:pt>
+                <c:pt idx="2">
+                  <c:v>KV cache</c:v>
+                </c:pt>
+                <c:pt idx="3">
+                  <c:v>空闲</c:v>
+                </c:pt>
+              </c:strCache>
+            </c:strRef>
+          </c:cat>
+          <c:val>
+            <c:numRef>
+              <c:f>Sheet1!$B$2:$B$5</c:f>
+              <c:numCache>
+                <c:formatCode>General</c:formatCode>
+                <c:ptCount val="4"/>
+                <c:pt idx="0">
+                  <c:v>45.3127788</c:v>
+                </c:pt>
+                <c:pt idx="1">
+                  <c:v>6.0</c:v>
+                </c:pt>
+                <c:pt idx="2">
+                  <c:v>0.8408064</c:v>
+                </c:pt>
+                <c:pt idx="3">
+                  <c:v>43.846414800000005</c:v>
+                </c:pt>
+              </c:numCache>
+            </c:numRef>
+          </c:val>
+        </c:ser>
+        <c:dLbls>
+          <c:numFmt formatCode="0.0%" sourceLinked="0"/>
+          <c:txPr>
+            <a:bodyPr/>
+            <a:lstStyle/>
+            <a:p>
+              <a:pPr>
+                <a:defRPr sz="900" b="1">
+                  <a:solidFill>
+                    <a:srgbClr val="1C242E"/>
+                  </a:solidFill>
+                  <a:latin typeface="Microsoft YaHei"/>
+                </a:defRPr>
+              </a:pPr>
+            </a:p>
+          </c:txPr>
+          <c:dLblPos val="outEnd"/>
+          <c:showLegendKey val="0"/>
+          <c:showVal val="0"/>
+          <c:showCatName val="1"/>
+          <c:showSerName val="0"/>
+          <c:showPercent val="1"/>
+          <c:showBubbleSize val="0"/>
+          <c:showLeaderLines val="1"/>
+        </c:dLbls>
+      </c:pieChart>
+    </c:plotArea>
+    <c:dispBlanksAs val="gap"/>
+  </c:chart>
+  <c:txPr>
+    <a:bodyPr/>
+    <a:lstStyle/>
+    <a:p>
+      <a:pPr>
+        <a:defRPr sz="1800"/>
+      </a:pPr>
+      <a:endParaRPr lang="en-US"/>
+    </a:p>
+  </c:txPr>
+  <c:externalData r:id="rId1">
+    <c:autoUpdate val="0"/>
+  </c:externalData>
+</c:chartSpace>
+</file>
+
+<file path=ppt/charts/chart5.xml><?xml version="1.0" encoding="utf-8"?>
+<c:chartSpace xmlns:c="http://schemas.openxmlformats.org/drawingml/2006/chart" xmlns:a="http://schemas.openxmlformats.org/drawingml/2006/main" xmlns:r="http://schemas.openxmlformats.org/officeDocument/2006/relationships">
+  <c:style val="10"/>
+  <c:chart>
+    <c:autoTitleDeleted val="0"/>
+    <c:plotArea>
+      <c:pieChart>
+        <c:varyColors val="1"/>
+        <c:ser>
+          <c:idx val="0"/>
+          <c:order val="0"/>
+          <c:tx>
+            <c:strRef>
+              <c:f>Sheet1!$B$1</c:f>
+              <c:strCache>
+                <c:ptCount val="1"/>
+                <c:pt idx="0">
+                  <c:v/>
+                </c:pt>
+              </c:strCache>
+            </c:strRef>
+          </c:tx>
+          <c:dPt>
+            <c:idx val="0"/>
+            <c:spPr>
+              <a:solidFill>
+                <a:srgbClr val="0E2A47"/>
+              </a:solidFill>
+              <a:ln>
+                <a:solidFill>
+                  <a:srgbClr val="FFFFFF"/>
+                </a:solidFill>
+              </a:ln>
+            </c:spPr>
+          </c:dPt>
+          <c:dPt>
+            <c:idx val="1"/>
+            <c:spPr>
+              <a:solidFill>
+                <a:srgbClr val="7A541C"/>
+              </a:solidFill>
+              <a:ln>
+                <a:solidFill>
+                  <a:srgbClr val="FFFFFF"/>
+                </a:solidFill>
+              </a:ln>
+            </c:spPr>
+          </c:dPt>
+          <c:dPt>
+            <c:idx val="2"/>
+            <c:spPr>
+              <a:solidFill>
+                <a:srgbClr val="0E7A76"/>
+              </a:solidFill>
+              <a:ln>
+                <a:solidFill>
+                  <a:srgbClr val="FFFFFF"/>
+                </a:solidFill>
+              </a:ln>
+            </c:spPr>
+          </c:dPt>
+          <c:dPt>
+            <c:idx val="3"/>
+            <c:spPr>
+              <a:solidFill>
+                <a:srgbClr val="DCE3E9"/>
+              </a:solidFill>
+              <a:ln>
+                <a:solidFill>
+                  <a:srgbClr val="FFFFFF"/>
+                </a:solidFill>
+              </a:ln>
+            </c:spPr>
+          </c:dPt>
+          <c:cat>
+            <c:strRef>
+              <c:f>Sheet1!$A$2:$A$5</c:f>
+              <c:strCache>
+                <c:ptCount val="4"/>
+                <c:pt idx="0">
+                  <c:v>模型权重</c:v>
+                </c:pt>
+                <c:pt idx="1">
+                  <c:v>系统预留</c:v>
+                </c:pt>
+                <c:pt idx="2">
+                  <c:v>KV cache</c:v>
+                </c:pt>
+                <c:pt idx="3">
+                  <c:v>空闲</c:v>
+                </c:pt>
+              </c:strCache>
+            </c:strRef>
+          </c:cat>
+          <c:val>
+            <c:numRef>
+              <c:f>Sheet1!$B$2:$B$5</c:f>
+              <c:numCache>
+                <c:formatCode>General</c:formatCode>
+                <c:ptCount val="4"/>
+                <c:pt idx="0">
+                  <c:v>45.3127788</c:v>
+                </c:pt>
+                <c:pt idx="1">
+                  <c:v>6.0</c:v>
+                </c:pt>
+                <c:pt idx="2">
+                  <c:v>44.6872212</c:v>
+                </c:pt>
+                <c:pt idx="3">
+                  <c:v>0.0</c:v>
+                </c:pt>
+              </c:numCache>
+            </c:numRef>
+          </c:val>
+        </c:ser>
+        <c:dLbls>
+          <c:numFmt formatCode="0.0%" sourceLinked="0"/>
+          <c:txPr>
+            <a:bodyPr/>
+            <a:lstStyle/>
+            <a:p>
+              <a:pPr>
+                <a:defRPr sz="900" b="1">
+                  <a:solidFill>
+                    <a:srgbClr val="1C242E"/>
+                  </a:solidFill>
+                  <a:latin typeface="Microsoft YaHei"/>
+                </a:defRPr>
+              </a:pPr>
+            </a:p>
+          </c:txPr>
+          <c:dLblPos val="outEnd"/>
+          <c:showLegendKey val="0"/>
+          <c:showVal val="0"/>
+          <c:showCatName val="1"/>
+          <c:showSerName val="0"/>
+          <c:showPercent val="1"/>
+          <c:showBubbleSize val="0"/>
+          <c:showLeaderLines val="1"/>
+        </c:dLbls>
+      </c:pieChart>
+    </c:plotArea>
+    <c:dispBlanksAs val="gap"/>
+  </c:chart>
+  <c:txPr>
+    <a:bodyPr/>
+    <a:lstStyle/>
+    <a:p>
+      <a:pPr>
+        <a:defRPr sz="1800"/>
+      </a:pPr>
+      <a:endParaRPr lang="en-US"/>
+    </a:p>
+  </c:txPr>
+  <c:externalData r:id="rId1">
+    <c:autoUpdate val="0"/>
+  </c:externalData>
+</c:chartSpace>
+</file>
+
+<file path=ppt/charts/chart6.xml><?xml version="1.0" encoding="utf-8"?>
+<c:chartSpace xmlns:c="http://schemas.openxmlformats.org/drawingml/2006/chart" xmlns:a="http://schemas.openxmlformats.org/drawingml/2006/main" xmlns:r="http://schemas.openxmlformats.org/officeDocument/2006/relationships">
+  <c:style val="10"/>
+  <c:chart>
+    <c:autoTitleDeleted val="0"/>
+    <c:plotArea>
+      <c:pieChart>
+        <c:varyColors val="1"/>
+        <c:ser>
+          <c:idx val="0"/>
+          <c:order val="0"/>
+          <c:tx>
+            <c:strRef>
+              <c:f>Sheet1!$B$1</c:f>
+              <c:strCache>
+                <c:ptCount val="1"/>
+                <c:pt idx="0">
+                  <c:v/>
+                </c:pt>
+              </c:strCache>
+            </c:strRef>
+          </c:tx>
+          <c:dPt>
+            <c:idx val="0"/>
+            <c:spPr>
+              <a:solidFill>
+                <a:srgbClr val="0E2A47"/>
+              </a:solidFill>
+              <a:ln>
+                <a:solidFill>
+                  <a:srgbClr val="FFFFFF"/>
+                </a:solidFill>
+              </a:ln>
+            </c:spPr>
+          </c:dPt>
+          <c:dPt>
+            <c:idx val="1"/>
+            <c:spPr>
+              <a:solidFill>
+                <a:srgbClr val="7A541C"/>
+              </a:solidFill>
+              <a:ln>
+                <a:solidFill>
+                  <a:srgbClr val="FFFFFF"/>
+                </a:solidFill>
+              </a:ln>
+            </c:spPr>
+          </c:dPt>
+          <c:dPt>
+            <c:idx val="2"/>
+            <c:spPr>
+              <a:solidFill>
+                <a:srgbClr val="0E7A76"/>
+              </a:solidFill>
+              <a:ln>
+                <a:solidFill>
+                  <a:srgbClr val="FFFFFF"/>
+                </a:solidFill>
+              </a:ln>
+            </c:spPr>
+          </c:dPt>
+          <c:dPt>
+            <c:idx val="3"/>
+            <c:spPr>
+              <a:solidFill>
+                <a:srgbClr val="DCE3E9"/>
+              </a:solidFill>
+              <a:ln>
+                <a:solidFill>
+                  <a:srgbClr val="FFFFFF"/>
+                </a:solidFill>
+              </a:ln>
+            </c:spPr>
+          </c:dPt>
+          <c:cat>
+            <c:strRef>
+              <c:f>Sheet1!$A$2:$A$5</c:f>
+              <c:strCache>
+                <c:ptCount val="4"/>
+                <c:pt idx="0">
+                  <c:v>模型权重</c:v>
+                </c:pt>
+                <c:pt idx="1">
+                  <c:v>系统预留</c:v>
+                </c:pt>
+                <c:pt idx="2">
+                  <c:v>KV cache</c:v>
+                </c:pt>
+                <c:pt idx="3">
+                  <c:v>空闲</c:v>
+                </c:pt>
+              </c:strCache>
+            </c:strRef>
+          </c:cat>
+          <c:val>
+            <c:numRef>
+              <c:f>Sheet1!$B$2:$B$5</c:f>
+              <c:numCache>
+                <c:formatCode>General</c:formatCode>
+                <c:ptCount val="4"/>
+                <c:pt idx="0">
+                  <c:v>45.3127788</c:v>
+                </c:pt>
+                <c:pt idx="1">
+                  <c:v>6.0</c:v>
+                </c:pt>
+                <c:pt idx="2">
+                  <c:v>44.6872212</c:v>
+                </c:pt>
+                <c:pt idx="3">
+                  <c:v>0.0</c:v>
+                </c:pt>
+              </c:numCache>
+            </c:numRef>
+          </c:val>
+        </c:ser>
+        <c:dLbls>
+          <c:numFmt formatCode="0.0%" sourceLinked="0"/>
+          <c:txPr>
+            <a:bodyPr/>
+            <a:lstStyle/>
+            <a:p>
+              <a:pPr>
+                <a:defRPr sz="900" b="1">
+                  <a:solidFill>
+                    <a:srgbClr val="1C242E"/>
+                  </a:solidFill>
+                  <a:latin typeface="Microsoft YaHei"/>
+                </a:defRPr>
+              </a:pPr>
+            </a:p>
+          </c:txPr>
+          <c:dLblPos val="outEnd"/>
+          <c:showLegendKey val="0"/>
+          <c:showVal val="0"/>
+          <c:showCatName val="1"/>
+          <c:showSerName val="0"/>
+          <c:showPercent val="1"/>
+          <c:showBubbleSize val="0"/>
+          <c:showLeaderLines val="1"/>
+        </c:dLbls>
+      </c:pieChart>
+    </c:plotArea>
+    <c:dispBlanksAs val="gap"/>
+  </c:chart>
+  <c:txPr>
+    <a:bodyPr/>
+    <a:lstStyle/>
+    <a:p>
+      <a:pPr>
+        <a:defRPr sz="1800"/>
+      </a:pPr>
+      <a:endParaRPr lang="en-US"/>
+    </a:p>
+  </c:txPr>
+  <c:externalData r:id="rId1">
+    <c:autoUpdate val="0"/>
+  </c:externalData>
+</c:chartSpace>
 </file>
 
 <file path=ppt/notesMasters/notesMaster1.xml><?xml version="1.0" encoding="utf-8"?>
@@ -653,6 +1621,146 @@
           <a:p>
             <a:r>
               <a:t>4K 10ms BS=201 data-plane=9.996224ms；4K 30ms BS=4352 data-plane=29.930840ms。生产摸高需要先给 measured fixed overhead 预留预算，再重新搜索 BS。</a:t>
+            </a:r>
+          </a:p>
+        </p:txBody>
+      </p:sp>
+      <p:sp>
+        <p:nvSpPr>
+          <p:cNvPr id="4" name="Slide Number Placeholder 3"/>
+          <p:cNvSpPr>
+            <a:spLocks noGrp="1"/>
+          </p:cNvSpPr>
+          <p:nvPr>
+            <p:ph type="sldNum" idx="5" sz="quarter"/>
+          </p:nvPr>
+        </p:nvSpPr>
+        <p:spPr/>
+      </p:sp>
+    </p:spTree>
+  </p:cSld>
+  <p:clrMapOvr>
+    <a:masterClrMapping/>
+  </p:clrMapOvr>
+</p:notes>
+</file>
+
+<file path=ppt/notesSlides/notesSlide12.xml><?xml version="1.0" encoding="utf-8"?>
+<p:notes xmlns:a="http://schemas.openxmlformats.org/drawingml/2006/main" xmlns:p="http://schemas.openxmlformats.org/presentationml/2006/main" xmlns:r="http://schemas.openxmlformats.org/officeDocument/2006/relationships">
+  <p:cSld>
+    <p:spTree>
+      <p:nvGrpSpPr>
+        <p:cNvPr id="1" name=""/>
+        <p:cNvGrpSpPr/>
+        <p:nvPr/>
+      </p:nvGrpSpPr>
+      <p:grpSpPr>
+        <a:xfrm>
+          <a:off x="0" y="0"/>
+          <a:ext cx="0" cy="0"/>
+          <a:chOff x="0" y="0"/>
+          <a:chExt cx="0" cy="0"/>
+        </a:xfrm>
+      </p:grpSpPr>
+      <p:sp>
+        <p:nvSpPr>
+          <p:cNvPr id="2" name="Slide Image Placeholder 1"/>
+          <p:cNvSpPr>
+            <a:spLocks noGrp="1"/>
+          </p:cNvSpPr>
+          <p:nvPr>
+            <p:ph type="sldImg" idx="2"/>
+          </p:nvPr>
+        </p:nvSpPr>
+        <p:spPr/>
+      </p:sp>
+      <p:sp>
+        <p:nvSpPr>
+          <p:cNvPr id="3" name="Notes Placeholder 2"/>
+          <p:cNvSpPr>
+            <a:spLocks noGrp="1"/>
+          </p:cNvSpPr>
+          <p:nvPr>
+            <p:ph type="body" idx="3" sz="quarter"/>
+          </p:nvPr>
+        </p:nvSpPr>
+        <p:spPr/>
+        <p:txBody>
+          <a:bodyPr/>
+          <a:lstStyle/>
+          <a:p>
+            <a:r>
+              <a:t>饼图按最忙活跃 GPU，不按 128 卡平均。每卡固定：路由专家 38.864 GB，共享专家 4.030 GB，Attention 2.419 GB，系统预留 6 GB。KV = ceil(BS/16) × store_seq(S) / 8。4K: BS=6176, kv=1.193GB, free=43.494GB. 256K: BS=96, kv=0.975GB, free=43.713GB. 1M: BS=6, kv=0.648GB, free=44.039GB.</a:t>
+            </a:r>
+          </a:p>
+        </p:txBody>
+      </p:sp>
+      <p:sp>
+        <p:nvSpPr>
+          <p:cNvPr id="4" name="Slide Number Placeholder 3"/>
+          <p:cNvSpPr>
+            <a:spLocks noGrp="1"/>
+          </p:cNvSpPr>
+          <p:nvPr>
+            <p:ph type="sldNum" idx="5" sz="quarter"/>
+          </p:nvPr>
+        </p:nvSpPr>
+        <p:spPr/>
+      </p:sp>
+    </p:spTree>
+  </p:cSld>
+  <p:clrMapOvr>
+    <a:masterClrMapping/>
+  </p:clrMapOvr>
+</p:notes>
+</file>
+
+<file path=ppt/notesSlides/notesSlide13.xml><?xml version="1.0" encoding="utf-8"?>
+<p:notes xmlns:a="http://schemas.openxmlformats.org/drawingml/2006/main" xmlns:p="http://schemas.openxmlformats.org/presentationml/2006/main" xmlns:r="http://schemas.openxmlformats.org/officeDocument/2006/relationships">
+  <p:cSld>
+    <p:spTree>
+      <p:nvGrpSpPr>
+        <p:cNvPr id="1" name=""/>
+        <p:cNvGrpSpPr/>
+        <p:nvPr/>
+      </p:nvGrpSpPr>
+      <p:grpSpPr>
+        <a:xfrm>
+          <a:off x="0" y="0"/>
+          <a:ext cx="0" cy="0"/>
+          <a:chOff x="0" y="0"/>
+          <a:chExt cx="0" cy="0"/>
+        </a:xfrm>
+      </p:grpSpPr>
+      <p:sp>
+        <p:nvSpPr>
+          <p:cNvPr id="2" name="Slide Image Placeholder 1"/>
+          <p:cNvSpPr>
+            <a:spLocks noGrp="1"/>
+          </p:cNvSpPr>
+          <p:nvPr>
+            <p:ph type="sldImg" idx="2"/>
+          </p:nvPr>
+        </p:nvSpPr>
+        <p:spPr/>
+      </p:sp>
+      <p:sp>
+        <p:nvSpPr>
+          <p:cNvPr id="3" name="Notes Placeholder 2"/>
+          <p:cNvSpPr>
+            <a:spLocks noGrp="1"/>
+          </p:cNvSpPr>
+          <p:nvPr>
+            <p:ph type="body" idx="3" sz="quarter"/>
+          </p:nvPr>
+        </p:nvSpPr>
+        <p:spPr/>
+        <p:txBody>
+          <a:bodyPr/>
+          <a:lstStyle/>
+          <a:p>
+            <a:r>
+              <a:t>Decode 饼图使用 30ms 最大批，按最忙活跃 GPU。HBM KV 上限 44.687 GB。4K: BS=4352, hbm_kv=0.841GB, pool=0.000GB, free=43.846GB. 512K: BS=2390, hbm_kv=44.687GB, pool=3.954GB, free=0.000GB. 1M: BS=1362, hbm_kv=44.687GB, pool=11.040GB, free=0.000GB.</a:t>
             </a:r>
           </a:p>
         </p:txBody>
@@ -4382,7 +5490,7 @@
                 <a:ea typeface="Microsoft YaHei"/>
                 <a:cs typeface="Microsoft YaHei"/>
               </a:rPr>
-              <a:t>1  /  11</a:t>
+              <a:t>1  /  13</a:t>
             </a:r>
           </a:p>
         </p:txBody>
@@ -7093,7 +8201,7 @@
                 <a:ea typeface="Microsoft YaHei"/>
                 <a:cs typeface="Microsoft YaHei"/>
               </a:rPr>
-              <a:t>10  /  11</a:t>
+              <a:t>10  /  13</a:t>
             </a:r>
           </a:p>
         </p:txBody>
@@ -9063,7 +10171,7 @@
                 <a:ea typeface="Microsoft YaHei"/>
                 <a:cs typeface="Microsoft YaHei"/>
               </a:rPr>
-              <a:t>11  /  11</a:t>
+              <a:t>11  /  13</a:t>
             </a:r>
           </a:p>
         </p:txBody>
@@ -10859,6 +11967,1880 @@
 </p:sld>
 </file>
 
+<file path=ppt/slides/slide12.xml><?xml version="1.0" encoding="utf-8"?>
+<p:sld xmlns:a="http://schemas.openxmlformats.org/drawingml/2006/main" xmlns:p="http://schemas.openxmlformats.org/presentationml/2006/main" xmlns:r="http://schemas.openxmlformats.org/officeDocument/2006/relationships">
+  <p:cSld>
+    <p:spTree>
+      <p:nvGrpSpPr>
+        <p:cNvPr id="1" name=""/>
+        <p:cNvGrpSpPr/>
+        <p:nvPr/>
+      </p:nvGrpSpPr>
+      <p:grpSpPr/>
+      <p:sp>
+        <p:nvSpPr>
+          <p:cNvPr id="2" name="Rectangle 1"/>
+          <p:cNvSpPr/>
+          <p:nvPr/>
+        </p:nvSpPr>
+        <p:spPr>
+          <a:xfrm>
+            <a:off x="0" y="0"/>
+            <a:ext cx="12191695" cy="73152"/>
+          </a:xfrm>
+          <a:prstGeom prst="rect">
+            <a:avLst/>
+          </a:prstGeom>
+          <a:solidFill>
+            <a:srgbClr val="145A96"/>
+          </a:solidFill>
+          <a:ln>
+            <a:noFill/>
+          </a:ln>
+        </p:spPr>
+        <p:style>
+          <a:lnRef idx="1">
+            <a:schemeClr val="accent1"/>
+          </a:lnRef>
+          <a:fillRef idx="3">
+            <a:schemeClr val="accent1"/>
+          </a:fillRef>
+          <a:effectRef idx="2">
+            <a:schemeClr val="accent1"/>
+          </a:effectRef>
+          <a:fontRef idx="minor">
+            <a:schemeClr val="lt1"/>
+          </a:fontRef>
+        </p:style>
+        <p:txBody>
+          <a:bodyPr rtlCol="0" anchor="ctr"/>
+          <a:lstStyle/>
+          <a:p>
+            <a:pPr algn="ctr"/>
+          </a:p>
+        </p:txBody>
+      </p:sp>
+      <p:sp>
+        <p:nvSpPr>
+          <p:cNvPr id="3" name="TextBox 2"/>
+          <p:cNvSpPr txBox="1"/>
+          <p:nvPr/>
+        </p:nvSpPr>
+        <p:spPr>
+          <a:xfrm>
+            <a:off x="384048" y="146304"/>
+            <a:ext cx="9692640" cy="256032"/>
+          </a:xfrm>
+          <a:prstGeom prst="rect">
+            <a:avLst/>
+          </a:prstGeom>
+          <a:noFill/>
+        </p:spPr>
+        <p:txBody>
+          <a:bodyPr wrap="square" lIns="0" rIns="0" tIns="0" bIns="0" anchor="ctr"/>
+          <a:lstStyle/>
+          <a:p>
+            <a:pPr algn="l">
+              <a:spcBef>
+                <a:spcPts val="0"/>
+              </a:spcBef>
+              <a:spcAft>
+                <a:spcPts val="0"/>
+              </a:spcAft>
+            </a:pPr>
+            <a:r>
+              <a:rPr sz="1200" b="1">
+                <a:solidFill>
+                  <a:srgbClr val="145A96"/>
+                </a:solidFill>
+                <a:latin typeface="Microsoft YaHei"/>
+                <a:ea typeface="Microsoft YaHei"/>
+                <a:cs typeface="Microsoft YaHei"/>
+              </a:rPr>
+              <a:t>HBM 容量    ·    TTFT ≤ 10 秒    ·    90% prefix 命中</a:t>
+            </a:r>
+          </a:p>
+        </p:txBody>
+      </p:sp>
+      <p:sp>
+        <p:nvSpPr>
+          <p:cNvPr id="4" name="TextBox 3"/>
+          <p:cNvSpPr txBox="1"/>
+          <p:nvPr/>
+        </p:nvSpPr>
+        <p:spPr>
+          <a:xfrm>
+            <a:off x="384048" y="384048"/>
+            <a:ext cx="11430000" cy="384048"/>
+          </a:xfrm>
+          <a:prstGeom prst="rect">
+            <a:avLst/>
+          </a:prstGeom>
+          <a:noFill/>
+        </p:spPr>
+        <p:txBody>
+          <a:bodyPr wrap="square" lIns="0" rIns="0" tIns="0" bIns="0" anchor="ctr"/>
+          <a:lstStyle/>
+          <a:p>
+            <a:pPr algn="l">
+              <a:spcBef>
+                <a:spcPts val="0"/>
+              </a:spcBef>
+              <a:spcAft>
+                <a:spcPts val="0"/>
+              </a:spcAft>
+            </a:pPr>
+            <a:r>
+              <a:rPr sz="2600" b="1">
+                <a:solidFill>
+                  <a:srgbClr val="0E2A47"/>
+                </a:solidFill>
+                <a:latin typeface="Microsoft YaHei"/>
+                <a:ea typeface="Microsoft YaHei"/>
+                <a:cs typeface="Microsoft YaHei"/>
+              </a:rPr>
+              <a:t>Prefill：输入变长后，时间摸高批下降，单卡 KV 占用仍小</a:t>
+            </a:r>
+          </a:p>
+        </p:txBody>
+      </p:sp>
+      <p:sp>
+        <p:nvSpPr>
+          <p:cNvPr id="5" name="TextBox 4"/>
+          <p:cNvSpPr txBox="1"/>
+          <p:nvPr/>
+        </p:nvSpPr>
+        <p:spPr>
+          <a:xfrm>
+            <a:off x="10424160" y="164592"/>
+            <a:ext cx="1371600" cy="237744"/>
+          </a:xfrm>
+          <a:prstGeom prst="rect">
+            <a:avLst/>
+          </a:prstGeom>
+          <a:noFill/>
+        </p:spPr>
+        <p:txBody>
+          <a:bodyPr wrap="square" lIns="0" rIns="0" tIns="0" bIns="0" anchor="ctr"/>
+          <a:lstStyle/>
+          <a:p>
+            <a:pPr algn="r">
+              <a:spcBef>
+                <a:spcPts val="0"/>
+              </a:spcBef>
+              <a:spcAft>
+                <a:spcPts val="0"/>
+              </a:spcAft>
+            </a:pPr>
+            <a:r>
+              <a:rPr sz="1200" b="0">
+                <a:solidFill>
+                  <a:srgbClr val="5A636E"/>
+                </a:solidFill>
+                <a:latin typeface="Microsoft YaHei"/>
+                <a:ea typeface="Microsoft YaHei"/>
+                <a:cs typeface="Microsoft YaHei"/>
+              </a:rPr>
+              <a:t>12  /  13</a:t>
+            </a:r>
+          </a:p>
+        </p:txBody>
+      </p:sp>
+      <p:sp>
+        <p:nvSpPr>
+          <p:cNvPr id="6" name="Rectangle 5"/>
+          <p:cNvSpPr/>
+          <p:nvPr/>
+        </p:nvSpPr>
+        <p:spPr>
+          <a:xfrm>
+            <a:off x="384048" y="6565392"/>
+            <a:ext cx="11430000" cy="9144"/>
+          </a:xfrm>
+          <a:prstGeom prst="rect">
+            <a:avLst/>
+          </a:prstGeom>
+          <a:solidFill>
+            <a:srgbClr val="D6DCE2"/>
+          </a:solidFill>
+          <a:ln>
+            <a:noFill/>
+          </a:ln>
+        </p:spPr>
+        <p:style>
+          <a:lnRef idx="1">
+            <a:schemeClr val="accent1"/>
+          </a:lnRef>
+          <a:fillRef idx="3">
+            <a:schemeClr val="accent1"/>
+          </a:fillRef>
+          <a:effectRef idx="2">
+            <a:schemeClr val="accent1"/>
+          </a:effectRef>
+          <a:fontRef idx="minor">
+            <a:schemeClr val="lt1"/>
+          </a:fontRef>
+        </p:style>
+        <p:txBody>
+          <a:bodyPr rtlCol="0" anchor="ctr"/>
+          <a:lstStyle/>
+          <a:p>
+            <a:pPr algn="ctr"/>
+          </a:p>
+        </p:txBody>
+      </p:sp>
+      <p:sp>
+        <p:nvSpPr>
+          <p:cNvPr id="7" name="TextBox 6"/>
+          <p:cNvSpPr txBox="1"/>
+          <p:nvPr/>
+        </p:nvSpPr>
+        <p:spPr>
+          <a:xfrm>
+            <a:off x="384048" y="6583680"/>
+            <a:ext cx="11430000" cy="219456"/>
+          </a:xfrm>
+          <a:prstGeom prst="rect">
+            <a:avLst/>
+          </a:prstGeom>
+          <a:noFill/>
+        </p:spPr>
+        <p:txBody>
+          <a:bodyPr wrap="square" lIns="0" rIns="0" tIns="0" bIns="0" anchor="ctr"/>
+          <a:lstStyle/>
+          <a:p>
+            <a:pPr algn="l">
+              <a:spcBef>
+                <a:spcPts val="0"/>
+              </a:spcBef>
+              <a:spcAft>
+                <a:spcPts val="0"/>
+              </a:spcAft>
+            </a:pPr>
+            <a:r>
+              <a:rPr sz="1100" b="0">
+                <a:solidFill>
+                  <a:srgbClr val="5A636E"/>
+                </a:solidFill>
+                <a:latin typeface="Microsoft YaHei"/>
+                <a:ea typeface="Microsoft YaHei"/>
+                <a:cs typeface="Microsoft YaHei"/>
+              </a:rPr>
+              <a:t>10T 为外推    ·    96 GB / 486 T、一份 128 卡副本    ·    访存与通信 80%    ·    计算 70%</a:t>
+            </a:r>
+          </a:p>
+        </p:txBody>
+      </p:sp>
+      <p:sp>
+        <p:nvSpPr>
+          <p:cNvPr id="8" name="Rounded Rectangle 7"/>
+          <p:cNvSpPr/>
+          <p:nvPr/>
+        </p:nvSpPr>
+        <p:spPr>
+          <a:xfrm>
+            <a:off x="384048" y="841248"/>
+            <a:ext cx="11430000" cy="420624"/>
+          </a:xfrm>
+          <a:prstGeom prst="roundRect">
+            <a:avLst/>
+          </a:prstGeom>
+          <a:solidFill>
+            <a:srgbClr val="E7F3F2"/>
+          </a:solidFill>
+          <a:ln>
+            <a:noFill/>
+          </a:ln>
+        </p:spPr>
+        <p:style>
+          <a:lnRef idx="1">
+            <a:schemeClr val="accent1"/>
+          </a:lnRef>
+          <a:fillRef idx="3">
+            <a:schemeClr val="accent1"/>
+          </a:fillRef>
+          <a:effectRef idx="2">
+            <a:schemeClr val="accent1"/>
+          </a:effectRef>
+          <a:fontRef idx="minor">
+            <a:schemeClr val="lt1"/>
+          </a:fontRef>
+        </p:style>
+        <p:txBody>
+          <a:bodyPr rtlCol="0" anchor="ctr"/>
+          <a:lstStyle/>
+          <a:p>
+            <a:pPr algn="ctr"/>
+          </a:p>
+        </p:txBody>
+      </p:sp>
+      <p:sp>
+        <p:nvSpPr>
+          <p:cNvPr id="9" name="TextBox 8"/>
+          <p:cNvSpPr txBox="1"/>
+          <p:nvPr/>
+        </p:nvSpPr>
+        <p:spPr>
+          <a:xfrm>
+            <a:off x="530352" y="841248"/>
+            <a:ext cx="11137392" cy="420624"/>
+          </a:xfrm>
+          <a:prstGeom prst="rect">
+            <a:avLst/>
+          </a:prstGeom>
+          <a:noFill/>
+        </p:spPr>
+        <p:txBody>
+          <a:bodyPr wrap="square" lIns="0" rIns="0" tIns="0" bIns="0" anchor="ctr"/>
+          <a:lstStyle/>
+          <a:p>
+            <a:pPr algn="l">
+              <a:spcBef>
+                <a:spcPts val="0"/>
+              </a:spcBef>
+              <a:spcAft>
+                <a:spcPts val="0"/>
+              </a:spcAft>
+            </a:pPr>
+            <a:r>
+              <a:rPr sz="1300" b="1">
+                <a:solidFill>
+                  <a:srgbClr val="0E7A76"/>
+                </a:solidFill>
+                <a:latin typeface="Microsoft YaHei"/>
+                <a:ea typeface="Microsoft YaHei"/>
+                <a:cs typeface="Microsoft YaHei"/>
+              </a:rPr>
+              <a:t>每个饼是最忙活跃卡的 96 GB HBM。模型权重固定 45.31 GB，系统预留 6 GB；prefix 经参数面拉入 HBM。</a:t>
+            </a:r>
+          </a:p>
+        </p:txBody>
+      </p:sp>
+      <p:graphicFrame>
+        <p:nvGraphicFramePr>
+          <p:cNvPr id="10" name="Chart 9"/>
+          <p:cNvGraphicFramePr>
+            <a:graphicFrameLocks noGrp="1"/>
+          </p:cNvGraphicFramePr>
+          <p:nvPr/>
+        </p:nvGraphicFramePr>
+        <p:xfrm>
+          <a:off x="384048" y="1572768"/>
+          <a:ext cx="3529584" cy="3127248"/>
+        </p:xfrm>
+        <a:graphic>
+          <a:graphicData uri="http://schemas.openxmlformats.org/drawingml/2006/chart">
+            <c:chart xmlns:c="http://schemas.openxmlformats.org/drawingml/2006/chart" r:id="rId2"/>
+          </a:graphicData>
+        </a:graphic>
+      </p:graphicFrame>
+      <p:sp>
+        <p:nvSpPr>
+          <p:cNvPr id="11" name="TextBox 10"/>
+          <p:cNvSpPr txBox="1"/>
+          <p:nvPr/>
+        </p:nvSpPr>
+        <p:spPr>
+          <a:xfrm>
+            <a:off x="384048" y="1261872"/>
+            <a:ext cx="3529584" cy="274320"/>
+          </a:xfrm>
+          <a:prstGeom prst="rect">
+            <a:avLst/>
+          </a:prstGeom>
+          <a:noFill/>
+        </p:spPr>
+        <p:txBody>
+          <a:bodyPr wrap="square" lIns="0" rIns="0" tIns="0" bIns="0" anchor="ctr"/>
+          <a:lstStyle/>
+          <a:p>
+            <a:pPr algn="ctr">
+              <a:spcBef>
+                <a:spcPts val="0"/>
+              </a:spcBef>
+              <a:spcAft>
+                <a:spcPts val="0"/>
+              </a:spcAft>
+            </a:pPr>
+            <a:r>
+              <a:rPr sz="1500" b="1">
+                <a:solidFill>
+                  <a:srgbClr val="0E2A47"/>
+                </a:solidFill>
+                <a:latin typeface="Microsoft YaHei"/>
+                <a:ea typeface="Microsoft YaHei"/>
+                <a:cs typeface="Microsoft YaHei"/>
+              </a:rPr>
+              <a:t>4K</a:t>
+            </a:r>
+          </a:p>
+        </p:txBody>
+      </p:sp>
+      <p:sp>
+        <p:nvSpPr>
+          <p:cNvPr id="12" name="TextBox 11"/>
+          <p:cNvSpPr txBox="1"/>
+          <p:nvPr/>
+        </p:nvSpPr>
+        <p:spPr>
+          <a:xfrm>
+            <a:off x="384048" y="4681728"/>
+            <a:ext cx="3529584" cy="530352"/>
+          </a:xfrm>
+          <a:prstGeom prst="rect">
+            <a:avLst/>
+          </a:prstGeom>
+          <a:noFill/>
+        </p:spPr>
+        <p:txBody>
+          <a:bodyPr wrap="square" lIns="0" rIns="0" tIns="0" bIns="0" anchor="ctr"/>
+          <a:lstStyle/>
+          <a:p>
+            <a:pPr algn="ctr">
+              <a:spcBef>
+                <a:spcPts val="0"/>
+              </a:spcBef>
+              <a:spcAft>
+                <a:spcPts val="0"/>
+              </a:spcAft>
+            </a:pPr>
+            <a:r>
+              <a:rPr sz="1100" b="0">
+                <a:solidFill>
+                  <a:srgbClr val="1C242E"/>
+                </a:solidFill>
+                <a:latin typeface="Microsoft YaHei"/>
+                <a:ea typeface="Microsoft YaHei"/>
+                <a:cs typeface="Microsoft YaHei"/>
+              </a:rPr>
+              <a:t>BS 6176    权重 45.31 GB    预留 6 GB</a:t>
+            </a:r>
+          </a:p>
+          <a:p>
+            <a:pPr algn="ctr">
+              <a:spcBef>
+                <a:spcPts val="0"/>
+              </a:spcBef>
+              <a:spcAft>
+                <a:spcPts val="0"/>
+              </a:spcAft>
+            </a:pPr>
+            <a:r>
+              <a:rPr sz="1100" b="0">
+                <a:solidFill>
+                  <a:srgbClr val="1C242E"/>
+                </a:solidFill>
+                <a:latin typeface="Microsoft YaHei"/>
+                <a:ea typeface="Microsoft YaHei"/>
+                <a:cs typeface="Microsoft YaHei"/>
+              </a:rPr>
+              <a:t>HBM KV 1.19 GB  ｜  空闲 43.49 GB</a:t>
+            </a:r>
+          </a:p>
+        </p:txBody>
+      </p:sp>
+      <p:sp>
+        <p:nvSpPr>
+          <p:cNvPr id="13" name="TextBox 12"/>
+          <p:cNvSpPr txBox="1"/>
+          <p:nvPr/>
+        </p:nvSpPr>
+        <p:spPr>
+          <a:xfrm>
+            <a:off x="384048" y="5230368"/>
+            <a:ext cx="3529584" cy="256032"/>
+          </a:xfrm>
+          <a:prstGeom prst="rect">
+            <a:avLst/>
+          </a:prstGeom>
+          <a:noFill/>
+        </p:spPr>
+        <p:txBody>
+          <a:bodyPr wrap="square" lIns="0" rIns="0" tIns="0" bIns="0" anchor="ctr"/>
+          <a:lstStyle/>
+          <a:p>
+            <a:pPr algn="ctr">
+              <a:spcBef>
+                <a:spcPts val="0"/>
+              </a:spcBef>
+              <a:spcAft>
+                <a:spcPts val="0"/>
+              </a:spcAft>
+            </a:pPr>
+            <a:r>
+              <a:rPr sz="1100" b="0">
+                <a:solidFill>
+                  <a:srgbClr val="5A636E"/>
+                </a:solidFill>
+                <a:latin typeface="Microsoft YaHei"/>
+                <a:ea typeface="Microsoft YaHei"/>
+                <a:cs typeface="Microsoft YaHei"/>
+              </a:rPr>
+              <a:t>DDR 池 KV（图外）：0</a:t>
+            </a:r>
+          </a:p>
+        </p:txBody>
+      </p:sp>
+      <p:graphicFrame>
+        <p:nvGraphicFramePr>
+          <p:cNvPr id="14" name="Chart 13"/>
+          <p:cNvGraphicFramePr>
+            <a:graphicFrameLocks noGrp="1"/>
+          </p:cNvGraphicFramePr>
+          <p:nvPr/>
+        </p:nvGraphicFramePr>
+        <p:xfrm>
+          <a:off x="4315968" y="1572768"/>
+          <a:ext cx="3529584" cy="3127248"/>
+        </p:xfrm>
+        <a:graphic>
+          <a:graphicData uri="http://schemas.openxmlformats.org/drawingml/2006/chart">
+            <c:chart xmlns:c="http://schemas.openxmlformats.org/drawingml/2006/chart" r:id="rId3"/>
+          </a:graphicData>
+        </a:graphic>
+      </p:graphicFrame>
+      <p:sp>
+        <p:nvSpPr>
+          <p:cNvPr id="15" name="TextBox 14"/>
+          <p:cNvSpPr txBox="1"/>
+          <p:nvPr/>
+        </p:nvSpPr>
+        <p:spPr>
+          <a:xfrm>
+            <a:off x="4315968" y="1261872"/>
+            <a:ext cx="3529584" cy="274320"/>
+          </a:xfrm>
+          <a:prstGeom prst="rect">
+            <a:avLst/>
+          </a:prstGeom>
+          <a:noFill/>
+        </p:spPr>
+        <p:txBody>
+          <a:bodyPr wrap="square" lIns="0" rIns="0" tIns="0" bIns="0" anchor="ctr"/>
+          <a:lstStyle/>
+          <a:p>
+            <a:pPr algn="ctr">
+              <a:spcBef>
+                <a:spcPts val="0"/>
+              </a:spcBef>
+              <a:spcAft>
+                <a:spcPts val="0"/>
+              </a:spcAft>
+            </a:pPr>
+            <a:r>
+              <a:rPr sz="1500" b="1">
+                <a:solidFill>
+                  <a:srgbClr val="0E2A47"/>
+                </a:solidFill>
+                <a:latin typeface="Microsoft YaHei"/>
+                <a:ea typeface="Microsoft YaHei"/>
+                <a:cs typeface="Microsoft YaHei"/>
+              </a:rPr>
+              <a:t>256K</a:t>
+            </a:r>
+          </a:p>
+        </p:txBody>
+      </p:sp>
+      <p:sp>
+        <p:nvSpPr>
+          <p:cNvPr id="16" name="TextBox 15"/>
+          <p:cNvSpPr txBox="1"/>
+          <p:nvPr/>
+        </p:nvSpPr>
+        <p:spPr>
+          <a:xfrm>
+            <a:off x="4315968" y="4681728"/>
+            <a:ext cx="3529584" cy="530352"/>
+          </a:xfrm>
+          <a:prstGeom prst="rect">
+            <a:avLst/>
+          </a:prstGeom>
+          <a:noFill/>
+        </p:spPr>
+        <p:txBody>
+          <a:bodyPr wrap="square" lIns="0" rIns="0" tIns="0" bIns="0" anchor="ctr"/>
+          <a:lstStyle/>
+          <a:p>
+            <a:pPr algn="ctr">
+              <a:spcBef>
+                <a:spcPts val="0"/>
+              </a:spcBef>
+              <a:spcAft>
+                <a:spcPts val="0"/>
+              </a:spcAft>
+            </a:pPr>
+            <a:r>
+              <a:rPr sz="1100" b="0">
+                <a:solidFill>
+                  <a:srgbClr val="1C242E"/>
+                </a:solidFill>
+                <a:latin typeface="Microsoft YaHei"/>
+                <a:ea typeface="Microsoft YaHei"/>
+                <a:cs typeface="Microsoft YaHei"/>
+              </a:rPr>
+              <a:t>BS 96    权重 45.31 GB    预留 6 GB</a:t>
+            </a:r>
+          </a:p>
+          <a:p>
+            <a:pPr algn="ctr">
+              <a:spcBef>
+                <a:spcPts val="0"/>
+              </a:spcBef>
+              <a:spcAft>
+                <a:spcPts val="0"/>
+              </a:spcAft>
+            </a:pPr>
+            <a:r>
+              <a:rPr sz="1100" b="0">
+                <a:solidFill>
+                  <a:srgbClr val="1C242E"/>
+                </a:solidFill>
+                <a:latin typeface="Microsoft YaHei"/>
+                <a:ea typeface="Microsoft YaHei"/>
+                <a:cs typeface="Microsoft YaHei"/>
+              </a:rPr>
+              <a:t>HBM KV 0.97 GB  ｜  空闲 43.71 GB</a:t>
+            </a:r>
+          </a:p>
+        </p:txBody>
+      </p:sp>
+      <p:sp>
+        <p:nvSpPr>
+          <p:cNvPr id="17" name="TextBox 16"/>
+          <p:cNvSpPr txBox="1"/>
+          <p:nvPr/>
+        </p:nvSpPr>
+        <p:spPr>
+          <a:xfrm>
+            <a:off x="4315968" y="5230368"/>
+            <a:ext cx="3529584" cy="256032"/>
+          </a:xfrm>
+          <a:prstGeom prst="rect">
+            <a:avLst/>
+          </a:prstGeom>
+          <a:noFill/>
+        </p:spPr>
+        <p:txBody>
+          <a:bodyPr wrap="square" lIns="0" rIns="0" tIns="0" bIns="0" anchor="ctr"/>
+          <a:lstStyle/>
+          <a:p>
+            <a:pPr algn="ctr">
+              <a:spcBef>
+                <a:spcPts val="0"/>
+              </a:spcBef>
+              <a:spcAft>
+                <a:spcPts val="0"/>
+              </a:spcAft>
+            </a:pPr>
+            <a:r>
+              <a:rPr sz="1100" b="0">
+                <a:solidFill>
+                  <a:srgbClr val="5A636E"/>
+                </a:solidFill>
+                <a:latin typeface="Microsoft YaHei"/>
+                <a:ea typeface="Microsoft YaHei"/>
+                <a:cs typeface="Microsoft YaHei"/>
+              </a:rPr>
+              <a:t>DDR 池 KV（图外）：0</a:t>
+            </a:r>
+          </a:p>
+        </p:txBody>
+      </p:sp>
+      <p:graphicFrame>
+        <p:nvGraphicFramePr>
+          <p:cNvPr id="18" name="Chart 17"/>
+          <p:cNvGraphicFramePr>
+            <a:graphicFrameLocks noGrp="1"/>
+          </p:cNvGraphicFramePr>
+          <p:nvPr/>
+        </p:nvGraphicFramePr>
+        <p:xfrm>
+          <a:off x="8247888" y="1572768"/>
+          <a:ext cx="3529584" cy="3127248"/>
+        </p:xfrm>
+        <a:graphic>
+          <a:graphicData uri="http://schemas.openxmlformats.org/drawingml/2006/chart">
+            <c:chart xmlns:c="http://schemas.openxmlformats.org/drawingml/2006/chart" r:id="rId4"/>
+          </a:graphicData>
+        </a:graphic>
+      </p:graphicFrame>
+      <p:sp>
+        <p:nvSpPr>
+          <p:cNvPr id="19" name="TextBox 18"/>
+          <p:cNvSpPr txBox="1"/>
+          <p:nvPr/>
+        </p:nvSpPr>
+        <p:spPr>
+          <a:xfrm>
+            <a:off x="8247888" y="1261872"/>
+            <a:ext cx="3529584" cy="274320"/>
+          </a:xfrm>
+          <a:prstGeom prst="rect">
+            <a:avLst/>
+          </a:prstGeom>
+          <a:noFill/>
+        </p:spPr>
+        <p:txBody>
+          <a:bodyPr wrap="square" lIns="0" rIns="0" tIns="0" bIns="0" anchor="ctr"/>
+          <a:lstStyle/>
+          <a:p>
+            <a:pPr algn="ctr">
+              <a:spcBef>
+                <a:spcPts val="0"/>
+              </a:spcBef>
+              <a:spcAft>
+                <a:spcPts val="0"/>
+              </a:spcAft>
+            </a:pPr>
+            <a:r>
+              <a:rPr sz="1500" b="1">
+                <a:solidFill>
+                  <a:srgbClr val="0E2A47"/>
+                </a:solidFill>
+                <a:latin typeface="Microsoft YaHei"/>
+                <a:ea typeface="Microsoft YaHei"/>
+                <a:cs typeface="Microsoft YaHei"/>
+              </a:rPr>
+              <a:t>1M</a:t>
+            </a:r>
+          </a:p>
+        </p:txBody>
+      </p:sp>
+      <p:sp>
+        <p:nvSpPr>
+          <p:cNvPr id="20" name="TextBox 19"/>
+          <p:cNvSpPr txBox="1"/>
+          <p:nvPr/>
+        </p:nvSpPr>
+        <p:spPr>
+          <a:xfrm>
+            <a:off x="8247888" y="4681728"/>
+            <a:ext cx="3529584" cy="530352"/>
+          </a:xfrm>
+          <a:prstGeom prst="rect">
+            <a:avLst/>
+          </a:prstGeom>
+          <a:noFill/>
+        </p:spPr>
+        <p:txBody>
+          <a:bodyPr wrap="square" lIns="0" rIns="0" tIns="0" bIns="0" anchor="ctr"/>
+          <a:lstStyle/>
+          <a:p>
+            <a:pPr algn="ctr">
+              <a:spcBef>
+                <a:spcPts val="0"/>
+              </a:spcBef>
+              <a:spcAft>
+                <a:spcPts val="0"/>
+              </a:spcAft>
+            </a:pPr>
+            <a:r>
+              <a:rPr sz="1100" b="0">
+                <a:solidFill>
+                  <a:srgbClr val="1C242E"/>
+                </a:solidFill>
+                <a:latin typeface="Microsoft YaHei"/>
+                <a:ea typeface="Microsoft YaHei"/>
+                <a:cs typeface="Microsoft YaHei"/>
+              </a:rPr>
+              <a:t>BS 6    权重 45.31 GB    预留 6 GB</a:t>
+            </a:r>
+          </a:p>
+          <a:p>
+            <a:pPr algn="ctr">
+              <a:spcBef>
+                <a:spcPts val="0"/>
+              </a:spcBef>
+              <a:spcAft>
+                <a:spcPts val="0"/>
+              </a:spcAft>
+            </a:pPr>
+            <a:r>
+              <a:rPr sz="1100" b="0">
+                <a:solidFill>
+                  <a:srgbClr val="1C242E"/>
+                </a:solidFill>
+                <a:latin typeface="Microsoft YaHei"/>
+                <a:ea typeface="Microsoft YaHei"/>
+                <a:cs typeface="Microsoft YaHei"/>
+              </a:rPr>
+              <a:t>HBM KV 0.65 GB  ｜  空闲 44.04 GB</a:t>
+            </a:r>
+          </a:p>
+        </p:txBody>
+      </p:sp>
+      <p:sp>
+        <p:nvSpPr>
+          <p:cNvPr id="21" name="TextBox 20"/>
+          <p:cNvSpPr txBox="1"/>
+          <p:nvPr/>
+        </p:nvSpPr>
+        <p:spPr>
+          <a:xfrm>
+            <a:off x="8247888" y="5230368"/>
+            <a:ext cx="3529584" cy="256032"/>
+          </a:xfrm>
+          <a:prstGeom prst="rect">
+            <a:avLst/>
+          </a:prstGeom>
+          <a:noFill/>
+        </p:spPr>
+        <p:txBody>
+          <a:bodyPr wrap="square" lIns="0" rIns="0" tIns="0" bIns="0" anchor="ctr"/>
+          <a:lstStyle/>
+          <a:p>
+            <a:pPr algn="ctr">
+              <a:spcBef>
+                <a:spcPts val="0"/>
+              </a:spcBef>
+              <a:spcAft>
+                <a:spcPts val="0"/>
+              </a:spcAft>
+            </a:pPr>
+            <a:r>
+              <a:rPr sz="1100" b="0">
+                <a:solidFill>
+                  <a:srgbClr val="5A636E"/>
+                </a:solidFill>
+                <a:latin typeface="Microsoft YaHei"/>
+                <a:ea typeface="Microsoft YaHei"/>
+                <a:cs typeface="Microsoft YaHei"/>
+              </a:rPr>
+              <a:t>DDR 池 KV（图外）：0</a:t>
+            </a:r>
+          </a:p>
+        </p:txBody>
+      </p:sp>
+      <p:sp>
+        <p:nvSpPr>
+          <p:cNvPr id="22" name="Rounded Rectangle 21"/>
+          <p:cNvSpPr/>
+          <p:nvPr/>
+        </p:nvSpPr>
+        <p:spPr>
+          <a:xfrm>
+            <a:off x="384048" y="5632704"/>
+            <a:ext cx="11430000" cy="786384"/>
+          </a:xfrm>
+          <a:prstGeom prst="roundRect">
+            <a:avLst/>
+          </a:prstGeom>
+          <a:solidFill>
+            <a:srgbClr val="F8F1E4"/>
+          </a:solidFill>
+          <a:ln>
+            <a:noFill/>
+          </a:ln>
+        </p:spPr>
+        <p:style>
+          <a:lnRef idx="1">
+            <a:schemeClr val="accent1"/>
+          </a:lnRef>
+          <a:fillRef idx="3">
+            <a:schemeClr val="accent1"/>
+          </a:fillRef>
+          <a:effectRef idx="2">
+            <a:schemeClr val="accent1"/>
+          </a:effectRef>
+          <a:fontRef idx="minor">
+            <a:schemeClr val="lt1"/>
+          </a:fontRef>
+        </p:style>
+        <p:txBody>
+          <a:bodyPr rtlCol="0" anchor="ctr"/>
+          <a:lstStyle/>
+          <a:p>
+            <a:pPr algn="ctr"/>
+          </a:p>
+        </p:txBody>
+      </p:sp>
+      <p:sp>
+        <p:nvSpPr>
+          <p:cNvPr id="23" name="TextBox 22"/>
+          <p:cNvSpPr txBox="1"/>
+          <p:nvPr/>
+        </p:nvSpPr>
+        <p:spPr>
+          <a:xfrm>
+            <a:off x="530352" y="5669280"/>
+            <a:ext cx="11137392" cy="713232"/>
+          </a:xfrm>
+          <a:prstGeom prst="rect">
+            <a:avLst/>
+          </a:prstGeom>
+          <a:noFill/>
+        </p:spPr>
+        <p:txBody>
+          <a:bodyPr wrap="square" lIns="0" rIns="0" tIns="0" bIns="0" anchor="ctr"/>
+          <a:lstStyle/>
+          <a:p>
+            <a:pPr algn="l">
+              <a:spcBef>
+                <a:spcPts val="0"/>
+              </a:spcBef>
+              <a:spcAft>
+                <a:spcPts val="0"/>
+              </a:spcAft>
+            </a:pPr>
+            <a:r>
+              <a:rPr sz="1200" b="0">
+                <a:solidFill>
+                  <a:srgbClr val="7A541C"/>
+                </a:solidFill>
+                <a:latin typeface="Microsoft YaHei"/>
+                <a:ea typeface="Microsoft YaHei"/>
+                <a:cs typeface="Microsoft YaHei"/>
+              </a:rPr>
+              <a:t>Prefill 的长输入先被 TTFT 限制：4K / 256K / 1M 的最大批分别是 6176 / 96 / 6，最忙卡 HBM KV 只有 1.19 / 0.97 / 0.65 GB，均不需要 DDR 池。</a:t>
+            </a:r>
+          </a:p>
+        </p:txBody>
+      </p:sp>
+    </p:spTree>
+  </p:cSld>
+  <p:clrMapOvr>
+    <a:masterClrMapping/>
+  </p:clrMapOvr>
+</p:sld>
+</file>
+
+<file path=ppt/slides/slide13.xml><?xml version="1.0" encoding="utf-8"?>
+<p:sld xmlns:a="http://schemas.openxmlformats.org/drawingml/2006/main" xmlns:p="http://schemas.openxmlformats.org/presentationml/2006/main" xmlns:r="http://schemas.openxmlformats.org/officeDocument/2006/relationships">
+  <p:cSld>
+    <p:spTree>
+      <p:nvGrpSpPr>
+        <p:cNvPr id="1" name=""/>
+        <p:cNvGrpSpPr/>
+        <p:nvPr/>
+      </p:nvGrpSpPr>
+      <p:grpSpPr/>
+      <p:sp>
+        <p:nvSpPr>
+          <p:cNvPr id="2" name="Rectangle 1"/>
+          <p:cNvSpPr/>
+          <p:nvPr/>
+        </p:nvSpPr>
+        <p:spPr>
+          <a:xfrm>
+            <a:off x="0" y="0"/>
+            <a:ext cx="12191695" cy="73152"/>
+          </a:xfrm>
+          <a:prstGeom prst="rect">
+            <a:avLst/>
+          </a:prstGeom>
+          <a:solidFill>
+            <a:srgbClr val="145A96"/>
+          </a:solidFill>
+          <a:ln>
+            <a:noFill/>
+          </a:ln>
+        </p:spPr>
+        <p:style>
+          <a:lnRef idx="1">
+            <a:schemeClr val="accent1"/>
+          </a:lnRef>
+          <a:fillRef idx="3">
+            <a:schemeClr val="accent1"/>
+          </a:fillRef>
+          <a:effectRef idx="2">
+            <a:schemeClr val="accent1"/>
+          </a:effectRef>
+          <a:fontRef idx="minor">
+            <a:schemeClr val="lt1"/>
+          </a:fontRef>
+        </p:style>
+        <p:txBody>
+          <a:bodyPr rtlCol="0" anchor="ctr"/>
+          <a:lstStyle/>
+          <a:p>
+            <a:pPr algn="ctr"/>
+          </a:p>
+        </p:txBody>
+      </p:sp>
+      <p:sp>
+        <p:nvSpPr>
+          <p:cNvPr id="3" name="TextBox 2"/>
+          <p:cNvSpPr txBox="1"/>
+          <p:nvPr/>
+        </p:nvSpPr>
+        <p:spPr>
+          <a:xfrm>
+            <a:off x="384048" y="146304"/>
+            <a:ext cx="9692640" cy="256032"/>
+          </a:xfrm>
+          <a:prstGeom prst="rect">
+            <a:avLst/>
+          </a:prstGeom>
+          <a:noFill/>
+        </p:spPr>
+        <p:txBody>
+          <a:bodyPr wrap="square" lIns="0" rIns="0" tIns="0" bIns="0" anchor="ctr"/>
+          <a:lstStyle/>
+          <a:p>
+            <a:pPr algn="l">
+              <a:spcBef>
+                <a:spcPts val="0"/>
+              </a:spcBef>
+              <a:spcAft>
+                <a:spcPts val="0"/>
+              </a:spcAft>
+            </a:pPr>
+            <a:r>
+              <a:rPr sz="1200" b="1">
+                <a:solidFill>
+                  <a:srgbClr val="145A96"/>
+                </a:solidFill>
+                <a:latin typeface="Microsoft YaHei"/>
+                <a:ea typeface="Microsoft YaHei"/>
+                <a:cs typeface="Microsoft YaHei"/>
+              </a:rPr>
+              <a:t>HBM 容量    ·    TPOT ≤ 30 毫秒</a:t>
+            </a:r>
+          </a:p>
+        </p:txBody>
+      </p:sp>
+      <p:sp>
+        <p:nvSpPr>
+          <p:cNvPr id="4" name="TextBox 3"/>
+          <p:cNvSpPr txBox="1"/>
+          <p:nvPr/>
+        </p:nvSpPr>
+        <p:spPr>
+          <a:xfrm>
+            <a:off x="384048" y="384048"/>
+            <a:ext cx="11430000" cy="384048"/>
+          </a:xfrm>
+          <a:prstGeom prst="rect">
+            <a:avLst/>
+          </a:prstGeom>
+          <a:noFill/>
+        </p:spPr>
+        <p:txBody>
+          <a:bodyPr wrap="square" lIns="0" rIns="0" tIns="0" bIns="0" anchor="ctr"/>
+          <a:lstStyle/>
+          <a:p>
+            <a:pPr algn="l">
+              <a:spcBef>
+                <a:spcPts val="0"/>
+              </a:spcBef>
+              <a:spcAft>
+                <a:spcPts val="0"/>
+              </a:spcAft>
+            </a:pPr>
+            <a:r>
+              <a:rPr sz="2600" b="1">
+                <a:solidFill>
+                  <a:srgbClr val="0E2A47"/>
+                </a:solidFill>
+                <a:latin typeface="Microsoft YaHei"/>
+                <a:ea typeface="Microsoft YaHei"/>
+                <a:cs typeface="Microsoft YaHei"/>
+              </a:rPr>
+              <a:t>Decode：30 毫秒摸高时，512K 起把 HBM KV 房间占满</a:t>
+            </a:r>
+          </a:p>
+        </p:txBody>
+      </p:sp>
+      <p:sp>
+        <p:nvSpPr>
+          <p:cNvPr id="5" name="TextBox 4"/>
+          <p:cNvSpPr txBox="1"/>
+          <p:nvPr/>
+        </p:nvSpPr>
+        <p:spPr>
+          <a:xfrm>
+            <a:off x="10424160" y="164592"/>
+            <a:ext cx="1371600" cy="237744"/>
+          </a:xfrm>
+          <a:prstGeom prst="rect">
+            <a:avLst/>
+          </a:prstGeom>
+          <a:noFill/>
+        </p:spPr>
+        <p:txBody>
+          <a:bodyPr wrap="square" lIns="0" rIns="0" tIns="0" bIns="0" anchor="ctr"/>
+          <a:lstStyle/>
+          <a:p>
+            <a:pPr algn="r">
+              <a:spcBef>
+                <a:spcPts val="0"/>
+              </a:spcBef>
+              <a:spcAft>
+                <a:spcPts val="0"/>
+              </a:spcAft>
+            </a:pPr>
+            <a:r>
+              <a:rPr sz="1200" b="0">
+                <a:solidFill>
+                  <a:srgbClr val="5A636E"/>
+                </a:solidFill>
+                <a:latin typeface="Microsoft YaHei"/>
+                <a:ea typeface="Microsoft YaHei"/>
+                <a:cs typeface="Microsoft YaHei"/>
+              </a:rPr>
+              <a:t>13  /  13</a:t>
+            </a:r>
+          </a:p>
+        </p:txBody>
+      </p:sp>
+      <p:sp>
+        <p:nvSpPr>
+          <p:cNvPr id="6" name="Rectangle 5"/>
+          <p:cNvSpPr/>
+          <p:nvPr/>
+        </p:nvSpPr>
+        <p:spPr>
+          <a:xfrm>
+            <a:off x="384048" y="6565392"/>
+            <a:ext cx="11430000" cy="9144"/>
+          </a:xfrm>
+          <a:prstGeom prst="rect">
+            <a:avLst/>
+          </a:prstGeom>
+          <a:solidFill>
+            <a:srgbClr val="D6DCE2"/>
+          </a:solidFill>
+          <a:ln>
+            <a:noFill/>
+          </a:ln>
+        </p:spPr>
+        <p:style>
+          <a:lnRef idx="1">
+            <a:schemeClr val="accent1"/>
+          </a:lnRef>
+          <a:fillRef idx="3">
+            <a:schemeClr val="accent1"/>
+          </a:fillRef>
+          <a:effectRef idx="2">
+            <a:schemeClr val="accent1"/>
+          </a:effectRef>
+          <a:fontRef idx="minor">
+            <a:schemeClr val="lt1"/>
+          </a:fontRef>
+        </p:style>
+        <p:txBody>
+          <a:bodyPr rtlCol="0" anchor="ctr"/>
+          <a:lstStyle/>
+          <a:p>
+            <a:pPr algn="ctr"/>
+          </a:p>
+        </p:txBody>
+      </p:sp>
+      <p:sp>
+        <p:nvSpPr>
+          <p:cNvPr id="7" name="TextBox 6"/>
+          <p:cNvSpPr txBox="1"/>
+          <p:nvPr/>
+        </p:nvSpPr>
+        <p:spPr>
+          <a:xfrm>
+            <a:off x="384048" y="6583680"/>
+            <a:ext cx="11430000" cy="219456"/>
+          </a:xfrm>
+          <a:prstGeom prst="rect">
+            <a:avLst/>
+          </a:prstGeom>
+          <a:noFill/>
+        </p:spPr>
+        <p:txBody>
+          <a:bodyPr wrap="square" lIns="0" rIns="0" tIns="0" bIns="0" anchor="ctr"/>
+          <a:lstStyle/>
+          <a:p>
+            <a:pPr algn="l">
+              <a:spcBef>
+                <a:spcPts val="0"/>
+              </a:spcBef>
+              <a:spcAft>
+                <a:spcPts val="0"/>
+              </a:spcAft>
+            </a:pPr>
+            <a:r>
+              <a:rPr sz="1100" b="0">
+                <a:solidFill>
+                  <a:srgbClr val="5A636E"/>
+                </a:solidFill>
+                <a:latin typeface="Microsoft YaHei"/>
+                <a:ea typeface="Microsoft YaHei"/>
+                <a:cs typeface="Microsoft YaHei"/>
+              </a:rPr>
+              <a:t>10T 为外推    ·    96 GB / 486 T、一份 128 卡副本    ·    访存与通信 80%    ·    计算 70%</a:t>
+            </a:r>
+          </a:p>
+        </p:txBody>
+      </p:sp>
+      <p:sp>
+        <p:nvSpPr>
+          <p:cNvPr id="8" name="Rounded Rectangle 7"/>
+          <p:cNvSpPr/>
+          <p:nvPr/>
+        </p:nvSpPr>
+        <p:spPr>
+          <a:xfrm>
+            <a:off x="384048" y="841248"/>
+            <a:ext cx="11430000" cy="420624"/>
+          </a:xfrm>
+          <a:prstGeom prst="roundRect">
+            <a:avLst/>
+          </a:prstGeom>
+          <a:solidFill>
+            <a:srgbClr val="E7F3F2"/>
+          </a:solidFill>
+          <a:ln>
+            <a:noFill/>
+          </a:ln>
+        </p:spPr>
+        <p:style>
+          <a:lnRef idx="1">
+            <a:schemeClr val="accent1"/>
+          </a:lnRef>
+          <a:fillRef idx="3">
+            <a:schemeClr val="accent1"/>
+          </a:fillRef>
+          <a:effectRef idx="2">
+            <a:schemeClr val="accent1"/>
+          </a:effectRef>
+          <a:fontRef idx="minor">
+            <a:schemeClr val="lt1"/>
+          </a:fontRef>
+        </p:style>
+        <p:txBody>
+          <a:bodyPr rtlCol="0" anchor="ctr"/>
+          <a:lstStyle/>
+          <a:p>
+            <a:pPr algn="ctr"/>
+          </a:p>
+        </p:txBody>
+      </p:sp>
+      <p:sp>
+        <p:nvSpPr>
+          <p:cNvPr id="9" name="TextBox 8"/>
+          <p:cNvSpPr txBox="1"/>
+          <p:nvPr/>
+        </p:nvSpPr>
+        <p:spPr>
+          <a:xfrm>
+            <a:off x="530352" y="841248"/>
+            <a:ext cx="11137392" cy="420624"/>
+          </a:xfrm>
+          <a:prstGeom prst="rect">
+            <a:avLst/>
+          </a:prstGeom>
+          <a:noFill/>
+        </p:spPr>
+        <p:txBody>
+          <a:bodyPr wrap="square" lIns="0" rIns="0" tIns="0" bIns="0" anchor="ctr"/>
+          <a:lstStyle/>
+          <a:p>
+            <a:pPr algn="l">
+              <a:spcBef>
+                <a:spcPts val="0"/>
+              </a:spcBef>
+              <a:spcAft>
+                <a:spcPts val="0"/>
+              </a:spcAft>
+            </a:pPr>
+            <a:r>
+              <a:rPr sz="1300" b="1">
+                <a:solidFill>
+                  <a:srgbClr val="0E7A76"/>
+                </a:solidFill>
+                <a:latin typeface="Microsoft YaHei"/>
+                <a:ea typeface="Microsoft YaHei"/>
+                <a:cs typeface="Microsoft YaHei"/>
+              </a:rPr>
+              <a:t>饼图只画单卡 96 GB HBM；放不下的 KV 在饼图外标出 DDR 池占用。仍按最忙活跃卡。</a:t>
+            </a:r>
+          </a:p>
+        </p:txBody>
+      </p:sp>
+      <p:graphicFrame>
+        <p:nvGraphicFramePr>
+          <p:cNvPr id="10" name="Chart 9"/>
+          <p:cNvGraphicFramePr>
+            <a:graphicFrameLocks noGrp="1"/>
+          </p:cNvGraphicFramePr>
+          <p:nvPr/>
+        </p:nvGraphicFramePr>
+        <p:xfrm>
+          <a:off x="384048" y="1572768"/>
+          <a:ext cx="3529584" cy="3127248"/>
+        </p:xfrm>
+        <a:graphic>
+          <a:graphicData uri="http://schemas.openxmlformats.org/drawingml/2006/chart">
+            <c:chart xmlns:c="http://schemas.openxmlformats.org/drawingml/2006/chart" r:id="rId2"/>
+          </a:graphicData>
+        </a:graphic>
+      </p:graphicFrame>
+      <p:sp>
+        <p:nvSpPr>
+          <p:cNvPr id="11" name="TextBox 10"/>
+          <p:cNvSpPr txBox="1"/>
+          <p:nvPr/>
+        </p:nvSpPr>
+        <p:spPr>
+          <a:xfrm>
+            <a:off x="384048" y="1261872"/>
+            <a:ext cx="3529584" cy="274320"/>
+          </a:xfrm>
+          <a:prstGeom prst="rect">
+            <a:avLst/>
+          </a:prstGeom>
+          <a:noFill/>
+        </p:spPr>
+        <p:txBody>
+          <a:bodyPr wrap="square" lIns="0" rIns="0" tIns="0" bIns="0" anchor="ctr"/>
+          <a:lstStyle/>
+          <a:p>
+            <a:pPr algn="ctr">
+              <a:spcBef>
+                <a:spcPts val="0"/>
+              </a:spcBef>
+              <a:spcAft>
+                <a:spcPts val="0"/>
+              </a:spcAft>
+            </a:pPr>
+            <a:r>
+              <a:rPr sz="1500" b="1">
+                <a:solidFill>
+                  <a:srgbClr val="0E2A47"/>
+                </a:solidFill>
+                <a:latin typeface="Microsoft YaHei"/>
+                <a:ea typeface="Microsoft YaHei"/>
+                <a:cs typeface="Microsoft YaHei"/>
+              </a:rPr>
+              <a:t>4K</a:t>
+            </a:r>
+          </a:p>
+        </p:txBody>
+      </p:sp>
+      <p:sp>
+        <p:nvSpPr>
+          <p:cNvPr id="12" name="TextBox 11"/>
+          <p:cNvSpPr txBox="1"/>
+          <p:nvPr/>
+        </p:nvSpPr>
+        <p:spPr>
+          <a:xfrm>
+            <a:off x="384048" y="4681728"/>
+            <a:ext cx="3529584" cy="530352"/>
+          </a:xfrm>
+          <a:prstGeom prst="rect">
+            <a:avLst/>
+          </a:prstGeom>
+          <a:noFill/>
+        </p:spPr>
+        <p:txBody>
+          <a:bodyPr wrap="square" lIns="0" rIns="0" tIns="0" bIns="0" anchor="ctr"/>
+          <a:lstStyle/>
+          <a:p>
+            <a:pPr algn="ctr">
+              <a:spcBef>
+                <a:spcPts val="0"/>
+              </a:spcBef>
+              <a:spcAft>
+                <a:spcPts val="0"/>
+              </a:spcAft>
+            </a:pPr>
+            <a:r>
+              <a:rPr sz="1100" b="0">
+                <a:solidFill>
+                  <a:srgbClr val="1C242E"/>
+                </a:solidFill>
+                <a:latin typeface="Microsoft YaHei"/>
+                <a:ea typeface="Microsoft YaHei"/>
+                <a:cs typeface="Microsoft YaHei"/>
+              </a:rPr>
+              <a:t>BS 4352    权重 45.31 GB    预留 6 GB</a:t>
+            </a:r>
+          </a:p>
+          <a:p>
+            <a:pPr algn="ctr">
+              <a:spcBef>
+                <a:spcPts val="0"/>
+              </a:spcBef>
+              <a:spcAft>
+                <a:spcPts val="0"/>
+              </a:spcAft>
+            </a:pPr>
+            <a:r>
+              <a:rPr sz="1100" b="0">
+                <a:solidFill>
+                  <a:srgbClr val="1C242E"/>
+                </a:solidFill>
+                <a:latin typeface="Microsoft YaHei"/>
+                <a:ea typeface="Microsoft YaHei"/>
+                <a:cs typeface="Microsoft YaHei"/>
+              </a:rPr>
+              <a:t>HBM KV 0.84 GB  ｜  空闲 43.85 GB</a:t>
+            </a:r>
+          </a:p>
+        </p:txBody>
+      </p:sp>
+      <p:sp>
+        <p:nvSpPr>
+          <p:cNvPr id="13" name="TextBox 12"/>
+          <p:cNvSpPr txBox="1"/>
+          <p:nvPr/>
+        </p:nvSpPr>
+        <p:spPr>
+          <a:xfrm>
+            <a:off x="384048" y="5230368"/>
+            <a:ext cx="3529584" cy="256032"/>
+          </a:xfrm>
+          <a:prstGeom prst="rect">
+            <a:avLst/>
+          </a:prstGeom>
+          <a:noFill/>
+        </p:spPr>
+        <p:txBody>
+          <a:bodyPr wrap="square" lIns="0" rIns="0" tIns="0" bIns="0" anchor="ctr"/>
+          <a:lstStyle/>
+          <a:p>
+            <a:pPr algn="ctr">
+              <a:spcBef>
+                <a:spcPts val="0"/>
+              </a:spcBef>
+              <a:spcAft>
+                <a:spcPts val="0"/>
+              </a:spcAft>
+            </a:pPr>
+            <a:r>
+              <a:rPr sz="1100" b="0">
+                <a:solidFill>
+                  <a:srgbClr val="5A636E"/>
+                </a:solidFill>
+                <a:latin typeface="Microsoft YaHei"/>
+                <a:ea typeface="Microsoft YaHei"/>
+                <a:cs typeface="Microsoft YaHei"/>
+              </a:rPr>
+              <a:t>DDR 池 KV（图外）：0</a:t>
+            </a:r>
+          </a:p>
+        </p:txBody>
+      </p:sp>
+      <p:graphicFrame>
+        <p:nvGraphicFramePr>
+          <p:cNvPr id="14" name="Chart 13"/>
+          <p:cNvGraphicFramePr>
+            <a:graphicFrameLocks noGrp="1"/>
+          </p:cNvGraphicFramePr>
+          <p:nvPr/>
+        </p:nvGraphicFramePr>
+        <p:xfrm>
+          <a:off x="4315968" y="1572768"/>
+          <a:ext cx="3529584" cy="3127248"/>
+        </p:xfrm>
+        <a:graphic>
+          <a:graphicData uri="http://schemas.openxmlformats.org/drawingml/2006/chart">
+            <c:chart xmlns:c="http://schemas.openxmlformats.org/drawingml/2006/chart" r:id="rId3"/>
+          </a:graphicData>
+        </a:graphic>
+      </p:graphicFrame>
+      <p:sp>
+        <p:nvSpPr>
+          <p:cNvPr id="15" name="TextBox 14"/>
+          <p:cNvSpPr txBox="1"/>
+          <p:nvPr/>
+        </p:nvSpPr>
+        <p:spPr>
+          <a:xfrm>
+            <a:off x="4315968" y="1261872"/>
+            <a:ext cx="3529584" cy="274320"/>
+          </a:xfrm>
+          <a:prstGeom prst="rect">
+            <a:avLst/>
+          </a:prstGeom>
+          <a:noFill/>
+        </p:spPr>
+        <p:txBody>
+          <a:bodyPr wrap="square" lIns="0" rIns="0" tIns="0" bIns="0" anchor="ctr"/>
+          <a:lstStyle/>
+          <a:p>
+            <a:pPr algn="ctr">
+              <a:spcBef>
+                <a:spcPts val="0"/>
+              </a:spcBef>
+              <a:spcAft>
+                <a:spcPts val="0"/>
+              </a:spcAft>
+            </a:pPr>
+            <a:r>
+              <a:rPr sz="1500" b="1">
+                <a:solidFill>
+                  <a:srgbClr val="0E2A47"/>
+                </a:solidFill>
+                <a:latin typeface="Microsoft YaHei"/>
+                <a:ea typeface="Microsoft YaHei"/>
+                <a:cs typeface="Microsoft YaHei"/>
+              </a:rPr>
+              <a:t>512K</a:t>
+            </a:r>
+          </a:p>
+        </p:txBody>
+      </p:sp>
+      <p:sp>
+        <p:nvSpPr>
+          <p:cNvPr id="16" name="TextBox 15"/>
+          <p:cNvSpPr txBox="1"/>
+          <p:nvPr/>
+        </p:nvSpPr>
+        <p:spPr>
+          <a:xfrm>
+            <a:off x="4315968" y="4681728"/>
+            <a:ext cx="3529584" cy="530352"/>
+          </a:xfrm>
+          <a:prstGeom prst="rect">
+            <a:avLst/>
+          </a:prstGeom>
+          <a:noFill/>
+        </p:spPr>
+        <p:txBody>
+          <a:bodyPr wrap="square" lIns="0" rIns="0" tIns="0" bIns="0" anchor="ctr"/>
+          <a:lstStyle/>
+          <a:p>
+            <a:pPr algn="ctr">
+              <a:spcBef>
+                <a:spcPts val="0"/>
+              </a:spcBef>
+              <a:spcAft>
+                <a:spcPts val="0"/>
+              </a:spcAft>
+            </a:pPr>
+            <a:r>
+              <a:rPr sz="1100" b="0">
+                <a:solidFill>
+                  <a:srgbClr val="1C242E"/>
+                </a:solidFill>
+                <a:latin typeface="Microsoft YaHei"/>
+                <a:ea typeface="Microsoft YaHei"/>
+                <a:cs typeface="Microsoft YaHei"/>
+              </a:rPr>
+              <a:t>BS 2390    权重 45.31 GB    预留 6 GB</a:t>
+            </a:r>
+          </a:p>
+          <a:p>
+            <a:pPr algn="ctr">
+              <a:spcBef>
+                <a:spcPts val="0"/>
+              </a:spcBef>
+              <a:spcAft>
+                <a:spcPts val="0"/>
+              </a:spcAft>
+            </a:pPr>
+            <a:r>
+              <a:rPr sz="1100" b="0">
+                <a:solidFill>
+                  <a:srgbClr val="1C242E"/>
+                </a:solidFill>
+                <a:latin typeface="Microsoft YaHei"/>
+                <a:ea typeface="Microsoft YaHei"/>
+                <a:cs typeface="Microsoft YaHei"/>
+              </a:rPr>
+              <a:t>HBM KV 44.69 GB  ｜  空闲 0.00 GB</a:t>
+            </a:r>
+          </a:p>
+        </p:txBody>
+      </p:sp>
+      <p:sp>
+        <p:nvSpPr>
+          <p:cNvPr id="17" name="TextBox 16"/>
+          <p:cNvSpPr txBox="1"/>
+          <p:nvPr/>
+        </p:nvSpPr>
+        <p:spPr>
+          <a:xfrm>
+            <a:off x="4315968" y="5230368"/>
+            <a:ext cx="3529584" cy="256032"/>
+          </a:xfrm>
+          <a:prstGeom prst="rect">
+            <a:avLst/>
+          </a:prstGeom>
+          <a:noFill/>
+        </p:spPr>
+        <p:txBody>
+          <a:bodyPr wrap="square" lIns="0" rIns="0" tIns="0" bIns="0" anchor="ctr"/>
+          <a:lstStyle/>
+          <a:p>
+            <a:pPr algn="ctr">
+              <a:spcBef>
+                <a:spcPts val="0"/>
+              </a:spcBef>
+              <a:spcAft>
+                <a:spcPts val="0"/>
+              </a:spcAft>
+            </a:pPr>
+            <a:r>
+              <a:rPr sz="1100" b="1">
+                <a:solidFill>
+                  <a:srgbClr val="7A541C"/>
+                </a:solidFill>
+                <a:latin typeface="Microsoft YaHei"/>
+                <a:ea typeface="Microsoft YaHei"/>
+                <a:cs typeface="Microsoft YaHei"/>
+              </a:rPr>
+              <a:t>DDR 池 KV（图外）：3.95 GB / 卡</a:t>
+            </a:r>
+          </a:p>
+        </p:txBody>
+      </p:sp>
+      <p:graphicFrame>
+        <p:nvGraphicFramePr>
+          <p:cNvPr id="18" name="Chart 17"/>
+          <p:cNvGraphicFramePr>
+            <a:graphicFrameLocks noGrp="1"/>
+          </p:cNvGraphicFramePr>
+          <p:nvPr/>
+        </p:nvGraphicFramePr>
+        <p:xfrm>
+          <a:off x="8247888" y="1572768"/>
+          <a:ext cx="3529584" cy="3127248"/>
+        </p:xfrm>
+        <a:graphic>
+          <a:graphicData uri="http://schemas.openxmlformats.org/drawingml/2006/chart">
+            <c:chart xmlns:c="http://schemas.openxmlformats.org/drawingml/2006/chart" r:id="rId4"/>
+          </a:graphicData>
+        </a:graphic>
+      </p:graphicFrame>
+      <p:sp>
+        <p:nvSpPr>
+          <p:cNvPr id="19" name="TextBox 18"/>
+          <p:cNvSpPr txBox="1"/>
+          <p:nvPr/>
+        </p:nvSpPr>
+        <p:spPr>
+          <a:xfrm>
+            <a:off x="8247888" y="1261872"/>
+            <a:ext cx="3529584" cy="274320"/>
+          </a:xfrm>
+          <a:prstGeom prst="rect">
+            <a:avLst/>
+          </a:prstGeom>
+          <a:noFill/>
+        </p:spPr>
+        <p:txBody>
+          <a:bodyPr wrap="square" lIns="0" rIns="0" tIns="0" bIns="0" anchor="ctr"/>
+          <a:lstStyle/>
+          <a:p>
+            <a:pPr algn="ctr">
+              <a:spcBef>
+                <a:spcPts val="0"/>
+              </a:spcBef>
+              <a:spcAft>
+                <a:spcPts val="0"/>
+              </a:spcAft>
+            </a:pPr>
+            <a:r>
+              <a:rPr sz="1500" b="1">
+                <a:solidFill>
+                  <a:srgbClr val="0E2A47"/>
+                </a:solidFill>
+                <a:latin typeface="Microsoft YaHei"/>
+                <a:ea typeface="Microsoft YaHei"/>
+                <a:cs typeface="Microsoft YaHei"/>
+              </a:rPr>
+              <a:t>1M</a:t>
+            </a:r>
+          </a:p>
+        </p:txBody>
+      </p:sp>
+      <p:sp>
+        <p:nvSpPr>
+          <p:cNvPr id="20" name="TextBox 19"/>
+          <p:cNvSpPr txBox="1"/>
+          <p:nvPr/>
+        </p:nvSpPr>
+        <p:spPr>
+          <a:xfrm>
+            <a:off x="8247888" y="4681728"/>
+            <a:ext cx="3529584" cy="530352"/>
+          </a:xfrm>
+          <a:prstGeom prst="rect">
+            <a:avLst/>
+          </a:prstGeom>
+          <a:noFill/>
+        </p:spPr>
+        <p:txBody>
+          <a:bodyPr wrap="square" lIns="0" rIns="0" tIns="0" bIns="0" anchor="ctr"/>
+          <a:lstStyle/>
+          <a:p>
+            <a:pPr algn="ctr">
+              <a:spcBef>
+                <a:spcPts val="0"/>
+              </a:spcBef>
+              <a:spcAft>
+                <a:spcPts val="0"/>
+              </a:spcAft>
+            </a:pPr>
+            <a:r>
+              <a:rPr sz="1100" b="0">
+                <a:solidFill>
+                  <a:srgbClr val="1C242E"/>
+                </a:solidFill>
+                <a:latin typeface="Microsoft YaHei"/>
+                <a:ea typeface="Microsoft YaHei"/>
+                <a:cs typeface="Microsoft YaHei"/>
+              </a:rPr>
+              <a:t>BS 1362    权重 45.31 GB    预留 6 GB</a:t>
+            </a:r>
+          </a:p>
+          <a:p>
+            <a:pPr algn="ctr">
+              <a:spcBef>
+                <a:spcPts val="0"/>
+              </a:spcBef>
+              <a:spcAft>
+                <a:spcPts val="0"/>
+              </a:spcAft>
+            </a:pPr>
+            <a:r>
+              <a:rPr sz="1100" b="0">
+                <a:solidFill>
+                  <a:srgbClr val="1C242E"/>
+                </a:solidFill>
+                <a:latin typeface="Microsoft YaHei"/>
+                <a:ea typeface="Microsoft YaHei"/>
+                <a:cs typeface="Microsoft YaHei"/>
+              </a:rPr>
+              <a:t>HBM KV 44.69 GB  ｜  空闲 0.00 GB</a:t>
+            </a:r>
+          </a:p>
+        </p:txBody>
+      </p:sp>
+      <p:sp>
+        <p:nvSpPr>
+          <p:cNvPr id="21" name="TextBox 20"/>
+          <p:cNvSpPr txBox="1"/>
+          <p:nvPr/>
+        </p:nvSpPr>
+        <p:spPr>
+          <a:xfrm>
+            <a:off x="8247888" y="5230368"/>
+            <a:ext cx="3529584" cy="256032"/>
+          </a:xfrm>
+          <a:prstGeom prst="rect">
+            <a:avLst/>
+          </a:prstGeom>
+          <a:noFill/>
+        </p:spPr>
+        <p:txBody>
+          <a:bodyPr wrap="square" lIns="0" rIns="0" tIns="0" bIns="0" anchor="ctr"/>
+          <a:lstStyle/>
+          <a:p>
+            <a:pPr algn="ctr">
+              <a:spcBef>
+                <a:spcPts val="0"/>
+              </a:spcBef>
+              <a:spcAft>
+                <a:spcPts val="0"/>
+              </a:spcAft>
+            </a:pPr>
+            <a:r>
+              <a:rPr sz="1100" b="1">
+                <a:solidFill>
+                  <a:srgbClr val="7A541C"/>
+                </a:solidFill>
+                <a:latin typeface="Microsoft YaHei"/>
+                <a:ea typeface="Microsoft YaHei"/>
+                <a:cs typeface="Microsoft YaHei"/>
+              </a:rPr>
+              <a:t>DDR 池 KV（图外）：11.04 GB / 卡</a:t>
+            </a:r>
+          </a:p>
+        </p:txBody>
+      </p:sp>
+      <p:sp>
+        <p:nvSpPr>
+          <p:cNvPr id="22" name="Rounded Rectangle 21"/>
+          <p:cNvSpPr/>
+          <p:nvPr/>
+        </p:nvSpPr>
+        <p:spPr>
+          <a:xfrm>
+            <a:off x="384048" y="5632704"/>
+            <a:ext cx="11430000" cy="786384"/>
+          </a:xfrm>
+          <a:prstGeom prst="roundRect">
+            <a:avLst/>
+          </a:prstGeom>
+          <a:solidFill>
+            <a:srgbClr val="F8F1E4"/>
+          </a:solidFill>
+          <a:ln>
+            <a:noFill/>
+          </a:ln>
+        </p:spPr>
+        <p:style>
+          <a:lnRef idx="1">
+            <a:schemeClr val="accent1"/>
+          </a:lnRef>
+          <a:fillRef idx="3">
+            <a:schemeClr val="accent1"/>
+          </a:fillRef>
+          <a:effectRef idx="2">
+            <a:schemeClr val="accent1"/>
+          </a:effectRef>
+          <a:fontRef idx="minor">
+            <a:schemeClr val="lt1"/>
+          </a:fontRef>
+        </p:style>
+        <p:txBody>
+          <a:bodyPr rtlCol="0" anchor="ctr"/>
+          <a:lstStyle/>
+          <a:p>
+            <a:pPr algn="ctr"/>
+          </a:p>
+        </p:txBody>
+      </p:sp>
+      <p:sp>
+        <p:nvSpPr>
+          <p:cNvPr id="23" name="TextBox 22"/>
+          <p:cNvSpPr txBox="1"/>
+          <p:nvPr/>
+        </p:nvSpPr>
+        <p:spPr>
+          <a:xfrm>
+            <a:off x="530352" y="5669280"/>
+            <a:ext cx="11137392" cy="713232"/>
+          </a:xfrm>
+          <a:prstGeom prst="rect">
+            <a:avLst/>
+          </a:prstGeom>
+          <a:noFill/>
+        </p:spPr>
+        <p:txBody>
+          <a:bodyPr wrap="square" lIns="0" rIns="0" tIns="0" bIns="0" anchor="ctr"/>
+          <a:lstStyle/>
+          <a:p>
+            <a:pPr algn="l">
+              <a:spcBef>
+                <a:spcPts val="0"/>
+              </a:spcBef>
+              <a:spcAft>
+                <a:spcPts val="0"/>
+              </a:spcAft>
+            </a:pPr>
+            <a:r>
+              <a:rPr sz="1200" b="0">
+                <a:solidFill>
+                  <a:srgbClr val="7A541C"/>
+                </a:solidFill>
+                <a:latin typeface="Microsoft YaHei"/>
+                <a:ea typeface="Microsoft YaHei"/>
+                <a:cs typeface="Microsoft YaHei"/>
+              </a:rPr>
+              <a:t>30 毫秒：512K / 1M 的最忙卡各有 3.95 / 11.04 GB KV 在 DDR 池。10 毫秒批更小，4K / 512K / 1M 的 HBM KV 仅 0.04 / 4.22 / 7.13 GB，均不进池。</a:t>
+            </a:r>
+          </a:p>
+        </p:txBody>
+      </p:sp>
+    </p:spTree>
+  </p:cSld>
+  <p:clrMapOvr>
+    <a:masterClrMapping/>
+  </p:clrMapOvr>
+</p:sld>
+</file>
+
 <file path=ppt/slides/slide2.xml><?xml version="1.0" encoding="utf-8"?>
 <p:sld xmlns:a="http://schemas.openxmlformats.org/drawingml/2006/main" xmlns:p="http://schemas.openxmlformats.org/presentationml/2006/main" xmlns:r="http://schemas.openxmlformats.org/officeDocument/2006/relationships">
   <p:cSld>
@@ -11033,7 +14015,7 @@
                 <a:ea typeface="Microsoft YaHei"/>
                 <a:cs typeface="Microsoft YaHei"/>
               </a:rPr>
-              <a:t>2  /  11</a:t>
+              <a:t>2  /  13</a:t>
             </a:r>
           </a:p>
         </p:txBody>
@@ -13887,7 +16869,7 @@
                 <a:ea typeface="Microsoft YaHei"/>
                 <a:cs typeface="Microsoft YaHei"/>
               </a:rPr>
-              <a:t>3  /  11</a:t>
+              <a:t>3  /  13</a:t>
             </a:r>
           </a:p>
         </p:txBody>
@@ -19342,7 +22324,7 @@
                 <a:ea typeface="Microsoft YaHei"/>
                 <a:cs typeface="Microsoft YaHei"/>
               </a:rPr>
-              <a:t>4  /  11</a:t>
+              <a:t>4  /  13</a:t>
             </a:r>
           </a:p>
         </p:txBody>
@@ -22678,7 +25660,7 @@
                 <a:ea typeface="Microsoft YaHei"/>
                 <a:cs typeface="Microsoft YaHei"/>
               </a:rPr>
-              <a:t>5  /  11</a:t>
+              <a:t>5  /  13</a:t>
             </a:r>
           </a:p>
         </p:txBody>
@@ -26014,7 +28996,7 @@
                 <a:ea typeface="Microsoft YaHei"/>
                 <a:cs typeface="Microsoft YaHei"/>
               </a:rPr>
-              <a:t>6  /  11</a:t>
+              <a:t>6  /  13</a:t>
             </a:r>
           </a:p>
         </p:txBody>
@@ -30064,7 +33046,7 @@
                 <a:ea typeface="Microsoft YaHei"/>
                 <a:cs typeface="Microsoft YaHei"/>
               </a:rPr>
-              <a:t>7  /  11</a:t>
+              <a:t>7  /  13</a:t>
             </a:r>
           </a:p>
         </p:txBody>
@@ -32243,7 +35225,7 @@
                 <a:ea typeface="Microsoft YaHei"/>
                 <a:cs typeface="Microsoft YaHei"/>
               </a:rPr>
-              <a:t>8  /  11</a:t>
+              <a:t>8  /  13</a:t>
             </a:r>
           </a:p>
         </p:txBody>
@@ -35294,7 +38276,7 @@
                 <a:ea typeface="Microsoft YaHei"/>
                 <a:cs typeface="Microsoft YaHei"/>
               </a:rPr>
-              <a:t>9  /  11</a:t>
+              <a:t>9  /  13</a:t>
             </a:r>
           </a:p>
         </p:txBody>

</xml_diff>

<commit_message>
docs: update DeepSeek SLO deck for 98% prefix hits
Co-authored-by: 69515164-rgb <69515164-rgb@users.noreply.github.com>
</commit_message>
<xml_diff>
--- a/docs/deepseek-96g-slo.pptx
+++ b/docs/deepseek-96g-slo.pptx
@@ -226,10 +226,10 @@
                   <c:v>6.0</c:v>
                 </c:pt>
                 <c:pt idx="2">
-                  <c:v>1.1932032</c:v>
+                  <c:v>5.966016</c:v>
                 </c:pt>
                 <c:pt idx="3">
-                  <c:v>43.494018000000004</c:v>
+                  <c:v>38.7212052</c:v>
                 </c:pt>
               </c:numCache>
             </c:numRef>
@@ -387,10 +387,10 @@
                   <c:v>6.0</c:v>
                 </c:pt>
                 <c:pt idx="2">
-                  <c:v>0.974518272</c:v>
+                  <c:v>4.87259136</c:v>
                 </c:pt>
                 <c:pt idx="3">
-                  <c:v>43.712702928000006</c:v>
+                  <c:v>39.81462984</c:v>
                 </c:pt>
               </c:numCache>
             </c:numRef>
@@ -548,10 +548,10 @@
                   <c:v>6.0</c:v>
                 </c:pt>
                 <c:pt idx="2">
-                  <c:v>0.64799232</c:v>
+                  <c:v>2.59196928</c:v>
                 </c:pt>
                 <c:pt idx="3">
-                  <c:v>44.03922888</c:v>
+                  <c:v>42.09525192</c:v>
                 </c:pt>
               </c:numCache>
             </c:numRef>
@@ -1550,7 +1550,7 @@
           <a:lstStyle/>
           <a:p>
             <a:r>
-              <a:t>冷请求 S=250991，Attention=9.602715s，AR=9.602715s，compute=6.561439s，HBM=0.000853s，MoE=0.397249s，P-D=0.003874s，tail=0.000000s，total=9.999964s。</a:t>
+              <a:t>冷请求 S=250991，Attention=9.602715s，AR=9.602715s，compute=6.561439s，HBM=0.000853s，MoE=0.397249s，P-D=0.003888s，tail=0.000000s，total=9.999964s。</a:t>
             </a:r>
           </a:p>
         </p:txBody>
@@ -1690,7 +1690,7 @@
           <a:lstStyle/>
           <a:p>
             <a:r>
-              <a:t>饼图按最忙活跃 GPU，不按 128 卡平均。每卡固定：路由专家 38.864 GB，共享专家 4.030 GB，Attention 2.419 GB，系统预留 6 GB。KV = ceil(BS/16) × store_seq(S) / 8。4K: BS=6176, kv=1.193GB, free=43.494GB. 256K: BS=96, kv=0.975GB, free=43.713GB. 1M: BS=6, kv=0.648GB, free=44.039GB.</a:t>
+              <a:t>饼图按最忙活跃 GPU，不按 128 卡平均。每卡固定：路由专家 38.864 GB，共享专家 4.030 GB，Attention 2.419 GB，系统预留 6 GB。KV = ceil(BS/16) × store_seq(S) / 8。4K: BS=30880, kv=5.966GB, free=38.721GB. 256K: BS=480, kv=4.873GB, free=39.815GB. 1M: BS=64, kv=2.592GB, free=42.095GB.</a:t>
             </a:r>
           </a:p>
         </p:txBody>
@@ -1830,7 +1830,7 @@
           <a:lstStyle/>
           <a:p>
             <a:r>
-              <a:t>单请求不跨副本。增加 Prefill 节点是多放几份 128 卡副本，提高并发，单条 TTFT 不变。冷请求没有 prefix 拉取。Attention = max(HBM, compute, AR)，MoE = dispatch + max(weight, GEMM) + combine，两段相加。在 S=250991：indexer 1.4222s，HCA 0.7348s，投影 3.5690s，稀疏注意力 0.8355s，Attention 计算 6.5614s，AR 9.6027s，所以 Attention 取 9.6027s。MoE 0.3972s。完整 KV 的 P-D 传输 3.87 ms，layer-wise 发送后尾巴 0.00 ms。数据面合计 10.0000s。固定开销没有实测，不计入；生产最大长度必须再留余量。</a:t>
+              <a:t>单请求不跨副本。增加 Prefill 节点是多放几份 128 卡副本，提高并发，单条 TTFT 不变。冷请求没有 prefix 拉取。Attention = max(HBM, compute, AR)，MoE = dispatch + max(weight, GEMM) + combine，两段相加。在 S=250991：indexer 1.4222s，HCA 0.7348s，投影 3.5690s，稀疏注意力 0.8355s，Attention 计算 6.5614s，AR 9.6027s，所以 Attention 取 9.6027s。MoE 0.3972s。完整 KV 的 P-D 传输 3.89 ms，layer-wise 发送后尾巴 0.00 ms。数据面合计 10.0000s。固定开销没有实测，不计入；生产最大长度必须再留余量。</a:t>
             </a:r>
           </a:p>
         </p:txBody>
@@ -1900,7 +1900,7 @@
           <a:lstStyle/>
           <a:p>
             <a:r>
-              <a:t>这一页的批是 128 卡副本上的全局批，每卡条数 = 全局批 / 128。切分与上一页相同：注意力 TP=8、DP=16，MoE EP=128。KV 命中 90%，命中部分经每卡 40 GB/s 的参数面拉到 HBM。每条只现算 10%，这些 query 的平均上下文约为 95%S。Attention = max(prefix pull, HBM, compute, AR)。MoE = dispatch + max(weight, GEMM) + combine。Attention 与 MoE 相加。4K 全局批 6176：现算 2.5297e+06 token，allreduce 6.049s，注意力计算 2.817s，专家计算 3.950s，EP 双向 0.652s，读专家权重 13.40 ms，拉 prefix 22.0 ms，合计 9.999s。再加一条是 10.015s。1M 全局批 6：现算 6.2915e+05，allreduce 4.012s，注意力计算 8.993s（indexer 4.716s），MoE 0.989s，EP 双向 0.163s，拉 prefix 14.6 ms，合计 9.982s。P-D 完整 KV 分层发送：4K 24.41 ms，1M 16.19 ms；尾巴都是 0。固定开销未计入。</a:t>
+              <a:t>这一页的批是 128 卡副本上的全局批，每卡条数 = 全局批 / 128。切分与上一页相同：注意力 TP=8、DP=16，MoE EP=128。KV 命中 98%，命中部分经每卡 40 GB/s 的参数面拉到 HBM。每条只现算 2%，这些 query 的平均上下文约为 99%S。Attention = max(prefix pull, HBM, compute, AR)。MoE = dispatch + max(weight, GEMM) + combine。Attention 与 MoE 相加。4K 全局批 30880：现算 2.5297e+06 token，allreduce 6.049s，注意力计算 2.819s，专家计算 3.950s，EP 双向 0.652s，读专家权重 13.40 ms，拉 prefix 146.7 ms，合计 9.999s。再加一条是 10.002s。1M 全局批 64：现算 1.3422e+06，allreduce 3.209s，注意力计算 7.435s（indexer 3.932s），MoE 2.101s，EP 双向 0.347s，拉 prefix 63.5 ms，合计 9.537s。P-D 完整 KV 分层发送：4K 149.15 ms，1M 64.80 ms；尾巴都是 0。固定开销未计入。</a:t>
             </a:r>
           </a:p>
         </p:txBody>
@@ -2040,7 +2040,7 @@
           <a:lstStyle/>
           <a:p>
             <a:r>
-              <a:t>30 毫秒用的切分与 10 毫秒相同：TP=8，DP=16，EP=128，128 卡一份副本。BS=4352 时命中率 1.0000，最忙卡激活 19.289 个专家。读权重 (38.86 GB + 4.03 GB) / 3.20 TB/s = 13.404 ms。机内 allreduce：ceil(4352/16) = 272 条，环上每层 2×7/8，61 层，除以 40 GB/s = 10.407 ms。Attention 15.256 ms，MoE 14.675 ms，合计 29.931 ms。4353 条是 30.255 ms。EP 双向 1.271 ms，专家计算 8.448 ms，效率 0.753。注意力计算 4.849 ms。显存：每卡 96 − 38.86 − 4.03 − 2.42 − 6 = 44.69 GB，128 卡共 5.72 TB。HBM 放不下的 KV 走每卡总线内存池。标称 480 GB/s，被 3.2 Tb/s 的口卡住，有效 320 GB/s，容量不设上限。H2D 只在 prefill。256K、全局批 3328 时仍全在 HBM。512K 降到 2390，池上读 1.57 ms。1M 降到 1362，0.25×10^6 降到 3328。4K、输出 512、命中 90%：Prefill 617.6 请求/秒。10 毫秒 Decode 39.3 请求/秒，P:D ≈ 1:15.7。30 毫秒 Decode 283.3 请求/秒，P:D ≈ 1:2.2。</a:t>
+              <a:t>30 毫秒用的切分与 10 毫秒相同：TP=8，DP=16，EP=128，128 卡一份副本。BS=4352 时命中率 1.0000，最忙卡激活 19.289 个专家。读权重 (38.86 GB + 4.03 GB) / 3.20 TB/s = 13.404 ms。机内 allreduce：ceil(4352/16) = 272 条，环上每层 2×7/8，61 层，除以 40 GB/s = 10.407 ms。Attention 15.256 ms，MoE 14.675 ms，合计 29.931 ms。4353 条是 30.255 ms。EP 双向 1.271 ms，专家计算 8.448 ms，效率 0.753。注意力计算 4.849 ms。显存：每卡 96 − 38.86 − 4.03 − 2.42 − 6 = 44.69 GB，128 卡共 5.72 TB。HBM 放不下的 KV 走每卡总线内存池。标称 480 GB/s，被 3.2 Tb/s 的口卡住，有效 320 GB/s，容量不设上限。H2D 只在 prefill。256K、全局批 3328 时仍全在 HBM。512K 降到 2390，池上读 1.57 ms。1M 降到 1362，0.25×10^6 降到 3328。4K、输出 512、命中 98%：Prefill 3088.0 请求/秒。10 毫秒 Decode 39.3 请求/秒，P:D ≈ 1:78.7。30 毫秒 Decode 283.3 请求/秒，P:D ≈ 1:10.9。</a:t>
             </a:r>
           </a:p>
         </p:txBody>
@@ -2110,7 +2110,7 @@
           <a:lstStyle/>
           <a:p>
             <a:r>
-              <a:t>BS 一律是 128 卡副本的全局批。每卡条数 = 全局批 / 128。存量 = S×4939.5 字节 + 4.50 MB。一步真正读的是压缩 indexer、最多 1024 条完整 KV 和 HCA，所以溢出比例高时，池上的读时延仍可能短于 allreduce。HBM 余量 5.72 TB。溢出进 GPU 的口是每卡总线内存池，有效 320 GB/s，容量不设上限。这个带宽是 min(480 GB/s, 3.2 Tb/s = 400 GB/s) 再取 80%。专家通信在 MoE 阶段走同一条 320 GB/s。H2D 64 GB/s 只在 prefill，decode 换入走内存池。Decode Attention = SWAP + max(HBM, compute) + AR；再加完整 MoE。S=4096 store=24.7MB cap=231300 b10=201 spill10=0.00% pool10=0.00ms b30=4352 spill30=0.00% pool30=0.00ms t30=29.93ms S=8192 store=45.0MB cap=127218 b10=201 spill10=0.00% pool10=0.00ms b30=4336 spill30=0.00% pool30=0.00ms t30=29.96ms S=32768 store=166.4MB cap=34384 b10=200 spill10=0.00% pool10=0.00ms b30=4176 spill30=0.00% pool30=0.00ms t30=30.00ms S=131072 store=651.9MB cap=8773 b10=199 spill10=0.00% pool10=0.00ms b30=3808 spill30=0.00% pool30=0.00ms t30=30.00ms S=262144 store=1299.4MB cap=4402 b10=197 spill10=0.00% pool10=0.00ms b30=3328 spill30=0.00% pool30=0.00ms t30=29.73ms S=524288 store=2594.2MB cap=2204 b10=193 spill10=0.00% pool10=0.00ms b30=2390 spill30=7.75% pool30=1.57ms t30=30.00ms S=1048576 store=5183.9MB cap=1103 b10=173 spill10=0.00% pool10=0.00ms b30=1362 spill30=18.99% pool30=4.28ms t30=29.99ms 2M 的 10 毫秒批 134，池上读 0.00 ms。4×10^6 的 10 毫秒批 68，30 毫秒批 416。0.25×10^6 的 10 毫秒批 197，30 毫秒批 3328。单条 1M、90% 命中的 TTFT 是 9.1650 秒。冷的 1M 单条是 57.689 秒。第 3 页 Prefill：4K 6176，8K 3088，32K 768，128K 192，256K 96，512K 32，1M 6。P:D 按 4K 进、512 出、90% 命中：Prefill 617.6 请求/秒，10 毫秒 Decode 39.3 请求/秒（1:15.73），30 毫秒 Decode 283.3 请求/秒（1:2.18）。副本数按这个吞吐比配置，单副本时延不变。</a:t>
+              <a:t>BS 一律是 128 卡副本的全局批。每卡条数 = 全局批 / 128。存量 = S×4939.5 字节 + 4.50 MB。一步真正读的是压缩 indexer、最多 1024 条完整 KV 和 HCA，所以溢出比例高时，池上的读时延仍可能短于 allreduce。HBM 余量 5.72 TB。溢出进 GPU 的口是每卡总线内存池，有效 320 GB/s，容量不设上限。这个带宽是 min(480 GB/s, 3.2 Tb/s = 400 GB/s) 再取 80%。专家通信在 MoE 阶段走同一条 320 GB/s。H2D 64 GB/s 只在 prefill，decode 换入走内存池。Decode Attention = SWAP + max(HBM, compute) + AR；再加完整 MoE。S=4096 store=24.7MB cap=231300 b10=201 spill10=0.00% pool10=0.00ms b30=4352 spill30=0.00% pool30=0.00ms t30=29.93ms S=8192 store=45.0MB cap=127218 b10=201 spill10=0.00% pool10=0.00ms b30=4336 spill30=0.00% pool30=0.00ms t30=29.96ms S=32768 store=166.4MB cap=34384 b10=200 spill10=0.00% pool10=0.00ms b30=4176 spill30=0.00% pool30=0.00ms t30=30.00ms S=131072 store=651.9MB cap=8773 b10=199 spill10=0.00% pool10=0.00ms b30=3808 spill30=0.00% pool30=0.00ms t30=30.00ms S=262144 store=1299.4MB cap=4402 b10=197 spill10=0.00% pool10=0.00ms b30=3328 spill30=0.00% pool30=0.00ms t30=29.73ms S=524288 store=2594.2MB cap=2204 b10=193 spill10=0.00% pool10=0.00ms b30=2390 spill30=7.75% pool30=1.57ms t30=30.00ms S=1048576 store=5183.9MB cap=1103 b10=173 spill10=0.00% pool10=0.00ms b30=1362 spill30=18.99% pool30=4.28ms t30=29.99ms 2M 的 10 毫秒批 134，池上读 0.00 ms。4×10^6 的 10 毫秒批 68，30 毫秒批 416。0.25×10^6 的 10 毫秒批 197，30 毫秒批 3328。单条 1M、98% 命中的 TTFT 是 1.8983 秒。冷的 1M 单条是 57.689 秒。第 3 页 Prefill：4K 30880，8K 15440，32K 3856，128K 960，256K 480，512K 192，1M 64。P:D 按 4K 进、512 出、98% 命中：Prefill 3088.0 请求/秒，10 毫秒 Decode 39.3 请求/秒（1:78.66），30 毫秒 Decode 283.3 请求/秒（1:10.90）。副本数按这个吞吐比配置，单副本时延不变。</a:t>
             </a:r>
           </a:p>
         </p:txBody>
@@ -8371,7 +8371,7 @@
                 <a:ea typeface="Microsoft YaHei"/>
                 <a:cs typeface="Microsoft YaHei"/>
               </a:rPr>
-              <a:t>本页所有时间已经包含完整 61 层。90% prefix 经参数面拉取，Decode 没有副本。</a:t>
+              <a:t>本页所有时间已经包含完整 61 层。98% prefix 经参数面拉取，Decode 没有副本。</a:t>
             </a:r>
           </a:p>
         </p:txBody>
@@ -8812,7 +8812,7 @@
                           <a:ea typeface="Microsoft YaHei"/>
                           <a:cs typeface="Microsoft YaHei"/>
                         </a:rPr>
-                        <a:t>⌈BS/16⌉ × 0.9S × 4939.5 / (8 × 40 GB/s)</a:t>
+                        <a:t>⌈BS/16⌉ × K(0.98S) / (8 × 40 GB/s)</a:t>
                       </a:r>
                     </a:p>
                   </a:txBody>
@@ -8867,7 +8867,7 @@
                           <a:ea typeface="Microsoft YaHei"/>
                           <a:cs typeface="Microsoft YaHei"/>
                         </a:rPr>
-                        <a:t>远端 KV → 参数面 → HBM；写入后 kernel 还会读一次</a:t>
+                        <a:t>K(x)=4939.5x+滑窗；远端 KV → HBM</a:t>
                       </a:r>
                     </a:p>
                   </a:txBody>
@@ -8979,7 +8979,7 @@
                           <a:ea typeface="Microsoft YaHei"/>
                           <a:cs typeface="Microsoft YaHei"/>
                         </a:rPr>
-                        <a:t>C = 0.1S × 0.9S + 0.1S × (0.1S + 1) / 2</a:t>
+                        <a:t>C = 0.02S × 0.98S + 0.02S × (0.02S + 1) / 2</a:t>
                       </a:r>
                     </a:p>
                   </a:txBody>
@@ -9034,7 +9034,7 @@
                           <a:ea typeface="Microsoft YaHei"/>
                           <a:cs typeface="Microsoft YaHei"/>
                         </a:rPr>
-                        <a:t>新 token 平均看到约 95% 的完整上下文</a:t>
+                        <a:t>新 token 平均看到约 99% 的完整上下文</a:t>
                       </a:r>
                     </a:p>
                   </a:txBody>
@@ -9480,7 +9480,7 @@
                           <a:ea typeface="Microsoft YaHei"/>
                           <a:cs typeface="Microsoft YaHei"/>
                         </a:rPr>
-                        <a:t>⌈BS/16⌉ × S × 4939.5 / (8 × 40 GB/s)</a:t>
+                        <a:t>⌈BS/16⌉ × K(S) / (8 × 40 GB/s)</a:t>
                       </a:r>
                     </a:p>
                   </a:txBody>
@@ -9535,7 +9535,7 @@
                           <a:ea typeface="Microsoft YaHei"/>
                           <a:cs typeface="Microsoft YaHei"/>
                         </a:rPr>
-                        <a:t>Decode 无 prefix 副本，必须收到完整 KV</a:t>
+                        <a:t>K(S)=4939.5S+4.50 MB；发送完整 KV</a:t>
                       </a:r>
                     </a:p>
                   </a:txBody>
@@ -12057,7 +12057,7 @@
                 <a:ea typeface="Microsoft YaHei"/>
                 <a:cs typeface="Microsoft YaHei"/>
               </a:rPr>
-              <a:t>HBM 容量    ·    TTFT ≤ 10 秒    ·    90% prefix 命中</a:t>
+              <a:t>HBM 容量    ·    TTFT ≤ 10 秒    ·    98% prefix 命中</a:t>
             </a:r>
           </a:p>
         </p:txBody>
@@ -12413,7 +12413,7 @@
                 <a:ea typeface="Microsoft YaHei"/>
                 <a:cs typeface="Microsoft YaHei"/>
               </a:rPr>
-              <a:t>BS 6176    权重 45.31 GB    预留 6 GB</a:t>
+              <a:t>BS 30880    权重 45.31 GB    预留 6 GB</a:t>
             </a:r>
           </a:p>
           <a:p>
@@ -12434,7 +12434,7 @@
                 <a:ea typeface="Microsoft YaHei"/>
                 <a:cs typeface="Microsoft YaHei"/>
               </a:rPr>
-              <a:t>HBM KV 1.19 GB  ｜  空闲 43.49 GB</a:t>
+              <a:t>HBM KV 5.97 GB  ｜  空闲 38.72 GB</a:t>
             </a:r>
           </a:p>
         </p:txBody>
@@ -12578,7 +12578,7 @@
                 <a:ea typeface="Microsoft YaHei"/>
                 <a:cs typeface="Microsoft YaHei"/>
               </a:rPr>
-              <a:t>BS 96    权重 45.31 GB    预留 6 GB</a:t>
+              <a:t>BS 480    权重 45.31 GB    预留 6 GB</a:t>
             </a:r>
           </a:p>
           <a:p>
@@ -12599,7 +12599,7 @@
                 <a:ea typeface="Microsoft YaHei"/>
                 <a:cs typeface="Microsoft YaHei"/>
               </a:rPr>
-              <a:t>HBM KV 0.97 GB  ｜  空闲 43.71 GB</a:t>
+              <a:t>HBM KV 4.87 GB  ｜  空闲 39.81 GB</a:t>
             </a:r>
           </a:p>
         </p:txBody>
@@ -12743,7 +12743,7 @@
                 <a:ea typeface="Microsoft YaHei"/>
                 <a:cs typeface="Microsoft YaHei"/>
               </a:rPr>
-              <a:t>BS 6    权重 45.31 GB    预留 6 GB</a:t>
+              <a:t>BS 64    权重 45.31 GB    预留 6 GB</a:t>
             </a:r>
           </a:p>
           <a:p>
@@ -12764,7 +12764,7 @@
                 <a:ea typeface="Microsoft YaHei"/>
                 <a:cs typeface="Microsoft YaHei"/>
               </a:rPr>
-              <a:t>HBM KV 0.65 GB  ｜  空闲 44.04 GB</a:t>
+              <a:t>HBM KV 2.59 GB  ｜  空闲 42.10 GB</a:t>
             </a:r>
           </a:p>
         </p:txBody>
@@ -12891,7 +12891,7 @@
                 <a:ea typeface="Microsoft YaHei"/>
                 <a:cs typeface="Microsoft YaHei"/>
               </a:rPr>
-              <a:t>Prefill 的长输入先被 TTFT 限制：4K / 256K / 1M 的最大批分别是 6176 / 96 / 6，最忙卡 HBM KV 只有 1.19 / 0.97 / 0.65 GB，均不需要 DDR 池。</a:t>
+              <a:t>Prefill 的长输入先被 TTFT 限制：4K / 256K / 1M 的最大批分别是 30880 / 480 / 64，最忙卡 HBM KV 只有 5.97 / 4.87 / 2.59 GB，均不需要 DDR 池。</a:t>
             </a:r>
           </a:p>
         </p:txBody>
@@ -16485,7 +16485,7 @@
                           <a:ea typeface="Microsoft YaHei"/>
                           <a:cs typeface="Microsoft YaHei"/>
                         </a:rPr>
-                        <a:t>9.60 秒 + 3.87 毫秒</a:t>
+                        <a:t>9.60 秒 + 3.89 毫秒</a:t>
                       </a:r>
                     </a:p>
                   </a:txBody>
@@ -16785,7 +16785,7 @@
                 <a:ea typeface="Microsoft YaHei"/>
                 <a:cs typeface="Microsoft YaHei"/>
               </a:rPr>
-              <a:t>Prefill    ·    TTFT ≤ 10 秒    ·    KV 命中 90%</a:t>
+              <a:t>Prefill    ·    TTFT ≤ 10 秒    ·    KV 命中 98%</a:t>
             </a:r>
           </a:p>
         </p:txBody>
@@ -16827,7 +16827,7 @@
                 <a:ea typeface="Microsoft YaHei"/>
                 <a:cs typeface="Microsoft YaHei"/>
               </a:rPr>
-              <a:t>4K 的 prefill 全局批是 6176，1M 是 6</a:t>
+              <a:t>4K 的 prefill 全局批是 30880，1M 是 64</a:t>
             </a:r>
           </a:p>
         </p:txBody>
@@ -17039,7 +17039,7 @@
                 <a:ea typeface="Microsoft YaHei"/>
                 <a:cs typeface="Microsoft YaHei"/>
               </a:rPr>
-              <a:t>90% prefix 经参数面 40 GB/s 拉入 HBM，只现算 10%。Attention 取拉取、融合 kernel、AR 的瓶颈，再加完整 MoE。</a:t>
+              <a:t>98% prefix 经参数面 40 GB/s 拉入 HBM，只现算 2%。Attention 取拉取、融合 kernel、AR 的瓶颈，再加完整 MoE。</a:t>
             </a:r>
           </a:p>
         </p:txBody>
@@ -17244,7 +17244,7 @@
                           <a:ea typeface="Microsoft YaHei"/>
                           <a:cs typeface="Microsoft YaHei"/>
                         </a:rPr>
-                        <a:t>4K，全局批 6176</a:t>
+                        <a:t>4K，全局批 30880</a:t>
                       </a:r>
                     </a:p>
                   </a:txBody>
@@ -17299,7 +17299,7 @@
                           <a:ea typeface="Microsoft YaHei"/>
                           <a:cs typeface="Microsoft YaHei"/>
                         </a:rPr>
-                        <a:t>1M，全局批 6</a:t>
+                        <a:t>1M，全局批 64</a:t>
                       </a:r>
                     </a:p>
                   </a:txBody>
@@ -17411,7 +17411,7 @@
                           <a:ea typeface="Microsoft YaHei"/>
                           <a:cs typeface="Microsoft YaHei"/>
                         </a:rPr>
-                        <a:t>批 × 输入 × 0.1</a:t>
+                        <a:t>批 × 输入 × 0.02</a:t>
                       </a:r>
                     </a:p>
                   </a:txBody>
@@ -17521,7 +17521,7 @@
                           <a:ea typeface="Microsoft YaHei"/>
                           <a:cs typeface="Microsoft YaHei"/>
                         </a:rPr>
-                        <a:t>629.1×10^3</a:t>
+                        <a:t>1.34×10^6</a:t>
                       </a:r>
                     </a:p>
                   </a:txBody>
@@ -17767,7 +17767,7 @@
                           <a:ea typeface="Microsoft YaHei"/>
                           <a:cs typeface="Microsoft YaHei"/>
                         </a:rPr>
-                        <a:t>4.01 秒</a:t>
+                        <a:t>3.21 秒</a:t>
                       </a:r>
                     </a:p>
                   </a:txBody>
@@ -18013,7 +18013,7 @@
                           <a:ea typeface="Microsoft YaHei"/>
                           <a:cs typeface="Microsoft YaHei"/>
                         </a:rPr>
-                        <a:t>8.99 秒</a:t>
+                        <a:t>7.44 秒</a:t>
                       </a:r>
                     </a:p>
                   </a:txBody>
@@ -18235,7 +18235,7 @@
                           <a:ea typeface="Microsoft YaHei"/>
                           <a:cs typeface="Microsoft YaHei"/>
                         </a:rPr>
-                        <a:t>0.99 秒</a:t>
+                        <a:t>2.10 秒</a:t>
                       </a:r>
                     </a:p>
                   </a:txBody>
@@ -18457,7 +18457,7 @@
                           <a:ea typeface="Microsoft YaHei"/>
                           <a:cs typeface="Microsoft YaHei"/>
                         </a:rPr>
-                        <a:t>10.0 秒</a:t>
+                        <a:t>9.54 秒</a:t>
                       </a:r>
                     </a:p>
                   </a:txBody>
@@ -19083,7 +19083,7 @@
                           <a:ea typeface="Microsoft YaHei"/>
                           <a:cs typeface="Microsoft YaHei"/>
                         </a:rPr>
-                        <a:t>6176</a:t>
+                        <a:t>30880</a:t>
                       </a:r>
                     </a:p>
                   </a:txBody>
@@ -19138,7 +19138,7 @@
                           <a:ea typeface="Microsoft YaHei"/>
                           <a:cs typeface="Microsoft YaHei"/>
                         </a:rPr>
-                        <a:t>48.2</a:t>
+                        <a:t>241.2</a:t>
                       </a:r>
                     </a:p>
                   </a:txBody>
@@ -19413,7 +19413,7 @@
                           <a:ea typeface="Microsoft YaHei"/>
                           <a:cs typeface="Microsoft YaHei"/>
                         </a:rPr>
-                        <a:t>22.0 毫秒</a:t>
+                        <a:t>146.7 毫秒</a:t>
                       </a:r>
                     </a:p>
                   </a:txBody>
@@ -19525,7 +19525,7 @@
                           <a:ea typeface="Microsoft YaHei"/>
                           <a:cs typeface="Microsoft YaHei"/>
                         </a:rPr>
-                        <a:t>3088</a:t>
+                        <a:t>15440</a:t>
                       </a:r>
                     </a:p>
                   </a:txBody>
@@ -19580,7 +19580,7 @@
                           <a:ea typeface="Microsoft YaHei"/>
                           <a:cs typeface="Microsoft YaHei"/>
                         </a:rPr>
-                        <a:t>24.1</a:t>
+                        <a:t>120.6</a:t>
                       </a:r>
                     </a:p>
                   </a:txBody>
@@ -19855,7 +19855,7 @@
                           <a:ea typeface="Microsoft YaHei"/>
                           <a:cs typeface="Microsoft YaHei"/>
                         </a:rPr>
-                        <a:t>22.0 毫秒</a:t>
+                        <a:t>133.1 毫秒</a:t>
                       </a:r>
                     </a:p>
                   </a:txBody>
@@ -19967,7 +19967,7 @@
                           <a:ea typeface="Microsoft YaHei"/>
                           <a:cs typeface="Microsoft YaHei"/>
                         </a:rPr>
-                        <a:t>768</a:t>
+                        <a:t>3856</a:t>
                       </a:r>
                     </a:p>
                   </a:txBody>
@@ -20022,7 +20022,7 @@
                           <a:ea typeface="Microsoft YaHei"/>
                           <a:cs typeface="Microsoft YaHei"/>
                         </a:rPr>
-                        <a:t>6.0</a:t>
+                        <a:t>30.1</a:t>
                       </a:r>
                     </a:p>
                   </a:txBody>
@@ -20077,7 +20077,7 @@
                           <a:ea typeface="Microsoft YaHei"/>
                           <a:cs typeface="Microsoft YaHei"/>
                         </a:rPr>
-                        <a:t>2.52×10^6</a:t>
+                        <a:t>2.53×10^6</a:t>
                       </a:r>
                     </a:p>
                   </a:txBody>
@@ -20132,7 +20132,7 @@
                           <a:ea typeface="Microsoft YaHei"/>
                           <a:cs typeface="Microsoft YaHei"/>
                         </a:rPr>
-                        <a:t>6.02 秒</a:t>
+                        <a:t>6.04 秒</a:t>
                       </a:r>
                     </a:p>
                   </a:txBody>
@@ -20187,7 +20187,7 @@
                           <a:ea typeface="Microsoft YaHei"/>
                           <a:cs typeface="Microsoft YaHei"/>
                         </a:rPr>
-                        <a:t>3.93 秒</a:t>
+                        <a:t>3.95 秒</a:t>
                       </a:r>
                     </a:p>
                   </a:txBody>
@@ -20242,7 +20242,7 @@
                           <a:ea typeface="Microsoft YaHei"/>
                           <a:cs typeface="Microsoft YaHei"/>
                         </a:rPr>
-                        <a:t>3.10 秒</a:t>
+                        <a:t>3.12 秒</a:t>
                       </a:r>
                     </a:p>
                   </a:txBody>
@@ -20297,7 +20297,7 @@
                           <a:ea typeface="Microsoft YaHei"/>
                           <a:cs typeface="Microsoft YaHei"/>
                         </a:rPr>
-                        <a:t>21.9 毫秒</a:t>
+                        <a:t>122.8 毫秒</a:t>
                       </a:r>
                     </a:p>
                   </a:txBody>
@@ -20409,7 +20409,7 @@
                           <a:ea typeface="Microsoft YaHei"/>
                           <a:cs typeface="Microsoft YaHei"/>
                         </a:rPr>
-                        <a:t>192</a:t>
+                        <a:t>960</a:t>
                       </a:r>
                     </a:p>
                   </a:txBody>
@@ -20464,7 +20464,7 @@
                           <a:ea typeface="Microsoft YaHei"/>
                           <a:cs typeface="Microsoft YaHei"/>
                         </a:rPr>
-                        <a:t>1.5</a:t>
+                        <a:t>7.5</a:t>
                       </a:r>
                     </a:p>
                   </a:txBody>
@@ -20684,7 +20684,7 @@
                           <a:ea typeface="Microsoft YaHei"/>
                           <a:cs typeface="Microsoft YaHei"/>
                         </a:rPr>
-                        <a:t>4.10 秒</a:t>
+                        <a:t>4.16 秒</a:t>
                       </a:r>
                     </a:p>
                   </a:txBody>
@@ -20739,7 +20739,7 @@
                           <a:ea typeface="Microsoft YaHei"/>
                           <a:cs typeface="Microsoft YaHei"/>
                         </a:rPr>
-                        <a:t>21.9 毫秒</a:t>
+                        <a:t>119.8 毫秒</a:t>
                       </a:r>
                     </a:p>
                   </a:txBody>
@@ -20851,7 +20851,7 @@
                           <a:ea typeface="Microsoft YaHei"/>
                           <a:cs typeface="Microsoft YaHei"/>
                         </a:rPr>
-                        <a:t>96</a:t>
+                        <a:t>480</a:t>
                       </a:r>
                     </a:p>
                   </a:txBody>
@@ -20906,7 +20906,7 @@
                           <a:ea typeface="Microsoft YaHei"/>
                           <a:cs typeface="Microsoft YaHei"/>
                         </a:rPr>
-                        <a:t>0.75</a:t>
+                        <a:t>3.8</a:t>
                       </a:r>
                     </a:p>
                   </a:txBody>
@@ -21126,7 +21126,7 @@
                           <a:ea typeface="Microsoft YaHei"/>
                           <a:cs typeface="Microsoft YaHei"/>
                         </a:rPr>
-                        <a:t>5.44 秒</a:t>
+                        <a:t>5.56 秒</a:t>
                       </a:r>
                     </a:p>
                   </a:txBody>
@@ -21181,7 +21181,7 @@
                           <a:ea typeface="Microsoft YaHei"/>
                           <a:cs typeface="Microsoft YaHei"/>
                         </a:rPr>
-                        <a:t>21.9 毫秒</a:t>
+                        <a:t>119.4 毫秒</a:t>
                       </a:r>
                     </a:p>
                   </a:txBody>
@@ -21293,7 +21293,7 @@
                           <a:ea typeface="Microsoft YaHei"/>
                           <a:cs typeface="Microsoft YaHei"/>
                         </a:rPr>
-                        <a:t>32</a:t>
+                        <a:t>192</a:t>
                       </a:r>
                     </a:p>
                   </a:txBody>
@@ -21348,7 +21348,7 @@
                           <a:ea typeface="Microsoft YaHei"/>
                           <a:cs typeface="Microsoft YaHei"/>
                         </a:rPr>
-                        <a:t>0.25</a:t>
+                        <a:t>1.5</a:t>
                       </a:r>
                     </a:p>
                   </a:txBody>
@@ -21403,7 +21403,7 @@
                           <a:ea typeface="Microsoft YaHei"/>
                           <a:cs typeface="Microsoft YaHei"/>
                         </a:rPr>
-                        <a:t>1.68×10^6</a:t>
+                        <a:t>2.01×10^6</a:t>
                       </a:r>
                     </a:p>
                   </a:txBody>
@@ -21458,7 +21458,7 @@
                           <a:ea typeface="Microsoft YaHei"/>
                           <a:cs typeface="Microsoft YaHei"/>
                         </a:rPr>
-                        <a:t>4.01 秒</a:t>
+                        <a:t>4.81 秒</a:t>
                       </a:r>
                     </a:p>
                   </a:txBody>
@@ -21513,7 +21513,7 @@
                           <a:ea typeface="Microsoft YaHei"/>
                           <a:cs typeface="Microsoft YaHei"/>
                         </a:rPr>
-                        <a:t>2.62 秒</a:t>
+                        <a:t>3.14 秒</a:t>
                       </a:r>
                     </a:p>
                   </a:txBody>
@@ -21568,7 +21568,7 @@
                           <a:ea typeface="Microsoft YaHei"/>
                           <a:cs typeface="Microsoft YaHei"/>
                         </a:rPr>
-                        <a:t>5.42 秒</a:t>
+                        <a:t>6.68 秒</a:t>
                       </a:r>
                     </a:p>
                   </a:txBody>
@@ -21623,7 +21623,7 @@
                           <a:ea typeface="Microsoft YaHei"/>
                           <a:cs typeface="Microsoft YaHei"/>
                         </a:rPr>
-                        <a:t>14.6 毫秒</a:t>
+                        <a:t>95.3 毫秒</a:t>
                       </a:r>
                     </a:p>
                   </a:txBody>
@@ -21735,7 +21735,7 @@
                           <a:ea typeface="Microsoft YaHei"/>
                           <a:cs typeface="Microsoft YaHei"/>
                         </a:rPr>
-                        <a:t>6</a:t>
+                        <a:t>64</a:t>
                       </a:r>
                     </a:p>
                   </a:txBody>
@@ -21790,7 +21790,7 @@
                           <a:ea typeface="Microsoft YaHei"/>
                           <a:cs typeface="Microsoft YaHei"/>
                         </a:rPr>
-                        <a:t>0.05</a:t>
+                        <a:t>0.50</a:t>
                       </a:r>
                     </a:p>
                   </a:txBody>
@@ -21845,7 +21845,7 @@
                           <a:ea typeface="Microsoft YaHei"/>
                           <a:cs typeface="Microsoft YaHei"/>
                         </a:rPr>
-                        <a:t>629.1×10^3</a:t>
+                        <a:t>1.34×10^6</a:t>
                       </a:r>
                     </a:p>
                   </a:txBody>
@@ -21900,7 +21900,7 @@
                           <a:ea typeface="Microsoft YaHei"/>
                           <a:cs typeface="Microsoft YaHei"/>
                         </a:rPr>
-                        <a:t>4.01 秒</a:t>
+                        <a:t>3.21 秒</a:t>
                       </a:r>
                     </a:p>
                   </a:txBody>
@@ -21955,7 +21955,7 @@
                           <a:ea typeface="Microsoft YaHei"/>
                           <a:cs typeface="Microsoft YaHei"/>
                         </a:rPr>
-                        <a:t>0.99 秒</a:t>
+                        <a:t>2.10 秒</a:t>
                       </a:r>
                     </a:p>
                   </a:txBody>
@@ -22010,7 +22010,7 @@
                           <a:ea typeface="Microsoft YaHei"/>
                           <a:cs typeface="Microsoft YaHei"/>
                         </a:rPr>
-                        <a:t>8.99 秒</a:t>
+                        <a:t>7.44 秒</a:t>
                       </a:r>
                     </a:p>
                   </a:txBody>
@@ -22065,7 +22065,7 @@
                           <a:ea typeface="Microsoft YaHei"/>
                           <a:cs typeface="Microsoft YaHei"/>
                         </a:rPr>
-                        <a:t>14.6 毫秒</a:t>
+                        <a:t>63.5 毫秒</a:t>
                       </a:r>
                     </a:p>
                   </a:txBody>
@@ -22137,7 +22137,7 @@
                 <a:ea typeface="Microsoft YaHei"/>
                 <a:cs typeface="Microsoft YaHei"/>
               </a:rPr>
-              <a:t>90% prefix 走参数面：4K 这一批拉取 22.0 毫秒，1M 拉取 14.6 毫秒；均短于 Attention 主瓶颈。</a:t>
+              <a:t>98% prefix 走参数面：4K 这一批拉取 146.7 毫秒，1M 拉取 63.5 毫秒；均短于 Attention 主瓶颈。</a:t>
             </a:r>
           </a:p>
         </p:txBody>
@@ -32859,7 +32859,7 @@
                 <a:ea typeface="Microsoft YaHei"/>
                 <a:cs typeface="Microsoft YaHei"/>
               </a:rPr>
-              <a:t>Prefill 的 10 秒全局批在第 3 页：4K 为 6176，1M 为 6。4K 进、512 出、90% 命中时，P:D 在 10 毫秒约 1:15.7，在 30 毫秒约 1:2.2。</a:t>
+              <a:t>Prefill 的 10 秒全局批在第 3 页：4K 为 30880，1M 为 64。4K 进、512 出、98% 命中时，P:D 在 10 毫秒约 1:78.7，在 30 毫秒约 1:10.9。</a:t>
             </a:r>
           </a:p>
         </p:txBody>
@@ -39221,7 +39221,7 @@
                           <a:ea typeface="Microsoft YaHei"/>
                           <a:cs typeface="Microsoft YaHei"/>
                         </a:rPr>
-                        <a:t>90% prefix 在远端 KV 缓存，经参数面拉取；Decode 没有副本</a:t>
+                        <a:t>98% prefix 在远端 KV 缓存，经参数面拉取；Decode 没有副本</a:t>
                       </a:r>
                     </a:p>
                   </a:txBody>

</xml_diff>

<commit_message>
docs: model aggregate fullmesh bandwidth
Co-authored-by: 69515164-rgb <69515164-rgb@users.noreply.github.com>
</commit_message>
<xml_diff>
--- a/docs/deepseek-96g-slo.pptx
+++ b/docs/deepseek-96g-slo.pptx
@@ -226,10 +226,10 @@
                   <c:v>6.0</c:v>
                 </c:pt>
                 <c:pt idx="2">
-                  <c:v>5.966016</c:v>
+                  <c:v>8.825376</c:v>
                 </c:pt>
                 <c:pt idx="3">
-                  <c:v>38.7212052</c:v>
+                  <c:v>35.861845200000005</c:v>
                 </c:pt>
               </c:numCache>
             </c:numRef>
@@ -387,10 +387,10 @@
                   <c:v>6.0</c:v>
                 </c:pt>
                 <c:pt idx="2">
-                  <c:v>4.87259136</c:v>
+                  <c:v>5.197430784</c:v>
                 </c:pt>
                 <c:pt idx="3">
-                  <c:v>39.81462984</c:v>
+                  <c:v>39.489790416000005</c:v>
                 </c:pt>
               </c:numCache>
             </c:numRef>
@@ -709,10 +709,10 @@
                   <c:v>6.0</c:v>
                 </c:pt>
                 <c:pt idx="2">
-                  <c:v>0.8408064</c:v>
+                  <c:v>1.5332352</c:v>
                 </c:pt>
                 <c:pt idx="3">
-                  <c:v>43.846414800000005</c:v>
+                  <c:v>43.153986</c:v>
                 </c:pt>
               </c:numCache>
             </c:numRef>
@@ -1480,7 +1480,7 @@
           <a:lstStyle/>
           <a:p>
             <a:r>
-              <a:t>1.6T 来自 V4-Pro 论文 arXiv:2606.19348：61 层，隐藏 7168，384 个路由专家，中间维 3072，每 token 激活 6 个，激活参数 49B。单个路由专家在全部层上是 3×7168×3072×61 = 4.030×10^9。384 个专家为 1.547×10^12，总参数 1.600×10^12 减去这一项，其余 5.260×10^10 含共享专家、注意力、mHC、词表和 MTP。10T 把专家数解成 2469，总参数 = 2469×4.030×10^9 + 5.260×10^10 = 1.000×10^13。FP4 容量 = 2469×4.030×10^9×0.5 字节 = 4.975 TB。640 GB 卡下限是 ceil(4.975 TB / 640 GB) = 8。单 token 通信量 6×3×7168×61 = 7.87×10^6 字节。每 token 仍只派 6 个专家，通信量不随专家总数变。后面几页是 96 GB、486 T 这一档。算力 486×10^12 再乘 70%，有效 340.2×10^12。注意力和专家用同一个峰值。HBM 96 GB，带宽 4 TB/s，计时取 80% 即 3.20 TB/s。H2D 是 64 GB/s（字节），80% 后 51.2 GB/s。这条链路只在 prefill 使用。权重放得进 HBM，冷的 10 秒不走 H2D。D2D 写的是 3.2 Tb/s（小写 b，比特）：3.2×10^12 / 8 = 400 GB/s 峰值，80% 后 320 GB/s。机内 8 卡 fullmesh，P2P 400 Gb/s = 50 GB/s 峰值，80% 后 40 GB/s。参数面同样 400 Gb/s，80% 后 40 GB/s。DDR5 的 1288.8 GB/s 和 768 GB 按一台 8 卡机器记。有效 1031 GB/s，每卡分到 128.9 GB/s 和 96 GB。H2D 只有 51.2 GB/s，主机路径被 H2D 卡住。超节点内直挂总线的 DDR 池容量不设上限，标称每卡 480 GB/s。GPU 单向口只有 400 GB/s，池的访问取两者里较慢的，80% 后 320 GB/s。换入发生在注意力阶段，专家 combine 发生在 MoE 阶段，两段各用满这条 320 GB/s。本页的池带宽按每卡，不把 480 GB/s 理解成 128 卡共享。注意力 TP=8 留在机内 fullmesh，16 台机器做 DP=16。MoE EP=128 走 D2D。每卡扣掉路由 38.86 GB、共享 4.03 GB、注意力 2.42 GB 和 6 GB 预留后，128 卡 KV 余量 5.72 TB。Prefill 与 Decode 的副本数可以按吞吐配，副本个数不改变单副本的 TTFT 和 TPOT。</a:t>
+              <a:t>1.6T 来自 V4-Pro 论文 arXiv:2606.19348：61 层，隐藏 7168，384 个路由专家，中间维 3072，每 token 激活 6 个，激活参数 49B。单个路由专家在全部层上是 3×7168×3072×61 = 4.030×10^9。384 个专家为 1.547×10^12，总参数 1.600×10^12 减去这一项，其余 5.260×10^10 含共享专家、注意力、mHC、词表和 MTP。10T 把专家数解成 2469，总参数 = 2469×4.030×10^9 + 5.260×10^10 = 1.000×10^13。FP4 容量 = 2469×4.030×10^9×0.5 字节 = 4.975 TB。640 GB 卡下限是 ceil(4.975 TB / 640 GB) = 8。单 token 通信量 6×3×7168×61 = 7.87×10^6 字节。每 token 仍只派 6 个专家，通信量不随专家总数变。后面几页是 96 GB、486 T 这一档。算力 486×10^12 再乘 70%，有效 340.2×10^12。注意力和专家用同一个峰值。HBM 96 GB，带宽 4 TB/s，计时取 80% 即 3.20 TB/s。H2D 是 64 GB/s（字节），80% 后 51.2 GB/s。这条链路只在 prefill 使用。权重放得进 HBM，冷的 10 秒不走 H2D。D2D 3.2 Tb/s：换算400 GB/s峰值，80%后320 GB/s。8卡fullmesh每卡有7条400 Gb/s链路：聚合350 GB/s峰值，受D2D口约束前已较低，80%后AllReduce按280 GB/s。参数面400 Gb/s，80%后40 GB/s。DDR5 的 1288.8 GB/s 和 768 GB 按一台 8 卡机器记。有效 1031 GB/s，每卡分到 128.9 GB/s 和 96 GB。H2D 只有 51.2 GB/s，主机路径被 H2D 卡住。超节点内直挂总线的 DDR 池容量不设上限，标称每卡 480 GB/s。GPU 单向口只有 400 GB/s，池的访问取两者里较慢的，80% 后 320 GB/s。换入发生在注意力阶段，专家 combine 发生在 MoE 阶段，两段各用满这条 320 GB/s。本页的池带宽按每卡，不把 480 GB/s 理解成 128 卡共享。注意力 TP=8 留在机内 fullmesh，16 台机器做 DP=16。MoE EP=128 走 D2D。每卡扣掉路由 38.86 GB、共享 4.03 GB、注意力 2.42 GB 和 6 GB 预留后，128 卡 KV 余量 5.72 TB。Prefill 与 Decode 的副本数可以按吞吐配，副本个数不改变单副本的 TTFT 和 TPOT。</a:t>
             </a:r>
           </a:p>
         </p:txBody>
@@ -1550,7 +1550,7 @@
           <a:lstStyle/>
           <a:p>
             <a:r>
-              <a:t>冷请求 S=250991，Attention=9.602715s，AR=9.602715s，compute=6.561439s，HBM=0.000853s，MoE=0.397249s，P-D=0.003888s，tail=0.000000s，total=9.999964s。</a:t>
+              <a:t>冷请求 S=329024，Attention=9.480423s，AR=1.798314s，compute=9.480423s，HBM=0.000883s，MoE=0.519552s，P-D=0.005093s，tail=0.000000s，total=9.999975s。</a:t>
             </a:r>
           </a:p>
         </p:txBody>
@@ -1620,7 +1620,7 @@
           <a:lstStyle/>
           <a:p>
             <a:r>
-              <a:t>4K 10ms BS=201 data-plane=9.996224ms；4K 30ms BS=4352 data-plane=29.930840ms。生产摸高需要先给 measured fixed overhead 预留预算，再重新搜索 BS。</a:t>
+              <a:t>4K 10ms BS=222 data-plane=9.988046ms；4K 30ms BS=7936 data-plane=29.936117ms。生产摸高需要先给 measured fixed overhead 预留预算，再重新搜索 BS。</a:t>
             </a:r>
           </a:p>
         </p:txBody>
@@ -1690,7 +1690,7 @@
           <a:lstStyle/>
           <a:p>
             <a:r>
-              <a:t>饼图按最忙活跃 GPU，不按 128 卡平均。每卡固定：路由专家 38.864 GB，共享专家 4.030 GB，Attention 2.419 GB，系统预留 6 GB。KV = ceil(BS/16) × store_seq(S) / 8。4K: BS=30880, kv=5.966GB, free=38.721GB. 256K: BS=480, kv=4.873GB, free=39.815GB. 1M: BS=64, kv=2.592GB, free=42.095GB.</a:t>
+              <a:t>饼图按最忙活跃 GPU，不按 128 卡平均。每卡固定：路由专家 38.864 GB，共享专家 4.030 GB，Attention 2.419 GB，系统预留 6 GB。KV = ceil(BS/16) × store_seq(S) / 8。4K: BS=45674, kv=8.825GB, free=35.862GB. 256K: BS=498, kv=5.197GB, free=39.490GB. 1M: BS=64, kv=2.592GB, free=42.095GB.</a:t>
             </a:r>
           </a:p>
         </p:txBody>
@@ -1760,7 +1760,7 @@
           <a:lstStyle/>
           <a:p>
             <a:r>
-              <a:t>Decode 饼图使用 30ms 最大批，按最忙活跃 GPU。HBM KV 上限 44.687 GB。4K: BS=4352, hbm_kv=0.841GB, pool=0.000GB, free=43.846GB. 512K: BS=2390, hbm_kv=44.687GB, pool=3.954GB, free=0.000GB. 1M: BS=1362, hbm_kv=44.687GB, pool=11.040GB, free=0.000GB.</a:t>
+              <a:t>Decode 饼图使用 30ms 最大批，按最忙活跃 GPU。HBM KV 上限 44.687 GB。4K: BS=7936, hbm_kv=1.533GB, pool=0.000GB, free=43.154GB. 256K: BS=4880, hbm_kv=44.687GB, pool=4.851GB, free=0.000GB. 1M: BS=1528, hbm_kv=44.687GB, pool=17.520GB, free=0.000GB.</a:t>
             </a:r>
           </a:p>
         </p:txBody>
@@ -1830,7 +1830,7 @@
           <a:lstStyle/>
           <a:p>
             <a:r>
-              <a:t>单请求不跨副本。增加 Prefill 节点是多放几份 128 卡副本，提高并发，单条 TTFT 不变。冷请求没有 prefix 拉取。Attention = max(HBM, compute, AR)，MoE = dispatch + max(weight, GEMM) + combine，两段相加。在 S=250991：indexer 1.4222s，HCA 0.7348s，投影 3.5690s，稀疏注意力 0.8355s，Attention 计算 6.5614s，AR 9.6027s，所以 Attention 取 9.6027s。MoE 0.3972s。完整 KV 的 P-D 传输 3.89 ms，layer-wise 发送后尾巴 0.00 ms。数据面合计 10.0000s。固定开销没有实测，不计入；生产最大长度必须再留余量。</a:t>
+              <a:t>单请求不跨副本。增加 Prefill 节点是多放几份 128 卡副本，提高并发，单条 TTFT 不变。冷请求没有 prefix 拉取。Attention = max(HBM, compute, AR)，MoE = dispatch + max(weight, GEMM) + combine，两段相加。在 S=329024：indexer 2.4439s，HCA 1.2627s，投影 4.6786s，稀疏注意力 1.0953s，Attention 计算 9.4804s，AR 1.7983s，所以 Attention 取 9.4804s。MoE 0.5196s。完整 KV 的 P-D 传输 5.09 ms，layer-wise 发送后尾巴 0.00 ms。数据面合计 10.0000s。固定开销没有实测，不计入；生产最大长度必须再留余量。</a:t>
             </a:r>
           </a:p>
         </p:txBody>
@@ -1900,7 +1900,7 @@
           <a:lstStyle/>
           <a:p>
             <a:r>
-              <a:t>这一页的批是 128 卡副本上的全局批，每卡条数 = 全局批 / 128。切分与上一页相同：注意力 TP=8、DP=16，MoE EP=128。KV 命中 98%，命中部分经每卡 40 GB/s 的参数面拉到 HBM。每条只现算 2%，这些 query 的平均上下文约为 99%S。Attention = max(prefix pull, HBM, compute, AR)。MoE = dispatch + max(weight, GEMM) + combine。Attention 与 MoE 相加。4K 全局批 30880：现算 2.5297e+06 token，allreduce 6.049s，注意力计算 2.819s，专家计算 3.950s，EP 双向 0.652s，读专家权重 13.40 ms，拉 prefix 146.7 ms，合计 9.999s。再加一条是 10.002s。1M 全局批 64：现算 1.3422e+06，allreduce 3.209s，注意力计算 7.435s（indexer 3.932s），MoE 2.101s，EP 双向 0.347s，拉 prefix 63.5 ms，合计 9.537s。P-D 完整 KV 分层发送：4K 149.15 ms，1M 64.80 ms；尾巴都是 0。固定开销未计入。</a:t>
+              <a:t>这一页的批是 128 卡副本上的全局批，每卡条数 = 全局批 / 128。切分与上一页相同：注意力 TP=8、DP=16，MoE EP=128。KV 命中 98%，命中部分经每卡 40 GB/s 的参数面拉到 HBM。每条只现算 2%，这些 query 的平均上下文约为 99%S。Attention = max(prefix pull, HBM, compute, AR)。MoE = dispatch + max(weight, GEMM) + combine。Attention 与 MoE 相加。4K 全局批 45674：现算 3.7416e+06 token，allreduce 1.278s，注意力计算 4.169s，专家计算 5.830s，EP 双向 0.963s，读专家权重 13.40 ms，拉 prefix 217.0 ms，合计 10.000s。再加一条是 10.007s。1M 全局批 64：现算 1.3422e+06，allreduce 0.458s，注意力计算 7.435s（indexer 3.932s），MoE 2.101s，EP 双向 0.347s，拉 prefix 63.5 ms，合计 9.537s。P-D 完整 KV 分层发送：4K 220.63 ms，1M 64.80 ms；尾巴都是 0。固定开销未计入。</a:t>
             </a:r>
           </a:p>
         </p:txBody>
@@ -1970,7 +1970,7 @@
           <a:lstStyle/>
           <a:p>
             <a:r>
-              <a:t>Decode 与 Prefill 用同一份 128 卡副本：注意力 TP=8、DP=16，MoE EP=128。加 Decode 节点是多副本，单副本的 TPOT 不变。Attention = SWAP + max(HBM, compute) + AR。MoE = dispatch + max(weight, GEMM) + combine。两段相加。命中率 = 1 − exp(−6×201 / 2469) = 0.3864。最忙卡激活专家 11.731。读权重 (11.731×2.015 GB + 4.030 GB) / 3.20 TB/s = 8.646 ms。机内 allreduce：ceil(201/16) = 13 条，每条 7168×2 字节，环上每层 2×7/8，61 层除以 40 GB/s = 0.497 ms。Attention 1.266 ms，MoE 8.730 ms，合计 9.996 ms。202 条是 10.017 ms。专家计算 4.826 ms，EP 双向 0.085 ms。注意力计算 0.285 ms，HBM 0.768 ms。4K – 8K 的全局批都是 201，KV 全在 HBM。2M 降到 134，存量约 0.0% 在总线内存池，池上稀疏读 0.00 ms，已经顶到 allreduce 留下的预算。1M 降到 173，0.25×10^6 降到 197。这些批的存量都放得进 HBM，池上换入是 0。H2D 只在 prefill。</a:t>
+              <a:t>Decode 与 Prefill 用同一份 128 卡副本：注意力 TP=8、DP=16，MoE EP=128。加 Decode 节点是多副本，单副本的 TPOT 不变。Attention = SWAP + max(HBM, compute) + AR。MoE = dispatch + max(weight, GEMM) + combine。两段相加。命中率 = 1 − exp(−6×222 / 2469) = 0.4170。最忙卡激活专家 12.374。读权重 (12.374×2.015 GB + 4.030 GB) / 3.20 TB/s = 9.050 ms。机内 allreduce：ceil(222/16) = 14 条，每条7168×2字节，每层通信量2×7/8，61层除以280 GB/s = 0.077 ms。Attention 0.846 ms，MoE 9.142 ms，合计 9.988 ms。223 条是 10.007 ms。专家计算 5.069 ms，EP 双向 0.092 ms。注意力计算 0.285 ms，HBM 0.769 ms。4K – 32K 的全局批都是 222，KV 全在 HBM。2M 降到 145，存量约 0.0% 在总线内存池，池上稀疏读 0.00 ms，已经顶到 allreduce 留下的预算。1M 降到 190，0.33×10^6 降到 216。这些批的存量都放得进 HBM，池上换入是 0。H2D 只在 prefill。</a:t>
             </a:r>
           </a:p>
         </p:txBody>
@@ -2040,7 +2040,7 @@
           <a:lstStyle/>
           <a:p>
             <a:r>
-              <a:t>30 毫秒用的切分与 10 毫秒相同：TP=8，DP=16，EP=128，128 卡一份副本。BS=4352 时命中率 1.0000，最忙卡激活 19.289 个专家。读权重 (38.86 GB + 4.03 GB) / 3.20 TB/s = 13.404 ms。机内 allreduce：ceil(4352/16) = 272 条，环上每层 2×7/8，61 层，除以 40 GB/s = 10.407 ms。Attention 15.256 ms，MoE 14.675 ms，合计 29.931 ms。4353 条是 30.255 ms。EP 双向 1.271 ms，专家计算 8.448 ms，效率 0.753。注意力计算 4.849 ms。显存：每卡 96 − 38.86 − 4.03 − 2.42 − 6 = 44.69 GB，128 卡共 5.72 TB。HBM 放不下的 KV 走每卡总线内存池。标称 480 GB/s，被 3.2 Tb/s 的口卡住，有效 320 GB/s，容量不设上限。H2D 只在 prefill。256K、全局批 3328 时仍全在 HBM。512K 降到 2390，池上读 1.57 ms。1M 降到 1362，0.25×10^6 降到 3328。4K、输出 512、命中 98%：Prefill 3088.0 请求/秒。10 毫秒 Decode 39.3 请求/秒，P:D ≈ 1:78.7。30 毫秒 Decode 283.3 请求/秒，P:D ≈ 1:10.9。</a:t>
+              <a:t>30 毫秒用的切分与 10 毫秒相同：TP=8，DP=16，EP=128，128 卡一份副本。BS=7936 时命中率 1.0000，最忙卡激活 19.289 个专家。读权重 (38.86 GB + 4.03 GB) / 3.20 TB/s = 13.404 ms。机内 allreduce：ceil(7936/16) = 496 条，每层通信量2×7/8，61层，除以280 GB/s = 2.711 ms。Attention 11.554 ms，MoE 18.382 ms，合计 29.936 ms。7937 条是 30.227 ms。EP 双向 2.243 ms，专家计算 16.139 ms，效率 0.665。注意力计算 8.843 ms。显存：每卡 96 − 38.86 − 4.03 − 2.42 − 6 = 44.69 GB，128 卡共 5.72 TB。HBM 放不下的 KV 走每卡总线内存池。标称 480 GB/s，被 3.2 Tb/s 的口卡住，有效 320 GB/s，容量不设上限。H2D 只在 prefill。256K、全局批 4880 时已有 9.8% KV 在池中，池上读 2.15 ms。512K 降到 2816，池上读 5.18 ms。1M 降到 1528，0.33×10^6 降到 4096。4K、输出 512、命中 98%：Prefill 4567.4 请求/秒。10 毫秒 Decode 43.4 请求/秒，P:D ≈ 1:105.3。30 毫秒 Decode 516.7 请求/秒，P:D ≈ 1:8.8。</a:t>
             </a:r>
           </a:p>
         </p:txBody>
@@ -2110,7 +2110,7 @@
           <a:lstStyle/>
           <a:p>
             <a:r>
-              <a:t>BS 一律是 128 卡副本的全局批。每卡条数 = 全局批 / 128。存量 = S×4939.5 字节 + 4.50 MB。一步真正读的是压缩 indexer、最多 1024 条完整 KV 和 HCA，所以溢出比例高时，池上的读时延仍可能短于 allreduce。HBM 余量 5.72 TB。溢出进 GPU 的口是每卡总线内存池，有效 320 GB/s，容量不设上限。这个带宽是 min(480 GB/s, 3.2 Tb/s = 400 GB/s) 再取 80%。专家通信在 MoE 阶段走同一条 320 GB/s。H2D 64 GB/s 只在 prefill，decode 换入走内存池。Decode Attention = SWAP + max(HBM, compute) + AR；再加完整 MoE。S=4096 store=24.7MB cap=231300 b10=201 spill10=0.00% pool10=0.00ms b30=4352 spill30=0.00% pool30=0.00ms t30=29.93ms S=8192 store=45.0MB cap=127218 b10=201 spill10=0.00% pool10=0.00ms b30=4336 spill30=0.00% pool30=0.00ms t30=29.96ms S=32768 store=166.4MB cap=34384 b10=200 spill10=0.00% pool10=0.00ms b30=4176 spill30=0.00% pool30=0.00ms t30=30.00ms S=131072 store=651.9MB cap=8773 b10=199 spill10=0.00% pool10=0.00ms b30=3808 spill30=0.00% pool30=0.00ms t30=30.00ms S=262144 store=1299.4MB cap=4402 b10=197 spill10=0.00% pool10=0.00ms b30=3328 spill30=0.00% pool30=0.00ms t30=29.73ms S=524288 store=2594.2MB cap=2204 b10=193 spill10=0.00% pool10=0.00ms b30=2390 spill30=7.75% pool30=1.57ms t30=30.00ms S=1048576 store=5183.9MB cap=1103 b10=173 spill10=0.00% pool10=0.00ms b30=1362 spill30=18.99% pool30=4.28ms t30=29.99ms 2M 的 10 毫秒批 134，池上读 0.00 ms。4×10^6 的 10 毫秒批 68，30 毫秒批 416。0.25×10^6 的 10 毫秒批 197，30 毫秒批 3328。单条 1M、98% 命中的 TTFT 是 1.8983 秒。冷的 1M 单条是 57.689 秒。第 3 页 Prefill：4K 30880，8K 15440，32K 3856，128K 960，256K 480，512K 192，1M 64。P:D 按 4K 进、512 出、98% 命中：Prefill 3088.0 请求/秒，10 毫秒 Decode 39.3 请求/秒（1:78.66），30 毫秒 Decode 283.3 请求/秒（1:10.90）。副本数按这个吞吐比配置，单副本时延不变。</a:t>
+              <a:t>BS 一律是 128 卡副本的全局批。每卡条数 = 全局批 / 128。存量 = S×4939.5 字节 + 4.50 MB。一步真正读的是压缩 indexer、最多 1024 条完整 KV 和 HCA，所以溢出比例高时，池上的读时延仍可能短于 allreduce。HBM 余量 5.72 TB。溢出进 GPU 的口是每卡总线内存池，有效 320 GB/s，容量不设上限。这个带宽是 min(480 GB/s, 3.2 Tb/s = 400 GB/s) 再取 80%。专家通信在 MoE 阶段走同一条 320 GB/s。H2D 64 GB/s 只在 prefill，decode 换入走内存池。Decode Attention = SWAP + max(HBM, compute) + AR；再加完整 MoE。S=4096 store=24.7MB cap=231300 b10=222 spill10=0.00% pool10=0.00ms b30=7936 spill30=0.00% pool30=0.00ms t30=29.94ms S=8192 store=45.0MB cap=127218 b10=222 spill10=0.00% pool10=0.00ms b30=7808 spill30=0.00% pool30=0.00ms t30=30.00ms S=32768 store=166.4MB cap=34384 b10=222 spill10=0.00% pool10=0.00ms b30=7424 spill30=0.00% pool30=0.00ms t30=29.96ms S=131072 store=651.9MB cap=8773 b10=220 spill10=0.00% pool10=0.00ms b30=6144 spill30=0.00% pool30=0.00ms t30=29.80ms S=262144 store=1299.4MB cap=4402 b10=218 spill10=0.00% pool10=0.00ms b30=4880 spill30=9.79% pool30=2.15ms t30=30.00ms S=524288 store=2594.2MB cap=2204 b10=213 spill10=0.00% pool10=0.00ms b30=2816 spill30=21.70% pool30=5.18ms t30=29.80ms S=1048576 store=5183.9MB cap=1103 b10=190 spill10=0.00% pool10=0.00ms b30=1528 spill30=27.79% pool30=7.00ms t30=29.99ms 2M 的 10 毫秒批 145，池上读 0.00 ms。4×10^6 的 10 毫秒批 72，30 毫秒批 429。0.33×10^6 的 10 毫秒批 216，30 毫秒批 4096。单条 1M、98% 命中的 TTFT 是 1.8983 秒。冷的 1M 单条是 57.689 秒。第 3 页 Prefill：4K 45674，8K 22676，32K 5456，128K 1184，256K 498，512K 192，1M 64。P:D 按 4K 进、512 出、98% 命中：Prefill 4567.4 请求/秒，10 毫秒 Decode 43.4 请求/秒（1:105.34），30 毫秒 Decode 516.7 请求/秒（1:8.84）。副本数按这个吞吐比配置，单副本时延不变。</a:t>
             </a:r>
           </a:p>
         </p:txBody>
@@ -2180,7 +2180,7 @@
           <a:lstStyle/>
           <a:p>
             <a:r>
-              <a:t>第 7、8 页只统计 decode KV 溢出到 DDR 池的输入长度。全在 HBM 的长度留在第 6 页，不在这里记 0。512K BS=2390 pool=503.9 MB t=1.575 ms ar=5.739 ca=8.552 step=29.998。1M BS=1362 pool=1371.2 MB t=4.285 ms step=29.993。10 毫秒曲线在本档没有溢出长度。</a:t>
+              <a:t>第 7、8 页只统计 decode KV 溢出到 DDR 池的输入长度。全在 HBM 的长度留在第 6 页，不在这里记 0。256K BS=4880 pool=689.1 MB t=2.153 ms ar=1.667 ca=11.360 step=30.000。0.33×10^6 BS=4096 pool=1035.1 MB t=3.235 ms step=29.499。10 毫秒曲线在本档没有溢出长度。</a:t>
             </a:r>
           </a:p>
         </p:txBody>
@@ -2250,7 +2250,7 @@
           <a:lstStyle/>
           <a:p>
             <a:r>
-              <a:t>池上字节 = spill × bs × n_csa_read(S) / 128。带宽 320 GB/s。n_csa_read = 30×(S/4)×64 + 31×(S/128)×576 + 30×min(1024,S/4)×576 + 61×128×576。512K bs=2390 spill=7.75% pool=503.9MB t=1.575ms step=29.998ms 1M bs=1362 spill=18.99% pool=1371.2MB t=4.285ms step=29.993ms 口径已固化：第 7、8 页不收录换入为 0 的输入长度。</a:t>
+              <a:t>池上字节 = spill × bs × n_csa_read(S) / 128。带宽 320 GB/s。n_csa_read = 30×(S/4)×64 + 31×(S/128)×576 + 30×min(1024,S/4)×576 + 61×128×576。256K bs=4880 spill=9.79% pool=689.1MB t=2.153ms step=30.000ms 512K bs=2816 spill=21.70% pool=1656.6MB t=5.177ms step=29.797ms 1M bs=1528 spill=27.79% pool=2240.1MB t=7.000ms step=29.991ms 0.33×10^6 bs=4096 spill=14.31% pool=1035.1MB t=3.235ms step=29.499ms 口径已固化：第 7、8 页不收录换入为 0 的输入长度。</a:t>
             </a:r>
           </a:p>
         </p:txBody>
@@ -8014,7 +8014,7 @@
                 <a:ea typeface="Microsoft YaHei"/>
                 <a:cs typeface="Microsoft YaHei"/>
               </a:rPr>
-              <a:t>D2D 每卡 3.2 Tb/s = 400 GB/s，取 80% 为 320 GB/s。内存池标称 480 GB/s，被这条 400 GB/s 的口卡住，有效也是 320 GB/s，容量不设上限。P2P 与参数面 400 Gb/s 取 80% 为 40 GB/s。超节点 128 卡，机内 8 卡 fullmesh。</a:t>
+              <a:t>D2D 每卡 3.2 Tb/s = 400 GB/s，取 80% 为 320 GB/s。内存池标称 480 GB/s，被这条 400 GB/s 的口卡住，有效也是 320 GB/s，容量不设上限。8卡fullmesh每条链路400 Gb/s，7链路并发后取80%为280 GB/s；参数面仍为40 GB/s。</a:t>
             </a:r>
           </a:p>
         </p:txBody>
@@ -9984,7 +9984,7 @@
                 <a:ea typeface="Microsoft YaHei"/>
                 <a:cs typeface="Microsoft YaHei"/>
               </a:rPr>
-              <a:t>冷请求最大输入 25.1 万：Attention 9.60 秒，其中 AR 9.60 秒、计算 6.56 秒；MoE 0.40 秒；P→D 总量 3.9 毫秒，全部被后续计算隐藏；数据面合计 10.00 秒。固定开销未计入。</a:t>
+              <a:t>冷请求最大输入 32.9 万：Attention 9.48 秒，其中 AR 1.80 秒、计算 9.48 秒；MoE 0.52 秒；P→D 总量 5.1 毫秒，全部被后续计算隐藏；数据面合计 10.00 秒。固定开销未计入。</a:t>
             </a:r>
           </a:p>
         </p:txBody>
@@ -11283,7 +11283,7 @@
                           <a:ea typeface="Microsoft YaHei"/>
                           <a:cs typeface="Microsoft YaHei"/>
                         </a:rPr>
-                        <a:t>61 × 2×7/8 × n×7168×2 / 40 GB/s</a:t>
+                        <a:t>61 × 2×7/8 × n×7168×2 / 280 GB/s</a:t>
                       </a:r>
                     </a:p>
                   </a:txBody>
@@ -11338,7 +11338,7 @@
                           <a:ea typeface="Microsoft YaHei"/>
                           <a:cs typeface="Microsoft YaHei"/>
                         </a:rPr>
-                        <a:t>没有实测融合，单独加在 kernel 后面</a:t>
+                        <a:t>8卡fullmesh七链路并发；单独加在kernel后</a:t>
                       </a:r>
                     </a:p>
                   </a:txBody>
@@ -11954,7 +11954,7 @@
                 <a:ea typeface="Microsoft YaHei"/>
                 <a:cs typeface="Microsoft YaHei"/>
               </a:rPr>
-              <a:t>4K：10 毫秒批 201，Attention 1.27 毫秒 + MoE 8.73 毫秒 = 10.00 毫秒；30 毫秒批 4352，Attention 15.26 毫秒 + MoE 14.67 毫秒 = 29.93 毫秒。两档都没有给 fixed 留余量。</a:t>
+              <a:t>4K：10 毫秒批 222，Attention 0.85 毫秒 + MoE 9.14 毫秒 = 9.99 毫秒；30 毫秒批 7936，Attention 11.55 毫秒 + MoE 18.38 毫秒 = 29.94 毫秒。两档都没有给 fixed 留余量。</a:t>
             </a:r>
           </a:p>
         </p:txBody>
@@ -12413,7 +12413,7 @@
                 <a:ea typeface="Microsoft YaHei"/>
                 <a:cs typeface="Microsoft YaHei"/>
               </a:rPr>
-              <a:t>BS 30880    权重 45.31 GB    预留 6 GB</a:t>
+              <a:t>BS 45674    权重 45.31 GB    预留 6 GB</a:t>
             </a:r>
           </a:p>
           <a:p>
@@ -12434,7 +12434,7 @@
                 <a:ea typeface="Microsoft YaHei"/>
                 <a:cs typeface="Microsoft YaHei"/>
               </a:rPr>
-              <a:t>HBM KV 5.97 GB  ｜  空闲 38.72 GB</a:t>
+              <a:t>HBM KV 8.83 GB  ｜  空闲 35.86 GB</a:t>
             </a:r>
           </a:p>
         </p:txBody>
@@ -12578,7 +12578,7 @@
                 <a:ea typeface="Microsoft YaHei"/>
                 <a:cs typeface="Microsoft YaHei"/>
               </a:rPr>
-              <a:t>BS 480    权重 45.31 GB    预留 6 GB</a:t>
+              <a:t>BS 498    权重 45.31 GB    预留 6 GB</a:t>
             </a:r>
           </a:p>
           <a:p>
@@ -12599,7 +12599,7 @@
                 <a:ea typeface="Microsoft YaHei"/>
                 <a:cs typeface="Microsoft YaHei"/>
               </a:rPr>
-              <a:t>HBM KV 4.87 GB  ｜  空闲 39.81 GB</a:t>
+              <a:t>HBM KV 5.20 GB  ｜  空闲 39.49 GB</a:t>
             </a:r>
           </a:p>
         </p:txBody>
@@ -12891,7 +12891,7 @@
                 <a:ea typeface="Microsoft YaHei"/>
                 <a:cs typeface="Microsoft YaHei"/>
               </a:rPr>
-              <a:t>Prefill 的长输入先被 TTFT 限制：4K / 256K / 1M 的最大批分别是 30880 / 480 / 64，最忙卡 HBM KV 只有 5.97 / 4.87 / 2.59 GB，均不需要 DDR 池。</a:t>
+              <a:t>Prefill 的长输入先被 TTFT 限制：4K / 256K / 1M 的最大批分别是 45674 / 498 / 64，最忙卡 HBM KV 只有 8.83 / 5.20 / 2.59 GB，均不需要 DDR 池。</a:t>
             </a:r>
           </a:p>
         </p:txBody>
@@ -13036,7 +13036,7 @@
                 <a:ea typeface="Microsoft YaHei"/>
                 <a:cs typeface="Microsoft YaHei"/>
               </a:rPr>
-              <a:t>Decode：30 毫秒摸高时，512K 起把 HBM KV 房间占满</a:t>
+              <a:t>Decode：30 毫秒摸高时，256K 起把 HBM KV 房间占满</a:t>
             </a:r>
           </a:p>
         </p:txBody>
@@ -13350,7 +13350,7 @@
                 <a:ea typeface="Microsoft YaHei"/>
                 <a:cs typeface="Microsoft YaHei"/>
               </a:rPr>
-              <a:t>BS 4352    权重 45.31 GB    预留 6 GB</a:t>
+              <a:t>BS 7936    权重 45.31 GB    预留 6 GB</a:t>
             </a:r>
           </a:p>
           <a:p>
@@ -13371,7 +13371,7 @@
                 <a:ea typeface="Microsoft YaHei"/>
                 <a:cs typeface="Microsoft YaHei"/>
               </a:rPr>
-              <a:t>HBM KV 0.84 GB  ｜  空闲 43.85 GB</a:t>
+              <a:t>HBM KV 1.53 GB  ｜  空闲 43.15 GB</a:t>
             </a:r>
           </a:p>
         </p:txBody>
@@ -13473,7 +13473,7 @@
                 <a:ea typeface="Microsoft YaHei"/>
                 <a:cs typeface="Microsoft YaHei"/>
               </a:rPr>
-              <a:t>512K</a:t>
+              <a:t>256K</a:t>
             </a:r>
           </a:p>
         </p:txBody>
@@ -13515,7 +13515,7 @@
                 <a:ea typeface="Microsoft YaHei"/>
                 <a:cs typeface="Microsoft YaHei"/>
               </a:rPr>
-              <a:t>BS 2390    权重 45.31 GB    预留 6 GB</a:t>
+              <a:t>BS 4880    权重 45.31 GB    预留 6 GB</a:t>
             </a:r>
           </a:p>
           <a:p>
@@ -13578,7 +13578,7 @@
                 <a:ea typeface="Microsoft YaHei"/>
                 <a:cs typeface="Microsoft YaHei"/>
               </a:rPr>
-              <a:t>DDR 池 KV（图外）：3.95 GB / 卡</a:t>
+              <a:t>DDR 池 KV（图外）：4.85 GB / 卡</a:t>
             </a:r>
           </a:p>
         </p:txBody>
@@ -13680,7 +13680,7 @@
                 <a:ea typeface="Microsoft YaHei"/>
                 <a:cs typeface="Microsoft YaHei"/>
               </a:rPr>
-              <a:t>BS 1362    权重 45.31 GB    预留 6 GB</a:t>
+              <a:t>BS 1528    权重 45.31 GB    预留 6 GB</a:t>
             </a:r>
           </a:p>
           <a:p>
@@ -13743,7 +13743,7 @@
                 <a:ea typeface="Microsoft YaHei"/>
                 <a:cs typeface="Microsoft YaHei"/>
               </a:rPr>
-              <a:t>DDR 池 KV（图外）：11.04 GB / 卡</a:t>
+              <a:t>DDR 池 KV（图外）：17.52 GB / 卡</a:t>
             </a:r>
           </a:p>
         </p:txBody>
@@ -13828,7 +13828,7 @@
                 <a:ea typeface="Microsoft YaHei"/>
                 <a:cs typeface="Microsoft YaHei"/>
               </a:rPr>
-              <a:t>30 毫秒：512K / 1M 的最忙卡各有 3.95 / 11.04 GB KV 在 DDR 池。10 毫秒批更小，4K / 512K / 1M 的 HBM KV 仅 0.04 / 4.22 / 7.13 GB，均不进池。</a:t>
+              <a:t>30 毫秒：256K / 1M 的最忙卡各有 4.85 / 17.52 GB KV 在 DDR 池。10 毫秒批更小，4K / 512K / 1M 的 HBM KV 仅 0.04 / 4.54 / 7.78 GB，均不进池。</a:t>
             </a:r>
           </a:p>
         </p:txBody>
@@ -13973,7 +13973,7 @@
                 <a:ea typeface="Microsoft YaHei"/>
                 <a:cs typeface="Microsoft YaHei"/>
               </a:rPr>
-              <a:t>10 秒对应的最大输入是 0.25×10^6</a:t>
+              <a:t>10 秒对应的最大输入是 0.33×10^6</a:t>
             </a:r>
           </a:p>
         </p:txBody>
@@ -14185,7 +14185,7 @@
                 <a:ea typeface="Microsoft YaHei"/>
                 <a:cs typeface="Microsoft YaHei"/>
               </a:rPr>
-              <a:t>冷请求：Attention 9.60 秒（AR 9.60 秒、计算 6.56 秒），MoE 0.40 秒；P→D 3.9 毫秒 全部隐藏。</a:t>
+              <a:t>冷请求：Attention 9.48 秒（AR 1.80 秒、计算 9.48 秒），MoE 0.52 秒；P→D 5.1 毫秒 全部隐藏。</a:t>
             </a:r>
           </a:p>
         </p:txBody>
@@ -14716,7 +14716,7 @@
                           <a:ea typeface="Microsoft YaHei"/>
                           <a:cs typeface="Microsoft YaHei"/>
                         </a:rPr>
-                        <a:t>8 卡 fullmesh</a:t>
+                        <a:t>8卡 fullmesh，7链路并发</a:t>
                       </a:r>
                     </a:p>
                     <a:p>
@@ -14740,7 +14740,7 @@
                           <a:ea typeface="Microsoft YaHei"/>
                           <a:cs typeface="Microsoft YaHei"/>
                         </a:rPr>
-                        <a:t>有效 40 GB/s</a:t>
+                        <a:t>AllReduce 有效 280 GB/s</a:t>
                       </a:r>
                     </a:p>
                   </a:txBody>
@@ -14795,7 +14795,7 @@
                           <a:ea typeface="Microsoft YaHei"/>
                           <a:cs typeface="Microsoft YaHei"/>
                         </a:rPr>
-                        <a:t>128 卡 D2D，有效 320 GB/s</a:t>
+                        <a:t>128卡 D2D，有效320 GB/s</a:t>
                       </a:r>
                     </a:p>
                     <a:p>
@@ -14819,7 +14819,7 @@
                           <a:ea typeface="Microsoft YaHei"/>
                           <a:cs typeface="Microsoft YaHei"/>
                         </a:rPr>
-                        <a:t>KV 走参数面，有效 40 GB/s</a:t>
+                        <a:t>KV走参数面，有效40 GB/s</a:t>
                       </a:r>
                     </a:p>
                   </a:txBody>
@@ -15170,7 +15170,7 @@
                           <a:ea typeface="Microsoft YaHei"/>
                           <a:cs typeface="Microsoft YaHei"/>
                         </a:rPr>
-                        <a:t>这一点由 AR 限制</a:t>
+                        <a:t>按实际最长通路决定</a:t>
                       </a:r>
                     </a:p>
                   </a:txBody>
@@ -15249,7 +15249,7 @@
                           <a:ea typeface="Microsoft YaHei"/>
                           <a:cs typeface="Microsoft YaHei"/>
                         </a:rPr>
-                        <a:t>到这个长度合计 0.40 秒</a:t>
+                        <a:t>到这个长度合计 0.52 秒</a:t>
                       </a:r>
                     </a:p>
                   </a:txBody>
@@ -15483,7 +15483,7 @@
                           <a:ea typeface="Microsoft YaHei"/>
                           <a:cs typeface="Microsoft YaHei"/>
                         </a:rPr>
-                        <a:t>S = 0.25×10^6 时</a:t>
+                        <a:t>S = 0.33×10^6 时</a:t>
                       </a:r>
                     </a:p>
                   </a:txBody>
@@ -15650,7 +15650,7 @@
                           <a:ea typeface="Microsoft YaHei"/>
                           <a:cs typeface="Microsoft YaHei"/>
                         </a:rPr>
-                        <a:t>1.42 秒</a:t>
+                        <a:t>2.44 秒</a:t>
                       </a:r>
                     </a:p>
                   </a:txBody>
@@ -15817,7 +15817,7 @@
                           <a:ea typeface="Microsoft YaHei"/>
                           <a:cs typeface="Microsoft YaHei"/>
                         </a:rPr>
-                        <a:t>0.73 秒</a:t>
+                        <a:t>1.26 秒</a:t>
                       </a:r>
                     </a:p>
                   </a:txBody>
@@ -15984,7 +15984,7 @@
                           <a:ea typeface="Microsoft YaHei"/>
                           <a:cs typeface="Microsoft YaHei"/>
                         </a:rPr>
-                        <a:t>0.40 秒</a:t>
+                        <a:t>0.52 秒</a:t>
                       </a:r>
                     </a:p>
                   </a:txBody>
@@ -16151,7 +16151,7 @@
                           <a:ea typeface="Microsoft YaHei"/>
                           <a:cs typeface="Microsoft YaHei"/>
                         </a:rPr>
-                        <a:t>3.57 秒</a:t>
+                        <a:t>4.68 秒</a:t>
                       </a:r>
                     </a:p>
                   </a:txBody>
@@ -16318,7 +16318,7 @@
                           <a:ea typeface="Microsoft YaHei"/>
                           <a:cs typeface="Microsoft YaHei"/>
                         </a:rPr>
-                        <a:t>0.84 秒</a:t>
+                        <a:t>1.10 秒</a:t>
                       </a:r>
                     </a:p>
                   </a:txBody>
@@ -16485,7 +16485,7 @@
                           <a:ea typeface="Microsoft YaHei"/>
                           <a:cs typeface="Microsoft YaHei"/>
                         </a:rPr>
-                        <a:t>9.60 秒 + 3.89 毫秒</a:t>
+                        <a:t>1.80 秒 + 5.09 毫秒</a:t>
                       </a:r>
                     </a:p>
                   </a:txBody>
@@ -16827,7 +16827,7 @@
                 <a:ea typeface="Microsoft YaHei"/>
                 <a:cs typeface="Microsoft YaHei"/>
               </a:rPr>
-              <a:t>4K 的 prefill 全局批是 30880，1M 是 64</a:t>
+              <a:t>4K 的 prefill 全局批是 45674，1M 是 64</a:t>
             </a:r>
           </a:p>
         </p:txBody>
@@ -17244,7 +17244,7 @@
                           <a:ea typeface="Microsoft YaHei"/>
                           <a:cs typeface="Microsoft YaHei"/>
                         </a:rPr>
-                        <a:t>4K，全局批 30880</a:t>
+                        <a:t>4K，全局批 45674</a:t>
                       </a:r>
                     </a:p>
                   </a:txBody>
@@ -17466,7 +17466,7 @@
                           <a:ea typeface="Microsoft YaHei"/>
                           <a:cs typeface="Microsoft YaHei"/>
                         </a:rPr>
-                        <a:t>2.53×10^6</a:t>
+                        <a:t>3.74×10^6</a:t>
                       </a:r>
                     </a:p>
                   </a:txBody>
@@ -17657,7 +17657,7 @@
                           <a:ea typeface="Microsoft YaHei"/>
                           <a:cs typeface="Microsoft YaHei"/>
                         </a:rPr>
-                        <a:t>61 层 × 2×7/8 / 40 GB/s</a:t>
+                        <a:t>61 层 × 2×7/8 / 280 GB/s</a:t>
                       </a:r>
                     </a:p>
                   </a:txBody>
@@ -17712,7 +17712,7 @@
                           <a:ea typeface="Microsoft YaHei"/>
                           <a:cs typeface="Microsoft YaHei"/>
                         </a:rPr>
-                        <a:t>6.05 秒</a:t>
+                        <a:t>1.28 秒</a:t>
                       </a:r>
                     </a:p>
                   </a:txBody>
@@ -17767,7 +17767,7 @@
                           <a:ea typeface="Microsoft YaHei"/>
                           <a:cs typeface="Microsoft YaHei"/>
                         </a:rPr>
-                        <a:t>3.21 秒</a:t>
+                        <a:t>0.46 秒</a:t>
                       </a:r>
                     </a:p>
                   </a:txBody>
@@ -17958,7 +17958,7 @@
                           <a:ea typeface="Microsoft YaHei"/>
                           <a:cs typeface="Microsoft YaHei"/>
                         </a:rPr>
-                        <a:t>2.82 秒</a:t>
+                        <a:t>4.17 秒</a:t>
                       </a:r>
                     </a:p>
                   </a:txBody>
@@ -18180,7 +18180,7 @@
                           <a:ea typeface="Microsoft YaHei"/>
                           <a:cs typeface="Microsoft YaHei"/>
                         </a:rPr>
-                        <a:t>3.95 秒</a:t>
+                        <a:t>5.83 秒</a:t>
                       </a:r>
                     </a:p>
                   </a:txBody>
@@ -19083,7 +19083,7 @@
                           <a:ea typeface="Microsoft YaHei"/>
                           <a:cs typeface="Microsoft YaHei"/>
                         </a:rPr>
-                        <a:t>30880</a:t>
+                        <a:t>45674</a:t>
                       </a:r>
                     </a:p>
                   </a:txBody>
@@ -19138,7 +19138,7 @@
                           <a:ea typeface="Microsoft YaHei"/>
                           <a:cs typeface="Microsoft YaHei"/>
                         </a:rPr>
-                        <a:t>241.2</a:t>
+                        <a:t>356.8</a:t>
                       </a:r>
                     </a:p>
                   </a:txBody>
@@ -19193,7 +19193,7 @@
                           <a:ea typeface="Microsoft YaHei"/>
                           <a:cs typeface="Microsoft YaHei"/>
                         </a:rPr>
-                        <a:t>2.53×10^6</a:t>
+                        <a:t>3.74×10^6</a:t>
                       </a:r>
                     </a:p>
                   </a:txBody>
@@ -19248,7 +19248,7 @@
                           <a:ea typeface="Microsoft YaHei"/>
                           <a:cs typeface="Microsoft YaHei"/>
                         </a:rPr>
-                        <a:t>6.05 秒</a:t>
+                        <a:t>1.28 秒</a:t>
                       </a:r>
                     </a:p>
                   </a:txBody>
@@ -19303,7 +19303,7 @@
                           <a:ea typeface="Microsoft YaHei"/>
                           <a:cs typeface="Microsoft YaHei"/>
                         </a:rPr>
-                        <a:t>3.95 秒</a:t>
+                        <a:t>5.83 秒</a:t>
                       </a:r>
                     </a:p>
                   </a:txBody>
@@ -19358,7 +19358,7 @@
                           <a:ea typeface="Microsoft YaHei"/>
                           <a:cs typeface="Microsoft YaHei"/>
                         </a:rPr>
-                        <a:t>2.82 秒</a:t>
+                        <a:t>4.17 秒</a:t>
                       </a:r>
                     </a:p>
                   </a:txBody>
@@ -19413,7 +19413,7 @@
                           <a:ea typeface="Microsoft YaHei"/>
                           <a:cs typeface="Microsoft YaHei"/>
                         </a:rPr>
-                        <a:t>146.7 毫秒</a:t>
+                        <a:t>217.0 毫秒</a:t>
                       </a:r>
                     </a:p>
                   </a:txBody>
@@ -19525,7 +19525,7 @@
                           <a:ea typeface="Microsoft YaHei"/>
                           <a:cs typeface="Microsoft YaHei"/>
                         </a:rPr>
-                        <a:t>15440</a:t>
+                        <a:t>22676</a:t>
                       </a:r>
                     </a:p>
                   </a:txBody>
@@ -19580,7 +19580,7 @@
                           <a:ea typeface="Microsoft YaHei"/>
                           <a:cs typeface="Microsoft YaHei"/>
                         </a:rPr>
-                        <a:t>120.6</a:t>
+                        <a:t>177.2</a:t>
                       </a:r>
                     </a:p>
                   </a:txBody>
@@ -19635,7 +19635,7 @@
                           <a:ea typeface="Microsoft YaHei"/>
                           <a:cs typeface="Microsoft YaHei"/>
                         </a:rPr>
-                        <a:t>2.53×10^6</a:t>
+                        <a:t>3.72×10^6</a:t>
                       </a:r>
                     </a:p>
                   </a:txBody>
@@ -19690,7 +19690,7 @@
                           <a:ea typeface="Microsoft YaHei"/>
                           <a:cs typeface="Microsoft YaHei"/>
                         </a:rPr>
-                        <a:t>6.05 秒</a:t>
+                        <a:t>1.27 秒</a:t>
                       </a:r>
                     </a:p>
                   </a:txBody>
@@ -19745,7 +19745,7 @@
                           <a:ea typeface="Microsoft YaHei"/>
                           <a:cs typeface="Microsoft YaHei"/>
                         </a:rPr>
-                        <a:t>3.95 秒</a:t>
+                        <a:t>5.79 秒</a:t>
                       </a:r>
                     </a:p>
                   </a:txBody>
@@ -19800,7 +19800,7 @@
                           <a:ea typeface="Microsoft YaHei"/>
                           <a:cs typeface="Microsoft YaHei"/>
                         </a:rPr>
-                        <a:t>2.86 秒</a:t>
+                        <a:t>4.21 秒</a:t>
                       </a:r>
                     </a:p>
                   </a:txBody>
@@ -19855,7 +19855,7 @@
                           <a:ea typeface="Microsoft YaHei"/>
                           <a:cs typeface="Microsoft YaHei"/>
                         </a:rPr>
-                        <a:t>133.1 毫秒</a:t>
+                        <a:t>195.7 毫秒</a:t>
                       </a:r>
                     </a:p>
                   </a:txBody>
@@ -19967,7 +19967,7 @@
                           <a:ea typeface="Microsoft YaHei"/>
                           <a:cs typeface="Microsoft YaHei"/>
                         </a:rPr>
-                        <a:t>3856</a:t>
+                        <a:t>5456</a:t>
                       </a:r>
                     </a:p>
                   </a:txBody>
@@ -20022,7 +20022,7 @@
                           <a:ea typeface="Microsoft YaHei"/>
                           <a:cs typeface="Microsoft YaHei"/>
                         </a:rPr>
-                        <a:t>30.1</a:t>
+                        <a:t>42.6</a:t>
                       </a:r>
                     </a:p>
                   </a:txBody>
@@ -20077,7 +20077,7 @@
                           <a:ea typeface="Microsoft YaHei"/>
                           <a:cs typeface="Microsoft YaHei"/>
                         </a:rPr>
-                        <a:t>2.53×10^6</a:t>
+                        <a:t>3.58×10^6</a:t>
                       </a:r>
                     </a:p>
                   </a:txBody>
@@ -20132,7 +20132,7 @@
                           <a:ea typeface="Microsoft YaHei"/>
                           <a:cs typeface="Microsoft YaHei"/>
                         </a:rPr>
-                        <a:t>6.04 秒</a:t>
+                        <a:t>1.22 秒</a:t>
                       </a:r>
                     </a:p>
                   </a:txBody>
@@ -20187,7 +20187,7 @@
                           <a:ea typeface="Microsoft YaHei"/>
                           <a:cs typeface="Microsoft YaHei"/>
                         </a:rPr>
-                        <a:t>3.95 秒</a:t>
+                        <a:t>5.57 秒</a:t>
                       </a:r>
                     </a:p>
                   </a:txBody>
@@ -20242,7 +20242,7 @@
                           <a:ea typeface="Microsoft YaHei"/>
                           <a:cs typeface="Microsoft YaHei"/>
                         </a:rPr>
-                        <a:t>3.12 秒</a:t>
+                        <a:t>4.42 秒</a:t>
                       </a:r>
                     </a:p>
                   </a:txBody>
@@ -20297,7 +20297,7 @@
                           <a:ea typeface="Microsoft YaHei"/>
                           <a:cs typeface="Microsoft YaHei"/>
                         </a:rPr>
-                        <a:t>122.8 毫秒</a:t>
+                        <a:t>173.8 毫秒</a:t>
                       </a:r>
                     </a:p>
                   </a:txBody>
@@ -20409,7 +20409,7 @@
                           <a:ea typeface="Microsoft YaHei"/>
                           <a:cs typeface="Microsoft YaHei"/>
                         </a:rPr>
-                        <a:t>960</a:t>
+                        <a:t>1184</a:t>
                       </a:r>
                     </a:p>
                   </a:txBody>
@@ -20464,7 +20464,7 @@
                           <a:ea typeface="Microsoft YaHei"/>
                           <a:cs typeface="Microsoft YaHei"/>
                         </a:rPr>
-                        <a:t>7.5</a:t>
+                        <a:t>9.2</a:t>
                       </a:r>
                     </a:p>
                   </a:txBody>
@@ -20519,7 +20519,7 @@
                           <a:ea typeface="Microsoft YaHei"/>
                           <a:cs typeface="Microsoft YaHei"/>
                         </a:rPr>
-                        <a:t>2.52×10^6</a:t>
+                        <a:t>3.10×10^6</a:t>
                       </a:r>
                     </a:p>
                   </a:txBody>
@@ -20574,7 +20574,7 @@
                           <a:ea typeface="Microsoft YaHei"/>
                           <a:cs typeface="Microsoft YaHei"/>
                         </a:rPr>
-                        <a:t>6.02 秒</a:t>
+                        <a:t>1.06 秒</a:t>
                       </a:r>
                     </a:p>
                   </a:txBody>
@@ -20629,7 +20629,7 @@
                           <a:ea typeface="Microsoft YaHei"/>
                           <a:cs typeface="Microsoft YaHei"/>
                         </a:rPr>
-                        <a:t>3.93 秒</a:t>
+                        <a:t>4.84 秒</a:t>
                       </a:r>
                     </a:p>
                   </a:txBody>
@@ -20684,7 +20684,7 @@
                           <a:ea typeface="Microsoft YaHei"/>
                           <a:cs typeface="Microsoft YaHei"/>
                         </a:rPr>
-                        <a:t>4.16 秒</a:t>
+                        <a:t>5.13 秒</a:t>
                       </a:r>
                     </a:p>
                   </a:txBody>
@@ -20739,7 +20739,7 @@
                           <a:ea typeface="Microsoft YaHei"/>
                           <a:cs typeface="Microsoft YaHei"/>
                         </a:rPr>
-                        <a:t>119.8 毫秒</a:t>
+                        <a:t>147.8 毫秒</a:t>
                       </a:r>
                     </a:p>
                   </a:txBody>
@@ -20851,7 +20851,7 @@
                           <a:ea typeface="Microsoft YaHei"/>
                           <a:cs typeface="Microsoft YaHei"/>
                         </a:rPr>
-                        <a:t>480</a:t>
+                        <a:t>498</a:t>
                       </a:r>
                     </a:p>
                   </a:txBody>
@@ -20906,7 +20906,7 @@
                           <a:ea typeface="Microsoft YaHei"/>
                           <a:cs typeface="Microsoft YaHei"/>
                         </a:rPr>
-                        <a:t>3.8</a:t>
+                        <a:t>3.9</a:t>
                       </a:r>
                     </a:p>
                   </a:txBody>
@@ -20961,7 +20961,7 @@
                           <a:ea typeface="Microsoft YaHei"/>
                           <a:cs typeface="Microsoft YaHei"/>
                         </a:rPr>
-                        <a:t>2.52×10^6</a:t>
+                        <a:t>2.61×10^6</a:t>
                       </a:r>
                     </a:p>
                   </a:txBody>
@@ -21016,7 +21016,7 @@
                           <a:ea typeface="Microsoft YaHei"/>
                           <a:cs typeface="Microsoft YaHei"/>
                         </a:rPr>
-                        <a:t>6.02 秒</a:t>
+                        <a:t>0.92 秒</a:t>
                       </a:r>
                     </a:p>
                   </a:txBody>
@@ -21071,7 +21071,7 @@
                           <a:ea typeface="Microsoft YaHei"/>
                           <a:cs typeface="Microsoft YaHei"/>
                         </a:rPr>
-                        <a:t>3.93 秒</a:t>
+                        <a:t>4.07 秒</a:t>
                       </a:r>
                     </a:p>
                   </a:txBody>
@@ -21126,7 +21126,7 @@
                           <a:ea typeface="Microsoft YaHei"/>
                           <a:cs typeface="Microsoft YaHei"/>
                         </a:rPr>
-                        <a:t>5.56 秒</a:t>
+                        <a:t>5.93 秒</a:t>
                       </a:r>
                     </a:p>
                   </a:txBody>
@@ -21181,7 +21181,7 @@
                           <a:ea typeface="Microsoft YaHei"/>
                           <a:cs typeface="Microsoft YaHei"/>
                         </a:rPr>
-                        <a:t>119.4 毫秒</a:t>
+                        <a:t>127.3 毫秒</a:t>
                       </a:r>
                     </a:p>
                   </a:txBody>
@@ -21458,7 +21458,7 @@
                           <a:ea typeface="Microsoft YaHei"/>
                           <a:cs typeface="Microsoft YaHei"/>
                         </a:rPr>
-                        <a:t>4.81 秒</a:t>
+                        <a:t>0.69 秒</a:t>
                       </a:r>
                     </a:p>
                   </a:txBody>
@@ -21900,7 +21900,7 @@
                           <a:ea typeface="Microsoft YaHei"/>
                           <a:cs typeface="Microsoft YaHei"/>
                         </a:rPr>
-                        <a:t>3.21 秒</a:t>
+                        <a:t>0.46 秒</a:t>
                       </a:r>
                     </a:p>
                   </a:txBody>
@@ -22137,7 +22137,7 @@
                 <a:ea typeface="Microsoft YaHei"/>
                 <a:cs typeface="Microsoft YaHei"/>
               </a:rPr>
-              <a:t>98% prefix 走参数面：4K 这一批拉取 146.7 毫秒，1M 拉取 63.5 毫秒；均短于 Attention 主瓶颈。</a:t>
+              <a:t>98% prefix 走参数面：4K 这一批拉取 217.0 毫秒，1M 拉取 63.5 毫秒；均短于 Attention 主瓶颈。</a:t>
             </a:r>
           </a:p>
         </p:txBody>
@@ -22282,7 +22282,7 @@
                 <a:ea typeface="Microsoft YaHei"/>
                 <a:cs typeface="Microsoft YaHei"/>
               </a:rPr>
-              <a:t>10 毫秒、短输入，全局批 201</a:t>
+              <a:t>10 毫秒、短输入，全局批 222</a:t>
             </a:r>
           </a:p>
         </p:txBody>
@@ -22494,7 +22494,7 @@
                 <a:ea typeface="Microsoft YaHei"/>
                 <a:cs typeface="Microsoft YaHei"/>
               </a:rPr>
-              <a:t>读专家 8.65 毫秒，只醒了 11.7 个。机内 allreduce 0.50 毫秒。专家 GEMM 4.83 毫秒。</a:t>
+              <a:t>读专家 9.05 毫秒，只醒了 12.4 个。机内 allreduce 0.08 毫秒。专家 GEMM 5.07 毫秒。</a:t>
             </a:r>
           </a:p>
         </p:txBody>
@@ -23091,7 +23091,7 @@
                           <a:ea typeface="Microsoft YaHei"/>
                           <a:cs typeface="Microsoft YaHei"/>
                         </a:rPr>
-                        <a:t>0.50 毫秒</a:t>
+                        <a:t>0.08 毫秒</a:t>
                       </a:r>
                     </a:p>
                   </a:txBody>
@@ -23170,7 +23170,7 @@
                           <a:ea typeface="Microsoft YaHei"/>
                           <a:cs typeface="Microsoft YaHei"/>
                         </a:rPr>
-                        <a:t>合计 0.08 毫秒</a:t>
+                        <a:t>合计 0.09 毫秒</a:t>
                       </a:r>
                     </a:p>
                   </a:txBody>
@@ -23361,7 +23361,7 @@
                           <a:ea typeface="Microsoft YaHei"/>
                           <a:cs typeface="Microsoft YaHei"/>
                         </a:rPr>
-                        <a:t>醒了 11.7 / 19.3 个</a:t>
+                        <a:t>醒了 12.4 / 19.3 个</a:t>
                       </a:r>
                     </a:p>
                     <a:p>
@@ -23385,7 +23385,7 @@
                           <a:ea typeface="Microsoft YaHei"/>
                           <a:cs typeface="Microsoft YaHei"/>
                         </a:rPr>
-                        <a:t>读权重 8.65 毫秒</a:t>
+                        <a:t>读权重 9.05 毫秒</a:t>
                       </a:r>
                     </a:p>
                   </a:txBody>
@@ -23600,7 +23600,7 @@
                           <a:ea typeface="Microsoft YaHei"/>
                           <a:cs typeface="Microsoft YaHei"/>
                         </a:rPr>
-                        <a:t>GEMM 4.83 毫秒</a:t>
+                        <a:t>GEMM 5.07 毫秒</a:t>
                       </a:r>
                     </a:p>
                   </a:txBody>
@@ -24071,7 +24071,7 @@
                           <a:ea typeface="Microsoft YaHei"/>
                           <a:cs typeface="Microsoft YaHei"/>
                         </a:rPr>
-                        <a:t>每组 13 条；61 层 ring</a:t>
+                        <a:t>每组 14 条；61层 fullmesh</a:t>
                       </a:r>
                     </a:p>
                     <a:p>
@@ -24095,7 +24095,7 @@
                           <a:ea typeface="Microsoft YaHei"/>
                           <a:cs typeface="Microsoft YaHei"/>
                         </a:rPr>
-                        <a:t>不假设与 kernel 重叠</a:t>
+                        <a:t>7链路并发，不与kernel重叠</a:t>
                       </a:r>
                     </a:p>
                   </a:txBody>
@@ -24150,7 +24150,7 @@
                           <a:ea typeface="Microsoft YaHei"/>
                           <a:cs typeface="Microsoft YaHei"/>
                         </a:rPr>
-                        <a:t>0.50 毫秒</a:t>
+                        <a:t>0.08 毫秒</a:t>
                       </a:r>
                     </a:p>
                   </a:txBody>
@@ -24341,7 +24341,7 @@
                           <a:ea typeface="Microsoft YaHei"/>
                           <a:cs typeface="Microsoft YaHei"/>
                         </a:rPr>
-                        <a:t>0.08 毫秒</a:t>
+                        <a:t>0.09 毫秒</a:t>
                       </a:r>
                     </a:p>
                   </a:txBody>
@@ -24453,7 +24453,7 @@
                           <a:ea typeface="Microsoft YaHei"/>
                           <a:cs typeface="Microsoft YaHei"/>
                         </a:rPr>
-                        <a:t>max(读权重 8.65, GEMM 4.83)</a:t>
+                        <a:t>max(读权重 9.05, GEMM 5.07)</a:t>
                       </a:r>
                     </a:p>
                   </a:txBody>
@@ -24508,7 +24508,7 @@
                           <a:ea typeface="Microsoft YaHei"/>
                           <a:cs typeface="Microsoft YaHei"/>
                         </a:rPr>
-                        <a:t>8.65 毫秒</a:t>
+                        <a:t>9.05 毫秒</a:t>
                       </a:r>
                     </a:p>
                   </a:txBody>
@@ -24620,7 +24620,7 @@
                           <a:ea typeface="Microsoft YaHei"/>
                           <a:cs typeface="Microsoft YaHei"/>
                         </a:rPr>
-                        <a:t>Attention 1.27 + MoE 8.73</a:t>
+                        <a:t>Attention 0.85 + MoE 9.14</a:t>
                       </a:r>
                     </a:p>
                   </a:txBody>
@@ -24675,7 +24675,7 @@
                           <a:ea typeface="Microsoft YaHei"/>
                           <a:cs typeface="Microsoft YaHei"/>
                         </a:rPr>
-                        <a:t>10.00 毫秒</a:t>
+                        <a:t>9.99 毫秒</a:t>
                       </a:r>
                     </a:p>
                   </a:txBody>
@@ -24792,7 +24792,7 @@
                 <a:ea typeface="Microsoft YaHei"/>
                 <a:cs typeface="Microsoft YaHei"/>
               </a:rPr>
-              <a:t>4K – 8K</a:t>
+              <a:t>4K – 32K</a:t>
             </a:r>
           </a:p>
         </p:txBody>
@@ -24834,7 +24834,7 @@
                 <a:ea typeface="Microsoft YaHei"/>
                 <a:cs typeface="Microsoft YaHei"/>
               </a:rPr>
-              <a:t>201</a:t>
+              <a:t>222</a:t>
             </a:r>
           </a:p>
         </p:txBody>
@@ -24876,7 +24876,7 @@
                 <a:ea typeface="Microsoft YaHei"/>
                 <a:cs typeface="Microsoft YaHei"/>
               </a:rPr>
-              <a:t>全局批，每卡 1.6 条</a:t>
+              <a:t>全局批，每卡 1.7 条</a:t>
             </a:r>
           </a:p>
           <a:p>
@@ -25026,7 +25026,7 @@
                 <a:ea typeface="Microsoft YaHei"/>
                 <a:cs typeface="Microsoft YaHei"/>
               </a:rPr>
-              <a:t>199</a:t>
+              <a:t>220</a:t>
             </a:r>
           </a:p>
         </p:txBody>
@@ -25068,7 +25068,7 @@
                 <a:ea typeface="Microsoft YaHei"/>
                 <a:cs typeface="Microsoft YaHei"/>
               </a:rPr>
-              <a:t>全局批，每卡 1.6 条</a:t>
+              <a:t>全局批，每卡 1.7 条</a:t>
             </a:r>
           </a:p>
           <a:p>
@@ -25218,7 +25218,7 @@
                 <a:ea typeface="Microsoft YaHei"/>
                 <a:cs typeface="Microsoft YaHei"/>
               </a:rPr>
-              <a:t>173</a:t>
+              <a:t>190</a:t>
             </a:r>
           </a:p>
         </p:txBody>
@@ -25260,7 +25260,7 @@
                 <a:ea typeface="Microsoft YaHei"/>
                 <a:cs typeface="Microsoft YaHei"/>
               </a:rPr>
-              <a:t>全局批，每卡 1.4 条</a:t>
+              <a:t>全局批，每卡 1.5 条</a:t>
             </a:r>
           </a:p>
           <a:p>
@@ -25368,7 +25368,7 @@
                 <a:ea typeface="Microsoft YaHei"/>
                 <a:cs typeface="Microsoft YaHei"/>
               </a:rPr>
-              <a:t>0.25×10^6</a:t>
+              <a:t>0.33×10^6</a:t>
             </a:r>
           </a:p>
         </p:txBody>
@@ -25410,7 +25410,7 @@
                 <a:ea typeface="Microsoft YaHei"/>
                 <a:cs typeface="Microsoft YaHei"/>
               </a:rPr>
-              <a:t>197</a:t>
+              <a:t>216</a:t>
             </a:r>
           </a:p>
         </p:txBody>
@@ -25452,7 +25452,7 @@
                 <a:ea typeface="Microsoft YaHei"/>
                 <a:cs typeface="Microsoft YaHei"/>
               </a:rPr>
-              <a:t>全局批，每卡 1.5 条</a:t>
+              <a:t>全局批，每卡 1.7 条</a:t>
             </a:r>
           </a:p>
           <a:p>
@@ -25618,7 +25618,7 @@
                 <a:ea typeface="Microsoft YaHei"/>
                 <a:cs typeface="Microsoft YaHei"/>
               </a:rPr>
-              <a:t>30 毫秒、短输入，全局批 4352</a:t>
+              <a:t>30 毫秒、短输入，全局批 7936</a:t>
             </a:r>
           </a:p>
         </p:txBody>
@@ -25830,7 +25830,7 @@
                 <a:ea typeface="Microsoft YaHei"/>
                 <a:cs typeface="Microsoft YaHei"/>
               </a:rPr>
-              <a:t>专家整卡读完 13.40 毫秒，机内 allreduce 10.41 毫秒。D2D 上的 EP 1.27 毫秒。</a:t>
+              <a:t>专家整卡读完 13.40 毫秒，机内 allreduce 2.71 毫秒。D2D 上的 EP 2.24 毫秒。</a:t>
             </a:r>
           </a:p>
         </p:txBody>
@@ -25914,7 +25914,7 @@
                 <a:ea typeface="Microsoft YaHei"/>
                 <a:cs typeface="Microsoft YaHei"/>
               </a:rPr>
-              <a:t>短输入、全局批 4352，这一步怎么加</a:t>
+              <a:t>短输入、全局批 7936，这一步怎么加</a:t>
             </a:r>
           </a:p>
         </p:txBody>
@@ -26212,7 +26212,7 @@
                           <a:ea typeface="Microsoft YaHei"/>
                           <a:cs typeface="Microsoft YaHei"/>
                         </a:rPr>
-                        <a:t>4352 / 16 = 272 条 / 组</a:t>
+                        <a:t>7936 / 16 = 496 条 / 组</a:t>
                       </a:r>
                     </a:p>
                   </a:txBody>
@@ -26506,7 +26506,7 @@
                           <a:ea typeface="Microsoft YaHei"/>
                           <a:cs typeface="Microsoft YaHei"/>
                         </a:rPr>
-                        <a:t>合计 1.27 毫秒</a:t>
+                        <a:t>合计 2.24 毫秒</a:t>
                       </a:r>
                     </a:p>
                   </a:txBody>
@@ -26833,7 +26833,7 @@
                           <a:ea typeface="Microsoft YaHei"/>
                           <a:cs typeface="Microsoft YaHei"/>
                         </a:rPr>
-                        <a:t>注意力计算 4.85 毫秒</a:t>
+                        <a:t>注意力计算 8.84 毫秒</a:t>
                       </a:r>
                     </a:p>
                     <a:p>
@@ -26857,7 +26857,7 @@
                           <a:ea typeface="Microsoft YaHei"/>
                           <a:cs typeface="Microsoft YaHei"/>
                         </a:rPr>
-                        <a:t>短于 allreduce</a:t>
+                        <a:t>与HBM取大后再加AR</a:t>
                       </a:r>
                     </a:p>
                   </a:txBody>
@@ -26912,7 +26912,7 @@
                           <a:ea typeface="Microsoft YaHei"/>
                           <a:cs typeface="Microsoft YaHei"/>
                         </a:rPr>
-                        <a:t>每专家约 12.1 token</a:t>
+                        <a:t>每专家约 21.3 token</a:t>
                       </a:r>
                     </a:p>
                     <a:p>
@@ -26936,7 +26936,7 @@
                           <a:ea typeface="Microsoft YaHei"/>
                           <a:cs typeface="Microsoft YaHei"/>
                         </a:rPr>
-                        <a:t>16 行砖，效率 75%，8.45 毫秒</a:t>
+                        <a:t>16 行砖，效率 66%，16.14 毫秒</a:t>
                       </a:r>
                     </a:p>
                   </a:txBody>
@@ -27240,7 +27240,7 @@
                           <a:ea typeface="Microsoft YaHei"/>
                           <a:cs typeface="Microsoft YaHei"/>
                         </a:rPr>
-                        <a:t>max(HBM 1.02, 计算 4.85)</a:t>
+                        <a:t>max(HBM 1.23, 计算 8.84)</a:t>
                       </a:r>
                     </a:p>
                   </a:txBody>
@@ -27295,7 +27295,7 @@
                           <a:ea typeface="Microsoft YaHei"/>
                           <a:cs typeface="Microsoft YaHei"/>
                         </a:rPr>
-                        <a:t>4.85 毫秒</a:t>
+                        <a:t>8.84 毫秒</a:t>
                       </a:r>
                     </a:p>
                   </a:txBody>
@@ -27407,7 +27407,7 @@
                           <a:ea typeface="Microsoft YaHei"/>
                           <a:cs typeface="Microsoft YaHei"/>
                         </a:rPr>
-                        <a:t>每组 272 条；61 层 ring</a:t>
+                        <a:t>每组 496 条；61层 fullmesh</a:t>
                       </a:r>
                     </a:p>
                     <a:p>
@@ -27431,7 +27431,7 @@
                           <a:ea typeface="Microsoft YaHei"/>
                           <a:cs typeface="Microsoft YaHei"/>
                         </a:rPr>
-                        <a:t>不假设与 kernel 重叠</a:t>
+                        <a:t>7链路并发，不与kernel重叠</a:t>
                       </a:r>
                     </a:p>
                   </a:txBody>
@@ -27486,7 +27486,7 @@
                           <a:ea typeface="Microsoft YaHei"/>
                           <a:cs typeface="Microsoft YaHei"/>
                         </a:rPr>
-                        <a:t>10.41 毫秒</a:t>
+                        <a:t>2.71 毫秒</a:t>
                       </a:r>
                     </a:p>
                   </a:txBody>
@@ -27677,7 +27677,7 @@
                           <a:ea typeface="Microsoft YaHei"/>
                           <a:cs typeface="Microsoft YaHei"/>
                         </a:rPr>
-                        <a:t>1.27 毫秒</a:t>
+                        <a:t>2.24 毫秒</a:t>
                       </a:r>
                     </a:p>
                   </a:txBody>
@@ -27789,7 +27789,7 @@
                           <a:ea typeface="Microsoft YaHei"/>
                           <a:cs typeface="Microsoft YaHei"/>
                         </a:rPr>
-                        <a:t>max(读权重 13.40, GEMM 8.45)</a:t>
+                        <a:t>max(读权重 13.40, GEMM 16.14)</a:t>
                       </a:r>
                     </a:p>
                   </a:txBody>
@@ -27844,7 +27844,7 @@
                           <a:ea typeface="Microsoft YaHei"/>
                           <a:cs typeface="Microsoft YaHei"/>
                         </a:rPr>
-                        <a:t>13.40 毫秒</a:t>
+                        <a:t>16.14 毫秒</a:t>
                       </a:r>
                     </a:p>
                   </a:txBody>
@@ -27956,7 +27956,7 @@
                           <a:ea typeface="Microsoft YaHei"/>
                           <a:cs typeface="Microsoft YaHei"/>
                         </a:rPr>
-                        <a:t>Attention 15.26 + MoE 14.67</a:t>
+                        <a:t>Attention 11.55 + MoE 18.38</a:t>
                       </a:r>
                     </a:p>
                   </a:txBody>
@@ -28011,7 +28011,7 @@
                           <a:ea typeface="Microsoft YaHei"/>
                           <a:cs typeface="Microsoft YaHei"/>
                         </a:rPr>
-                        <a:t>29.93 毫秒</a:t>
+                        <a:t>29.94 毫秒</a:t>
                       </a:r>
                     </a:p>
                   </a:txBody>
@@ -28170,7 +28170,7 @@
                 <a:ea typeface="Microsoft YaHei"/>
                 <a:cs typeface="Microsoft YaHei"/>
               </a:rPr>
-              <a:t>4352</a:t>
+              <a:t>7936</a:t>
             </a:r>
           </a:p>
         </p:txBody>
@@ -28212,7 +28212,7 @@
                 <a:ea typeface="Microsoft YaHei"/>
                 <a:cs typeface="Microsoft YaHei"/>
               </a:rPr>
-              <a:t>全局批，每卡 34.0 条</a:t>
+              <a:t>全局批，每卡 62.0 条</a:t>
             </a:r>
           </a:p>
           <a:p>
@@ -28362,7 +28362,7 @@
                 <a:ea typeface="Microsoft YaHei"/>
                 <a:cs typeface="Microsoft YaHei"/>
               </a:rPr>
-              <a:t>3328</a:t>
+              <a:t>4880</a:t>
             </a:r>
           </a:p>
         </p:txBody>
@@ -28404,7 +28404,7 @@
                 <a:ea typeface="Microsoft YaHei"/>
                 <a:cs typeface="Microsoft YaHei"/>
               </a:rPr>
-              <a:t>全局批，每卡 26.0 条</a:t>
+              <a:t>全局批，每卡 38.1 条</a:t>
             </a:r>
           </a:p>
           <a:p>
@@ -28425,7 +28425,7 @@
                 <a:ea typeface="Microsoft YaHei"/>
                 <a:cs typeface="Microsoft YaHei"/>
               </a:rPr>
-              <a:t>全在 HBM</a:t>
+              <a:t>9.8% 在总线内存池</a:t>
             </a:r>
           </a:p>
         </p:txBody>
@@ -28554,7 +28554,7 @@
                 <a:ea typeface="Microsoft YaHei"/>
                 <a:cs typeface="Microsoft YaHei"/>
               </a:rPr>
-              <a:t>2390</a:t>
+              <a:t>2816</a:t>
             </a:r>
           </a:p>
         </p:txBody>
@@ -28596,7 +28596,7 @@
                 <a:ea typeface="Microsoft YaHei"/>
                 <a:cs typeface="Microsoft YaHei"/>
               </a:rPr>
-              <a:t>全局批，每卡 18.7 条</a:t>
+              <a:t>全局批，每卡 22.0 条</a:t>
             </a:r>
           </a:p>
           <a:p>
@@ -28617,7 +28617,7 @@
                 <a:ea typeface="Microsoft YaHei"/>
                 <a:cs typeface="Microsoft YaHei"/>
               </a:rPr>
-              <a:t>7.7% 在总线内存池</a:t>
+              <a:t>21.7% 在总线内存池</a:t>
             </a:r>
           </a:p>
         </p:txBody>
@@ -28704,7 +28704,7 @@
                 <a:ea typeface="Microsoft YaHei"/>
                 <a:cs typeface="Microsoft YaHei"/>
               </a:rPr>
-              <a:t>0.25×10^6</a:t>
+              <a:t>0.33×10^6</a:t>
             </a:r>
           </a:p>
         </p:txBody>
@@ -28746,7 +28746,7 @@
                 <a:ea typeface="Microsoft YaHei"/>
                 <a:cs typeface="Microsoft YaHei"/>
               </a:rPr>
-              <a:t>3328</a:t>
+              <a:t>4096</a:t>
             </a:r>
           </a:p>
         </p:txBody>
@@ -28788,7 +28788,7 @@
                 <a:ea typeface="Microsoft YaHei"/>
                 <a:cs typeface="Microsoft YaHei"/>
               </a:rPr>
-              <a:t>全局批，每卡 26.0 条</a:t>
+              <a:t>全局批，每卡 32.0 条</a:t>
             </a:r>
           </a:p>
           <a:p>
@@ -28809,7 +28809,7 @@
                 <a:ea typeface="Microsoft YaHei"/>
                 <a:cs typeface="Microsoft YaHei"/>
               </a:rPr>
-              <a:t>全在 HBM</a:t>
+              <a:t>14.3% 在总线内存池</a:t>
             </a:r>
           </a:p>
         </p:txBody>
@@ -28954,7 +28954,7 @@
                 <a:ea typeface="Microsoft YaHei"/>
                 <a:cs typeface="Microsoft YaHei"/>
               </a:rPr>
-              <a:t>10 毫秒这些长度都不进池；256K 的 30 毫秒仍是 4352</a:t>
+              <a:t>10 毫秒都不进池；30 毫秒从 256K 开始使用 DDR 池</a:t>
             </a:r>
           </a:p>
         </p:txBody>
@@ -29830,7 +29830,7 @@
                           <a:ea typeface="Microsoft YaHei"/>
                           <a:cs typeface="Microsoft YaHei"/>
                         </a:rPr>
-                        <a:t>201</a:t>
+                        <a:t>222</a:t>
                       </a:r>
                     </a:p>
                   </a:txBody>
@@ -29885,7 +29885,7 @@
                           <a:ea typeface="Microsoft YaHei"/>
                           <a:cs typeface="Microsoft YaHei"/>
                         </a:rPr>
-                        <a:t>1.6</a:t>
+                        <a:t>1.7</a:t>
                       </a:r>
                     </a:p>
                   </a:txBody>
@@ -29940,7 +29940,7 @@
                           <a:ea typeface="Microsoft YaHei"/>
                           <a:cs typeface="Microsoft YaHei"/>
                         </a:rPr>
-                        <a:t>4352</a:t>
+                        <a:t>7936</a:t>
                       </a:r>
                     </a:p>
                   </a:txBody>
@@ -29995,7 +29995,7 @@
                           <a:ea typeface="Microsoft YaHei"/>
                           <a:cs typeface="Microsoft YaHei"/>
                         </a:rPr>
-                        <a:t>34.0</a:t>
+                        <a:t>62.0</a:t>
                       </a:r>
                     </a:p>
                   </a:txBody>
@@ -30272,7 +30272,7 @@
                           <a:ea typeface="Microsoft YaHei"/>
                           <a:cs typeface="Microsoft YaHei"/>
                         </a:rPr>
-                        <a:t>201</a:t>
+                        <a:t>222</a:t>
                       </a:r>
                     </a:p>
                   </a:txBody>
@@ -30327,7 +30327,7 @@
                           <a:ea typeface="Microsoft YaHei"/>
                           <a:cs typeface="Microsoft YaHei"/>
                         </a:rPr>
-                        <a:t>1.6</a:t>
+                        <a:t>1.7</a:t>
                       </a:r>
                     </a:p>
                   </a:txBody>
@@ -30382,7 +30382,7 @@
                           <a:ea typeface="Microsoft YaHei"/>
                           <a:cs typeface="Microsoft YaHei"/>
                         </a:rPr>
-                        <a:t>4336</a:t>
+                        <a:t>7808</a:t>
                       </a:r>
                     </a:p>
                   </a:txBody>
@@ -30437,7 +30437,7 @@
                           <a:ea typeface="Microsoft YaHei"/>
                           <a:cs typeface="Microsoft YaHei"/>
                         </a:rPr>
-                        <a:t>33.9</a:t>
+                        <a:t>61.0</a:t>
                       </a:r>
                     </a:p>
                   </a:txBody>
@@ -30714,7 +30714,7 @@
                           <a:ea typeface="Microsoft YaHei"/>
                           <a:cs typeface="Microsoft YaHei"/>
                         </a:rPr>
-                        <a:t>200</a:t>
+                        <a:t>222</a:t>
                       </a:r>
                     </a:p>
                   </a:txBody>
@@ -30769,7 +30769,7 @@
                           <a:ea typeface="Microsoft YaHei"/>
                           <a:cs typeface="Microsoft YaHei"/>
                         </a:rPr>
-                        <a:t>1.6</a:t>
+                        <a:t>1.7</a:t>
                       </a:r>
                     </a:p>
                   </a:txBody>
@@ -30824,7 +30824,7 @@
                           <a:ea typeface="Microsoft YaHei"/>
                           <a:cs typeface="Microsoft YaHei"/>
                         </a:rPr>
-                        <a:t>4176</a:t>
+                        <a:t>7424</a:t>
                       </a:r>
                     </a:p>
                   </a:txBody>
@@ -30879,7 +30879,7 @@
                           <a:ea typeface="Microsoft YaHei"/>
                           <a:cs typeface="Microsoft YaHei"/>
                         </a:rPr>
-                        <a:t>32.6</a:t>
+                        <a:t>58.0</a:t>
                       </a:r>
                     </a:p>
                   </a:txBody>
@@ -31156,7 +31156,7 @@
                           <a:ea typeface="Microsoft YaHei"/>
                           <a:cs typeface="Microsoft YaHei"/>
                         </a:rPr>
-                        <a:t>199</a:t>
+                        <a:t>220</a:t>
                       </a:r>
                     </a:p>
                   </a:txBody>
@@ -31211,7 +31211,7 @@
                           <a:ea typeface="Microsoft YaHei"/>
                           <a:cs typeface="Microsoft YaHei"/>
                         </a:rPr>
-                        <a:t>1.6</a:t>
+                        <a:t>1.7</a:t>
                       </a:r>
                     </a:p>
                   </a:txBody>
@@ -31266,7 +31266,7 @@
                           <a:ea typeface="Microsoft YaHei"/>
                           <a:cs typeface="Microsoft YaHei"/>
                         </a:rPr>
-                        <a:t>3808</a:t>
+                        <a:t>6144</a:t>
                       </a:r>
                     </a:p>
                   </a:txBody>
@@ -31321,7 +31321,7 @@
                           <a:ea typeface="Microsoft YaHei"/>
                           <a:cs typeface="Microsoft YaHei"/>
                         </a:rPr>
-                        <a:t>29.8</a:t>
+                        <a:t>48.0</a:t>
                       </a:r>
                     </a:p>
                   </a:txBody>
@@ -31427,7 +31427,7 @@
                       <a:r>
                         <a:rPr sz="1200" b="1">
                           <a:solidFill>
-                            <a:srgbClr val="0E2A47"/>
+                            <a:srgbClr val="0E7A76"/>
                           </a:solidFill>
                           <a:latin typeface="Microsoft YaHei"/>
                           <a:ea typeface="Microsoft YaHei"/>
@@ -31480,9 +31480,9 @@
                         </a:lnSpc>
                       </a:pPr>
                       <a:r>
-                        <a:rPr sz="1200" b="0">
-                          <a:solidFill>
-                            <a:srgbClr val="1C242E"/>
+                        <a:rPr sz="1200" b="1">
+                          <a:solidFill>
+                            <a:srgbClr val="0E7A76"/>
                           </a:solidFill>
                           <a:latin typeface="Microsoft YaHei"/>
                           <a:ea typeface="Microsoft YaHei"/>
@@ -31494,50 +31494,50 @@
                   </a:txBody>
                   <a:tcPr marL="54864" marR="54864" marT="27432" marB="18288" anchor="ctr">
                     <a:solidFill>
-                      <a:srgbClr val="FFFFFF"/>
-                    </a:solidFill>
-                    <a:lnL w="6350">
-                      <a:solidFill>
-                        <a:srgbClr val="D6DCE2"/>
-                      </a:solidFill>
-                    </a:lnL>
-                    <a:lnR w="6350">
-                      <a:solidFill>
-                        <a:srgbClr val="D6DCE2"/>
-                      </a:solidFill>
-                    </a:lnR>
-                    <a:lnT w="6350">
-                      <a:solidFill>
-                        <a:srgbClr val="D6DCE2"/>
-                      </a:solidFill>
-                    </a:lnT>
-                    <a:lnB w="6350">
-                      <a:solidFill>
-                        <a:srgbClr val="D6DCE2"/>
-                      </a:solidFill>
-                    </a:lnB>
-                  </a:tcPr>
-                </a:tc>
-                <a:tc>
-                  <a:txBody>
-                    <a:bodyPr wrap="square"/>
-                    <a:lstStyle/>
-                    <a:p>
-                      <a:pPr algn="l">
-                        <a:spcBef>
-                          <a:spcPts val="0"/>
-                        </a:spcBef>
-                        <a:spcAft>
-                          <a:spcPts val="0"/>
-                        </a:spcAft>
-                        <a:lnSpc>
-                          <a:spcPct val="100000"/>
-                        </a:lnSpc>
-                      </a:pPr>
-                      <a:r>
-                        <a:rPr sz="1200" b="0">
-                          <a:solidFill>
-                            <a:srgbClr val="1C242E"/>
+                      <a:srgbClr val="E7F3F2"/>
+                    </a:solidFill>
+                    <a:lnL w="6350">
+                      <a:solidFill>
+                        <a:srgbClr val="D6DCE2"/>
+                      </a:solidFill>
+                    </a:lnL>
+                    <a:lnR w="6350">
+                      <a:solidFill>
+                        <a:srgbClr val="D6DCE2"/>
+                      </a:solidFill>
+                    </a:lnR>
+                    <a:lnT w="6350">
+                      <a:solidFill>
+                        <a:srgbClr val="D6DCE2"/>
+                      </a:solidFill>
+                    </a:lnT>
+                    <a:lnB w="6350">
+                      <a:solidFill>
+                        <a:srgbClr val="D6DCE2"/>
+                      </a:solidFill>
+                    </a:lnB>
+                  </a:tcPr>
+                </a:tc>
+                <a:tc>
+                  <a:txBody>
+                    <a:bodyPr wrap="square"/>
+                    <a:lstStyle/>
+                    <a:p>
+                      <a:pPr algn="l">
+                        <a:spcBef>
+                          <a:spcPts val="0"/>
+                        </a:spcBef>
+                        <a:spcAft>
+                          <a:spcPts val="0"/>
+                        </a:spcAft>
+                        <a:lnSpc>
+                          <a:spcPct val="100000"/>
+                        </a:lnSpc>
+                      </a:pPr>
+                      <a:r>
+                        <a:rPr sz="1200" b="1">
+                          <a:solidFill>
+                            <a:srgbClr val="0E7A76"/>
                           </a:solidFill>
                           <a:latin typeface="Microsoft YaHei"/>
                           <a:ea typeface="Microsoft YaHei"/>
@@ -31549,282 +31549,282 @@
                   </a:txBody>
                   <a:tcPr marL="54864" marR="54864" marT="27432" marB="18288" anchor="ctr">
                     <a:solidFill>
-                      <a:srgbClr val="FFFFFF"/>
-                    </a:solidFill>
-                    <a:lnL w="6350">
-                      <a:solidFill>
-                        <a:srgbClr val="D6DCE2"/>
-                      </a:solidFill>
-                    </a:lnL>
-                    <a:lnR w="6350">
-                      <a:solidFill>
-                        <a:srgbClr val="D6DCE2"/>
-                      </a:solidFill>
-                    </a:lnR>
-                    <a:lnT w="6350">
-                      <a:solidFill>
-                        <a:srgbClr val="D6DCE2"/>
-                      </a:solidFill>
-                    </a:lnT>
-                    <a:lnB w="6350">
-                      <a:solidFill>
-                        <a:srgbClr val="D6DCE2"/>
-                      </a:solidFill>
-                    </a:lnB>
-                  </a:tcPr>
-                </a:tc>
-                <a:tc>
-                  <a:txBody>
-                    <a:bodyPr wrap="square"/>
-                    <a:lstStyle/>
-                    <a:p>
-                      <a:pPr algn="l">
-                        <a:spcBef>
-                          <a:spcPts val="0"/>
-                        </a:spcBef>
-                        <a:spcAft>
-                          <a:spcPts val="0"/>
-                        </a:spcAft>
-                        <a:lnSpc>
-                          <a:spcPct val="100000"/>
-                        </a:lnSpc>
-                      </a:pPr>
-                      <a:r>
-                        <a:rPr sz="1200" b="0">
-                          <a:solidFill>
-                            <a:srgbClr val="1C242E"/>
-                          </a:solidFill>
-                          <a:latin typeface="Microsoft YaHei"/>
-                          <a:ea typeface="Microsoft YaHei"/>
-                          <a:cs typeface="Microsoft YaHei"/>
-                        </a:rPr>
-                        <a:t>197</a:t>
-                      </a:r>
-                    </a:p>
-                  </a:txBody>
-                  <a:tcPr marL="54864" marR="54864" marT="27432" marB="18288" anchor="ctr">
-                    <a:solidFill>
-                      <a:srgbClr val="FFFFFF"/>
-                    </a:solidFill>
-                    <a:lnL w="6350">
-                      <a:solidFill>
-                        <a:srgbClr val="D6DCE2"/>
-                      </a:solidFill>
-                    </a:lnL>
-                    <a:lnR w="6350">
-                      <a:solidFill>
-                        <a:srgbClr val="D6DCE2"/>
-                      </a:solidFill>
-                    </a:lnR>
-                    <a:lnT w="6350">
-                      <a:solidFill>
-                        <a:srgbClr val="D6DCE2"/>
-                      </a:solidFill>
-                    </a:lnT>
-                    <a:lnB w="6350">
-                      <a:solidFill>
-                        <a:srgbClr val="D6DCE2"/>
-                      </a:solidFill>
-                    </a:lnB>
-                  </a:tcPr>
-                </a:tc>
-                <a:tc>
-                  <a:txBody>
-                    <a:bodyPr wrap="square"/>
-                    <a:lstStyle/>
-                    <a:p>
-                      <a:pPr algn="l">
-                        <a:spcBef>
-                          <a:spcPts val="0"/>
-                        </a:spcBef>
-                        <a:spcAft>
-                          <a:spcPts val="0"/>
-                        </a:spcAft>
-                        <a:lnSpc>
-                          <a:spcPct val="100000"/>
-                        </a:lnSpc>
-                      </a:pPr>
-                      <a:r>
-                        <a:rPr sz="1200" b="0">
-                          <a:solidFill>
-                            <a:srgbClr val="1C242E"/>
-                          </a:solidFill>
-                          <a:latin typeface="Microsoft YaHei"/>
-                          <a:ea typeface="Microsoft YaHei"/>
-                          <a:cs typeface="Microsoft YaHei"/>
-                        </a:rPr>
-                        <a:t>1.5</a:t>
-                      </a:r>
-                    </a:p>
-                  </a:txBody>
-                  <a:tcPr marL="54864" marR="54864" marT="27432" marB="18288" anchor="ctr">
-                    <a:solidFill>
-                      <a:srgbClr val="FFFFFF"/>
-                    </a:solidFill>
-                    <a:lnL w="6350">
-                      <a:solidFill>
-                        <a:srgbClr val="D6DCE2"/>
-                      </a:solidFill>
-                    </a:lnL>
-                    <a:lnR w="6350">
-                      <a:solidFill>
-                        <a:srgbClr val="D6DCE2"/>
-                      </a:solidFill>
-                    </a:lnR>
-                    <a:lnT w="6350">
-                      <a:solidFill>
-                        <a:srgbClr val="D6DCE2"/>
-                      </a:solidFill>
-                    </a:lnT>
-                    <a:lnB w="6350">
-                      <a:solidFill>
-                        <a:srgbClr val="D6DCE2"/>
-                      </a:solidFill>
-                    </a:lnB>
-                  </a:tcPr>
-                </a:tc>
-                <a:tc>
-                  <a:txBody>
-                    <a:bodyPr wrap="square"/>
-                    <a:lstStyle/>
-                    <a:p>
-                      <a:pPr algn="l">
-                        <a:spcBef>
-                          <a:spcPts val="0"/>
-                        </a:spcBef>
-                        <a:spcAft>
-                          <a:spcPts val="0"/>
-                        </a:spcAft>
-                        <a:lnSpc>
-                          <a:spcPct val="100000"/>
-                        </a:lnSpc>
-                      </a:pPr>
-                      <a:r>
-                        <a:rPr sz="1200" b="0">
-                          <a:solidFill>
-                            <a:srgbClr val="1C242E"/>
-                          </a:solidFill>
-                          <a:latin typeface="Microsoft YaHei"/>
-                          <a:ea typeface="Microsoft YaHei"/>
-                          <a:cs typeface="Microsoft YaHei"/>
-                        </a:rPr>
-                        <a:t>3328</a:t>
-                      </a:r>
-                    </a:p>
-                  </a:txBody>
-                  <a:tcPr marL="54864" marR="54864" marT="27432" marB="18288" anchor="ctr">
-                    <a:solidFill>
-                      <a:srgbClr val="FFFFFF"/>
-                    </a:solidFill>
-                    <a:lnL w="6350">
-                      <a:solidFill>
-                        <a:srgbClr val="D6DCE2"/>
-                      </a:solidFill>
-                    </a:lnL>
-                    <a:lnR w="6350">
-                      <a:solidFill>
-                        <a:srgbClr val="D6DCE2"/>
-                      </a:solidFill>
-                    </a:lnR>
-                    <a:lnT w="6350">
-                      <a:solidFill>
-                        <a:srgbClr val="D6DCE2"/>
-                      </a:solidFill>
-                    </a:lnT>
-                    <a:lnB w="6350">
-                      <a:solidFill>
-                        <a:srgbClr val="D6DCE2"/>
-                      </a:solidFill>
-                    </a:lnB>
-                  </a:tcPr>
-                </a:tc>
-                <a:tc>
-                  <a:txBody>
-                    <a:bodyPr wrap="square"/>
-                    <a:lstStyle/>
-                    <a:p>
-                      <a:pPr algn="l">
-                        <a:spcBef>
-                          <a:spcPts val="0"/>
-                        </a:spcBef>
-                        <a:spcAft>
-                          <a:spcPts val="0"/>
-                        </a:spcAft>
-                        <a:lnSpc>
-                          <a:spcPct val="100000"/>
-                        </a:lnSpc>
-                      </a:pPr>
-                      <a:r>
-                        <a:rPr sz="1200" b="0">
-                          <a:solidFill>
-                            <a:srgbClr val="1C242E"/>
-                          </a:solidFill>
-                          <a:latin typeface="Microsoft YaHei"/>
-                          <a:ea typeface="Microsoft YaHei"/>
-                          <a:cs typeface="Microsoft YaHei"/>
-                        </a:rPr>
-                        <a:t>26.0</a:t>
-                      </a:r>
-                    </a:p>
-                  </a:txBody>
-                  <a:tcPr marL="54864" marR="54864" marT="27432" marB="18288" anchor="ctr">
-                    <a:solidFill>
-                      <a:srgbClr val="FFFFFF"/>
-                    </a:solidFill>
-                    <a:lnL w="6350">
-                      <a:solidFill>
-                        <a:srgbClr val="D6DCE2"/>
-                      </a:solidFill>
-                    </a:lnL>
-                    <a:lnR w="6350">
-                      <a:solidFill>
-                        <a:srgbClr val="D6DCE2"/>
-                      </a:solidFill>
-                    </a:lnR>
-                    <a:lnT w="6350">
-                      <a:solidFill>
-                        <a:srgbClr val="D6DCE2"/>
-                      </a:solidFill>
-                    </a:lnT>
-                    <a:lnB w="6350">
-                      <a:solidFill>
-                        <a:srgbClr val="D6DCE2"/>
-                      </a:solidFill>
-                    </a:lnB>
-                  </a:tcPr>
-                </a:tc>
-                <a:tc>
-                  <a:txBody>
-                    <a:bodyPr wrap="square"/>
-                    <a:lstStyle/>
-                    <a:p>
-                      <a:pPr algn="l">
-                        <a:spcBef>
-                          <a:spcPts val="0"/>
-                        </a:spcBef>
-                        <a:spcAft>
-                          <a:spcPts val="0"/>
-                        </a:spcAft>
-                        <a:lnSpc>
-                          <a:spcPct val="100000"/>
-                        </a:lnSpc>
-                      </a:pPr>
-                      <a:r>
-                        <a:rPr sz="1200" b="0">
-                          <a:solidFill>
-                            <a:srgbClr val="1C242E"/>
-                          </a:solidFill>
-                          <a:latin typeface="Microsoft YaHei"/>
-                          <a:ea typeface="Microsoft YaHei"/>
-                          <a:cs typeface="Microsoft YaHei"/>
-                        </a:rPr>
-                        <a:t>全在 HBM</a:t>
-                      </a:r>
-                    </a:p>
-                  </a:txBody>
-                  <a:tcPr marL="54864" marR="54864" marT="27432" marB="18288" anchor="ctr">
-                    <a:solidFill>
-                      <a:srgbClr val="FFFFFF"/>
+                      <a:srgbClr val="E7F3F2"/>
+                    </a:solidFill>
+                    <a:lnL w="6350">
+                      <a:solidFill>
+                        <a:srgbClr val="D6DCE2"/>
+                      </a:solidFill>
+                    </a:lnL>
+                    <a:lnR w="6350">
+                      <a:solidFill>
+                        <a:srgbClr val="D6DCE2"/>
+                      </a:solidFill>
+                    </a:lnR>
+                    <a:lnT w="6350">
+                      <a:solidFill>
+                        <a:srgbClr val="D6DCE2"/>
+                      </a:solidFill>
+                    </a:lnT>
+                    <a:lnB w="6350">
+                      <a:solidFill>
+                        <a:srgbClr val="D6DCE2"/>
+                      </a:solidFill>
+                    </a:lnB>
+                  </a:tcPr>
+                </a:tc>
+                <a:tc>
+                  <a:txBody>
+                    <a:bodyPr wrap="square"/>
+                    <a:lstStyle/>
+                    <a:p>
+                      <a:pPr algn="l">
+                        <a:spcBef>
+                          <a:spcPts val="0"/>
+                        </a:spcBef>
+                        <a:spcAft>
+                          <a:spcPts val="0"/>
+                        </a:spcAft>
+                        <a:lnSpc>
+                          <a:spcPct val="100000"/>
+                        </a:lnSpc>
+                      </a:pPr>
+                      <a:r>
+                        <a:rPr sz="1200" b="1">
+                          <a:solidFill>
+                            <a:srgbClr val="0E7A76"/>
+                          </a:solidFill>
+                          <a:latin typeface="Microsoft YaHei"/>
+                          <a:ea typeface="Microsoft YaHei"/>
+                          <a:cs typeface="Microsoft YaHei"/>
+                        </a:rPr>
+                        <a:t>218</a:t>
+                      </a:r>
+                    </a:p>
+                  </a:txBody>
+                  <a:tcPr marL="54864" marR="54864" marT="27432" marB="18288" anchor="ctr">
+                    <a:solidFill>
+                      <a:srgbClr val="E7F3F2"/>
+                    </a:solidFill>
+                    <a:lnL w="6350">
+                      <a:solidFill>
+                        <a:srgbClr val="D6DCE2"/>
+                      </a:solidFill>
+                    </a:lnL>
+                    <a:lnR w="6350">
+                      <a:solidFill>
+                        <a:srgbClr val="D6DCE2"/>
+                      </a:solidFill>
+                    </a:lnR>
+                    <a:lnT w="6350">
+                      <a:solidFill>
+                        <a:srgbClr val="D6DCE2"/>
+                      </a:solidFill>
+                    </a:lnT>
+                    <a:lnB w="6350">
+                      <a:solidFill>
+                        <a:srgbClr val="D6DCE2"/>
+                      </a:solidFill>
+                    </a:lnB>
+                  </a:tcPr>
+                </a:tc>
+                <a:tc>
+                  <a:txBody>
+                    <a:bodyPr wrap="square"/>
+                    <a:lstStyle/>
+                    <a:p>
+                      <a:pPr algn="l">
+                        <a:spcBef>
+                          <a:spcPts val="0"/>
+                        </a:spcBef>
+                        <a:spcAft>
+                          <a:spcPts val="0"/>
+                        </a:spcAft>
+                        <a:lnSpc>
+                          <a:spcPct val="100000"/>
+                        </a:lnSpc>
+                      </a:pPr>
+                      <a:r>
+                        <a:rPr sz="1200" b="1">
+                          <a:solidFill>
+                            <a:srgbClr val="0E7A76"/>
+                          </a:solidFill>
+                          <a:latin typeface="Microsoft YaHei"/>
+                          <a:ea typeface="Microsoft YaHei"/>
+                          <a:cs typeface="Microsoft YaHei"/>
+                        </a:rPr>
+                        <a:t>1.7</a:t>
+                      </a:r>
+                    </a:p>
+                  </a:txBody>
+                  <a:tcPr marL="54864" marR="54864" marT="27432" marB="18288" anchor="ctr">
+                    <a:solidFill>
+                      <a:srgbClr val="E7F3F2"/>
+                    </a:solidFill>
+                    <a:lnL w="6350">
+                      <a:solidFill>
+                        <a:srgbClr val="D6DCE2"/>
+                      </a:solidFill>
+                    </a:lnL>
+                    <a:lnR w="6350">
+                      <a:solidFill>
+                        <a:srgbClr val="D6DCE2"/>
+                      </a:solidFill>
+                    </a:lnR>
+                    <a:lnT w="6350">
+                      <a:solidFill>
+                        <a:srgbClr val="D6DCE2"/>
+                      </a:solidFill>
+                    </a:lnT>
+                    <a:lnB w="6350">
+                      <a:solidFill>
+                        <a:srgbClr val="D6DCE2"/>
+                      </a:solidFill>
+                    </a:lnB>
+                  </a:tcPr>
+                </a:tc>
+                <a:tc>
+                  <a:txBody>
+                    <a:bodyPr wrap="square"/>
+                    <a:lstStyle/>
+                    <a:p>
+                      <a:pPr algn="l">
+                        <a:spcBef>
+                          <a:spcPts val="0"/>
+                        </a:spcBef>
+                        <a:spcAft>
+                          <a:spcPts val="0"/>
+                        </a:spcAft>
+                        <a:lnSpc>
+                          <a:spcPct val="100000"/>
+                        </a:lnSpc>
+                      </a:pPr>
+                      <a:r>
+                        <a:rPr sz="1200" b="1">
+                          <a:solidFill>
+                            <a:srgbClr val="0E7A76"/>
+                          </a:solidFill>
+                          <a:latin typeface="Microsoft YaHei"/>
+                          <a:ea typeface="Microsoft YaHei"/>
+                          <a:cs typeface="Microsoft YaHei"/>
+                        </a:rPr>
+                        <a:t>4880</a:t>
+                      </a:r>
+                    </a:p>
+                  </a:txBody>
+                  <a:tcPr marL="54864" marR="54864" marT="27432" marB="18288" anchor="ctr">
+                    <a:solidFill>
+                      <a:srgbClr val="E7F3F2"/>
+                    </a:solidFill>
+                    <a:lnL w="6350">
+                      <a:solidFill>
+                        <a:srgbClr val="D6DCE2"/>
+                      </a:solidFill>
+                    </a:lnL>
+                    <a:lnR w="6350">
+                      <a:solidFill>
+                        <a:srgbClr val="D6DCE2"/>
+                      </a:solidFill>
+                    </a:lnR>
+                    <a:lnT w="6350">
+                      <a:solidFill>
+                        <a:srgbClr val="D6DCE2"/>
+                      </a:solidFill>
+                    </a:lnT>
+                    <a:lnB w="6350">
+                      <a:solidFill>
+                        <a:srgbClr val="D6DCE2"/>
+                      </a:solidFill>
+                    </a:lnB>
+                  </a:tcPr>
+                </a:tc>
+                <a:tc>
+                  <a:txBody>
+                    <a:bodyPr wrap="square"/>
+                    <a:lstStyle/>
+                    <a:p>
+                      <a:pPr algn="l">
+                        <a:spcBef>
+                          <a:spcPts val="0"/>
+                        </a:spcBef>
+                        <a:spcAft>
+                          <a:spcPts val="0"/>
+                        </a:spcAft>
+                        <a:lnSpc>
+                          <a:spcPct val="100000"/>
+                        </a:lnSpc>
+                      </a:pPr>
+                      <a:r>
+                        <a:rPr sz="1200" b="1">
+                          <a:solidFill>
+                            <a:srgbClr val="0E7A76"/>
+                          </a:solidFill>
+                          <a:latin typeface="Microsoft YaHei"/>
+                          <a:ea typeface="Microsoft YaHei"/>
+                          <a:cs typeface="Microsoft YaHei"/>
+                        </a:rPr>
+                        <a:t>38.1</a:t>
+                      </a:r>
+                    </a:p>
+                  </a:txBody>
+                  <a:tcPr marL="54864" marR="54864" marT="27432" marB="18288" anchor="ctr">
+                    <a:solidFill>
+                      <a:srgbClr val="E7F3F2"/>
+                    </a:solidFill>
+                    <a:lnL w="6350">
+                      <a:solidFill>
+                        <a:srgbClr val="D6DCE2"/>
+                      </a:solidFill>
+                    </a:lnL>
+                    <a:lnR w="6350">
+                      <a:solidFill>
+                        <a:srgbClr val="D6DCE2"/>
+                      </a:solidFill>
+                    </a:lnR>
+                    <a:lnT w="6350">
+                      <a:solidFill>
+                        <a:srgbClr val="D6DCE2"/>
+                      </a:solidFill>
+                    </a:lnT>
+                    <a:lnB w="6350">
+                      <a:solidFill>
+                        <a:srgbClr val="D6DCE2"/>
+                      </a:solidFill>
+                    </a:lnB>
+                  </a:tcPr>
+                </a:tc>
+                <a:tc>
+                  <a:txBody>
+                    <a:bodyPr wrap="square"/>
+                    <a:lstStyle/>
+                    <a:p>
+                      <a:pPr algn="l">
+                        <a:spcBef>
+                          <a:spcPts val="0"/>
+                        </a:spcBef>
+                        <a:spcAft>
+                          <a:spcPts val="0"/>
+                        </a:spcAft>
+                        <a:lnSpc>
+                          <a:spcPct val="100000"/>
+                        </a:lnSpc>
+                      </a:pPr>
+                      <a:r>
+                        <a:rPr sz="1200" b="1">
+                          <a:solidFill>
+                            <a:srgbClr val="0E7A76"/>
+                          </a:solidFill>
+                          <a:latin typeface="Microsoft YaHei"/>
+                          <a:ea typeface="Microsoft YaHei"/>
+                          <a:cs typeface="Microsoft YaHei"/>
+                        </a:rPr>
+                        <a:t>9.8% 在总线内存池</a:t>
+                      </a:r>
+                    </a:p>
+                  </a:txBody>
+                  <a:tcPr marL="54864" marR="54864" marT="27432" marB="18288" anchor="ctr">
+                    <a:solidFill>
+                      <a:srgbClr val="E7F3F2"/>
                     </a:solidFill>
                     <a:lnL w="6350">
                       <a:solidFill>
@@ -32040,7 +32040,7 @@
                           <a:ea typeface="Microsoft YaHei"/>
                           <a:cs typeface="Microsoft YaHei"/>
                         </a:rPr>
-                        <a:t>193</a:t>
+                        <a:t>213</a:t>
                       </a:r>
                     </a:p>
                   </a:txBody>
@@ -32095,7 +32095,7 @@
                           <a:ea typeface="Microsoft YaHei"/>
                           <a:cs typeface="Microsoft YaHei"/>
                         </a:rPr>
-                        <a:t>1.5</a:t>
+                        <a:t>1.7</a:t>
                       </a:r>
                     </a:p>
                   </a:txBody>
@@ -32150,7 +32150,7 @@
                           <a:ea typeface="Microsoft YaHei"/>
                           <a:cs typeface="Microsoft YaHei"/>
                         </a:rPr>
-                        <a:t>2390</a:t>
+                        <a:t>2816</a:t>
                       </a:r>
                     </a:p>
                   </a:txBody>
@@ -32205,7 +32205,7 @@
                           <a:ea typeface="Microsoft YaHei"/>
                           <a:cs typeface="Microsoft YaHei"/>
                         </a:rPr>
-                        <a:t>18.7</a:t>
+                        <a:t>22.0</a:t>
                       </a:r>
                     </a:p>
                   </a:txBody>
@@ -32260,7 +32260,7 @@
                           <a:ea typeface="Microsoft YaHei"/>
                           <a:cs typeface="Microsoft YaHei"/>
                         </a:rPr>
-                        <a:t>7.7% 在总线内存池</a:t>
+                        <a:t>21.7% 在总线内存池</a:t>
                       </a:r>
                     </a:p>
                   </a:txBody>
@@ -32482,7 +32482,7 @@
                           <a:ea typeface="Microsoft YaHei"/>
                           <a:cs typeface="Microsoft YaHei"/>
                         </a:rPr>
-                        <a:t>173</a:t>
+                        <a:t>190</a:t>
                       </a:r>
                     </a:p>
                   </a:txBody>
@@ -32537,7 +32537,7 @@
                           <a:ea typeface="Microsoft YaHei"/>
                           <a:cs typeface="Microsoft YaHei"/>
                         </a:rPr>
-                        <a:t>1.4</a:t>
+                        <a:t>1.5</a:t>
                       </a:r>
                     </a:p>
                   </a:txBody>
@@ -32592,7 +32592,7 @@
                           <a:ea typeface="Microsoft YaHei"/>
                           <a:cs typeface="Microsoft YaHei"/>
                         </a:rPr>
-                        <a:t>1362</a:t>
+                        <a:t>1528</a:t>
                       </a:r>
                     </a:p>
                   </a:txBody>
@@ -32647,7 +32647,7 @@
                           <a:ea typeface="Microsoft YaHei"/>
                           <a:cs typeface="Microsoft YaHei"/>
                         </a:rPr>
-                        <a:t>10.6</a:t>
+                        <a:t>11.9</a:t>
                       </a:r>
                     </a:p>
                   </a:txBody>
@@ -32702,7 +32702,7 @@
                           <a:ea typeface="Microsoft YaHei"/>
                           <a:cs typeface="Microsoft YaHei"/>
                         </a:rPr>
-                        <a:t>19.0% 在总线内存池</a:t>
+                        <a:t>27.8% 在总线内存池</a:t>
                       </a:r>
                     </a:p>
                   </a:txBody>
@@ -32817,7 +32817,7 @@
                 <a:ea typeface="Microsoft YaHei"/>
                 <a:cs typeface="Microsoft YaHei"/>
               </a:rPr>
-              <a:t>10 毫秒在 4K – 8K 都是 201，全在 HBM。短输入 Attention 1.27 毫秒，MoE 8.73 毫秒。1M 降到 173，0.25×10^6 是 197，仍然全在 HBM。</a:t>
+              <a:t>10 毫秒在 4K – 32K 都是 222，全在 HBM。短输入 Attention 0.85 毫秒，MoE 9.14 毫秒。1M 降到 190，0.33×10^6 是 216，仍然全在 HBM。</a:t>
             </a:r>
           </a:p>
           <a:p>
@@ -32838,7 +32838,7 @@
                 <a:ea typeface="Microsoft YaHei"/>
                 <a:cs typeface="Microsoft YaHei"/>
               </a:rPr>
-              <a:t>30 毫秒短输入为 4352。256K 为 3328，仍全在 HBM；Attention 15.3 毫秒，MoE 14.4 毫秒。512K 降到 2390，1M 为 1362，0.25×10^6 为 3328。</a:t>
+              <a:t>30 毫秒短输入为 7936。256K 为 4880，已有 9.8% KV 在池中；Attention 15.2 毫秒，MoE 14.8 毫秒。512K 降到 2816，1M 为 1528，0.33×10^6 为 4096。</a:t>
             </a:r>
           </a:p>
           <a:p>
@@ -32859,7 +32859,7 @@
                 <a:ea typeface="Microsoft YaHei"/>
                 <a:cs typeface="Microsoft YaHei"/>
               </a:rPr>
-              <a:t>Prefill 的 10 秒全局批在第 3 页：4K 为 30880，1M 为 64。4K 进、512 出、98% 命中时，P:D 在 10 毫秒约 1:78.7，在 30 毫秒约 1:10.9。</a:t>
+              <a:t>Prefill 的 10 秒全局批在第 3 页：4K 为 45674，1M 为 64。4K 进、512 出、98% 命中时，P:D 在 10 毫秒约 1:105.3，在 30 毫秒约 1:8.8。</a:t>
             </a:r>
           </a:p>
         </p:txBody>
@@ -33004,7 +33004,7 @@
                 <a:ea typeface="Microsoft YaHei"/>
                 <a:cs typeface="Microsoft YaHei"/>
               </a:rPr>
-              <a:t>512K 每卡换入 503.9 MB，1M 换入 1.37 GB</a:t>
+              <a:t>256K 每卡换入 689.1 MB，0.33×10^6 换入 1.04 GB</a:t>
             </a:r>
           </a:p>
         </p:txBody>
@@ -33323,7 +33323,7 @@
                           <a:ea typeface="Microsoft YaHei"/>
                           <a:cs typeface="Microsoft YaHei"/>
                         </a:rPr>
-                        <a:t>512K · 批 2390 · 溢出 7.7%</a:t>
+                        <a:t>256K · 批 4880 · 溢出 9.8%</a:t>
                       </a:r>
                     </a:p>
                   </a:txBody>
@@ -33378,7 +33378,7 @@
                           <a:ea typeface="Microsoft YaHei"/>
                           <a:cs typeface="Microsoft YaHei"/>
                         </a:rPr>
-                        <a:t>1M · 批 1362 · 溢出 19.0%</a:t>
+                        <a:t>0.33×10^6 · 批 4096 · 溢出 14.3%</a:t>
                       </a:r>
                     </a:p>
                   </a:txBody>
@@ -33657,7 +33657,7 @@
                           <a:ea typeface="Microsoft YaHei"/>
                           <a:cs typeface="Microsoft YaHei"/>
                         </a:rPr>
-                        <a:t>229.6 MB · 5.74 毫秒</a:t>
+                        <a:t>466.8 MB · 1.67 毫秒</a:t>
                       </a:r>
                     </a:p>
                   </a:txBody>
@@ -33712,7 +33712,7 @@
                           <a:ea typeface="Microsoft YaHei"/>
                           <a:cs typeface="Microsoft YaHei"/>
                         </a:rPr>
-                        <a:t>131.6 MB · 3.29 毫秒</a:t>
+                        <a:t>391.8 MB · 1.40 毫秒</a:t>
                       </a:r>
                     </a:p>
                   </a:txBody>
@@ -33824,7 +33824,7 @@
                           <a:ea typeface="Microsoft YaHei"/>
                           <a:cs typeface="Microsoft YaHei"/>
                         </a:rPr>
-                        <a:t>效率 43% · 8.07 毫秒</a:t>
+                        <a:t>效率 84% · 8.45 毫秒</a:t>
                       </a:r>
                     </a:p>
                   </a:txBody>
@@ -33879,7 +33879,7 @@
                           <a:ea typeface="Microsoft YaHei"/>
                           <a:cs typeface="Microsoft YaHei"/>
                         </a:rPr>
-                        <a:t>效率 26% · 7.69 毫秒</a:t>
+                        <a:t>效率 71% · 8.07 毫秒</a:t>
                       </a:r>
                     </a:p>
                   </a:txBody>
@@ -33991,7 +33991,7 @@
                           <a:ea typeface="Microsoft YaHei"/>
                           <a:cs typeface="Microsoft YaHei"/>
                         </a:rPr>
-                        <a:t>232.8 MB · 0.73 毫秒</a:t>
+                        <a:t>452.8 MB · 1.41 毫秒</a:t>
                       </a:r>
                     </a:p>
                   </a:txBody>
@@ -34046,7 +34046,7 @@
                           <a:ea typeface="Microsoft YaHei"/>
                           <a:cs typeface="Microsoft YaHei"/>
                         </a:rPr>
-                        <a:t>139.5 MB · 0.44 毫秒</a:t>
+                        <a:t>384.1 MB · 1.20 毫秒</a:t>
                       </a:r>
                     </a:p>
                   </a:txBody>
@@ -34158,7 +34158,7 @@
                           <a:ea typeface="Microsoft YaHei"/>
                           <a:cs typeface="Microsoft YaHei"/>
                         </a:rPr>
-                        <a:t>8.55 毫秒</a:t>
+                        <a:t>11.36 毫秒</a:t>
                       </a:r>
                     </a:p>
                   </a:txBody>
@@ -34213,7 +34213,7 @@
                           <a:ea typeface="Microsoft YaHei"/>
                           <a:cs typeface="Microsoft YaHei"/>
                         </a:rPr>
-                        <a:t>8.58 毫秒</a:t>
+                        <a:t>10.26 毫秒</a:t>
                       </a:r>
                     </a:p>
                   </a:txBody>
@@ -34492,7 +34492,7 @@
                           <a:ea typeface="Microsoft YaHei"/>
                           <a:cs typeface="Microsoft YaHei"/>
                         </a:rPr>
-                        <a:t>8.92 GB · 2.79 毫秒</a:t>
+                        <a:t>9.46 GB · 2.96 毫秒</a:t>
                       </a:r>
                     </a:p>
                   </a:txBody>
@@ -34547,7 +34547,7 @@
                           <a:ea typeface="Microsoft YaHei"/>
                           <a:cs typeface="Microsoft YaHei"/>
                         </a:rPr>
-                        <a:t>9.64 GB · 3.01 毫秒</a:t>
+                        <a:t>9.65 GB · 3.02 毫秒</a:t>
                       </a:r>
                     </a:p>
                   </a:txBody>
@@ -34659,7 +34659,7 @@
                           <a:ea typeface="Microsoft YaHei"/>
                           <a:cs typeface="Microsoft YaHei"/>
                         </a:rPr>
-                        <a:t>503.9 MB · 1.57 毫秒</a:t>
+                        <a:t>689.1 MB · 2.15 毫秒</a:t>
                       </a:r>
                     </a:p>
                   </a:txBody>
@@ -34714,7 +34714,7 @@
                           <a:ea typeface="Microsoft YaHei"/>
                           <a:cs typeface="Microsoft YaHei"/>
                         </a:rPr>
-                        <a:t>1.37 GB · 4.28 毫秒</a:t>
+                        <a:t>1.04 GB · 3.23 毫秒</a:t>
                       </a:r>
                     </a:p>
                   </a:txBody>
@@ -34881,7 +34881,7 @@
                           <a:ea typeface="Microsoft YaHei"/>
                           <a:cs typeface="Microsoft YaHei"/>
                         </a:rPr>
-                        <a:t>换入 + 注意力计算 + AR + 读专家 · 29.99 毫秒</a:t>
+                        <a:t>换入 + 注意力计算 + AR + 读专家 · 29.50 毫秒</a:t>
                       </a:r>
                     </a:p>
                   </a:txBody>
@@ -34996,7 +34996,7 @@
                 <a:ea typeface="Microsoft YaHei"/>
                 <a:cs typeface="Microsoft YaHei"/>
               </a:rPr>
-              <a:t>字节按每卡。512K 溢出 7.7%，换入 503.9 MB / 320 GB/s = 1.57 毫秒，然后从 HBM 再读全部 KV；Attention 15.87 毫秒，MoE 14.13 毫秒。128 卡换入合计 64.50 GB。</a:t>
+              <a:t>字节按每卡。256K 溢出 9.8%，换入 689.1 MB / 320 GB/s = 2.15 毫秒，然后从 HBM 再读全部 KV；Attention 15.18 毫秒，MoE 14.82 毫秒。128 卡换入合计 88.21 GB。</a:t>
             </a:r>
           </a:p>
           <a:p>
@@ -35017,7 +35017,7 @@
                 <a:ea typeface="Microsoft YaHei"/>
                 <a:cs typeface="Microsoft YaHei"/>
               </a:rPr>
-              <a:t>1M 换入 1.37 GB、4.28 毫秒；Attention 16.15 毫秒，MoE 13.84 毫秒，批 1362。128 卡换入合计 175.51 GB。</a:t>
+              <a:t>0.33×10^6 换入 1.04 GB、3.23 毫秒；Attention 14.89 毫秒，MoE 14.60 毫秒，批 4096。128 卡换入合计 132.49 GB。</a:t>
             </a:r>
           </a:p>
           <a:p>
@@ -35038,7 +35038,7 @@
                 <a:ea typeface="Microsoft YaHei"/>
                 <a:cs typeface="Microsoft YaHei"/>
               </a:rPr>
-              <a:t>10 毫秒到 0.25×10^6 仍全在 HBM，没有进池的长度，不进这两页。后面的分析沿用这个口径。</a:t>
+              <a:t>10 毫秒到 0.33×10^6 仍全在 HBM，没有进池的长度，不进这两页。后面的分析沿用这个口径。</a:t>
             </a:r>
           </a:p>
         </p:txBody>
@@ -35183,7 +35183,7 @@
                 <a:ea typeface="Microsoft YaHei"/>
                 <a:cs typeface="Microsoft YaHei"/>
               </a:rPr>
-              <a:t>进池的长度从 512K 起，批从 2390 降到 1362</a:t>
+              <a:t>进池的长度从 256K 起，批从 4880 降到 4096</a:t>
             </a:r>
           </a:p>
         </p:txBody>
@@ -35410,7 +35410,7 @@
         </p:nvGraphicFramePr>
         <p:xfrm>
           <a:off x="384048" y="1353312"/>
-          <a:ext cx="11247120" cy="1115568"/>
+          <a:ext cx="11247120" cy="1883664"/>
         </p:xfrm>
         <a:graphic>
           <a:graphicData uri="http://schemas.openxmlformats.org/drawingml/2006/table">
@@ -35894,7 +35894,7 @@
                           <a:ea typeface="Microsoft YaHei"/>
                           <a:cs typeface="Microsoft YaHei"/>
                         </a:rPr>
-                        <a:t>512K</a:t>
+                        <a:t>256K</a:t>
                       </a:r>
                     </a:p>
                   </a:txBody>
@@ -35949,7 +35949,7 @@
                           <a:ea typeface="Microsoft YaHei"/>
                           <a:cs typeface="Microsoft YaHei"/>
                         </a:rPr>
-                        <a:t>2390</a:t>
+                        <a:t>4880</a:t>
                       </a:r>
                     </a:p>
                   </a:txBody>
@@ -36004,7 +36004,7 @@
                           <a:ea typeface="Microsoft YaHei"/>
                           <a:cs typeface="Microsoft YaHei"/>
                         </a:rPr>
-                        <a:t>18.7</a:t>
+                        <a:t>38.1</a:t>
                       </a:r>
                     </a:p>
                   </a:txBody>
@@ -36059,7 +36059,7 @@
                           <a:ea typeface="Microsoft YaHei"/>
                           <a:cs typeface="Microsoft YaHei"/>
                         </a:rPr>
-                        <a:t>7.7%</a:t>
+                        <a:t>9.8%</a:t>
                       </a:r>
                     </a:p>
                   </a:txBody>
@@ -36114,7 +36114,7 @@
                           <a:ea typeface="Microsoft YaHei"/>
                           <a:cs typeface="Microsoft YaHei"/>
                         </a:rPr>
-                        <a:t>503.9 MB</a:t>
+                        <a:t>689.1 MB</a:t>
                       </a:r>
                     </a:p>
                   </a:txBody>
@@ -36169,7 +36169,7 @@
                           <a:ea typeface="Microsoft YaHei"/>
                           <a:cs typeface="Microsoft YaHei"/>
                         </a:rPr>
-                        <a:t>64.50 GB</a:t>
+                        <a:t>88.21 GB</a:t>
                       </a:r>
                     </a:p>
                   </a:txBody>
@@ -36224,7 +36224,7 @@
                           <a:ea typeface="Microsoft YaHei"/>
                           <a:cs typeface="Microsoft YaHei"/>
                         </a:rPr>
-                        <a:t>1.57 毫秒</a:t>
+                        <a:t>2.15 毫秒</a:t>
                       </a:r>
                     </a:p>
                   </a:txBody>
@@ -36279,7 +36279,7 @@
                           <a:ea typeface="Microsoft YaHei"/>
                           <a:cs typeface="Microsoft YaHei"/>
                         </a:rPr>
-                        <a:t>注意力计算 8.55 毫秒</a:t>
+                        <a:t>注意力计算 11.36 毫秒</a:t>
                       </a:r>
                     </a:p>
                   </a:txBody>
@@ -36336,6 +36336,448 @@
                           <a:ea typeface="Microsoft YaHei"/>
                           <a:cs typeface="Microsoft YaHei"/>
                         </a:rPr>
+                        <a:t>512K</a:t>
+                      </a:r>
+                    </a:p>
+                  </a:txBody>
+                  <a:tcPr marL="54864" marR="54864" marT="27432" marB="18288" anchor="ctr">
+                    <a:solidFill>
+                      <a:srgbClr val="F4F7FA"/>
+                    </a:solidFill>
+                    <a:lnL w="6350">
+                      <a:solidFill>
+                        <a:srgbClr val="D6DCE2"/>
+                      </a:solidFill>
+                    </a:lnL>
+                    <a:lnR w="6350">
+                      <a:solidFill>
+                        <a:srgbClr val="D6DCE2"/>
+                      </a:solidFill>
+                    </a:lnR>
+                    <a:lnT w="6350">
+                      <a:solidFill>
+                        <a:srgbClr val="D6DCE2"/>
+                      </a:solidFill>
+                    </a:lnT>
+                    <a:lnB w="6350">
+                      <a:solidFill>
+                        <a:srgbClr val="D6DCE2"/>
+                      </a:solidFill>
+                    </a:lnB>
+                  </a:tcPr>
+                </a:tc>
+                <a:tc>
+                  <a:txBody>
+                    <a:bodyPr wrap="square"/>
+                    <a:lstStyle/>
+                    <a:p>
+                      <a:pPr algn="l">
+                        <a:spcBef>
+                          <a:spcPts val="0"/>
+                        </a:spcBef>
+                        <a:spcAft>
+                          <a:spcPts val="0"/>
+                        </a:spcAft>
+                        <a:lnSpc>
+                          <a:spcPct val="100000"/>
+                        </a:lnSpc>
+                      </a:pPr>
+                      <a:r>
+                        <a:rPr sz="1200" b="0">
+                          <a:solidFill>
+                            <a:srgbClr val="1C242E"/>
+                          </a:solidFill>
+                          <a:latin typeface="Microsoft YaHei"/>
+                          <a:ea typeface="Microsoft YaHei"/>
+                          <a:cs typeface="Microsoft YaHei"/>
+                        </a:rPr>
+                        <a:t>2816</a:t>
+                      </a:r>
+                    </a:p>
+                  </a:txBody>
+                  <a:tcPr marL="54864" marR="54864" marT="27432" marB="18288" anchor="ctr">
+                    <a:solidFill>
+                      <a:srgbClr val="FFFFFF"/>
+                    </a:solidFill>
+                    <a:lnL w="6350">
+                      <a:solidFill>
+                        <a:srgbClr val="D6DCE2"/>
+                      </a:solidFill>
+                    </a:lnL>
+                    <a:lnR w="6350">
+                      <a:solidFill>
+                        <a:srgbClr val="D6DCE2"/>
+                      </a:solidFill>
+                    </a:lnR>
+                    <a:lnT w="6350">
+                      <a:solidFill>
+                        <a:srgbClr val="D6DCE2"/>
+                      </a:solidFill>
+                    </a:lnT>
+                    <a:lnB w="6350">
+                      <a:solidFill>
+                        <a:srgbClr val="D6DCE2"/>
+                      </a:solidFill>
+                    </a:lnB>
+                  </a:tcPr>
+                </a:tc>
+                <a:tc>
+                  <a:txBody>
+                    <a:bodyPr wrap="square"/>
+                    <a:lstStyle/>
+                    <a:p>
+                      <a:pPr algn="l">
+                        <a:spcBef>
+                          <a:spcPts val="0"/>
+                        </a:spcBef>
+                        <a:spcAft>
+                          <a:spcPts val="0"/>
+                        </a:spcAft>
+                        <a:lnSpc>
+                          <a:spcPct val="100000"/>
+                        </a:lnSpc>
+                      </a:pPr>
+                      <a:r>
+                        <a:rPr sz="1200" b="0">
+                          <a:solidFill>
+                            <a:srgbClr val="1C242E"/>
+                          </a:solidFill>
+                          <a:latin typeface="Microsoft YaHei"/>
+                          <a:ea typeface="Microsoft YaHei"/>
+                          <a:cs typeface="Microsoft YaHei"/>
+                        </a:rPr>
+                        <a:t>22.0</a:t>
+                      </a:r>
+                    </a:p>
+                  </a:txBody>
+                  <a:tcPr marL="54864" marR="54864" marT="27432" marB="18288" anchor="ctr">
+                    <a:solidFill>
+                      <a:srgbClr val="FFFFFF"/>
+                    </a:solidFill>
+                    <a:lnL w="6350">
+                      <a:solidFill>
+                        <a:srgbClr val="D6DCE2"/>
+                      </a:solidFill>
+                    </a:lnL>
+                    <a:lnR w="6350">
+                      <a:solidFill>
+                        <a:srgbClr val="D6DCE2"/>
+                      </a:solidFill>
+                    </a:lnR>
+                    <a:lnT w="6350">
+                      <a:solidFill>
+                        <a:srgbClr val="D6DCE2"/>
+                      </a:solidFill>
+                    </a:lnT>
+                    <a:lnB w="6350">
+                      <a:solidFill>
+                        <a:srgbClr val="D6DCE2"/>
+                      </a:solidFill>
+                    </a:lnB>
+                  </a:tcPr>
+                </a:tc>
+                <a:tc>
+                  <a:txBody>
+                    <a:bodyPr wrap="square"/>
+                    <a:lstStyle/>
+                    <a:p>
+                      <a:pPr algn="l">
+                        <a:spcBef>
+                          <a:spcPts val="0"/>
+                        </a:spcBef>
+                        <a:spcAft>
+                          <a:spcPts val="0"/>
+                        </a:spcAft>
+                        <a:lnSpc>
+                          <a:spcPct val="100000"/>
+                        </a:lnSpc>
+                      </a:pPr>
+                      <a:r>
+                        <a:rPr sz="1200" b="0">
+                          <a:solidFill>
+                            <a:srgbClr val="1C242E"/>
+                          </a:solidFill>
+                          <a:latin typeface="Microsoft YaHei"/>
+                          <a:ea typeface="Microsoft YaHei"/>
+                          <a:cs typeface="Microsoft YaHei"/>
+                        </a:rPr>
+                        <a:t>21.7%</a:t>
+                      </a:r>
+                    </a:p>
+                  </a:txBody>
+                  <a:tcPr marL="54864" marR="54864" marT="27432" marB="18288" anchor="ctr">
+                    <a:solidFill>
+                      <a:srgbClr val="FFFFFF"/>
+                    </a:solidFill>
+                    <a:lnL w="6350">
+                      <a:solidFill>
+                        <a:srgbClr val="D6DCE2"/>
+                      </a:solidFill>
+                    </a:lnL>
+                    <a:lnR w="6350">
+                      <a:solidFill>
+                        <a:srgbClr val="D6DCE2"/>
+                      </a:solidFill>
+                    </a:lnR>
+                    <a:lnT w="6350">
+                      <a:solidFill>
+                        <a:srgbClr val="D6DCE2"/>
+                      </a:solidFill>
+                    </a:lnT>
+                    <a:lnB w="6350">
+                      <a:solidFill>
+                        <a:srgbClr val="D6DCE2"/>
+                      </a:solidFill>
+                    </a:lnB>
+                  </a:tcPr>
+                </a:tc>
+                <a:tc>
+                  <a:txBody>
+                    <a:bodyPr wrap="square"/>
+                    <a:lstStyle/>
+                    <a:p>
+                      <a:pPr algn="l">
+                        <a:spcBef>
+                          <a:spcPts val="0"/>
+                        </a:spcBef>
+                        <a:spcAft>
+                          <a:spcPts val="0"/>
+                        </a:spcAft>
+                        <a:lnSpc>
+                          <a:spcPct val="100000"/>
+                        </a:lnSpc>
+                      </a:pPr>
+                      <a:r>
+                        <a:rPr sz="1200" b="0">
+                          <a:solidFill>
+                            <a:srgbClr val="1C242E"/>
+                          </a:solidFill>
+                          <a:latin typeface="Microsoft YaHei"/>
+                          <a:ea typeface="Microsoft YaHei"/>
+                          <a:cs typeface="Microsoft YaHei"/>
+                        </a:rPr>
+                        <a:t>1.66 GB</a:t>
+                      </a:r>
+                    </a:p>
+                  </a:txBody>
+                  <a:tcPr marL="54864" marR="54864" marT="27432" marB="18288" anchor="ctr">
+                    <a:solidFill>
+                      <a:srgbClr val="FFFFFF"/>
+                    </a:solidFill>
+                    <a:lnL w="6350">
+                      <a:solidFill>
+                        <a:srgbClr val="D6DCE2"/>
+                      </a:solidFill>
+                    </a:lnL>
+                    <a:lnR w="6350">
+                      <a:solidFill>
+                        <a:srgbClr val="D6DCE2"/>
+                      </a:solidFill>
+                    </a:lnR>
+                    <a:lnT w="6350">
+                      <a:solidFill>
+                        <a:srgbClr val="D6DCE2"/>
+                      </a:solidFill>
+                    </a:lnT>
+                    <a:lnB w="6350">
+                      <a:solidFill>
+                        <a:srgbClr val="D6DCE2"/>
+                      </a:solidFill>
+                    </a:lnB>
+                  </a:tcPr>
+                </a:tc>
+                <a:tc>
+                  <a:txBody>
+                    <a:bodyPr wrap="square"/>
+                    <a:lstStyle/>
+                    <a:p>
+                      <a:pPr algn="l">
+                        <a:spcBef>
+                          <a:spcPts val="0"/>
+                        </a:spcBef>
+                        <a:spcAft>
+                          <a:spcPts val="0"/>
+                        </a:spcAft>
+                        <a:lnSpc>
+                          <a:spcPct val="100000"/>
+                        </a:lnSpc>
+                      </a:pPr>
+                      <a:r>
+                        <a:rPr sz="1200" b="0">
+                          <a:solidFill>
+                            <a:srgbClr val="1C242E"/>
+                          </a:solidFill>
+                          <a:latin typeface="Microsoft YaHei"/>
+                          <a:ea typeface="Microsoft YaHei"/>
+                          <a:cs typeface="Microsoft YaHei"/>
+                        </a:rPr>
+                        <a:t>212.05 GB</a:t>
+                      </a:r>
+                    </a:p>
+                  </a:txBody>
+                  <a:tcPr marL="54864" marR="54864" marT="27432" marB="18288" anchor="ctr">
+                    <a:solidFill>
+                      <a:srgbClr val="FFFFFF"/>
+                    </a:solidFill>
+                    <a:lnL w="6350">
+                      <a:solidFill>
+                        <a:srgbClr val="D6DCE2"/>
+                      </a:solidFill>
+                    </a:lnL>
+                    <a:lnR w="6350">
+                      <a:solidFill>
+                        <a:srgbClr val="D6DCE2"/>
+                      </a:solidFill>
+                    </a:lnR>
+                    <a:lnT w="6350">
+                      <a:solidFill>
+                        <a:srgbClr val="D6DCE2"/>
+                      </a:solidFill>
+                    </a:lnT>
+                    <a:lnB w="6350">
+                      <a:solidFill>
+                        <a:srgbClr val="D6DCE2"/>
+                      </a:solidFill>
+                    </a:lnB>
+                  </a:tcPr>
+                </a:tc>
+                <a:tc>
+                  <a:txBody>
+                    <a:bodyPr wrap="square"/>
+                    <a:lstStyle/>
+                    <a:p>
+                      <a:pPr algn="l">
+                        <a:spcBef>
+                          <a:spcPts val="0"/>
+                        </a:spcBef>
+                        <a:spcAft>
+                          <a:spcPts val="0"/>
+                        </a:spcAft>
+                        <a:lnSpc>
+                          <a:spcPct val="100000"/>
+                        </a:lnSpc>
+                      </a:pPr>
+                      <a:r>
+                        <a:rPr sz="1200" b="0">
+                          <a:solidFill>
+                            <a:srgbClr val="1C242E"/>
+                          </a:solidFill>
+                          <a:latin typeface="Microsoft YaHei"/>
+                          <a:ea typeface="Microsoft YaHei"/>
+                          <a:cs typeface="Microsoft YaHei"/>
+                        </a:rPr>
+                        <a:t>5.18 毫秒</a:t>
+                      </a:r>
+                    </a:p>
+                  </a:txBody>
+                  <a:tcPr marL="54864" marR="54864" marT="27432" marB="18288" anchor="ctr">
+                    <a:solidFill>
+                      <a:srgbClr val="FFFFFF"/>
+                    </a:solidFill>
+                    <a:lnL w="6350">
+                      <a:solidFill>
+                        <a:srgbClr val="D6DCE2"/>
+                      </a:solidFill>
+                    </a:lnL>
+                    <a:lnR w="6350">
+                      <a:solidFill>
+                        <a:srgbClr val="D6DCE2"/>
+                      </a:solidFill>
+                    </a:lnR>
+                    <a:lnT w="6350">
+                      <a:solidFill>
+                        <a:srgbClr val="D6DCE2"/>
+                      </a:solidFill>
+                    </a:lnT>
+                    <a:lnB w="6350">
+                      <a:solidFill>
+                        <a:srgbClr val="D6DCE2"/>
+                      </a:solidFill>
+                    </a:lnB>
+                  </a:tcPr>
+                </a:tc>
+                <a:tc>
+                  <a:txBody>
+                    <a:bodyPr wrap="square"/>
+                    <a:lstStyle/>
+                    <a:p>
+                      <a:pPr algn="l">
+                        <a:spcBef>
+                          <a:spcPts val="0"/>
+                        </a:spcBef>
+                        <a:spcAft>
+                          <a:spcPts val="0"/>
+                        </a:spcAft>
+                        <a:lnSpc>
+                          <a:spcPct val="100000"/>
+                        </a:lnSpc>
+                      </a:pPr>
+                      <a:r>
+                        <a:rPr sz="1200" b="0">
+                          <a:solidFill>
+                            <a:srgbClr val="1C242E"/>
+                          </a:solidFill>
+                          <a:latin typeface="Microsoft YaHei"/>
+                          <a:ea typeface="Microsoft YaHei"/>
+                          <a:cs typeface="Microsoft YaHei"/>
+                        </a:rPr>
+                        <a:t>注意力计算 9.41 毫秒</a:t>
+                      </a:r>
+                    </a:p>
+                  </a:txBody>
+                  <a:tcPr marL="54864" marR="54864" marT="27432" marB="18288" anchor="ctr">
+                    <a:solidFill>
+                      <a:srgbClr val="FFFFFF"/>
+                    </a:solidFill>
+                    <a:lnL w="6350">
+                      <a:solidFill>
+                        <a:srgbClr val="D6DCE2"/>
+                      </a:solidFill>
+                    </a:lnL>
+                    <a:lnR w="6350">
+                      <a:solidFill>
+                        <a:srgbClr val="D6DCE2"/>
+                      </a:solidFill>
+                    </a:lnR>
+                    <a:lnT w="6350">
+                      <a:solidFill>
+                        <a:srgbClr val="D6DCE2"/>
+                      </a:solidFill>
+                    </a:lnT>
+                    <a:lnB w="6350">
+                      <a:solidFill>
+                        <a:srgbClr val="D6DCE2"/>
+                      </a:solidFill>
+                    </a:lnB>
+                  </a:tcPr>
+                </a:tc>
+              </a:tr>
+              <a:tr h="384048">
+                <a:tc>
+                  <a:txBody>
+                    <a:bodyPr wrap="square"/>
+                    <a:lstStyle/>
+                    <a:p>
+                      <a:pPr algn="l">
+                        <a:spcBef>
+                          <a:spcPts val="0"/>
+                        </a:spcBef>
+                        <a:spcAft>
+                          <a:spcPts val="0"/>
+                        </a:spcAft>
+                        <a:lnSpc>
+                          <a:spcPct val="100000"/>
+                        </a:lnSpc>
+                      </a:pPr>
+                      <a:r>
+                        <a:rPr sz="1200" b="1">
+                          <a:solidFill>
+                            <a:srgbClr val="0E2A47"/>
+                          </a:solidFill>
+                          <a:latin typeface="Microsoft YaHei"/>
+                          <a:ea typeface="Microsoft YaHei"/>
+                          <a:cs typeface="Microsoft YaHei"/>
+                        </a:rPr>
                         <a:t>1M</a:t>
                       </a:r>
                     </a:p>
@@ -36391,7 +36833,7 @@
                           <a:ea typeface="Microsoft YaHei"/>
                           <a:cs typeface="Microsoft YaHei"/>
                         </a:rPr>
-                        <a:t>1362</a:t>
+                        <a:t>1528</a:t>
                       </a:r>
                     </a:p>
                   </a:txBody>
@@ -36446,7 +36888,7 @@
                           <a:ea typeface="Microsoft YaHei"/>
                           <a:cs typeface="Microsoft YaHei"/>
                         </a:rPr>
-                        <a:t>10.6</a:t>
+                        <a:t>11.9</a:t>
                       </a:r>
                     </a:p>
                   </a:txBody>
@@ -36501,7 +36943,7 @@
                           <a:ea typeface="Microsoft YaHei"/>
                           <a:cs typeface="Microsoft YaHei"/>
                         </a:rPr>
-                        <a:t>19.0%</a:t>
+                        <a:t>27.8%</a:t>
                       </a:r>
                     </a:p>
                   </a:txBody>
@@ -36556,7 +36998,7 @@
                           <a:ea typeface="Microsoft YaHei"/>
                           <a:cs typeface="Microsoft YaHei"/>
                         </a:rPr>
-                        <a:t>1.37 GB</a:t>
+                        <a:t>2.24 GB</a:t>
                       </a:r>
                     </a:p>
                   </a:txBody>
@@ -36611,7 +37053,7 @@
                           <a:ea typeface="Microsoft YaHei"/>
                           <a:cs typeface="Microsoft YaHei"/>
                         </a:rPr>
-                        <a:t>175.51 GB</a:t>
+                        <a:t>286.73 GB</a:t>
                       </a:r>
                     </a:p>
                   </a:txBody>
@@ -36666,7 +37108,7 @@
                           <a:ea typeface="Microsoft YaHei"/>
                           <a:cs typeface="Microsoft YaHei"/>
                         </a:rPr>
-                        <a:t>4.28 毫秒</a:t>
+                        <a:t>7.00 毫秒</a:t>
                       </a:r>
                     </a:p>
                   </a:txBody>
@@ -36722,6 +37164,448 @@
                           <a:cs typeface="Microsoft YaHei"/>
                         </a:rPr>
                         <a:t>注意力计算 8.58 毫秒</a:t>
+                      </a:r>
+                    </a:p>
+                  </a:txBody>
+                  <a:tcPr marL="54864" marR="54864" marT="27432" marB="18288" anchor="ctr">
+                    <a:solidFill>
+                      <a:srgbClr val="FFFFFF"/>
+                    </a:solidFill>
+                    <a:lnL w="6350">
+                      <a:solidFill>
+                        <a:srgbClr val="D6DCE2"/>
+                      </a:solidFill>
+                    </a:lnL>
+                    <a:lnR w="6350">
+                      <a:solidFill>
+                        <a:srgbClr val="D6DCE2"/>
+                      </a:solidFill>
+                    </a:lnR>
+                    <a:lnT w="6350">
+                      <a:solidFill>
+                        <a:srgbClr val="D6DCE2"/>
+                      </a:solidFill>
+                    </a:lnT>
+                    <a:lnB w="6350">
+                      <a:solidFill>
+                        <a:srgbClr val="D6DCE2"/>
+                      </a:solidFill>
+                    </a:lnB>
+                  </a:tcPr>
+                </a:tc>
+              </a:tr>
+              <a:tr h="384048">
+                <a:tc>
+                  <a:txBody>
+                    <a:bodyPr wrap="square"/>
+                    <a:lstStyle/>
+                    <a:p>
+                      <a:pPr algn="l">
+                        <a:spcBef>
+                          <a:spcPts val="0"/>
+                        </a:spcBef>
+                        <a:spcAft>
+                          <a:spcPts val="0"/>
+                        </a:spcAft>
+                        <a:lnSpc>
+                          <a:spcPct val="100000"/>
+                        </a:lnSpc>
+                      </a:pPr>
+                      <a:r>
+                        <a:rPr sz="1200" b="1">
+                          <a:solidFill>
+                            <a:srgbClr val="0E2A47"/>
+                          </a:solidFill>
+                          <a:latin typeface="Microsoft YaHei"/>
+                          <a:ea typeface="Microsoft YaHei"/>
+                          <a:cs typeface="Microsoft YaHei"/>
+                        </a:rPr>
+                        <a:t>0.33×10^6</a:t>
+                      </a:r>
+                    </a:p>
+                  </a:txBody>
+                  <a:tcPr marL="54864" marR="54864" marT="27432" marB="18288" anchor="ctr">
+                    <a:solidFill>
+                      <a:srgbClr val="F4F7FA"/>
+                    </a:solidFill>
+                    <a:lnL w="6350">
+                      <a:solidFill>
+                        <a:srgbClr val="D6DCE2"/>
+                      </a:solidFill>
+                    </a:lnL>
+                    <a:lnR w="6350">
+                      <a:solidFill>
+                        <a:srgbClr val="D6DCE2"/>
+                      </a:solidFill>
+                    </a:lnR>
+                    <a:lnT w="6350">
+                      <a:solidFill>
+                        <a:srgbClr val="D6DCE2"/>
+                      </a:solidFill>
+                    </a:lnT>
+                    <a:lnB w="6350">
+                      <a:solidFill>
+                        <a:srgbClr val="D6DCE2"/>
+                      </a:solidFill>
+                    </a:lnB>
+                  </a:tcPr>
+                </a:tc>
+                <a:tc>
+                  <a:txBody>
+                    <a:bodyPr wrap="square"/>
+                    <a:lstStyle/>
+                    <a:p>
+                      <a:pPr algn="l">
+                        <a:spcBef>
+                          <a:spcPts val="0"/>
+                        </a:spcBef>
+                        <a:spcAft>
+                          <a:spcPts val="0"/>
+                        </a:spcAft>
+                        <a:lnSpc>
+                          <a:spcPct val="100000"/>
+                        </a:lnSpc>
+                      </a:pPr>
+                      <a:r>
+                        <a:rPr sz="1200" b="0">
+                          <a:solidFill>
+                            <a:srgbClr val="1C242E"/>
+                          </a:solidFill>
+                          <a:latin typeface="Microsoft YaHei"/>
+                          <a:ea typeface="Microsoft YaHei"/>
+                          <a:cs typeface="Microsoft YaHei"/>
+                        </a:rPr>
+                        <a:t>4096</a:t>
+                      </a:r>
+                    </a:p>
+                  </a:txBody>
+                  <a:tcPr marL="54864" marR="54864" marT="27432" marB="18288" anchor="ctr">
+                    <a:solidFill>
+                      <a:srgbClr val="FFFFFF"/>
+                    </a:solidFill>
+                    <a:lnL w="6350">
+                      <a:solidFill>
+                        <a:srgbClr val="D6DCE2"/>
+                      </a:solidFill>
+                    </a:lnL>
+                    <a:lnR w="6350">
+                      <a:solidFill>
+                        <a:srgbClr val="D6DCE2"/>
+                      </a:solidFill>
+                    </a:lnR>
+                    <a:lnT w="6350">
+                      <a:solidFill>
+                        <a:srgbClr val="D6DCE2"/>
+                      </a:solidFill>
+                    </a:lnT>
+                    <a:lnB w="6350">
+                      <a:solidFill>
+                        <a:srgbClr val="D6DCE2"/>
+                      </a:solidFill>
+                    </a:lnB>
+                  </a:tcPr>
+                </a:tc>
+                <a:tc>
+                  <a:txBody>
+                    <a:bodyPr wrap="square"/>
+                    <a:lstStyle/>
+                    <a:p>
+                      <a:pPr algn="l">
+                        <a:spcBef>
+                          <a:spcPts val="0"/>
+                        </a:spcBef>
+                        <a:spcAft>
+                          <a:spcPts val="0"/>
+                        </a:spcAft>
+                        <a:lnSpc>
+                          <a:spcPct val="100000"/>
+                        </a:lnSpc>
+                      </a:pPr>
+                      <a:r>
+                        <a:rPr sz="1200" b="0">
+                          <a:solidFill>
+                            <a:srgbClr val="1C242E"/>
+                          </a:solidFill>
+                          <a:latin typeface="Microsoft YaHei"/>
+                          <a:ea typeface="Microsoft YaHei"/>
+                          <a:cs typeface="Microsoft YaHei"/>
+                        </a:rPr>
+                        <a:t>32.0</a:t>
+                      </a:r>
+                    </a:p>
+                  </a:txBody>
+                  <a:tcPr marL="54864" marR="54864" marT="27432" marB="18288" anchor="ctr">
+                    <a:solidFill>
+                      <a:srgbClr val="FFFFFF"/>
+                    </a:solidFill>
+                    <a:lnL w="6350">
+                      <a:solidFill>
+                        <a:srgbClr val="D6DCE2"/>
+                      </a:solidFill>
+                    </a:lnL>
+                    <a:lnR w="6350">
+                      <a:solidFill>
+                        <a:srgbClr val="D6DCE2"/>
+                      </a:solidFill>
+                    </a:lnR>
+                    <a:lnT w="6350">
+                      <a:solidFill>
+                        <a:srgbClr val="D6DCE2"/>
+                      </a:solidFill>
+                    </a:lnT>
+                    <a:lnB w="6350">
+                      <a:solidFill>
+                        <a:srgbClr val="D6DCE2"/>
+                      </a:solidFill>
+                    </a:lnB>
+                  </a:tcPr>
+                </a:tc>
+                <a:tc>
+                  <a:txBody>
+                    <a:bodyPr wrap="square"/>
+                    <a:lstStyle/>
+                    <a:p>
+                      <a:pPr algn="l">
+                        <a:spcBef>
+                          <a:spcPts val="0"/>
+                        </a:spcBef>
+                        <a:spcAft>
+                          <a:spcPts val="0"/>
+                        </a:spcAft>
+                        <a:lnSpc>
+                          <a:spcPct val="100000"/>
+                        </a:lnSpc>
+                      </a:pPr>
+                      <a:r>
+                        <a:rPr sz="1200" b="0">
+                          <a:solidFill>
+                            <a:srgbClr val="1C242E"/>
+                          </a:solidFill>
+                          <a:latin typeface="Microsoft YaHei"/>
+                          <a:ea typeface="Microsoft YaHei"/>
+                          <a:cs typeface="Microsoft YaHei"/>
+                        </a:rPr>
+                        <a:t>14.3%</a:t>
+                      </a:r>
+                    </a:p>
+                  </a:txBody>
+                  <a:tcPr marL="54864" marR="54864" marT="27432" marB="18288" anchor="ctr">
+                    <a:solidFill>
+                      <a:srgbClr val="FFFFFF"/>
+                    </a:solidFill>
+                    <a:lnL w="6350">
+                      <a:solidFill>
+                        <a:srgbClr val="D6DCE2"/>
+                      </a:solidFill>
+                    </a:lnL>
+                    <a:lnR w="6350">
+                      <a:solidFill>
+                        <a:srgbClr val="D6DCE2"/>
+                      </a:solidFill>
+                    </a:lnR>
+                    <a:lnT w="6350">
+                      <a:solidFill>
+                        <a:srgbClr val="D6DCE2"/>
+                      </a:solidFill>
+                    </a:lnT>
+                    <a:lnB w="6350">
+                      <a:solidFill>
+                        <a:srgbClr val="D6DCE2"/>
+                      </a:solidFill>
+                    </a:lnB>
+                  </a:tcPr>
+                </a:tc>
+                <a:tc>
+                  <a:txBody>
+                    <a:bodyPr wrap="square"/>
+                    <a:lstStyle/>
+                    <a:p>
+                      <a:pPr algn="l">
+                        <a:spcBef>
+                          <a:spcPts val="0"/>
+                        </a:spcBef>
+                        <a:spcAft>
+                          <a:spcPts val="0"/>
+                        </a:spcAft>
+                        <a:lnSpc>
+                          <a:spcPct val="100000"/>
+                        </a:lnSpc>
+                      </a:pPr>
+                      <a:r>
+                        <a:rPr sz="1200" b="0">
+                          <a:solidFill>
+                            <a:srgbClr val="1C242E"/>
+                          </a:solidFill>
+                          <a:latin typeface="Microsoft YaHei"/>
+                          <a:ea typeface="Microsoft YaHei"/>
+                          <a:cs typeface="Microsoft YaHei"/>
+                        </a:rPr>
+                        <a:t>1.04 GB</a:t>
+                      </a:r>
+                    </a:p>
+                  </a:txBody>
+                  <a:tcPr marL="54864" marR="54864" marT="27432" marB="18288" anchor="ctr">
+                    <a:solidFill>
+                      <a:srgbClr val="FFFFFF"/>
+                    </a:solidFill>
+                    <a:lnL w="6350">
+                      <a:solidFill>
+                        <a:srgbClr val="D6DCE2"/>
+                      </a:solidFill>
+                    </a:lnL>
+                    <a:lnR w="6350">
+                      <a:solidFill>
+                        <a:srgbClr val="D6DCE2"/>
+                      </a:solidFill>
+                    </a:lnR>
+                    <a:lnT w="6350">
+                      <a:solidFill>
+                        <a:srgbClr val="D6DCE2"/>
+                      </a:solidFill>
+                    </a:lnT>
+                    <a:lnB w="6350">
+                      <a:solidFill>
+                        <a:srgbClr val="D6DCE2"/>
+                      </a:solidFill>
+                    </a:lnB>
+                  </a:tcPr>
+                </a:tc>
+                <a:tc>
+                  <a:txBody>
+                    <a:bodyPr wrap="square"/>
+                    <a:lstStyle/>
+                    <a:p>
+                      <a:pPr algn="l">
+                        <a:spcBef>
+                          <a:spcPts val="0"/>
+                        </a:spcBef>
+                        <a:spcAft>
+                          <a:spcPts val="0"/>
+                        </a:spcAft>
+                        <a:lnSpc>
+                          <a:spcPct val="100000"/>
+                        </a:lnSpc>
+                      </a:pPr>
+                      <a:r>
+                        <a:rPr sz="1200" b="0">
+                          <a:solidFill>
+                            <a:srgbClr val="1C242E"/>
+                          </a:solidFill>
+                          <a:latin typeface="Microsoft YaHei"/>
+                          <a:ea typeface="Microsoft YaHei"/>
+                          <a:cs typeface="Microsoft YaHei"/>
+                        </a:rPr>
+                        <a:t>132.49 GB</a:t>
+                      </a:r>
+                    </a:p>
+                  </a:txBody>
+                  <a:tcPr marL="54864" marR="54864" marT="27432" marB="18288" anchor="ctr">
+                    <a:solidFill>
+                      <a:srgbClr val="FFFFFF"/>
+                    </a:solidFill>
+                    <a:lnL w="6350">
+                      <a:solidFill>
+                        <a:srgbClr val="D6DCE2"/>
+                      </a:solidFill>
+                    </a:lnL>
+                    <a:lnR w="6350">
+                      <a:solidFill>
+                        <a:srgbClr val="D6DCE2"/>
+                      </a:solidFill>
+                    </a:lnR>
+                    <a:lnT w="6350">
+                      <a:solidFill>
+                        <a:srgbClr val="D6DCE2"/>
+                      </a:solidFill>
+                    </a:lnT>
+                    <a:lnB w="6350">
+                      <a:solidFill>
+                        <a:srgbClr val="D6DCE2"/>
+                      </a:solidFill>
+                    </a:lnB>
+                  </a:tcPr>
+                </a:tc>
+                <a:tc>
+                  <a:txBody>
+                    <a:bodyPr wrap="square"/>
+                    <a:lstStyle/>
+                    <a:p>
+                      <a:pPr algn="l">
+                        <a:spcBef>
+                          <a:spcPts val="0"/>
+                        </a:spcBef>
+                        <a:spcAft>
+                          <a:spcPts val="0"/>
+                        </a:spcAft>
+                        <a:lnSpc>
+                          <a:spcPct val="100000"/>
+                        </a:lnSpc>
+                      </a:pPr>
+                      <a:r>
+                        <a:rPr sz="1200" b="0">
+                          <a:solidFill>
+                            <a:srgbClr val="1C242E"/>
+                          </a:solidFill>
+                          <a:latin typeface="Microsoft YaHei"/>
+                          <a:ea typeface="Microsoft YaHei"/>
+                          <a:cs typeface="Microsoft YaHei"/>
+                        </a:rPr>
+                        <a:t>3.23 毫秒</a:t>
+                      </a:r>
+                    </a:p>
+                  </a:txBody>
+                  <a:tcPr marL="54864" marR="54864" marT="27432" marB="18288" anchor="ctr">
+                    <a:solidFill>
+                      <a:srgbClr val="FFFFFF"/>
+                    </a:solidFill>
+                    <a:lnL w="6350">
+                      <a:solidFill>
+                        <a:srgbClr val="D6DCE2"/>
+                      </a:solidFill>
+                    </a:lnL>
+                    <a:lnR w="6350">
+                      <a:solidFill>
+                        <a:srgbClr val="D6DCE2"/>
+                      </a:solidFill>
+                    </a:lnR>
+                    <a:lnT w="6350">
+                      <a:solidFill>
+                        <a:srgbClr val="D6DCE2"/>
+                      </a:solidFill>
+                    </a:lnT>
+                    <a:lnB w="6350">
+                      <a:solidFill>
+                        <a:srgbClr val="D6DCE2"/>
+                      </a:solidFill>
+                    </a:lnB>
+                  </a:tcPr>
+                </a:tc>
+                <a:tc>
+                  <a:txBody>
+                    <a:bodyPr wrap="square"/>
+                    <a:lstStyle/>
+                    <a:p>
+                      <a:pPr algn="l">
+                        <a:spcBef>
+                          <a:spcPts val="0"/>
+                        </a:spcBef>
+                        <a:spcAft>
+                          <a:spcPts val="0"/>
+                        </a:spcAft>
+                        <a:lnSpc>
+                          <a:spcPct val="100000"/>
+                        </a:lnSpc>
+                      </a:pPr>
+                      <a:r>
+                        <a:rPr sz="1200" b="0">
+                          <a:solidFill>
+                            <a:srgbClr val="1C242E"/>
+                          </a:solidFill>
+                          <a:latin typeface="Microsoft YaHei"/>
+                          <a:ea typeface="Microsoft YaHei"/>
+                          <a:cs typeface="Microsoft YaHei"/>
+                        </a:rPr>
+                        <a:t>注意力计算 10.26 毫秒</a:t>
                       </a:r>
                     </a:p>
                   </a:txBody>
@@ -36808,7 +37692,7 @@
         </p:nvGraphicFramePr>
         <p:xfrm>
           <a:off x="384048" y="3712463"/>
-          <a:ext cx="11247120" cy="987552"/>
+          <a:ext cx="11247120" cy="1645920"/>
         </p:xfrm>
         <a:graphic>
           <a:graphicData uri="http://schemas.openxmlformats.org/drawingml/2006/table">
@@ -37236,7 +38120,7 @@
                           <a:ea typeface="Microsoft YaHei"/>
                           <a:cs typeface="Microsoft YaHei"/>
                         </a:rPr>
-                        <a:t>512K</a:t>
+                        <a:t>256K</a:t>
                       </a:r>
                     </a:p>
                   </a:txBody>
@@ -37291,7 +38175,7 @@
                           <a:ea typeface="Microsoft YaHei"/>
                           <a:cs typeface="Microsoft YaHei"/>
                         </a:rPr>
-                        <a:t>1.57 毫秒</a:t>
+                        <a:t>2.15 毫秒</a:t>
                       </a:r>
                     </a:p>
                   </a:txBody>
@@ -37346,7 +38230,7 @@
                           <a:ea typeface="Microsoft YaHei"/>
                           <a:cs typeface="Microsoft YaHei"/>
                         </a:rPr>
-                        <a:t>5.74 毫秒</a:t>
+                        <a:t>1.67 毫秒</a:t>
                       </a:r>
                     </a:p>
                   </a:txBody>
@@ -37401,7 +38285,7 @@
                           <a:ea typeface="Microsoft YaHei"/>
                           <a:cs typeface="Microsoft YaHei"/>
                         </a:rPr>
-                        <a:t>8.55 毫秒</a:t>
+                        <a:t>11.36 毫秒</a:t>
                       </a:r>
                     </a:p>
                   </a:txBody>
@@ -37456,7 +38340,7 @@
                           <a:ea typeface="Microsoft YaHei"/>
                           <a:cs typeface="Microsoft YaHei"/>
                         </a:rPr>
-                        <a:t>2.79 毫秒</a:t>
+                        <a:t>2.96 毫秒</a:t>
                       </a:r>
                     </a:p>
                   </a:txBody>
@@ -37623,6 +38507,393 @@
                           <a:ea typeface="Microsoft YaHei"/>
                           <a:cs typeface="Microsoft YaHei"/>
                         </a:rPr>
+                        <a:t>512K</a:t>
+                      </a:r>
+                    </a:p>
+                  </a:txBody>
+                  <a:tcPr marL="54864" marR="54864" marT="27432" marB="18288" anchor="ctr">
+                    <a:solidFill>
+                      <a:srgbClr val="F4F7FA"/>
+                    </a:solidFill>
+                    <a:lnL w="6350">
+                      <a:solidFill>
+                        <a:srgbClr val="D6DCE2"/>
+                      </a:solidFill>
+                    </a:lnL>
+                    <a:lnR w="6350">
+                      <a:solidFill>
+                        <a:srgbClr val="D6DCE2"/>
+                      </a:solidFill>
+                    </a:lnR>
+                    <a:lnT w="6350">
+                      <a:solidFill>
+                        <a:srgbClr val="D6DCE2"/>
+                      </a:solidFill>
+                    </a:lnT>
+                    <a:lnB w="6350">
+                      <a:solidFill>
+                        <a:srgbClr val="D6DCE2"/>
+                      </a:solidFill>
+                    </a:lnB>
+                  </a:tcPr>
+                </a:tc>
+                <a:tc>
+                  <a:txBody>
+                    <a:bodyPr wrap="square"/>
+                    <a:lstStyle/>
+                    <a:p>
+                      <a:pPr algn="l">
+                        <a:spcBef>
+                          <a:spcPts val="0"/>
+                        </a:spcBef>
+                        <a:spcAft>
+                          <a:spcPts val="0"/>
+                        </a:spcAft>
+                        <a:lnSpc>
+                          <a:spcPct val="100000"/>
+                        </a:lnSpc>
+                      </a:pPr>
+                      <a:r>
+                        <a:rPr sz="1200" b="0">
+                          <a:solidFill>
+                            <a:srgbClr val="1C242E"/>
+                          </a:solidFill>
+                          <a:latin typeface="Microsoft YaHei"/>
+                          <a:ea typeface="Microsoft YaHei"/>
+                          <a:cs typeface="Microsoft YaHei"/>
+                        </a:rPr>
+                        <a:t>5.18 毫秒</a:t>
+                      </a:r>
+                    </a:p>
+                  </a:txBody>
+                  <a:tcPr marL="54864" marR="54864" marT="27432" marB="18288" anchor="ctr">
+                    <a:solidFill>
+                      <a:srgbClr val="FFFFFF"/>
+                    </a:solidFill>
+                    <a:lnL w="6350">
+                      <a:solidFill>
+                        <a:srgbClr val="D6DCE2"/>
+                      </a:solidFill>
+                    </a:lnL>
+                    <a:lnR w="6350">
+                      <a:solidFill>
+                        <a:srgbClr val="D6DCE2"/>
+                      </a:solidFill>
+                    </a:lnR>
+                    <a:lnT w="6350">
+                      <a:solidFill>
+                        <a:srgbClr val="D6DCE2"/>
+                      </a:solidFill>
+                    </a:lnT>
+                    <a:lnB w="6350">
+                      <a:solidFill>
+                        <a:srgbClr val="D6DCE2"/>
+                      </a:solidFill>
+                    </a:lnB>
+                  </a:tcPr>
+                </a:tc>
+                <a:tc>
+                  <a:txBody>
+                    <a:bodyPr wrap="square"/>
+                    <a:lstStyle/>
+                    <a:p>
+                      <a:pPr algn="l">
+                        <a:spcBef>
+                          <a:spcPts val="0"/>
+                        </a:spcBef>
+                        <a:spcAft>
+                          <a:spcPts val="0"/>
+                        </a:spcAft>
+                        <a:lnSpc>
+                          <a:spcPct val="100000"/>
+                        </a:lnSpc>
+                      </a:pPr>
+                      <a:r>
+                        <a:rPr sz="1200" b="0">
+                          <a:solidFill>
+                            <a:srgbClr val="1C242E"/>
+                          </a:solidFill>
+                          <a:latin typeface="Microsoft YaHei"/>
+                          <a:ea typeface="Microsoft YaHei"/>
+                          <a:cs typeface="Microsoft YaHei"/>
+                        </a:rPr>
+                        <a:t>0.96 毫秒</a:t>
+                      </a:r>
+                    </a:p>
+                  </a:txBody>
+                  <a:tcPr marL="54864" marR="54864" marT="27432" marB="18288" anchor="ctr">
+                    <a:solidFill>
+                      <a:srgbClr val="FFFFFF"/>
+                    </a:solidFill>
+                    <a:lnL w="6350">
+                      <a:solidFill>
+                        <a:srgbClr val="D6DCE2"/>
+                      </a:solidFill>
+                    </a:lnL>
+                    <a:lnR w="6350">
+                      <a:solidFill>
+                        <a:srgbClr val="D6DCE2"/>
+                      </a:solidFill>
+                    </a:lnR>
+                    <a:lnT w="6350">
+                      <a:solidFill>
+                        <a:srgbClr val="D6DCE2"/>
+                      </a:solidFill>
+                    </a:lnT>
+                    <a:lnB w="6350">
+                      <a:solidFill>
+                        <a:srgbClr val="D6DCE2"/>
+                      </a:solidFill>
+                    </a:lnB>
+                  </a:tcPr>
+                </a:tc>
+                <a:tc>
+                  <a:txBody>
+                    <a:bodyPr wrap="square"/>
+                    <a:lstStyle/>
+                    <a:p>
+                      <a:pPr algn="l">
+                        <a:spcBef>
+                          <a:spcPts val="0"/>
+                        </a:spcBef>
+                        <a:spcAft>
+                          <a:spcPts val="0"/>
+                        </a:spcAft>
+                        <a:lnSpc>
+                          <a:spcPct val="100000"/>
+                        </a:lnSpc>
+                      </a:pPr>
+                      <a:r>
+                        <a:rPr sz="1200" b="0">
+                          <a:solidFill>
+                            <a:srgbClr val="1C242E"/>
+                          </a:solidFill>
+                          <a:latin typeface="Microsoft YaHei"/>
+                          <a:ea typeface="Microsoft YaHei"/>
+                          <a:cs typeface="Microsoft YaHei"/>
+                        </a:rPr>
+                        <a:t>9.41 毫秒</a:t>
+                      </a:r>
+                    </a:p>
+                  </a:txBody>
+                  <a:tcPr marL="54864" marR="54864" marT="27432" marB="18288" anchor="ctr">
+                    <a:solidFill>
+                      <a:srgbClr val="FFFFFF"/>
+                    </a:solidFill>
+                    <a:lnL w="6350">
+                      <a:solidFill>
+                        <a:srgbClr val="D6DCE2"/>
+                      </a:solidFill>
+                    </a:lnL>
+                    <a:lnR w="6350">
+                      <a:solidFill>
+                        <a:srgbClr val="D6DCE2"/>
+                      </a:solidFill>
+                    </a:lnR>
+                    <a:lnT w="6350">
+                      <a:solidFill>
+                        <a:srgbClr val="D6DCE2"/>
+                      </a:solidFill>
+                    </a:lnT>
+                    <a:lnB w="6350">
+                      <a:solidFill>
+                        <a:srgbClr val="D6DCE2"/>
+                      </a:solidFill>
+                    </a:lnB>
+                  </a:tcPr>
+                </a:tc>
+                <a:tc>
+                  <a:txBody>
+                    <a:bodyPr wrap="square"/>
+                    <a:lstStyle/>
+                    <a:p>
+                      <a:pPr algn="l">
+                        <a:spcBef>
+                          <a:spcPts val="0"/>
+                        </a:spcBef>
+                        <a:spcAft>
+                          <a:spcPts val="0"/>
+                        </a:spcAft>
+                        <a:lnSpc>
+                          <a:spcPct val="100000"/>
+                        </a:lnSpc>
+                      </a:pPr>
+                      <a:r>
+                        <a:rPr sz="1200" b="0">
+                          <a:solidFill>
+                            <a:srgbClr val="1C242E"/>
+                          </a:solidFill>
+                          <a:latin typeface="Microsoft YaHei"/>
+                          <a:ea typeface="Microsoft YaHei"/>
+                          <a:cs typeface="Microsoft YaHei"/>
+                        </a:rPr>
+                        <a:t>3.14 毫秒</a:t>
+                      </a:r>
+                    </a:p>
+                  </a:txBody>
+                  <a:tcPr marL="54864" marR="54864" marT="27432" marB="18288" anchor="ctr">
+                    <a:solidFill>
+                      <a:srgbClr val="FFFFFF"/>
+                    </a:solidFill>
+                    <a:lnL w="6350">
+                      <a:solidFill>
+                        <a:srgbClr val="D6DCE2"/>
+                      </a:solidFill>
+                    </a:lnL>
+                    <a:lnR w="6350">
+                      <a:solidFill>
+                        <a:srgbClr val="D6DCE2"/>
+                      </a:solidFill>
+                    </a:lnR>
+                    <a:lnT w="6350">
+                      <a:solidFill>
+                        <a:srgbClr val="D6DCE2"/>
+                      </a:solidFill>
+                    </a:lnT>
+                    <a:lnB w="6350">
+                      <a:solidFill>
+                        <a:srgbClr val="D6DCE2"/>
+                      </a:solidFill>
+                    </a:lnB>
+                  </a:tcPr>
+                </a:tc>
+                <a:tc>
+                  <a:txBody>
+                    <a:bodyPr wrap="square"/>
+                    <a:lstStyle/>
+                    <a:p>
+                      <a:pPr algn="l">
+                        <a:spcBef>
+                          <a:spcPts val="0"/>
+                        </a:spcBef>
+                        <a:spcAft>
+                          <a:spcPts val="0"/>
+                        </a:spcAft>
+                        <a:lnSpc>
+                          <a:spcPct val="100000"/>
+                        </a:lnSpc>
+                      </a:pPr>
+                      <a:r>
+                        <a:rPr sz="1200" b="0">
+                          <a:solidFill>
+                            <a:srgbClr val="1C242E"/>
+                          </a:solidFill>
+                          <a:latin typeface="Microsoft YaHei"/>
+                          <a:ea typeface="Microsoft YaHei"/>
+                          <a:cs typeface="Microsoft YaHei"/>
+                        </a:rPr>
+                        <a:t>13.40 毫秒</a:t>
+                      </a:r>
+                    </a:p>
+                  </a:txBody>
+                  <a:tcPr marL="54864" marR="54864" marT="27432" marB="18288" anchor="ctr">
+                    <a:solidFill>
+                      <a:srgbClr val="FFFFFF"/>
+                    </a:solidFill>
+                    <a:lnL w="6350">
+                      <a:solidFill>
+                        <a:srgbClr val="D6DCE2"/>
+                      </a:solidFill>
+                    </a:lnL>
+                    <a:lnR w="6350">
+                      <a:solidFill>
+                        <a:srgbClr val="D6DCE2"/>
+                      </a:solidFill>
+                    </a:lnR>
+                    <a:lnT w="6350">
+                      <a:solidFill>
+                        <a:srgbClr val="D6DCE2"/>
+                      </a:solidFill>
+                    </a:lnT>
+                    <a:lnB w="6350">
+                      <a:solidFill>
+                        <a:srgbClr val="D6DCE2"/>
+                      </a:solidFill>
+                    </a:lnB>
+                  </a:tcPr>
+                </a:tc>
+                <a:tc>
+                  <a:txBody>
+                    <a:bodyPr wrap="square"/>
+                    <a:lstStyle/>
+                    <a:p>
+                      <a:pPr algn="l">
+                        <a:spcBef>
+                          <a:spcPts val="0"/>
+                        </a:spcBef>
+                        <a:spcAft>
+                          <a:spcPts val="0"/>
+                        </a:spcAft>
+                        <a:lnSpc>
+                          <a:spcPct val="100000"/>
+                        </a:lnSpc>
+                      </a:pPr>
+                      <a:r>
+                        <a:rPr sz="1200" b="0">
+                          <a:solidFill>
+                            <a:srgbClr val="1C242E"/>
+                          </a:solidFill>
+                          <a:latin typeface="Microsoft YaHei"/>
+                          <a:ea typeface="Microsoft YaHei"/>
+                          <a:cs typeface="Microsoft YaHei"/>
+                        </a:rPr>
+                        <a:t>29.80 毫秒</a:t>
+                      </a:r>
+                    </a:p>
+                  </a:txBody>
+                  <a:tcPr marL="54864" marR="54864" marT="27432" marB="18288" anchor="ctr">
+                    <a:solidFill>
+                      <a:srgbClr val="FFFFFF"/>
+                    </a:solidFill>
+                    <a:lnL w="6350">
+                      <a:solidFill>
+                        <a:srgbClr val="D6DCE2"/>
+                      </a:solidFill>
+                    </a:lnL>
+                    <a:lnR w="6350">
+                      <a:solidFill>
+                        <a:srgbClr val="D6DCE2"/>
+                      </a:solidFill>
+                    </a:lnR>
+                    <a:lnT w="6350">
+                      <a:solidFill>
+                        <a:srgbClr val="D6DCE2"/>
+                      </a:solidFill>
+                    </a:lnT>
+                    <a:lnB w="6350">
+                      <a:solidFill>
+                        <a:srgbClr val="D6DCE2"/>
+                      </a:solidFill>
+                    </a:lnB>
+                  </a:tcPr>
+                </a:tc>
+              </a:tr>
+              <a:tr h="329184">
+                <a:tc>
+                  <a:txBody>
+                    <a:bodyPr wrap="square"/>
+                    <a:lstStyle/>
+                    <a:p>
+                      <a:pPr algn="l">
+                        <a:spcBef>
+                          <a:spcPts val="0"/>
+                        </a:spcBef>
+                        <a:spcAft>
+                          <a:spcPts val="0"/>
+                        </a:spcAft>
+                        <a:lnSpc>
+                          <a:spcPct val="100000"/>
+                        </a:lnSpc>
+                      </a:pPr>
+                      <a:r>
+                        <a:rPr sz="1200" b="1">
+                          <a:solidFill>
+                            <a:srgbClr val="0E2A47"/>
+                          </a:solidFill>
+                          <a:latin typeface="Microsoft YaHei"/>
+                          <a:ea typeface="Microsoft YaHei"/>
+                          <a:cs typeface="Microsoft YaHei"/>
+                        </a:rPr>
                         <a:t>1M</a:t>
                       </a:r>
                     </a:p>
@@ -37678,7 +38949,7 @@
                           <a:ea typeface="Microsoft YaHei"/>
                           <a:cs typeface="Microsoft YaHei"/>
                         </a:rPr>
-                        <a:t>4.28 毫秒</a:t>
+                        <a:t>7.00 毫秒</a:t>
                       </a:r>
                     </a:p>
                   </a:txBody>
@@ -37733,7 +39004,7 @@
                           <a:ea typeface="Microsoft YaHei"/>
                           <a:cs typeface="Microsoft YaHei"/>
                         </a:rPr>
-                        <a:t>3.29 毫秒</a:t>
+                        <a:t>0.52 毫秒</a:t>
                       </a:r>
                     </a:p>
                   </a:txBody>
@@ -37843,7 +39114,7 @@
                           <a:ea typeface="Microsoft YaHei"/>
                           <a:cs typeface="Microsoft YaHei"/>
                         </a:rPr>
-                        <a:t>3.01 毫秒</a:t>
+                        <a:t>3.28 毫秒</a:t>
                       </a:r>
                     </a:p>
                   </a:txBody>
@@ -37954,6 +39225,393 @@
                           <a:cs typeface="Microsoft YaHei"/>
                         </a:rPr>
                         <a:t>29.99 毫秒</a:t>
+                      </a:r>
+                    </a:p>
+                  </a:txBody>
+                  <a:tcPr marL="54864" marR="54864" marT="27432" marB="18288" anchor="ctr">
+                    <a:solidFill>
+                      <a:srgbClr val="FFFFFF"/>
+                    </a:solidFill>
+                    <a:lnL w="6350">
+                      <a:solidFill>
+                        <a:srgbClr val="D6DCE2"/>
+                      </a:solidFill>
+                    </a:lnL>
+                    <a:lnR w="6350">
+                      <a:solidFill>
+                        <a:srgbClr val="D6DCE2"/>
+                      </a:solidFill>
+                    </a:lnR>
+                    <a:lnT w="6350">
+                      <a:solidFill>
+                        <a:srgbClr val="D6DCE2"/>
+                      </a:solidFill>
+                    </a:lnT>
+                    <a:lnB w="6350">
+                      <a:solidFill>
+                        <a:srgbClr val="D6DCE2"/>
+                      </a:solidFill>
+                    </a:lnB>
+                  </a:tcPr>
+                </a:tc>
+              </a:tr>
+              <a:tr h="329184">
+                <a:tc>
+                  <a:txBody>
+                    <a:bodyPr wrap="square"/>
+                    <a:lstStyle/>
+                    <a:p>
+                      <a:pPr algn="l">
+                        <a:spcBef>
+                          <a:spcPts val="0"/>
+                        </a:spcBef>
+                        <a:spcAft>
+                          <a:spcPts val="0"/>
+                        </a:spcAft>
+                        <a:lnSpc>
+                          <a:spcPct val="100000"/>
+                        </a:lnSpc>
+                      </a:pPr>
+                      <a:r>
+                        <a:rPr sz="1200" b="1">
+                          <a:solidFill>
+                            <a:srgbClr val="0E2A47"/>
+                          </a:solidFill>
+                          <a:latin typeface="Microsoft YaHei"/>
+                          <a:ea typeface="Microsoft YaHei"/>
+                          <a:cs typeface="Microsoft YaHei"/>
+                        </a:rPr>
+                        <a:t>0.33×10^6</a:t>
+                      </a:r>
+                    </a:p>
+                  </a:txBody>
+                  <a:tcPr marL="54864" marR="54864" marT="27432" marB="18288" anchor="ctr">
+                    <a:solidFill>
+                      <a:srgbClr val="F4F7FA"/>
+                    </a:solidFill>
+                    <a:lnL w="6350">
+                      <a:solidFill>
+                        <a:srgbClr val="D6DCE2"/>
+                      </a:solidFill>
+                    </a:lnL>
+                    <a:lnR w="6350">
+                      <a:solidFill>
+                        <a:srgbClr val="D6DCE2"/>
+                      </a:solidFill>
+                    </a:lnR>
+                    <a:lnT w="6350">
+                      <a:solidFill>
+                        <a:srgbClr val="D6DCE2"/>
+                      </a:solidFill>
+                    </a:lnT>
+                    <a:lnB w="6350">
+                      <a:solidFill>
+                        <a:srgbClr val="D6DCE2"/>
+                      </a:solidFill>
+                    </a:lnB>
+                  </a:tcPr>
+                </a:tc>
+                <a:tc>
+                  <a:txBody>
+                    <a:bodyPr wrap="square"/>
+                    <a:lstStyle/>
+                    <a:p>
+                      <a:pPr algn="l">
+                        <a:spcBef>
+                          <a:spcPts val="0"/>
+                        </a:spcBef>
+                        <a:spcAft>
+                          <a:spcPts val="0"/>
+                        </a:spcAft>
+                        <a:lnSpc>
+                          <a:spcPct val="100000"/>
+                        </a:lnSpc>
+                      </a:pPr>
+                      <a:r>
+                        <a:rPr sz="1200" b="0">
+                          <a:solidFill>
+                            <a:srgbClr val="1C242E"/>
+                          </a:solidFill>
+                          <a:latin typeface="Microsoft YaHei"/>
+                          <a:ea typeface="Microsoft YaHei"/>
+                          <a:cs typeface="Microsoft YaHei"/>
+                        </a:rPr>
+                        <a:t>3.23 毫秒</a:t>
+                      </a:r>
+                    </a:p>
+                  </a:txBody>
+                  <a:tcPr marL="54864" marR="54864" marT="27432" marB="18288" anchor="ctr">
+                    <a:solidFill>
+                      <a:srgbClr val="FFFFFF"/>
+                    </a:solidFill>
+                    <a:lnL w="6350">
+                      <a:solidFill>
+                        <a:srgbClr val="D6DCE2"/>
+                      </a:solidFill>
+                    </a:lnL>
+                    <a:lnR w="6350">
+                      <a:solidFill>
+                        <a:srgbClr val="D6DCE2"/>
+                      </a:solidFill>
+                    </a:lnR>
+                    <a:lnT w="6350">
+                      <a:solidFill>
+                        <a:srgbClr val="D6DCE2"/>
+                      </a:solidFill>
+                    </a:lnT>
+                    <a:lnB w="6350">
+                      <a:solidFill>
+                        <a:srgbClr val="D6DCE2"/>
+                      </a:solidFill>
+                    </a:lnB>
+                  </a:tcPr>
+                </a:tc>
+                <a:tc>
+                  <a:txBody>
+                    <a:bodyPr wrap="square"/>
+                    <a:lstStyle/>
+                    <a:p>
+                      <a:pPr algn="l">
+                        <a:spcBef>
+                          <a:spcPts val="0"/>
+                        </a:spcBef>
+                        <a:spcAft>
+                          <a:spcPts val="0"/>
+                        </a:spcAft>
+                        <a:lnSpc>
+                          <a:spcPct val="100000"/>
+                        </a:lnSpc>
+                      </a:pPr>
+                      <a:r>
+                        <a:rPr sz="1200" b="0">
+                          <a:solidFill>
+                            <a:srgbClr val="1C242E"/>
+                          </a:solidFill>
+                          <a:latin typeface="Microsoft YaHei"/>
+                          <a:ea typeface="Microsoft YaHei"/>
+                          <a:cs typeface="Microsoft YaHei"/>
+                        </a:rPr>
+                        <a:t>1.40 毫秒</a:t>
+                      </a:r>
+                    </a:p>
+                  </a:txBody>
+                  <a:tcPr marL="54864" marR="54864" marT="27432" marB="18288" anchor="ctr">
+                    <a:solidFill>
+                      <a:srgbClr val="FFFFFF"/>
+                    </a:solidFill>
+                    <a:lnL w="6350">
+                      <a:solidFill>
+                        <a:srgbClr val="D6DCE2"/>
+                      </a:solidFill>
+                    </a:lnL>
+                    <a:lnR w="6350">
+                      <a:solidFill>
+                        <a:srgbClr val="D6DCE2"/>
+                      </a:solidFill>
+                    </a:lnR>
+                    <a:lnT w="6350">
+                      <a:solidFill>
+                        <a:srgbClr val="D6DCE2"/>
+                      </a:solidFill>
+                    </a:lnT>
+                    <a:lnB w="6350">
+                      <a:solidFill>
+                        <a:srgbClr val="D6DCE2"/>
+                      </a:solidFill>
+                    </a:lnB>
+                  </a:tcPr>
+                </a:tc>
+                <a:tc>
+                  <a:txBody>
+                    <a:bodyPr wrap="square"/>
+                    <a:lstStyle/>
+                    <a:p>
+                      <a:pPr algn="l">
+                        <a:spcBef>
+                          <a:spcPts val="0"/>
+                        </a:spcBef>
+                        <a:spcAft>
+                          <a:spcPts val="0"/>
+                        </a:spcAft>
+                        <a:lnSpc>
+                          <a:spcPct val="100000"/>
+                        </a:lnSpc>
+                      </a:pPr>
+                      <a:r>
+                        <a:rPr sz="1200" b="0">
+                          <a:solidFill>
+                            <a:srgbClr val="1C242E"/>
+                          </a:solidFill>
+                          <a:latin typeface="Microsoft YaHei"/>
+                          <a:ea typeface="Microsoft YaHei"/>
+                          <a:cs typeface="Microsoft YaHei"/>
+                        </a:rPr>
+                        <a:t>10.26 毫秒</a:t>
+                      </a:r>
+                    </a:p>
+                  </a:txBody>
+                  <a:tcPr marL="54864" marR="54864" marT="27432" marB="18288" anchor="ctr">
+                    <a:solidFill>
+                      <a:srgbClr val="FFFFFF"/>
+                    </a:solidFill>
+                    <a:lnL w="6350">
+                      <a:solidFill>
+                        <a:srgbClr val="D6DCE2"/>
+                      </a:solidFill>
+                    </a:lnL>
+                    <a:lnR w="6350">
+                      <a:solidFill>
+                        <a:srgbClr val="D6DCE2"/>
+                      </a:solidFill>
+                    </a:lnR>
+                    <a:lnT w="6350">
+                      <a:solidFill>
+                        <a:srgbClr val="D6DCE2"/>
+                      </a:solidFill>
+                    </a:lnT>
+                    <a:lnB w="6350">
+                      <a:solidFill>
+                        <a:srgbClr val="D6DCE2"/>
+                      </a:solidFill>
+                    </a:lnB>
+                  </a:tcPr>
+                </a:tc>
+                <a:tc>
+                  <a:txBody>
+                    <a:bodyPr wrap="square"/>
+                    <a:lstStyle/>
+                    <a:p>
+                      <a:pPr algn="l">
+                        <a:spcBef>
+                          <a:spcPts val="0"/>
+                        </a:spcBef>
+                        <a:spcAft>
+                          <a:spcPts val="0"/>
+                        </a:spcAft>
+                        <a:lnSpc>
+                          <a:spcPct val="100000"/>
+                        </a:lnSpc>
+                      </a:pPr>
+                      <a:r>
+                        <a:rPr sz="1200" b="0">
+                          <a:solidFill>
+                            <a:srgbClr val="1C242E"/>
+                          </a:solidFill>
+                          <a:latin typeface="Microsoft YaHei"/>
+                          <a:ea typeface="Microsoft YaHei"/>
+                          <a:cs typeface="Microsoft YaHei"/>
+                        </a:rPr>
+                        <a:t>3.02 毫秒</a:t>
+                      </a:r>
+                    </a:p>
+                  </a:txBody>
+                  <a:tcPr marL="54864" marR="54864" marT="27432" marB="18288" anchor="ctr">
+                    <a:solidFill>
+                      <a:srgbClr val="FFFFFF"/>
+                    </a:solidFill>
+                    <a:lnL w="6350">
+                      <a:solidFill>
+                        <a:srgbClr val="D6DCE2"/>
+                      </a:solidFill>
+                    </a:lnL>
+                    <a:lnR w="6350">
+                      <a:solidFill>
+                        <a:srgbClr val="D6DCE2"/>
+                      </a:solidFill>
+                    </a:lnR>
+                    <a:lnT w="6350">
+                      <a:solidFill>
+                        <a:srgbClr val="D6DCE2"/>
+                      </a:solidFill>
+                    </a:lnT>
+                    <a:lnB w="6350">
+                      <a:solidFill>
+                        <a:srgbClr val="D6DCE2"/>
+                      </a:solidFill>
+                    </a:lnB>
+                  </a:tcPr>
+                </a:tc>
+                <a:tc>
+                  <a:txBody>
+                    <a:bodyPr wrap="square"/>
+                    <a:lstStyle/>
+                    <a:p>
+                      <a:pPr algn="l">
+                        <a:spcBef>
+                          <a:spcPts val="0"/>
+                        </a:spcBef>
+                        <a:spcAft>
+                          <a:spcPts val="0"/>
+                        </a:spcAft>
+                        <a:lnSpc>
+                          <a:spcPct val="100000"/>
+                        </a:lnSpc>
+                      </a:pPr>
+                      <a:r>
+                        <a:rPr sz="1200" b="0">
+                          <a:solidFill>
+                            <a:srgbClr val="1C242E"/>
+                          </a:solidFill>
+                          <a:latin typeface="Microsoft YaHei"/>
+                          <a:ea typeface="Microsoft YaHei"/>
+                          <a:cs typeface="Microsoft YaHei"/>
+                        </a:rPr>
+                        <a:t>13.40 毫秒</a:t>
+                      </a:r>
+                    </a:p>
+                  </a:txBody>
+                  <a:tcPr marL="54864" marR="54864" marT="27432" marB="18288" anchor="ctr">
+                    <a:solidFill>
+                      <a:srgbClr val="FFFFFF"/>
+                    </a:solidFill>
+                    <a:lnL w="6350">
+                      <a:solidFill>
+                        <a:srgbClr val="D6DCE2"/>
+                      </a:solidFill>
+                    </a:lnL>
+                    <a:lnR w="6350">
+                      <a:solidFill>
+                        <a:srgbClr val="D6DCE2"/>
+                      </a:solidFill>
+                    </a:lnR>
+                    <a:lnT w="6350">
+                      <a:solidFill>
+                        <a:srgbClr val="D6DCE2"/>
+                      </a:solidFill>
+                    </a:lnT>
+                    <a:lnB w="6350">
+                      <a:solidFill>
+                        <a:srgbClr val="D6DCE2"/>
+                      </a:solidFill>
+                    </a:lnB>
+                  </a:tcPr>
+                </a:tc>
+                <a:tc>
+                  <a:txBody>
+                    <a:bodyPr wrap="square"/>
+                    <a:lstStyle/>
+                    <a:p>
+                      <a:pPr algn="l">
+                        <a:spcBef>
+                          <a:spcPts val="0"/>
+                        </a:spcBef>
+                        <a:spcAft>
+                          <a:spcPts val="0"/>
+                        </a:spcAft>
+                        <a:lnSpc>
+                          <a:spcPct val="100000"/>
+                        </a:lnSpc>
+                      </a:pPr>
+                      <a:r>
+                        <a:rPr sz="1200" b="0">
+                          <a:solidFill>
+                            <a:srgbClr val="1C242E"/>
+                          </a:solidFill>
+                          <a:latin typeface="Microsoft YaHei"/>
+                          <a:ea typeface="Microsoft YaHei"/>
+                          <a:cs typeface="Microsoft YaHei"/>
+                        </a:rPr>
+                        <a:t>29.50 毫秒</a:t>
                       </a:r>
                     </a:p>
                   </a:txBody>
@@ -38089,7 +39747,7 @@
                 <a:ea typeface="Microsoft YaHei"/>
                 <a:cs typeface="Microsoft YaHei"/>
               </a:rPr>
-              <a:t>10 毫秒到 0.25×10^6 仍全在 HBM，128K 也全在 HBM。这两页只保留溢出大于 0 的长度，后面的分析沿用这个口径。</a:t>
+              <a:t>10 毫秒到 0.33×10^6 仍全在 HBM，128K 也全在 HBM。这两页只保留溢出大于 0 的长度，后面的分析沿用这个口径。</a:t>
             </a:r>
           </a:p>
         </p:txBody>

</xml_diff>

<commit_message>
docs: fix recalculated slide labels and ordering
Co-authored-by: 69515164-rgb <69515164-rgb@users.noreply.github.com>
</commit_message>
<xml_diff>
--- a/docs/deepseek-96g-slo.pptx
+++ b/docs/deepseek-96g-slo.pptx
@@ -2180,7 +2180,7 @@
           <a:lstStyle/>
           <a:p>
             <a:r>
-              <a:t>第 7、8 页只统计 decode KV 溢出到 DDR 池的输入长度。全在 HBM 的长度留在第 6 页，不在这里记 0。256K BS=4880 pool=689.1 MB t=2.153 ms ar=1.667 ca=11.360 step=30.000。0.33×10^6 BS=4096 pool=1035.1 MB t=3.235 ms step=29.499。10 毫秒曲线在本档没有溢出长度。</a:t>
+              <a:t>第 7、8 页只统计 decode KV 溢出到 DDR 池的输入长度。全在 HBM 的长度留在第 6 页，不在这里记 0。256K BS=4880 pool=689.1 MB t=2.153 ms ar=1.667 ca=11.360 step=30.000。1M BS=1528 pool=2240.1 MB t=7.000 ms step=29.991。10 毫秒曲线在本档没有溢出长度。</a:t>
             </a:r>
           </a:p>
         </p:txBody>
@@ -2250,7 +2250,7 @@
           <a:lstStyle/>
           <a:p>
             <a:r>
-              <a:t>池上字节 = spill × bs × n_csa_read(S) / 128。带宽 320 GB/s。n_csa_read = 30×(S/4)×64 + 31×(S/128)×576 + 30×min(1024,S/4)×576 + 61×128×576。256K bs=4880 spill=9.79% pool=689.1MB t=2.153ms step=30.000ms 512K bs=2816 spill=21.70% pool=1656.6MB t=5.177ms step=29.797ms 1M bs=1528 spill=27.79% pool=2240.1MB t=7.000ms step=29.991ms 0.33×10^6 bs=4096 spill=14.31% pool=1035.1MB t=3.235ms step=29.499ms 口径已固化：第 7、8 页不收录换入为 0 的输入长度。</a:t>
+              <a:t>池上字节 = spill × bs × n_csa_read(S) / 128。带宽 320 GB/s。n_csa_read = 30×(S/4)×64 + 31×(S/128)×576 + 30×min(1024,S/4)×576 + 61×128×576。256K bs=4880 spill=9.79% pool=689.1MB t=2.153ms step=30.000ms 0.33×10^6 bs=4096 spill=14.31% pool=1035.1MB t=3.235ms step=29.499ms 512K bs=2816 spill=21.70% pool=1656.6MB t=5.177ms step=29.797ms 1M bs=1528 spill=27.79% pool=2240.1MB t=7.000ms step=29.991ms 口径已固化：第 7、8 页不收录换入为 0 的输入长度。</a:t>
             </a:r>
           </a:p>
         </p:txBody>
@@ -16597,7 +16597,7 @@
                           <a:ea typeface="Microsoft YaHei"/>
                           <a:cs typeface="Microsoft YaHei"/>
                         </a:rPr>
-                        <a:t>Attention 9.60 秒 + MoE 0.40 秒；P→D 尾巴为 0</a:t>
+                        <a:t>Attention 9.48 秒 + MoE 0.52 秒；P→D 尾巴为 0</a:t>
                       </a:r>
                     </a:p>
                   </a:txBody>
@@ -33004,7 +33004,7 @@
                 <a:ea typeface="Microsoft YaHei"/>
                 <a:cs typeface="Microsoft YaHei"/>
               </a:rPr>
-              <a:t>256K 每卡换入 689.1 MB，0.33×10^6 换入 1.04 GB</a:t>
+              <a:t>256K 每卡换入 689.1 MB，1M 换入 2.24 GB</a:t>
             </a:r>
           </a:p>
         </p:txBody>
@@ -33378,7 +33378,7 @@
                           <a:ea typeface="Microsoft YaHei"/>
                           <a:cs typeface="Microsoft YaHei"/>
                         </a:rPr>
-                        <a:t>0.33×10^6 · 批 4096 · 溢出 14.3%</a:t>
+                        <a:t>1M · 批 1528 · 溢出 27.8%</a:t>
                       </a:r>
                     </a:p>
                   </a:txBody>
@@ -33712,7 +33712,7 @@
                           <a:ea typeface="Microsoft YaHei"/>
                           <a:cs typeface="Microsoft YaHei"/>
                         </a:rPr>
-                        <a:t>391.8 MB · 1.40 毫秒</a:t>
+                        <a:t>146.9 MB · 0.52 毫秒</a:t>
                       </a:r>
                     </a:p>
                   </a:txBody>
@@ -33879,7 +33879,7 @@
                           <a:ea typeface="Microsoft YaHei"/>
                           <a:cs typeface="Microsoft YaHei"/>
                         </a:rPr>
-                        <a:t>效率 71% · 8.07 毫秒</a:t>
+                        <a:t>效率 29% · 7.69 毫秒</a:t>
                       </a:r>
                     </a:p>
                   </a:txBody>
@@ -34046,7 +34046,7 @@
                           <a:ea typeface="Microsoft YaHei"/>
                           <a:cs typeface="Microsoft YaHei"/>
                         </a:rPr>
-                        <a:t>384.1 MB · 1.20 毫秒</a:t>
+                        <a:t>154.8 MB · 0.48 毫秒</a:t>
                       </a:r>
                     </a:p>
                   </a:txBody>
@@ -34213,7 +34213,7 @@
                           <a:ea typeface="Microsoft YaHei"/>
                           <a:cs typeface="Microsoft YaHei"/>
                         </a:rPr>
-                        <a:t>10.26 毫秒</a:t>
+                        <a:t>8.58 毫秒</a:t>
                       </a:r>
                     </a:p>
                   </a:txBody>
@@ -34547,7 +34547,7 @@
                           <a:ea typeface="Microsoft YaHei"/>
                           <a:cs typeface="Microsoft YaHei"/>
                         </a:rPr>
-                        <a:t>9.65 GB · 3.02 毫秒</a:t>
+                        <a:t>10.48 GB · 3.28 毫秒</a:t>
                       </a:r>
                     </a:p>
                   </a:txBody>
@@ -34714,7 +34714,7 @@
                           <a:ea typeface="Microsoft YaHei"/>
                           <a:cs typeface="Microsoft YaHei"/>
                         </a:rPr>
-                        <a:t>1.04 GB · 3.23 毫秒</a:t>
+                        <a:t>2.24 GB · 7.00 毫秒</a:t>
                       </a:r>
                     </a:p>
                   </a:txBody>
@@ -34881,7 +34881,7 @@
                           <a:ea typeface="Microsoft YaHei"/>
                           <a:cs typeface="Microsoft YaHei"/>
                         </a:rPr>
-                        <a:t>换入 + 注意力计算 + AR + 读专家 · 29.50 毫秒</a:t>
+                        <a:t>换入 + 注意力计算 + AR + 读专家 · 29.99 毫秒</a:t>
                       </a:r>
                     </a:p>
                   </a:txBody>
@@ -35017,7 +35017,7 @@
                 <a:ea typeface="Microsoft YaHei"/>
                 <a:cs typeface="Microsoft YaHei"/>
               </a:rPr>
-              <a:t>0.33×10^6 换入 1.04 GB、3.23 毫秒；Attention 14.89 毫秒，MoE 14.60 毫秒，批 4096。128 卡换入合计 132.49 GB。</a:t>
+              <a:t>1M 换入 2.24 GB、7.00 毫秒；Attention 16.10 毫秒，MoE 13.89 毫秒，批 1528。128 卡换入合计 286.73 GB。</a:t>
             </a:r>
           </a:p>
           <a:p>
@@ -35183,7 +35183,7 @@
                 <a:ea typeface="Microsoft YaHei"/>
                 <a:cs typeface="Microsoft YaHei"/>
               </a:rPr>
-              <a:t>进池的长度从 256K 起，批从 4880 降到 4096</a:t>
+              <a:t>进池的长度从 256K 起，批从 4880 降到 1528</a:t>
             </a:r>
           </a:p>
         </p:txBody>
@@ -36336,7 +36336,7 @@
                           <a:ea typeface="Microsoft YaHei"/>
                           <a:cs typeface="Microsoft YaHei"/>
                         </a:rPr>
-                        <a:t>512K</a:t>
+                        <a:t>0.33×10^6</a:t>
                       </a:r>
                     </a:p>
                   </a:txBody>
@@ -36391,7 +36391,7 @@
                           <a:ea typeface="Microsoft YaHei"/>
                           <a:cs typeface="Microsoft YaHei"/>
                         </a:rPr>
-                        <a:t>2816</a:t>
+                        <a:t>4096</a:t>
                       </a:r>
                     </a:p>
                   </a:txBody>
@@ -36446,7 +36446,7 @@
                           <a:ea typeface="Microsoft YaHei"/>
                           <a:cs typeface="Microsoft YaHei"/>
                         </a:rPr>
-                        <a:t>22.0</a:t>
+                        <a:t>32.0</a:t>
                       </a:r>
                     </a:p>
                   </a:txBody>
@@ -36501,7 +36501,7 @@
                           <a:ea typeface="Microsoft YaHei"/>
                           <a:cs typeface="Microsoft YaHei"/>
                         </a:rPr>
-                        <a:t>21.7%</a:t>
+                        <a:t>14.3%</a:t>
                       </a:r>
                     </a:p>
                   </a:txBody>
@@ -36556,7 +36556,7 @@
                           <a:ea typeface="Microsoft YaHei"/>
                           <a:cs typeface="Microsoft YaHei"/>
                         </a:rPr>
-                        <a:t>1.66 GB</a:t>
+                        <a:t>1.04 GB</a:t>
                       </a:r>
                     </a:p>
                   </a:txBody>
@@ -36611,7 +36611,7 @@
                           <a:ea typeface="Microsoft YaHei"/>
                           <a:cs typeface="Microsoft YaHei"/>
                         </a:rPr>
-                        <a:t>212.05 GB</a:t>
+                        <a:t>132.49 GB</a:t>
                       </a:r>
                     </a:p>
                   </a:txBody>
@@ -36666,7 +36666,7 @@
                           <a:ea typeface="Microsoft YaHei"/>
                           <a:cs typeface="Microsoft YaHei"/>
                         </a:rPr>
-                        <a:t>5.18 毫秒</a:t>
+                        <a:t>3.23 毫秒</a:t>
                       </a:r>
                     </a:p>
                   </a:txBody>
@@ -36721,7 +36721,7 @@
                           <a:ea typeface="Microsoft YaHei"/>
                           <a:cs typeface="Microsoft YaHei"/>
                         </a:rPr>
-                        <a:t>注意力计算 9.41 毫秒</a:t>
+                        <a:t>注意力计算 10.26 毫秒</a:t>
                       </a:r>
                     </a:p>
                   </a:txBody>
@@ -36778,7 +36778,7 @@
                           <a:ea typeface="Microsoft YaHei"/>
                           <a:cs typeface="Microsoft YaHei"/>
                         </a:rPr>
-                        <a:t>1M</a:t>
+                        <a:t>512K</a:t>
                       </a:r>
                     </a:p>
                   </a:txBody>
@@ -36833,7 +36833,7 @@
                           <a:ea typeface="Microsoft YaHei"/>
                           <a:cs typeface="Microsoft YaHei"/>
                         </a:rPr>
-                        <a:t>1528</a:t>
+                        <a:t>2816</a:t>
                       </a:r>
                     </a:p>
                   </a:txBody>
@@ -36888,7 +36888,7 @@
                           <a:ea typeface="Microsoft YaHei"/>
                           <a:cs typeface="Microsoft YaHei"/>
                         </a:rPr>
-                        <a:t>11.9</a:t>
+                        <a:t>22.0</a:t>
                       </a:r>
                     </a:p>
                   </a:txBody>
@@ -36943,7 +36943,7 @@
                           <a:ea typeface="Microsoft YaHei"/>
                           <a:cs typeface="Microsoft YaHei"/>
                         </a:rPr>
-                        <a:t>27.8%</a:t>
+                        <a:t>21.7%</a:t>
                       </a:r>
                     </a:p>
                   </a:txBody>
@@ -36998,7 +36998,7 @@
                           <a:ea typeface="Microsoft YaHei"/>
                           <a:cs typeface="Microsoft YaHei"/>
                         </a:rPr>
-                        <a:t>2.24 GB</a:t>
+                        <a:t>1.66 GB</a:t>
                       </a:r>
                     </a:p>
                   </a:txBody>
@@ -37053,7 +37053,7 @@
                           <a:ea typeface="Microsoft YaHei"/>
                           <a:cs typeface="Microsoft YaHei"/>
                         </a:rPr>
-                        <a:t>286.73 GB</a:t>
+                        <a:t>212.05 GB</a:t>
                       </a:r>
                     </a:p>
                   </a:txBody>
@@ -37108,7 +37108,7 @@
                           <a:ea typeface="Microsoft YaHei"/>
                           <a:cs typeface="Microsoft YaHei"/>
                         </a:rPr>
-                        <a:t>7.00 毫秒</a:t>
+                        <a:t>5.18 毫秒</a:t>
                       </a:r>
                     </a:p>
                   </a:txBody>
@@ -37163,7 +37163,7 @@
                           <a:ea typeface="Microsoft YaHei"/>
                           <a:cs typeface="Microsoft YaHei"/>
                         </a:rPr>
-                        <a:t>注意力计算 8.58 毫秒</a:t>
+                        <a:t>注意力计算 9.41 毫秒</a:t>
                       </a:r>
                     </a:p>
                   </a:txBody>
@@ -37220,7 +37220,7 @@
                           <a:ea typeface="Microsoft YaHei"/>
                           <a:cs typeface="Microsoft YaHei"/>
                         </a:rPr>
-                        <a:t>0.33×10^6</a:t>
+                        <a:t>1M</a:t>
                       </a:r>
                     </a:p>
                   </a:txBody>
@@ -37275,7 +37275,7 @@
                           <a:ea typeface="Microsoft YaHei"/>
                           <a:cs typeface="Microsoft YaHei"/>
                         </a:rPr>
-                        <a:t>4096</a:t>
+                        <a:t>1528</a:t>
                       </a:r>
                     </a:p>
                   </a:txBody>
@@ -37330,7 +37330,7 @@
                           <a:ea typeface="Microsoft YaHei"/>
                           <a:cs typeface="Microsoft YaHei"/>
                         </a:rPr>
-                        <a:t>32.0</a:t>
+                        <a:t>11.9</a:t>
                       </a:r>
                     </a:p>
                   </a:txBody>
@@ -37385,7 +37385,7 @@
                           <a:ea typeface="Microsoft YaHei"/>
                           <a:cs typeface="Microsoft YaHei"/>
                         </a:rPr>
-                        <a:t>14.3%</a:t>
+                        <a:t>27.8%</a:t>
                       </a:r>
                     </a:p>
                   </a:txBody>
@@ -37440,7 +37440,7 @@
                           <a:ea typeface="Microsoft YaHei"/>
                           <a:cs typeface="Microsoft YaHei"/>
                         </a:rPr>
-                        <a:t>1.04 GB</a:t>
+                        <a:t>2.24 GB</a:t>
                       </a:r>
                     </a:p>
                   </a:txBody>
@@ -37495,7 +37495,7 @@
                           <a:ea typeface="Microsoft YaHei"/>
                           <a:cs typeface="Microsoft YaHei"/>
                         </a:rPr>
-                        <a:t>132.49 GB</a:t>
+                        <a:t>286.73 GB</a:t>
                       </a:r>
                     </a:p>
                   </a:txBody>
@@ -37550,7 +37550,7 @@
                           <a:ea typeface="Microsoft YaHei"/>
                           <a:cs typeface="Microsoft YaHei"/>
                         </a:rPr>
-                        <a:t>3.23 毫秒</a:t>
+                        <a:t>7.00 毫秒</a:t>
                       </a:r>
                     </a:p>
                   </a:txBody>
@@ -37605,7 +37605,7 @@
                           <a:ea typeface="Microsoft YaHei"/>
                           <a:cs typeface="Microsoft YaHei"/>
                         </a:rPr>
-                        <a:t>注意力计算 10.26 毫秒</a:t>
+                        <a:t>注意力计算 8.58 毫秒</a:t>
                       </a:r>
                     </a:p>
                   </a:txBody>
@@ -38507,7 +38507,7 @@
                           <a:ea typeface="Microsoft YaHei"/>
                           <a:cs typeface="Microsoft YaHei"/>
                         </a:rPr>
-                        <a:t>512K</a:t>
+                        <a:t>0.33×10^6</a:t>
                       </a:r>
                     </a:p>
                   </a:txBody>
@@ -38562,7 +38562,7 @@
                           <a:ea typeface="Microsoft YaHei"/>
                           <a:cs typeface="Microsoft YaHei"/>
                         </a:rPr>
-                        <a:t>5.18 毫秒</a:t>
+                        <a:t>3.23 毫秒</a:t>
                       </a:r>
                     </a:p>
                   </a:txBody>
@@ -38617,7 +38617,7 @@
                           <a:ea typeface="Microsoft YaHei"/>
                           <a:cs typeface="Microsoft YaHei"/>
                         </a:rPr>
-                        <a:t>0.96 毫秒</a:t>
+                        <a:t>1.40 毫秒</a:t>
                       </a:r>
                     </a:p>
                   </a:txBody>
@@ -38672,7 +38672,7 @@
                           <a:ea typeface="Microsoft YaHei"/>
                           <a:cs typeface="Microsoft YaHei"/>
                         </a:rPr>
-                        <a:t>9.41 毫秒</a:t>
+                        <a:t>10.26 毫秒</a:t>
                       </a:r>
                     </a:p>
                   </a:txBody>
@@ -38727,7 +38727,7 @@
                           <a:ea typeface="Microsoft YaHei"/>
                           <a:cs typeface="Microsoft YaHei"/>
                         </a:rPr>
-                        <a:t>3.14 毫秒</a:t>
+                        <a:t>3.02 毫秒</a:t>
                       </a:r>
                     </a:p>
                   </a:txBody>
@@ -38837,7 +38837,7 @@
                           <a:ea typeface="Microsoft YaHei"/>
                           <a:cs typeface="Microsoft YaHei"/>
                         </a:rPr>
-                        <a:t>29.80 毫秒</a:t>
+                        <a:t>29.50 毫秒</a:t>
                       </a:r>
                     </a:p>
                   </a:txBody>
@@ -38894,7 +38894,7 @@
                           <a:ea typeface="Microsoft YaHei"/>
                           <a:cs typeface="Microsoft YaHei"/>
                         </a:rPr>
-                        <a:t>1M</a:t>
+                        <a:t>512K</a:t>
                       </a:r>
                     </a:p>
                   </a:txBody>
@@ -38949,7 +38949,7 @@
                           <a:ea typeface="Microsoft YaHei"/>
                           <a:cs typeface="Microsoft YaHei"/>
                         </a:rPr>
-                        <a:t>7.00 毫秒</a:t>
+                        <a:t>5.18 毫秒</a:t>
                       </a:r>
                     </a:p>
                   </a:txBody>
@@ -39004,7 +39004,7 @@
                           <a:ea typeface="Microsoft YaHei"/>
                           <a:cs typeface="Microsoft YaHei"/>
                         </a:rPr>
-                        <a:t>0.52 毫秒</a:t>
+                        <a:t>0.96 毫秒</a:t>
                       </a:r>
                     </a:p>
                   </a:txBody>
@@ -39059,7 +39059,7 @@
                           <a:ea typeface="Microsoft YaHei"/>
                           <a:cs typeface="Microsoft YaHei"/>
                         </a:rPr>
-                        <a:t>8.58 毫秒</a:t>
+                        <a:t>9.41 毫秒</a:t>
                       </a:r>
                     </a:p>
                   </a:txBody>
@@ -39114,7 +39114,7 @@
                           <a:ea typeface="Microsoft YaHei"/>
                           <a:cs typeface="Microsoft YaHei"/>
                         </a:rPr>
-                        <a:t>3.28 毫秒</a:t>
+                        <a:t>3.14 毫秒</a:t>
                       </a:r>
                     </a:p>
                   </a:txBody>
@@ -39224,7 +39224,7 @@
                           <a:ea typeface="Microsoft YaHei"/>
                           <a:cs typeface="Microsoft YaHei"/>
                         </a:rPr>
-                        <a:t>29.99 毫秒</a:t>
+                        <a:t>29.80 毫秒</a:t>
                       </a:r>
                     </a:p>
                   </a:txBody>
@@ -39281,7 +39281,7 @@
                           <a:ea typeface="Microsoft YaHei"/>
                           <a:cs typeface="Microsoft YaHei"/>
                         </a:rPr>
-                        <a:t>0.33×10^6</a:t>
+                        <a:t>1M</a:t>
                       </a:r>
                     </a:p>
                   </a:txBody>
@@ -39336,7 +39336,7 @@
                           <a:ea typeface="Microsoft YaHei"/>
                           <a:cs typeface="Microsoft YaHei"/>
                         </a:rPr>
-                        <a:t>3.23 毫秒</a:t>
+                        <a:t>7.00 毫秒</a:t>
                       </a:r>
                     </a:p>
                   </a:txBody>
@@ -39391,7 +39391,7 @@
                           <a:ea typeface="Microsoft YaHei"/>
                           <a:cs typeface="Microsoft YaHei"/>
                         </a:rPr>
-                        <a:t>1.40 毫秒</a:t>
+                        <a:t>0.52 毫秒</a:t>
                       </a:r>
                     </a:p>
                   </a:txBody>
@@ -39446,7 +39446,7 @@
                           <a:ea typeface="Microsoft YaHei"/>
                           <a:cs typeface="Microsoft YaHei"/>
                         </a:rPr>
-                        <a:t>10.26 毫秒</a:t>
+                        <a:t>8.58 毫秒</a:t>
                       </a:r>
                     </a:p>
                   </a:txBody>
@@ -39501,7 +39501,7 @@
                           <a:ea typeface="Microsoft YaHei"/>
                           <a:cs typeface="Microsoft YaHei"/>
                         </a:rPr>
-                        <a:t>3.02 毫秒</a:t>
+                        <a:t>3.28 毫秒</a:t>
                       </a:r>
                     </a:p>
                   </a:txBody>
@@ -39611,7 +39611,7 @@
                           <a:ea typeface="Microsoft YaHei"/>
                           <a:cs typeface="Microsoft YaHei"/>
                         </a:rPr>
-                        <a:t>29.50 毫秒</a:t>
+                        <a:t>29.99 毫秒</a:t>
                       </a:r>
                     </a:p>
                   </a:txBody>

</xml_diff>

<commit_message>
docs: add Prefill MoE timing breakdown
Co-authored-by: 69515164-rgb <69515164-rgb@users.noreply.github.com>
</commit_message>
<xml_diff>
--- a/docs/deepseek-96g-slo.pptx
+++ b/docs/deepseek-96g-slo.pptx
@@ -18,6 +18,7 @@
     <p:sldId id="266" r:id="rId18"/>
     <p:sldId id="267" r:id="rId19"/>
     <p:sldId id="268" r:id="rId20"/>
+    <p:sldId id="269" r:id="rId21"/>
   </p:sldIdLst>
   <p:sldSz cx="12191695" cy="6858000" type="screen4x3"/>
   <p:notesSz cx="6858000" cy="9144000"/>
@@ -1761,6 +1762,76 @@
           <a:p>
             <a:r>
               <a:t>Decode 饼图使用 30ms 最大批，按最忙活跃 GPU。HBM KV 上限 44.687 GB。4K: BS=7936, hbm_kv=1.533GB, pool=0.000GB, free=43.154GB. 256K: BS=4880, hbm_kv=44.687GB, pool=4.851GB, free=0.000GB. 1M: BS=1528, hbm_kv=44.687GB, pool=17.520GB, free=0.000GB.</a:t>
+            </a:r>
+          </a:p>
+        </p:txBody>
+      </p:sp>
+      <p:sp>
+        <p:nvSpPr>
+          <p:cNvPr id="4" name="Slide Number Placeholder 3"/>
+          <p:cNvSpPr>
+            <a:spLocks noGrp="1"/>
+          </p:cNvSpPr>
+          <p:nvPr>
+            <p:ph type="sldNum" idx="5" sz="quarter"/>
+          </p:nvPr>
+        </p:nvSpPr>
+        <p:spPr/>
+      </p:sp>
+    </p:spTree>
+  </p:cSld>
+  <p:clrMapOvr>
+    <a:masterClrMapping/>
+  </p:clrMapOvr>
+</p:notes>
+</file>
+
+<file path=ppt/notesSlides/notesSlide14.xml><?xml version="1.0" encoding="utf-8"?>
+<p:notes xmlns:a="http://schemas.openxmlformats.org/drawingml/2006/main" xmlns:p="http://schemas.openxmlformats.org/presentationml/2006/main" xmlns:r="http://schemas.openxmlformats.org/officeDocument/2006/relationships">
+  <p:cSld>
+    <p:spTree>
+      <p:nvGrpSpPr>
+        <p:cNvPr id="1" name=""/>
+        <p:cNvGrpSpPr/>
+        <p:nvPr/>
+      </p:nvGrpSpPr>
+      <p:grpSpPr>
+        <a:xfrm>
+          <a:off x="0" y="0"/>
+          <a:ext cx="0" cy="0"/>
+          <a:chOff x="0" y="0"/>
+          <a:chExt cx="0" cy="0"/>
+        </a:xfrm>
+      </p:grpSpPr>
+      <p:sp>
+        <p:nvSpPr>
+          <p:cNvPr id="2" name="Slide Image Placeholder 1"/>
+          <p:cNvSpPr>
+            <a:spLocks noGrp="1"/>
+          </p:cNvSpPr>
+          <p:nvPr>
+            <p:ph type="sldImg" idx="2"/>
+          </p:nvPr>
+        </p:nvSpPr>
+        <p:spPr/>
+      </p:sp>
+      <p:sp>
+        <p:nvSpPr>
+          <p:cNvPr id="3" name="Notes Placeholder 2"/>
+          <p:cNvSpPr>
+            <a:spLocks noGrp="1"/>
+          </p:cNvSpPr>
+          <p:nvPr>
+            <p:ph type="body" idx="3" sz="quarter"/>
+          </p:nvPr>
+        </p:nvSpPr>
+        <p:spPr/>
+        <p:txBody>
+          <a:bodyPr/>
+          <a:lstStyle/>
+          <a:p>
+            <a:r>
+              <a:t>Prefill MoE按最忙EP卡统计。dispatch和combine分别计算，不能互相重叠；专家权重读取与GEMM位于融合kernel内，取二者最大值。4K: BS=45674, Q=3741614, dispatch=0.481581s, weight=0.013404s, gemm=4.867284s, combine=0.481581s, total=5.830445s. 8K: BS=22676, Q=3715236, dispatch=0.478194s, weight=0.013404s, gemm=4.833490s, combine=0.478194s, total=5.789877s. 32K: BS=5456, Q=3575644, dispatch=0.460269s, weight=0.013404s, gemm=4.653798s, combine=0.460269s, total=5.574336s. 128K: BS=1184, Q=3103785, dispatch=0.399671s, weight=0.013404s, gemm=4.040202s, combine=0.399671s, total=4.839545s. 256K: BS=498, Q=2610954, dispatch=0.336368s, weight=0.013404s, gemm=3.400502s, combine=0.336368s, total=4.073238s. 512K: BS=192, Q=2013266, dispatch=0.259572s, weight=0.013404s, gemm=2.624869s, combine=0.259572s, total=3.144013s. 1M: BS=64, Q=1342177, dispatch=0.173298s, weight=0.013404s, gemm=1.754787s, combine=0.173298s, total=2.101384s.</a:t>
             </a:r>
           </a:p>
         </p:txBody>
@@ -5490,7 +5561,7 @@
                 <a:ea typeface="Microsoft YaHei"/>
                 <a:cs typeface="Microsoft YaHei"/>
               </a:rPr>
-              <a:t>1  /  13</a:t>
+              <a:t>1  /  14</a:t>
             </a:r>
           </a:p>
         </p:txBody>
@@ -8201,7 +8272,7 @@
                 <a:ea typeface="Microsoft YaHei"/>
                 <a:cs typeface="Microsoft YaHei"/>
               </a:rPr>
-              <a:t>10  /  13</a:t>
+              <a:t>10  /  14</a:t>
             </a:r>
           </a:p>
         </p:txBody>
@@ -10171,7 +10242,7 @@
                 <a:ea typeface="Microsoft YaHei"/>
                 <a:cs typeface="Microsoft YaHei"/>
               </a:rPr>
-              <a:t>11  /  13</a:t>
+              <a:t>11  /  14</a:t>
             </a:r>
           </a:p>
         </p:txBody>
@@ -12141,7 +12212,7 @@
                 <a:ea typeface="Microsoft YaHei"/>
                 <a:cs typeface="Microsoft YaHei"/>
               </a:rPr>
-              <a:t>12  /  13</a:t>
+              <a:t>12  /  14</a:t>
             </a:r>
           </a:p>
         </p:txBody>
@@ -13078,7 +13149,7 @@
                 <a:ea typeface="Microsoft YaHei"/>
                 <a:cs typeface="Microsoft YaHei"/>
               </a:rPr>
-              <a:t>13  /  13</a:t>
+              <a:t>13  /  14</a:t>
             </a:r>
           </a:p>
         </p:txBody>
@@ -13841,6 +13912,4056 @@
 </p:sld>
 </file>
 
+<file path=ppt/slides/slide14.xml><?xml version="1.0" encoding="utf-8"?>
+<p:sld xmlns:a="http://schemas.openxmlformats.org/drawingml/2006/main" xmlns:p="http://schemas.openxmlformats.org/presentationml/2006/main" xmlns:r="http://schemas.openxmlformats.org/officeDocument/2006/relationships">
+  <p:cSld>
+    <p:spTree>
+      <p:nvGrpSpPr>
+        <p:cNvPr id="1" name=""/>
+        <p:cNvGrpSpPr/>
+        <p:nvPr/>
+      </p:nvGrpSpPr>
+      <p:grpSpPr/>
+      <p:sp>
+        <p:nvSpPr>
+          <p:cNvPr id="2" name="Rectangle 1"/>
+          <p:cNvSpPr/>
+          <p:nvPr/>
+        </p:nvSpPr>
+        <p:spPr>
+          <a:xfrm>
+            <a:off x="0" y="0"/>
+            <a:ext cx="12191695" cy="73152"/>
+          </a:xfrm>
+          <a:prstGeom prst="rect">
+            <a:avLst/>
+          </a:prstGeom>
+          <a:solidFill>
+            <a:srgbClr val="145A96"/>
+          </a:solidFill>
+          <a:ln>
+            <a:noFill/>
+          </a:ln>
+        </p:spPr>
+        <p:style>
+          <a:lnRef idx="1">
+            <a:schemeClr val="accent1"/>
+          </a:lnRef>
+          <a:fillRef idx="3">
+            <a:schemeClr val="accent1"/>
+          </a:fillRef>
+          <a:effectRef idx="2">
+            <a:schemeClr val="accent1"/>
+          </a:effectRef>
+          <a:fontRef idx="minor">
+            <a:schemeClr val="lt1"/>
+          </a:fontRef>
+        </p:style>
+        <p:txBody>
+          <a:bodyPr rtlCol="0" anchor="ctr"/>
+          <a:lstStyle/>
+          <a:p>
+            <a:pPr algn="ctr"/>
+          </a:p>
+        </p:txBody>
+      </p:sp>
+      <p:sp>
+        <p:nvSpPr>
+          <p:cNvPr id="3" name="TextBox 2"/>
+          <p:cNvSpPr txBox="1"/>
+          <p:nvPr/>
+        </p:nvSpPr>
+        <p:spPr>
+          <a:xfrm>
+            <a:off x="384048" y="146304"/>
+            <a:ext cx="9692640" cy="256032"/>
+          </a:xfrm>
+          <a:prstGeom prst="rect">
+            <a:avLst/>
+          </a:prstGeom>
+          <a:noFill/>
+        </p:spPr>
+        <p:txBody>
+          <a:bodyPr wrap="square" lIns="0" rIns="0" tIns="0" bIns="0" anchor="ctr"/>
+          <a:lstStyle/>
+          <a:p>
+            <a:pPr algn="l">
+              <a:spcBef>
+                <a:spcPts val="0"/>
+              </a:spcBef>
+              <a:spcAft>
+                <a:spcPts val="0"/>
+              </a:spcAft>
+            </a:pPr>
+            <a:r>
+              <a:rPr sz="1200" b="1">
+                <a:solidFill>
+                  <a:srgbClr val="145A96"/>
+                </a:solidFill>
+                <a:latin typeface="Microsoft YaHei"/>
+                <a:ea typeface="Microsoft YaHei"/>
+                <a:cs typeface="Microsoft YaHei"/>
+              </a:rPr>
+              <a:t>Prefill    ·    MoE 分阶段    ·    KV 命中 98%</a:t>
+            </a:r>
+          </a:p>
+        </p:txBody>
+      </p:sp>
+      <p:sp>
+        <p:nvSpPr>
+          <p:cNvPr id="4" name="TextBox 3"/>
+          <p:cNvSpPr txBox="1"/>
+          <p:nvPr/>
+        </p:nvSpPr>
+        <p:spPr>
+          <a:xfrm>
+            <a:off x="384048" y="384048"/>
+            <a:ext cx="11430000" cy="384048"/>
+          </a:xfrm>
+          <a:prstGeom prst="rect">
+            <a:avLst/>
+          </a:prstGeom>
+          <a:noFill/>
+        </p:spPr>
+        <p:txBody>
+          <a:bodyPr wrap="square" lIns="0" rIns="0" tIns="0" bIns="0" anchor="ctr"/>
+          <a:lstStyle/>
+          <a:p>
+            <a:pPr algn="l">
+              <a:spcBef>
+                <a:spcPts val="0"/>
+              </a:spcBef>
+              <a:spcAft>
+                <a:spcPts val="0"/>
+              </a:spcAft>
+            </a:pPr>
+            <a:r>
+              <a:rPr sz="2600" b="1">
+                <a:solidFill>
+                  <a:srgbClr val="0E2A47"/>
+                </a:solidFill>
+                <a:latin typeface="Microsoft YaHei"/>
+                <a:ea typeface="Microsoft YaHei"/>
+                <a:cs typeface="Microsoft YaHei"/>
+              </a:rPr>
+              <a:t>Prefill MoE：长输入的摸高批下降，MoE 耗时随总现算 token 下降</a:t>
+            </a:r>
+          </a:p>
+        </p:txBody>
+      </p:sp>
+      <p:sp>
+        <p:nvSpPr>
+          <p:cNvPr id="5" name="TextBox 4"/>
+          <p:cNvSpPr txBox="1"/>
+          <p:nvPr/>
+        </p:nvSpPr>
+        <p:spPr>
+          <a:xfrm>
+            <a:off x="10424160" y="164592"/>
+            <a:ext cx="1371600" cy="237744"/>
+          </a:xfrm>
+          <a:prstGeom prst="rect">
+            <a:avLst/>
+          </a:prstGeom>
+          <a:noFill/>
+        </p:spPr>
+        <p:txBody>
+          <a:bodyPr wrap="square" lIns="0" rIns="0" tIns="0" bIns="0" anchor="ctr"/>
+          <a:lstStyle/>
+          <a:p>
+            <a:pPr algn="r">
+              <a:spcBef>
+                <a:spcPts val="0"/>
+              </a:spcBef>
+              <a:spcAft>
+                <a:spcPts val="0"/>
+              </a:spcAft>
+            </a:pPr>
+            <a:r>
+              <a:rPr sz="1200" b="0">
+                <a:solidFill>
+                  <a:srgbClr val="5A636E"/>
+                </a:solidFill>
+                <a:latin typeface="Microsoft YaHei"/>
+                <a:ea typeface="Microsoft YaHei"/>
+                <a:cs typeface="Microsoft YaHei"/>
+              </a:rPr>
+              <a:t>14  /  14</a:t>
+            </a:r>
+          </a:p>
+        </p:txBody>
+      </p:sp>
+      <p:sp>
+        <p:nvSpPr>
+          <p:cNvPr id="6" name="Rectangle 5"/>
+          <p:cNvSpPr/>
+          <p:nvPr/>
+        </p:nvSpPr>
+        <p:spPr>
+          <a:xfrm>
+            <a:off x="384048" y="6565392"/>
+            <a:ext cx="11430000" cy="9144"/>
+          </a:xfrm>
+          <a:prstGeom prst="rect">
+            <a:avLst/>
+          </a:prstGeom>
+          <a:solidFill>
+            <a:srgbClr val="D6DCE2"/>
+          </a:solidFill>
+          <a:ln>
+            <a:noFill/>
+          </a:ln>
+        </p:spPr>
+        <p:style>
+          <a:lnRef idx="1">
+            <a:schemeClr val="accent1"/>
+          </a:lnRef>
+          <a:fillRef idx="3">
+            <a:schemeClr val="accent1"/>
+          </a:fillRef>
+          <a:effectRef idx="2">
+            <a:schemeClr val="accent1"/>
+          </a:effectRef>
+          <a:fontRef idx="minor">
+            <a:schemeClr val="lt1"/>
+          </a:fontRef>
+        </p:style>
+        <p:txBody>
+          <a:bodyPr rtlCol="0" anchor="ctr"/>
+          <a:lstStyle/>
+          <a:p>
+            <a:pPr algn="ctr"/>
+          </a:p>
+        </p:txBody>
+      </p:sp>
+      <p:sp>
+        <p:nvSpPr>
+          <p:cNvPr id="7" name="TextBox 6"/>
+          <p:cNvSpPr txBox="1"/>
+          <p:nvPr/>
+        </p:nvSpPr>
+        <p:spPr>
+          <a:xfrm>
+            <a:off x="384048" y="6583680"/>
+            <a:ext cx="11430000" cy="219456"/>
+          </a:xfrm>
+          <a:prstGeom prst="rect">
+            <a:avLst/>
+          </a:prstGeom>
+          <a:noFill/>
+        </p:spPr>
+        <p:txBody>
+          <a:bodyPr wrap="square" lIns="0" rIns="0" tIns="0" bIns="0" anchor="ctr"/>
+          <a:lstStyle/>
+          <a:p>
+            <a:pPr algn="l">
+              <a:spcBef>
+                <a:spcPts val="0"/>
+              </a:spcBef>
+              <a:spcAft>
+                <a:spcPts val="0"/>
+              </a:spcAft>
+            </a:pPr>
+            <a:r>
+              <a:rPr sz="1100" b="0">
+                <a:solidFill>
+                  <a:srgbClr val="5A636E"/>
+                </a:solidFill>
+                <a:latin typeface="Microsoft YaHei"/>
+                <a:ea typeface="Microsoft YaHei"/>
+                <a:cs typeface="Microsoft YaHei"/>
+              </a:rPr>
+              <a:t>10T 为外推    ·    96 GB / 486 T、一份 128 卡副本    ·    访存与通信 80%    ·    计算 70%</a:t>
+            </a:r>
+          </a:p>
+        </p:txBody>
+      </p:sp>
+      <p:sp>
+        <p:nvSpPr>
+          <p:cNvPr id="8" name="Rounded Rectangle 7"/>
+          <p:cNvSpPr/>
+          <p:nvPr/>
+        </p:nvSpPr>
+        <p:spPr>
+          <a:xfrm>
+            <a:off x="384048" y="841248"/>
+            <a:ext cx="11430000" cy="420624"/>
+          </a:xfrm>
+          <a:prstGeom prst="roundRect">
+            <a:avLst/>
+          </a:prstGeom>
+          <a:solidFill>
+            <a:srgbClr val="E7F3F2"/>
+          </a:solidFill>
+          <a:ln>
+            <a:noFill/>
+          </a:ln>
+        </p:spPr>
+        <p:style>
+          <a:lnRef idx="1">
+            <a:schemeClr val="accent1"/>
+          </a:lnRef>
+          <a:fillRef idx="3">
+            <a:schemeClr val="accent1"/>
+          </a:fillRef>
+          <a:effectRef idx="2">
+            <a:schemeClr val="accent1"/>
+          </a:effectRef>
+          <a:fontRef idx="minor">
+            <a:schemeClr val="lt1"/>
+          </a:fontRef>
+        </p:style>
+        <p:txBody>
+          <a:bodyPr rtlCol="0" anchor="ctr"/>
+          <a:lstStyle/>
+          <a:p>
+            <a:pPr algn="ctr"/>
+          </a:p>
+        </p:txBody>
+      </p:sp>
+      <p:sp>
+        <p:nvSpPr>
+          <p:cNvPr id="9" name="TextBox 8"/>
+          <p:cNvSpPr txBox="1"/>
+          <p:nvPr/>
+        </p:nvSpPr>
+        <p:spPr>
+          <a:xfrm>
+            <a:off x="530352" y="841248"/>
+            <a:ext cx="11137392" cy="420624"/>
+          </a:xfrm>
+          <a:prstGeom prst="rect">
+            <a:avLst/>
+          </a:prstGeom>
+          <a:noFill/>
+        </p:spPr>
+        <p:txBody>
+          <a:bodyPr wrap="square" lIns="0" rIns="0" tIns="0" bIns="0" anchor="ctr"/>
+          <a:lstStyle/>
+          <a:p>
+            <a:pPr algn="l">
+              <a:spcBef>
+                <a:spcPts val="0"/>
+              </a:spcBef>
+              <a:spcAft>
+                <a:spcPts val="0"/>
+              </a:spcAft>
+            </a:pPr>
+            <a:r>
+              <a:rPr sz="1300" b="1">
+                <a:solidFill>
+                  <a:srgbClr val="0E7A76"/>
+                </a:solidFill>
+                <a:latin typeface="Microsoft YaHei"/>
+                <a:ea typeface="Microsoft YaHei"/>
+                <a:cs typeface="Microsoft YaHei"/>
+              </a:rPr>
+              <a:t>每行采用该输入长度在 TTFT≤10秒下的最大全局批。MoE = dispatch + max(专家权重读取, 专家GEMM) + combine。</a:t>
+            </a:r>
+          </a:p>
+        </p:txBody>
+      </p:sp>
+      <p:graphicFrame>
+        <p:nvGraphicFramePr>
+          <p:cNvPr id="10" name="Table 9"/>
+          <p:cNvGraphicFramePr>
+            <a:graphicFrameLocks noGrp="1"/>
+          </p:cNvGraphicFramePr>
+          <p:nvPr/>
+        </p:nvGraphicFramePr>
+        <p:xfrm>
+          <a:off x="384048" y="1371600"/>
+          <a:ext cx="10515600" cy="3099816"/>
+        </p:xfrm>
+        <a:graphic>
+          <a:graphicData uri="http://schemas.openxmlformats.org/drawingml/2006/table">
+            <a:tbl>
+              <a:tblPr firstRow="1"/>
+              <a:tblGrid>
+                <a:gridCol w="822960"/>
+                <a:gridCol w="1143000"/>
+                <a:gridCol w="1325880"/>
+                <a:gridCol w="1325880"/>
+                <a:gridCol w="1417320"/>
+                <a:gridCol w="1417320"/>
+                <a:gridCol w="1325880"/>
+                <a:gridCol w="1737360"/>
+              </a:tblGrid>
+              <a:tr h="347472">
+                <a:tc>
+                  <a:txBody>
+                    <a:bodyPr wrap="square"/>
+                    <a:lstStyle/>
+                    <a:p>
+                      <a:pPr algn="l">
+                        <a:spcBef>
+                          <a:spcPts val="0"/>
+                        </a:spcBef>
+                        <a:spcAft>
+                          <a:spcPts val="0"/>
+                        </a:spcAft>
+                        <a:lnSpc>
+                          <a:spcPct val="100000"/>
+                        </a:lnSpc>
+                      </a:pPr>
+                      <a:r>
+                        <a:rPr sz="1200" b="1">
+                          <a:solidFill>
+                            <a:srgbClr val="FFFFFF"/>
+                          </a:solidFill>
+                          <a:latin typeface="Microsoft YaHei"/>
+                          <a:ea typeface="Microsoft YaHei"/>
+                          <a:cs typeface="Microsoft YaHei"/>
+                        </a:rPr>
+                        <a:t>输入</a:t>
+                      </a:r>
+                    </a:p>
+                  </a:txBody>
+                  <a:tcPr marL="54864" marR="54864" marT="27432" marB="18288" anchor="ctr">
+                    <a:solidFill>
+                      <a:srgbClr val="0E2A47"/>
+                    </a:solidFill>
+                    <a:lnL w="6350">
+                      <a:solidFill>
+                        <a:srgbClr val="D6DCE2"/>
+                      </a:solidFill>
+                    </a:lnL>
+                    <a:lnR w="6350">
+                      <a:solidFill>
+                        <a:srgbClr val="D6DCE2"/>
+                      </a:solidFill>
+                    </a:lnR>
+                    <a:lnT w="6350">
+                      <a:solidFill>
+                        <a:srgbClr val="D6DCE2"/>
+                      </a:solidFill>
+                    </a:lnT>
+                    <a:lnB w="6350">
+                      <a:solidFill>
+                        <a:srgbClr val="D6DCE2"/>
+                      </a:solidFill>
+                    </a:lnB>
+                  </a:tcPr>
+                </a:tc>
+                <a:tc>
+                  <a:txBody>
+                    <a:bodyPr wrap="square"/>
+                    <a:lstStyle/>
+                    <a:p>
+                      <a:pPr algn="l">
+                        <a:spcBef>
+                          <a:spcPts val="0"/>
+                        </a:spcBef>
+                        <a:spcAft>
+                          <a:spcPts val="0"/>
+                        </a:spcAft>
+                        <a:lnSpc>
+                          <a:spcPct val="100000"/>
+                        </a:lnSpc>
+                      </a:pPr>
+                      <a:r>
+                        <a:rPr sz="1200" b="1">
+                          <a:solidFill>
+                            <a:srgbClr val="FFFFFF"/>
+                          </a:solidFill>
+                          <a:latin typeface="Microsoft YaHei"/>
+                          <a:ea typeface="Microsoft YaHei"/>
+                          <a:cs typeface="Microsoft YaHei"/>
+                        </a:rPr>
+                        <a:t>10秒全局批</a:t>
+                      </a:r>
+                    </a:p>
+                  </a:txBody>
+                  <a:tcPr marL="54864" marR="54864" marT="27432" marB="18288" anchor="ctr">
+                    <a:solidFill>
+                      <a:srgbClr val="0E2A47"/>
+                    </a:solidFill>
+                    <a:lnL w="6350">
+                      <a:solidFill>
+                        <a:srgbClr val="D6DCE2"/>
+                      </a:solidFill>
+                    </a:lnL>
+                    <a:lnR w="6350">
+                      <a:solidFill>
+                        <a:srgbClr val="D6DCE2"/>
+                      </a:solidFill>
+                    </a:lnR>
+                    <a:lnT w="6350">
+                      <a:solidFill>
+                        <a:srgbClr val="D6DCE2"/>
+                      </a:solidFill>
+                    </a:lnT>
+                    <a:lnB w="6350">
+                      <a:solidFill>
+                        <a:srgbClr val="D6DCE2"/>
+                      </a:solidFill>
+                    </a:lnB>
+                  </a:tcPr>
+                </a:tc>
+                <a:tc>
+                  <a:txBody>
+                    <a:bodyPr wrap="square"/>
+                    <a:lstStyle/>
+                    <a:p>
+                      <a:pPr algn="l">
+                        <a:spcBef>
+                          <a:spcPts val="0"/>
+                        </a:spcBef>
+                        <a:spcAft>
+                          <a:spcPts val="0"/>
+                        </a:spcAft>
+                        <a:lnSpc>
+                          <a:spcPct val="100000"/>
+                        </a:lnSpc>
+                      </a:pPr>
+                      <a:r>
+                        <a:rPr sz="1200" b="1">
+                          <a:solidFill>
+                            <a:srgbClr val="FFFFFF"/>
+                          </a:solidFill>
+                          <a:latin typeface="Microsoft YaHei"/>
+                          <a:ea typeface="Microsoft YaHei"/>
+                          <a:cs typeface="Microsoft YaHei"/>
+                        </a:rPr>
+                        <a:t>现算token</a:t>
+                      </a:r>
+                    </a:p>
+                  </a:txBody>
+                  <a:tcPr marL="54864" marR="54864" marT="27432" marB="18288" anchor="ctr">
+                    <a:solidFill>
+                      <a:srgbClr val="0E2A47"/>
+                    </a:solidFill>
+                    <a:lnL w="6350">
+                      <a:solidFill>
+                        <a:srgbClr val="D6DCE2"/>
+                      </a:solidFill>
+                    </a:lnL>
+                    <a:lnR w="6350">
+                      <a:solidFill>
+                        <a:srgbClr val="D6DCE2"/>
+                      </a:solidFill>
+                    </a:lnR>
+                    <a:lnT w="6350">
+                      <a:solidFill>
+                        <a:srgbClr val="D6DCE2"/>
+                      </a:solidFill>
+                    </a:lnT>
+                    <a:lnB w="6350">
+                      <a:solidFill>
+                        <a:srgbClr val="D6DCE2"/>
+                      </a:solidFill>
+                    </a:lnB>
+                  </a:tcPr>
+                </a:tc>
+                <a:tc>
+                  <a:txBody>
+                    <a:bodyPr wrap="square"/>
+                    <a:lstStyle/>
+                    <a:p>
+                      <a:pPr algn="l">
+                        <a:spcBef>
+                          <a:spcPts val="0"/>
+                        </a:spcBef>
+                        <a:spcAft>
+                          <a:spcPts val="0"/>
+                        </a:spcAft>
+                        <a:lnSpc>
+                          <a:spcPct val="100000"/>
+                        </a:lnSpc>
+                      </a:pPr>
+                      <a:r>
+                        <a:rPr sz="1200" b="1">
+                          <a:solidFill>
+                            <a:srgbClr val="FFFFFF"/>
+                          </a:solidFill>
+                          <a:latin typeface="Microsoft YaHei"/>
+                          <a:ea typeface="Microsoft YaHei"/>
+                          <a:cs typeface="Microsoft YaHei"/>
+                        </a:rPr>
+                        <a:t>dispatch</a:t>
+                      </a:r>
+                    </a:p>
+                  </a:txBody>
+                  <a:tcPr marL="54864" marR="54864" marT="27432" marB="18288" anchor="ctr">
+                    <a:solidFill>
+                      <a:srgbClr val="0E2A47"/>
+                    </a:solidFill>
+                    <a:lnL w="6350">
+                      <a:solidFill>
+                        <a:srgbClr val="D6DCE2"/>
+                      </a:solidFill>
+                    </a:lnL>
+                    <a:lnR w="6350">
+                      <a:solidFill>
+                        <a:srgbClr val="D6DCE2"/>
+                      </a:solidFill>
+                    </a:lnR>
+                    <a:lnT w="6350">
+                      <a:solidFill>
+                        <a:srgbClr val="D6DCE2"/>
+                      </a:solidFill>
+                    </a:lnT>
+                    <a:lnB w="6350">
+                      <a:solidFill>
+                        <a:srgbClr val="D6DCE2"/>
+                      </a:solidFill>
+                    </a:lnB>
+                  </a:tcPr>
+                </a:tc>
+                <a:tc>
+                  <a:txBody>
+                    <a:bodyPr wrap="square"/>
+                    <a:lstStyle/>
+                    <a:p>
+                      <a:pPr algn="l">
+                        <a:spcBef>
+                          <a:spcPts val="0"/>
+                        </a:spcBef>
+                        <a:spcAft>
+                          <a:spcPts val="0"/>
+                        </a:spcAft>
+                        <a:lnSpc>
+                          <a:spcPct val="100000"/>
+                        </a:lnSpc>
+                      </a:pPr>
+                      <a:r>
+                        <a:rPr sz="1200" b="1">
+                          <a:solidFill>
+                            <a:srgbClr val="FFFFFF"/>
+                          </a:solidFill>
+                          <a:latin typeface="Microsoft YaHei"/>
+                          <a:ea typeface="Microsoft YaHei"/>
+                          <a:cs typeface="Microsoft YaHei"/>
+                        </a:rPr>
+                        <a:t>读专家权重</a:t>
+                      </a:r>
+                    </a:p>
+                  </a:txBody>
+                  <a:tcPr marL="54864" marR="54864" marT="27432" marB="18288" anchor="ctr">
+                    <a:solidFill>
+                      <a:srgbClr val="0E2A47"/>
+                    </a:solidFill>
+                    <a:lnL w="6350">
+                      <a:solidFill>
+                        <a:srgbClr val="D6DCE2"/>
+                      </a:solidFill>
+                    </a:lnL>
+                    <a:lnR w="6350">
+                      <a:solidFill>
+                        <a:srgbClr val="D6DCE2"/>
+                      </a:solidFill>
+                    </a:lnR>
+                    <a:lnT w="6350">
+                      <a:solidFill>
+                        <a:srgbClr val="D6DCE2"/>
+                      </a:solidFill>
+                    </a:lnT>
+                    <a:lnB w="6350">
+                      <a:solidFill>
+                        <a:srgbClr val="D6DCE2"/>
+                      </a:solidFill>
+                    </a:lnB>
+                  </a:tcPr>
+                </a:tc>
+                <a:tc>
+                  <a:txBody>
+                    <a:bodyPr wrap="square"/>
+                    <a:lstStyle/>
+                    <a:p>
+                      <a:pPr algn="l">
+                        <a:spcBef>
+                          <a:spcPts val="0"/>
+                        </a:spcBef>
+                        <a:spcAft>
+                          <a:spcPts val="0"/>
+                        </a:spcAft>
+                        <a:lnSpc>
+                          <a:spcPct val="100000"/>
+                        </a:lnSpc>
+                      </a:pPr>
+                      <a:r>
+                        <a:rPr sz="1200" b="1">
+                          <a:solidFill>
+                            <a:srgbClr val="FFFFFF"/>
+                          </a:solidFill>
+                          <a:latin typeface="Microsoft YaHei"/>
+                          <a:ea typeface="Microsoft YaHei"/>
+                          <a:cs typeface="Microsoft YaHei"/>
+                        </a:rPr>
+                        <a:t>专家GEMM</a:t>
+                      </a:r>
+                    </a:p>
+                  </a:txBody>
+                  <a:tcPr marL="54864" marR="54864" marT="27432" marB="18288" anchor="ctr">
+                    <a:solidFill>
+                      <a:srgbClr val="0E2A47"/>
+                    </a:solidFill>
+                    <a:lnL w="6350">
+                      <a:solidFill>
+                        <a:srgbClr val="D6DCE2"/>
+                      </a:solidFill>
+                    </a:lnL>
+                    <a:lnR w="6350">
+                      <a:solidFill>
+                        <a:srgbClr val="D6DCE2"/>
+                      </a:solidFill>
+                    </a:lnR>
+                    <a:lnT w="6350">
+                      <a:solidFill>
+                        <a:srgbClr val="D6DCE2"/>
+                      </a:solidFill>
+                    </a:lnT>
+                    <a:lnB w="6350">
+                      <a:solidFill>
+                        <a:srgbClr val="D6DCE2"/>
+                      </a:solidFill>
+                    </a:lnB>
+                  </a:tcPr>
+                </a:tc>
+                <a:tc>
+                  <a:txBody>
+                    <a:bodyPr wrap="square"/>
+                    <a:lstStyle/>
+                    <a:p>
+                      <a:pPr algn="l">
+                        <a:spcBef>
+                          <a:spcPts val="0"/>
+                        </a:spcBef>
+                        <a:spcAft>
+                          <a:spcPts val="0"/>
+                        </a:spcAft>
+                        <a:lnSpc>
+                          <a:spcPct val="100000"/>
+                        </a:lnSpc>
+                      </a:pPr>
+                      <a:r>
+                        <a:rPr sz="1200" b="1">
+                          <a:solidFill>
+                            <a:srgbClr val="FFFFFF"/>
+                          </a:solidFill>
+                          <a:latin typeface="Microsoft YaHei"/>
+                          <a:ea typeface="Microsoft YaHei"/>
+                          <a:cs typeface="Microsoft YaHei"/>
+                        </a:rPr>
+                        <a:t>combine</a:t>
+                      </a:r>
+                    </a:p>
+                  </a:txBody>
+                  <a:tcPr marL="54864" marR="54864" marT="27432" marB="18288" anchor="ctr">
+                    <a:solidFill>
+                      <a:srgbClr val="0E2A47"/>
+                    </a:solidFill>
+                    <a:lnL w="6350">
+                      <a:solidFill>
+                        <a:srgbClr val="D6DCE2"/>
+                      </a:solidFill>
+                    </a:lnL>
+                    <a:lnR w="6350">
+                      <a:solidFill>
+                        <a:srgbClr val="D6DCE2"/>
+                      </a:solidFill>
+                    </a:lnR>
+                    <a:lnT w="6350">
+                      <a:solidFill>
+                        <a:srgbClr val="D6DCE2"/>
+                      </a:solidFill>
+                    </a:lnT>
+                    <a:lnB w="6350">
+                      <a:solidFill>
+                        <a:srgbClr val="D6DCE2"/>
+                      </a:solidFill>
+                    </a:lnB>
+                  </a:tcPr>
+                </a:tc>
+                <a:tc>
+                  <a:txBody>
+                    <a:bodyPr wrap="square"/>
+                    <a:lstStyle/>
+                    <a:p>
+                      <a:pPr algn="l">
+                        <a:spcBef>
+                          <a:spcPts val="0"/>
+                        </a:spcBef>
+                        <a:spcAft>
+                          <a:spcPts val="0"/>
+                        </a:spcAft>
+                        <a:lnSpc>
+                          <a:spcPct val="100000"/>
+                        </a:lnSpc>
+                      </a:pPr>
+                      <a:r>
+                        <a:rPr sz="1200" b="1">
+                          <a:solidFill>
+                            <a:srgbClr val="FFFFFF"/>
+                          </a:solidFill>
+                          <a:latin typeface="Microsoft YaHei"/>
+                          <a:ea typeface="Microsoft YaHei"/>
+                          <a:cs typeface="Microsoft YaHei"/>
+                        </a:rPr>
+                        <a:t>MoE合计</a:t>
+                      </a:r>
+                    </a:p>
+                  </a:txBody>
+                  <a:tcPr marL="54864" marR="54864" marT="27432" marB="18288" anchor="ctr">
+                    <a:solidFill>
+                      <a:srgbClr val="0E2A47"/>
+                    </a:solidFill>
+                    <a:lnL w="6350">
+                      <a:solidFill>
+                        <a:srgbClr val="D6DCE2"/>
+                      </a:solidFill>
+                    </a:lnL>
+                    <a:lnR w="6350">
+                      <a:solidFill>
+                        <a:srgbClr val="D6DCE2"/>
+                      </a:solidFill>
+                    </a:lnR>
+                    <a:lnT w="6350">
+                      <a:solidFill>
+                        <a:srgbClr val="D6DCE2"/>
+                      </a:solidFill>
+                    </a:lnT>
+                    <a:lnB w="6350">
+                      <a:solidFill>
+                        <a:srgbClr val="D6DCE2"/>
+                      </a:solidFill>
+                    </a:lnB>
+                  </a:tcPr>
+                </a:tc>
+              </a:tr>
+              <a:tr h="393192">
+                <a:tc>
+                  <a:txBody>
+                    <a:bodyPr wrap="square"/>
+                    <a:lstStyle/>
+                    <a:p>
+                      <a:pPr algn="l">
+                        <a:spcBef>
+                          <a:spcPts val="0"/>
+                        </a:spcBef>
+                        <a:spcAft>
+                          <a:spcPts val="0"/>
+                        </a:spcAft>
+                        <a:lnSpc>
+                          <a:spcPct val="100000"/>
+                        </a:lnSpc>
+                      </a:pPr>
+                      <a:r>
+                        <a:rPr sz="1200" b="1">
+                          <a:solidFill>
+                            <a:srgbClr val="0E7A76"/>
+                          </a:solidFill>
+                          <a:latin typeface="Microsoft YaHei"/>
+                          <a:ea typeface="Microsoft YaHei"/>
+                          <a:cs typeface="Microsoft YaHei"/>
+                        </a:rPr>
+                        <a:t>4K</a:t>
+                      </a:r>
+                    </a:p>
+                  </a:txBody>
+                  <a:tcPr marL="54864" marR="54864" marT="27432" marB="18288" anchor="ctr">
+                    <a:solidFill>
+                      <a:srgbClr val="F4F7FA"/>
+                    </a:solidFill>
+                    <a:lnL w="6350">
+                      <a:solidFill>
+                        <a:srgbClr val="D6DCE2"/>
+                      </a:solidFill>
+                    </a:lnL>
+                    <a:lnR w="6350">
+                      <a:solidFill>
+                        <a:srgbClr val="D6DCE2"/>
+                      </a:solidFill>
+                    </a:lnR>
+                    <a:lnT w="6350">
+                      <a:solidFill>
+                        <a:srgbClr val="D6DCE2"/>
+                      </a:solidFill>
+                    </a:lnT>
+                    <a:lnB w="6350">
+                      <a:solidFill>
+                        <a:srgbClr val="D6DCE2"/>
+                      </a:solidFill>
+                    </a:lnB>
+                  </a:tcPr>
+                </a:tc>
+                <a:tc>
+                  <a:txBody>
+                    <a:bodyPr wrap="square"/>
+                    <a:lstStyle/>
+                    <a:p>
+                      <a:pPr algn="l">
+                        <a:spcBef>
+                          <a:spcPts val="0"/>
+                        </a:spcBef>
+                        <a:spcAft>
+                          <a:spcPts val="0"/>
+                        </a:spcAft>
+                        <a:lnSpc>
+                          <a:spcPct val="100000"/>
+                        </a:lnSpc>
+                      </a:pPr>
+                      <a:r>
+                        <a:rPr sz="1200" b="1">
+                          <a:solidFill>
+                            <a:srgbClr val="0E7A76"/>
+                          </a:solidFill>
+                          <a:latin typeface="Microsoft YaHei"/>
+                          <a:ea typeface="Microsoft YaHei"/>
+                          <a:cs typeface="Microsoft YaHei"/>
+                        </a:rPr>
+                        <a:t>45674</a:t>
+                      </a:r>
+                    </a:p>
+                  </a:txBody>
+                  <a:tcPr marL="54864" marR="54864" marT="27432" marB="18288" anchor="ctr">
+                    <a:solidFill>
+                      <a:srgbClr val="E7F3F2"/>
+                    </a:solidFill>
+                    <a:lnL w="6350">
+                      <a:solidFill>
+                        <a:srgbClr val="D6DCE2"/>
+                      </a:solidFill>
+                    </a:lnL>
+                    <a:lnR w="6350">
+                      <a:solidFill>
+                        <a:srgbClr val="D6DCE2"/>
+                      </a:solidFill>
+                    </a:lnR>
+                    <a:lnT w="6350">
+                      <a:solidFill>
+                        <a:srgbClr val="D6DCE2"/>
+                      </a:solidFill>
+                    </a:lnT>
+                    <a:lnB w="6350">
+                      <a:solidFill>
+                        <a:srgbClr val="D6DCE2"/>
+                      </a:solidFill>
+                    </a:lnB>
+                  </a:tcPr>
+                </a:tc>
+                <a:tc>
+                  <a:txBody>
+                    <a:bodyPr wrap="square"/>
+                    <a:lstStyle/>
+                    <a:p>
+                      <a:pPr algn="l">
+                        <a:spcBef>
+                          <a:spcPts val="0"/>
+                        </a:spcBef>
+                        <a:spcAft>
+                          <a:spcPts val="0"/>
+                        </a:spcAft>
+                        <a:lnSpc>
+                          <a:spcPct val="100000"/>
+                        </a:lnSpc>
+                      </a:pPr>
+                      <a:r>
+                        <a:rPr sz="1200" b="1">
+                          <a:solidFill>
+                            <a:srgbClr val="0E7A76"/>
+                          </a:solidFill>
+                          <a:latin typeface="Microsoft YaHei"/>
+                          <a:ea typeface="Microsoft YaHei"/>
+                          <a:cs typeface="Microsoft YaHei"/>
+                        </a:rPr>
+                        <a:t>3.74×10^6</a:t>
+                      </a:r>
+                    </a:p>
+                  </a:txBody>
+                  <a:tcPr marL="54864" marR="54864" marT="27432" marB="18288" anchor="ctr">
+                    <a:solidFill>
+                      <a:srgbClr val="E7F3F2"/>
+                    </a:solidFill>
+                    <a:lnL w="6350">
+                      <a:solidFill>
+                        <a:srgbClr val="D6DCE2"/>
+                      </a:solidFill>
+                    </a:lnL>
+                    <a:lnR w="6350">
+                      <a:solidFill>
+                        <a:srgbClr val="D6DCE2"/>
+                      </a:solidFill>
+                    </a:lnR>
+                    <a:lnT w="6350">
+                      <a:solidFill>
+                        <a:srgbClr val="D6DCE2"/>
+                      </a:solidFill>
+                    </a:lnT>
+                    <a:lnB w="6350">
+                      <a:solidFill>
+                        <a:srgbClr val="D6DCE2"/>
+                      </a:solidFill>
+                    </a:lnB>
+                  </a:tcPr>
+                </a:tc>
+                <a:tc>
+                  <a:txBody>
+                    <a:bodyPr wrap="square"/>
+                    <a:lstStyle/>
+                    <a:p>
+                      <a:pPr algn="l">
+                        <a:spcBef>
+                          <a:spcPts val="0"/>
+                        </a:spcBef>
+                        <a:spcAft>
+                          <a:spcPts val="0"/>
+                        </a:spcAft>
+                        <a:lnSpc>
+                          <a:spcPct val="100000"/>
+                        </a:lnSpc>
+                      </a:pPr>
+                      <a:r>
+                        <a:rPr sz="1200" b="1">
+                          <a:solidFill>
+                            <a:srgbClr val="0E7A76"/>
+                          </a:solidFill>
+                          <a:latin typeface="Microsoft YaHei"/>
+                          <a:ea typeface="Microsoft YaHei"/>
+                          <a:cs typeface="Microsoft YaHei"/>
+                        </a:rPr>
+                        <a:t>0.48 秒</a:t>
+                      </a:r>
+                    </a:p>
+                  </a:txBody>
+                  <a:tcPr marL="54864" marR="54864" marT="27432" marB="18288" anchor="ctr">
+                    <a:solidFill>
+                      <a:srgbClr val="E7F3F2"/>
+                    </a:solidFill>
+                    <a:lnL w="6350">
+                      <a:solidFill>
+                        <a:srgbClr val="D6DCE2"/>
+                      </a:solidFill>
+                    </a:lnL>
+                    <a:lnR w="6350">
+                      <a:solidFill>
+                        <a:srgbClr val="D6DCE2"/>
+                      </a:solidFill>
+                    </a:lnR>
+                    <a:lnT w="6350">
+                      <a:solidFill>
+                        <a:srgbClr val="D6DCE2"/>
+                      </a:solidFill>
+                    </a:lnT>
+                    <a:lnB w="6350">
+                      <a:solidFill>
+                        <a:srgbClr val="D6DCE2"/>
+                      </a:solidFill>
+                    </a:lnB>
+                  </a:tcPr>
+                </a:tc>
+                <a:tc>
+                  <a:txBody>
+                    <a:bodyPr wrap="square"/>
+                    <a:lstStyle/>
+                    <a:p>
+                      <a:pPr algn="l">
+                        <a:spcBef>
+                          <a:spcPts val="0"/>
+                        </a:spcBef>
+                        <a:spcAft>
+                          <a:spcPts val="0"/>
+                        </a:spcAft>
+                        <a:lnSpc>
+                          <a:spcPct val="100000"/>
+                        </a:lnSpc>
+                      </a:pPr>
+                      <a:r>
+                        <a:rPr sz="1200" b="1">
+                          <a:solidFill>
+                            <a:srgbClr val="0E7A76"/>
+                          </a:solidFill>
+                          <a:latin typeface="Microsoft YaHei"/>
+                          <a:ea typeface="Microsoft YaHei"/>
+                          <a:cs typeface="Microsoft YaHei"/>
+                        </a:rPr>
+                        <a:t>13.4 毫秒</a:t>
+                      </a:r>
+                    </a:p>
+                  </a:txBody>
+                  <a:tcPr marL="54864" marR="54864" marT="27432" marB="18288" anchor="ctr">
+                    <a:solidFill>
+                      <a:srgbClr val="E7F3F2"/>
+                    </a:solidFill>
+                    <a:lnL w="6350">
+                      <a:solidFill>
+                        <a:srgbClr val="D6DCE2"/>
+                      </a:solidFill>
+                    </a:lnL>
+                    <a:lnR w="6350">
+                      <a:solidFill>
+                        <a:srgbClr val="D6DCE2"/>
+                      </a:solidFill>
+                    </a:lnR>
+                    <a:lnT w="6350">
+                      <a:solidFill>
+                        <a:srgbClr val="D6DCE2"/>
+                      </a:solidFill>
+                    </a:lnT>
+                    <a:lnB w="6350">
+                      <a:solidFill>
+                        <a:srgbClr val="D6DCE2"/>
+                      </a:solidFill>
+                    </a:lnB>
+                  </a:tcPr>
+                </a:tc>
+                <a:tc>
+                  <a:txBody>
+                    <a:bodyPr wrap="square"/>
+                    <a:lstStyle/>
+                    <a:p>
+                      <a:pPr algn="l">
+                        <a:spcBef>
+                          <a:spcPts val="0"/>
+                        </a:spcBef>
+                        <a:spcAft>
+                          <a:spcPts val="0"/>
+                        </a:spcAft>
+                        <a:lnSpc>
+                          <a:spcPct val="100000"/>
+                        </a:lnSpc>
+                      </a:pPr>
+                      <a:r>
+                        <a:rPr sz="1200" b="1">
+                          <a:solidFill>
+                            <a:srgbClr val="0E7A76"/>
+                          </a:solidFill>
+                          <a:latin typeface="Microsoft YaHei"/>
+                          <a:ea typeface="Microsoft YaHei"/>
+                          <a:cs typeface="Microsoft YaHei"/>
+                        </a:rPr>
+                        <a:t>4.87 秒</a:t>
+                      </a:r>
+                    </a:p>
+                  </a:txBody>
+                  <a:tcPr marL="54864" marR="54864" marT="27432" marB="18288" anchor="ctr">
+                    <a:solidFill>
+                      <a:srgbClr val="E7F3F2"/>
+                    </a:solidFill>
+                    <a:lnL w="6350">
+                      <a:solidFill>
+                        <a:srgbClr val="D6DCE2"/>
+                      </a:solidFill>
+                    </a:lnL>
+                    <a:lnR w="6350">
+                      <a:solidFill>
+                        <a:srgbClr val="D6DCE2"/>
+                      </a:solidFill>
+                    </a:lnR>
+                    <a:lnT w="6350">
+                      <a:solidFill>
+                        <a:srgbClr val="D6DCE2"/>
+                      </a:solidFill>
+                    </a:lnT>
+                    <a:lnB w="6350">
+                      <a:solidFill>
+                        <a:srgbClr val="D6DCE2"/>
+                      </a:solidFill>
+                    </a:lnB>
+                  </a:tcPr>
+                </a:tc>
+                <a:tc>
+                  <a:txBody>
+                    <a:bodyPr wrap="square"/>
+                    <a:lstStyle/>
+                    <a:p>
+                      <a:pPr algn="l">
+                        <a:spcBef>
+                          <a:spcPts val="0"/>
+                        </a:spcBef>
+                        <a:spcAft>
+                          <a:spcPts val="0"/>
+                        </a:spcAft>
+                        <a:lnSpc>
+                          <a:spcPct val="100000"/>
+                        </a:lnSpc>
+                      </a:pPr>
+                      <a:r>
+                        <a:rPr sz="1200" b="1">
+                          <a:solidFill>
+                            <a:srgbClr val="0E7A76"/>
+                          </a:solidFill>
+                          <a:latin typeface="Microsoft YaHei"/>
+                          <a:ea typeface="Microsoft YaHei"/>
+                          <a:cs typeface="Microsoft YaHei"/>
+                        </a:rPr>
+                        <a:t>0.48 秒</a:t>
+                      </a:r>
+                    </a:p>
+                  </a:txBody>
+                  <a:tcPr marL="54864" marR="54864" marT="27432" marB="18288" anchor="ctr">
+                    <a:solidFill>
+                      <a:srgbClr val="E7F3F2"/>
+                    </a:solidFill>
+                    <a:lnL w="6350">
+                      <a:solidFill>
+                        <a:srgbClr val="D6DCE2"/>
+                      </a:solidFill>
+                    </a:lnL>
+                    <a:lnR w="6350">
+                      <a:solidFill>
+                        <a:srgbClr val="D6DCE2"/>
+                      </a:solidFill>
+                    </a:lnR>
+                    <a:lnT w="6350">
+                      <a:solidFill>
+                        <a:srgbClr val="D6DCE2"/>
+                      </a:solidFill>
+                    </a:lnT>
+                    <a:lnB w="6350">
+                      <a:solidFill>
+                        <a:srgbClr val="D6DCE2"/>
+                      </a:solidFill>
+                    </a:lnB>
+                  </a:tcPr>
+                </a:tc>
+                <a:tc>
+                  <a:txBody>
+                    <a:bodyPr wrap="square"/>
+                    <a:lstStyle/>
+                    <a:p>
+                      <a:pPr algn="l">
+                        <a:spcBef>
+                          <a:spcPts val="0"/>
+                        </a:spcBef>
+                        <a:spcAft>
+                          <a:spcPts val="0"/>
+                        </a:spcAft>
+                        <a:lnSpc>
+                          <a:spcPct val="100000"/>
+                        </a:lnSpc>
+                      </a:pPr>
+                      <a:r>
+                        <a:rPr sz="1200" b="1">
+                          <a:solidFill>
+                            <a:srgbClr val="0E7A76"/>
+                          </a:solidFill>
+                          <a:latin typeface="Microsoft YaHei"/>
+                          <a:ea typeface="Microsoft YaHei"/>
+                          <a:cs typeface="Microsoft YaHei"/>
+                        </a:rPr>
+                        <a:t>5.83 秒</a:t>
+                      </a:r>
+                    </a:p>
+                  </a:txBody>
+                  <a:tcPr marL="54864" marR="54864" marT="27432" marB="18288" anchor="ctr">
+                    <a:solidFill>
+                      <a:srgbClr val="E7F3F2"/>
+                    </a:solidFill>
+                    <a:lnL w="6350">
+                      <a:solidFill>
+                        <a:srgbClr val="D6DCE2"/>
+                      </a:solidFill>
+                    </a:lnL>
+                    <a:lnR w="6350">
+                      <a:solidFill>
+                        <a:srgbClr val="D6DCE2"/>
+                      </a:solidFill>
+                    </a:lnR>
+                    <a:lnT w="6350">
+                      <a:solidFill>
+                        <a:srgbClr val="D6DCE2"/>
+                      </a:solidFill>
+                    </a:lnT>
+                    <a:lnB w="6350">
+                      <a:solidFill>
+                        <a:srgbClr val="D6DCE2"/>
+                      </a:solidFill>
+                    </a:lnB>
+                  </a:tcPr>
+                </a:tc>
+              </a:tr>
+              <a:tr h="393192">
+                <a:tc>
+                  <a:txBody>
+                    <a:bodyPr wrap="square"/>
+                    <a:lstStyle/>
+                    <a:p>
+                      <a:pPr algn="l">
+                        <a:spcBef>
+                          <a:spcPts val="0"/>
+                        </a:spcBef>
+                        <a:spcAft>
+                          <a:spcPts val="0"/>
+                        </a:spcAft>
+                        <a:lnSpc>
+                          <a:spcPct val="100000"/>
+                        </a:lnSpc>
+                      </a:pPr>
+                      <a:r>
+                        <a:rPr sz="1200" b="1">
+                          <a:solidFill>
+                            <a:srgbClr val="0E2A47"/>
+                          </a:solidFill>
+                          <a:latin typeface="Microsoft YaHei"/>
+                          <a:ea typeface="Microsoft YaHei"/>
+                          <a:cs typeface="Microsoft YaHei"/>
+                        </a:rPr>
+                        <a:t>8K</a:t>
+                      </a:r>
+                    </a:p>
+                  </a:txBody>
+                  <a:tcPr marL="54864" marR="54864" marT="27432" marB="18288" anchor="ctr">
+                    <a:solidFill>
+                      <a:srgbClr val="F4F7FA"/>
+                    </a:solidFill>
+                    <a:lnL w="6350">
+                      <a:solidFill>
+                        <a:srgbClr val="D6DCE2"/>
+                      </a:solidFill>
+                    </a:lnL>
+                    <a:lnR w="6350">
+                      <a:solidFill>
+                        <a:srgbClr val="D6DCE2"/>
+                      </a:solidFill>
+                    </a:lnR>
+                    <a:lnT w="6350">
+                      <a:solidFill>
+                        <a:srgbClr val="D6DCE2"/>
+                      </a:solidFill>
+                    </a:lnT>
+                    <a:lnB w="6350">
+                      <a:solidFill>
+                        <a:srgbClr val="D6DCE2"/>
+                      </a:solidFill>
+                    </a:lnB>
+                  </a:tcPr>
+                </a:tc>
+                <a:tc>
+                  <a:txBody>
+                    <a:bodyPr wrap="square"/>
+                    <a:lstStyle/>
+                    <a:p>
+                      <a:pPr algn="l">
+                        <a:spcBef>
+                          <a:spcPts val="0"/>
+                        </a:spcBef>
+                        <a:spcAft>
+                          <a:spcPts val="0"/>
+                        </a:spcAft>
+                        <a:lnSpc>
+                          <a:spcPct val="100000"/>
+                        </a:lnSpc>
+                      </a:pPr>
+                      <a:r>
+                        <a:rPr sz="1200" b="0">
+                          <a:solidFill>
+                            <a:srgbClr val="1C242E"/>
+                          </a:solidFill>
+                          <a:latin typeface="Microsoft YaHei"/>
+                          <a:ea typeface="Microsoft YaHei"/>
+                          <a:cs typeface="Microsoft YaHei"/>
+                        </a:rPr>
+                        <a:t>22676</a:t>
+                      </a:r>
+                    </a:p>
+                  </a:txBody>
+                  <a:tcPr marL="54864" marR="54864" marT="27432" marB="18288" anchor="ctr">
+                    <a:solidFill>
+                      <a:srgbClr val="FFFFFF"/>
+                    </a:solidFill>
+                    <a:lnL w="6350">
+                      <a:solidFill>
+                        <a:srgbClr val="D6DCE2"/>
+                      </a:solidFill>
+                    </a:lnL>
+                    <a:lnR w="6350">
+                      <a:solidFill>
+                        <a:srgbClr val="D6DCE2"/>
+                      </a:solidFill>
+                    </a:lnR>
+                    <a:lnT w="6350">
+                      <a:solidFill>
+                        <a:srgbClr val="D6DCE2"/>
+                      </a:solidFill>
+                    </a:lnT>
+                    <a:lnB w="6350">
+                      <a:solidFill>
+                        <a:srgbClr val="D6DCE2"/>
+                      </a:solidFill>
+                    </a:lnB>
+                  </a:tcPr>
+                </a:tc>
+                <a:tc>
+                  <a:txBody>
+                    <a:bodyPr wrap="square"/>
+                    <a:lstStyle/>
+                    <a:p>
+                      <a:pPr algn="l">
+                        <a:spcBef>
+                          <a:spcPts val="0"/>
+                        </a:spcBef>
+                        <a:spcAft>
+                          <a:spcPts val="0"/>
+                        </a:spcAft>
+                        <a:lnSpc>
+                          <a:spcPct val="100000"/>
+                        </a:lnSpc>
+                      </a:pPr>
+                      <a:r>
+                        <a:rPr sz="1200" b="0">
+                          <a:solidFill>
+                            <a:srgbClr val="1C242E"/>
+                          </a:solidFill>
+                          <a:latin typeface="Microsoft YaHei"/>
+                          <a:ea typeface="Microsoft YaHei"/>
+                          <a:cs typeface="Microsoft YaHei"/>
+                        </a:rPr>
+                        <a:t>3.72×10^6</a:t>
+                      </a:r>
+                    </a:p>
+                  </a:txBody>
+                  <a:tcPr marL="54864" marR="54864" marT="27432" marB="18288" anchor="ctr">
+                    <a:solidFill>
+                      <a:srgbClr val="FFFFFF"/>
+                    </a:solidFill>
+                    <a:lnL w="6350">
+                      <a:solidFill>
+                        <a:srgbClr val="D6DCE2"/>
+                      </a:solidFill>
+                    </a:lnL>
+                    <a:lnR w="6350">
+                      <a:solidFill>
+                        <a:srgbClr val="D6DCE2"/>
+                      </a:solidFill>
+                    </a:lnR>
+                    <a:lnT w="6350">
+                      <a:solidFill>
+                        <a:srgbClr val="D6DCE2"/>
+                      </a:solidFill>
+                    </a:lnT>
+                    <a:lnB w="6350">
+                      <a:solidFill>
+                        <a:srgbClr val="D6DCE2"/>
+                      </a:solidFill>
+                    </a:lnB>
+                  </a:tcPr>
+                </a:tc>
+                <a:tc>
+                  <a:txBody>
+                    <a:bodyPr wrap="square"/>
+                    <a:lstStyle/>
+                    <a:p>
+                      <a:pPr algn="l">
+                        <a:spcBef>
+                          <a:spcPts val="0"/>
+                        </a:spcBef>
+                        <a:spcAft>
+                          <a:spcPts val="0"/>
+                        </a:spcAft>
+                        <a:lnSpc>
+                          <a:spcPct val="100000"/>
+                        </a:lnSpc>
+                      </a:pPr>
+                      <a:r>
+                        <a:rPr sz="1200" b="0">
+                          <a:solidFill>
+                            <a:srgbClr val="1C242E"/>
+                          </a:solidFill>
+                          <a:latin typeface="Microsoft YaHei"/>
+                          <a:ea typeface="Microsoft YaHei"/>
+                          <a:cs typeface="Microsoft YaHei"/>
+                        </a:rPr>
+                        <a:t>0.48 秒</a:t>
+                      </a:r>
+                    </a:p>
+                  </a:txBody>
+                  <a:tcPr marL="54864" marR="54864" marT="27432" marB="18288" anchor="ctr">
+                    <a:solidFill>
+                      <a:srgbClr val="FFFFFF"/>
+                    </a:solidFill>
+                    <a:lnL w="6350">
+                      <a:solidFill>
+                        <a:srgbClr val="D6DCE2"/>
+                      </a:solidFill>
+                    </a:lnL>
+                    <a:lnR w="6350">
+                      <a:solidFill>
+                        <a:srgbClr val="D6DCE2"/>
+                      </a:solidFill>
+                    </a:lnR>
+                    <a:lnT w="6350">
+                      <a:solidFill>
+                        <a:srgbClr val="D6DCE2"/>
+                      </a:solidFill>
+                    </a:lnT>
+                    <a:lnB w="6350">
+                      <a:solidFill>
+                        <a:srgbClr val="D6DCE2"/>
+                      </a:solidFill>
+                    </a:lnB>
+                  </a:tcPr>
+                </a:tc>
+                <a:tc>
+                  <a:txBody>
+                    <a:bodyPr wrap="square"/>
+                    <a:lstStyle/>
+                    <a:p>
+                      <a:pPr algn="l">
+                        <a:spcBef>
+                          <a:spcPts val="0"/>
+                        </a:spcBef>
+                        <a:spcAft>
+                          <a:spcPts val="0"/>
+                        </a:spcAft>
+                        <a:lnSpc>
+                          <a:spcPct val="100000"/>
+                        </a:lnSpc>
+                      </a:pPr>
+                      <a:r>
+                        <a:rPr sz="1200" b="0">
+                          <a:solidFill>
+                            <a:srgbClr val="1C242E"/>
+                          </a:solidFill>
+                          <a:latin typeface="Microsoft YaHei"/>
+                          <a:ea typeface="Microsoft YaHei"/>
+                          <a:cs typeface="Microsoft YaHei"/>
+                        </a:rPr>
+                        <a:t>13.4 毫秒</a:t>
+                      </a:r>
+                    </a:p>
+                  </a:txBody>
+                  <a:tcPr marL="54864" marR="54864" marT="27432" marB="18288" anchor="ctr">
+                    <a:solidFill>
+                      <a:srgbClr val="FFFFFF"/>
+                    </a:solidFill>
+                    <a:lnL w="6350">
+                      <a:solidFill>
+                        <a:srgbClr val="D6DCE2"/>
+                      </a:solidFill>
+                    </a:lnL>
+                    <a:lnR w="6350">
+                      <a:solidFill>
+                        <a:srgbClr val="D6DCE2"/>
+                      </a:solidFill>
+                    </a:lnR>
+                    <a:lnT w="6350">
+                      <a:solidFill>
+                        <a:srgbClr val="D6DCE2"/>
+                      </a:solidFill>
+                    </a:lnT>
+                    <a:lnB w="6350">
+                      <a:solidFill>
+                        <a:srgbClr val="D6DCE2"/>
+                      </a:solidFill>
+                    </a:lnB>
+                  </a:tcPr>
+                </a:tc>
+                <a:tc>
+                  <a:txBody>
+                    <a:bodyPr wrap="square"/>
+                    <a:lstStyle/>
+                    <a:p>
+                      <a:pPr algn="l">
+                        <a:spcBef>
+                          <a:spcPts val="0"/>
+                        </a:spcBef>
+                        <a:spcAft>
+                          <a:spcPts val="0"/>
+                        </a:spcAft>
+                        <a:lnSpc>
+                          <a:spcPct val="100000"/>
+                        </a:lnSpc>
+                      </a:pPr>
+                      <a:r>
+                        <a:rPr sz="1200" b="0">
+                          <a:solidFill>
+                            <a:srgbClr val="1C242E"/>
+                          </a:solidFill>
+                          <a:latin typeface="Microsoft YaHei"/>
+                          <a:ea typeface="Microsoft YaHei"/>
+                          <a:cs typeface="Microsoft YaHei"/>
+                        </a:rPr>
+                        <a:t>4.83 秒</a:t>
+                      </a:r>
+                    </a:p>
+                  </a:txBody>
+                  <a:tcPr marL="54864" marR="54864" marT="27432" marB="18288" anchor="ctr">
+                    <a:solidFill>
+                      <a:srgbClr val="FFFFFF"/>
+                    </a:solidFill>
+                    <a:lnL w="6350">
+                      <a:solidFill>
+                        <a:srgbClr val="D6DCE2"/>
+                      </a:solidFill>
+                    </a:lnL>
+                    <a:lnR w="6350">
+                      <a:solidFill>
+                        <a:srgbClr val="D6DCE2"/>
+                      </a:solidFill>
+                    </a:lnR>
+                    <a:lnT w="6350">
+                      <a:solidFill>
+                        <a:srgbClr val="D6DCE2"/>
+                      </a:solidFill>
+                    </a:lnT>
+                    <a:lnB w="6350">
+                      <a:solidFill>
+                        <a:srgbClr val="D6DCE2"/>
+                      </a:solidFill>
+                    </a:lnB>
+                  </a:tcPr>
+                </a:tc>
+                <a:tc>
+                  <a:txBody>
+                    <a:bodyPr wrap="square"/>
+                    <a:lstStyle/>
+                    <a:p>
+                      <a:pPr algn="l">
+                        <a:spcBef>
+                          <a:spcPts val="0"/>
+                        </a:spcBef>
+                        <a:spcAft>
+                          <a:spcPts val="0"/>
+                        </a:spcAft>
+                        <a:lnSpc>
+                          <a:spcPct val="100000"/>
+                        </a:lnSpc>
+                      </a:pPr>
+                      <a:r>
+                        <a:rPr sz="1200" b="0">
+                          <a:solidFill>
+                            <a:srgbClr val="1C242E"/>
+                          </a:solidFill>
+                          <a:latin typeface="Microsoft YaHei"/>
+                          <a:ea typeface="Microsoft YaHei"/>
+                          <a:cs typeface="Microsoft YaHei"/>
+                        </a:rPr>
+                        <a:t>0.48 秒</a:t>
+                      </a:r>
+                    </a:p>
+                  </a:txBody>
+                  <a:tcPr marL="54864" marR="54864" marT="27432" marB="18288" anchor="ctr">
+                    <a:solidFill>
+                      <a:srgbClr val="FFFFFF"/>
+                    </a:solidFill>
+                    <a:lnL w="6350">
+                      <a:solidFill>
+                        <a:srgbClr val="D6DCE2"/>
+                      </a:solidFill>
+                    </a:lnL>
+                    <a:lnR w="6350">
+                      <a:solidFill>
+                        <a:srgbClr val="D6DCE2"/>
+                      </a:solidFill>
+                    </a:lnR>
+                    <a:lnT w="6350">
+                      <a:solidFill>
+                        <a:srgbClr val="D6DCE2"/>
+                      </a:solidFill>
+                    </a:lnT>
+                    <a:lnB w="6350">
+                      <a:solidFill>
+                        <a:srgbClr val="D6DCE2"/>
+                      </a:solidFill>
+                    </a:lnB>
+                  </a:tcPr>
+                </a:tc>
+                <a:tc>
+                  <a:txBody>
+                    <a:bodyPr wrap="square"/>
+                    <a:lstStyle/>
+                    <a:p>
+                      <a:pPr algn="l">
+                        <a:spcBef>
+                          <a:spcPts val="0"/>
+                        </a:spcBef>
+                        <a:spcAft>
+                          <a:spcPts val="0"/>
+                        </a:spcAft>
+                        <a:lnSpc>
+                          <a:spcPct val="100000"/>
+                        </a:lnSpc>
+                      </a:pPr>
+                      <a:r>
+                        <a:rPr sz="1200" b="0">
+                          <a:solidFill>
+                            <a:srgbClr val="1C242E"/>
+                          </a:solidFill>
+                          <a:latin typeface="Microsoft YaHei"/>
+                          <a:ea typeface="Microsoft YaHei"/>
+                          <a:cs typeface="Microsoft YaHei"/>
+                        </a:rPr>
+                        <a:t>5.79 秒</a:t>
+                      </a:r>
+                    </a:p>
+                  </a:txBody>
+                  <a:tcPr marL="54864" marR="54864" marT="27432" marB="18288" anchor="ctr">
+                    <a:solidFill>
+                      <a:srgbClr val="FFFFFF"/>
+                    </a:solidFill>
+                    <a:lnL w="6350">
+                      <a:solidFill>
+                        <a:srgbClr val="D6DCE2"/>
+                      </a:solidFill>
+                    </a:lnL>
+                    <a:lnR w="6350">
+                      <a:solidFill>
+                        <a:srgbClr val="D6DCE2"/>
+                      </a:solidFill>
+                    </a:lnR>
+                    <a:lnT w="6350">
+                      <a:solidFill>
+                        <a:srgbClr val="D6DCE2"/>
+                      </a:solidFill>
+                    </a:lnT>
+                    <a:lnB w="6350">
+                      <a:solidFill>
+                        <a:srgbClr val="D6DCE2"/>
+                      </a:solidFill>
+                    </a:lnB>
+                  </a:tcPr>
+                </a:tc>
+              </a:tr>
+              <a:tr h="393192">
+                <a:tc>
+                  <a:txBody>
+                    <a:bodyPr wrap="square"/>
+                    <a:lstStyle/>
+                    <a:p>
+                      <a:pPr algn="l">
+                        <a:spcBef>
+                          <a:spcPts val="0"/>
+                        </a:spcBef>
+                        <a:spcAft>
+                          <a:spcPts val="0"/>
+                        </a:spcAft>
+                        <a:lnSpc>
+                          <a:spcPct val="100000"/>
+                        </a:lnSpc>
+                      </a:pPr>
+                      <a:r>
+                        <a:rPr sz="1200" b="1">
+                          <a:solidFill>
+                            <a:srgbClr val="0E2A47"/>
+                          </a:solidFill>
+                          <a:latin typeface="Microsoft YaHei"/>
+                          <a:ea typeface="Microsoft YaHei"/>
+                          <a:cs typeface="Microsoft YaHei"/>
+                        </a:rPr>
+                        <a:t>32K</a:t>
+                      </a:r>
+                    </a:p>
+                  </a:txBody>
+                  <a:tcPr marL="54864" marR="54864" marT="27432" marB="18288" anchor="ctr">
+                    <a:solidFill>
+                      <a:srgbClr val="F4F7FA"/>
+                    </a:solidFill>
+                    <a:lnL w="6350">
+                      <a:solidFill>
+                        <a:srgbClr val="D6DCE2"/>
+                      </a:solidFill>
+                    </a:lnL>
+                    <a:lnR w="6350">
+                      <a:solidFill>
+                        <a:srgbClr val="D6DCE2"/>
+                      </a:solidFill>
+                    </a:lnR>
+                    <a:lnT w="6350">
+                      <a:solidFill>
+                        <a:srgbClr val="D6DCE2"/>
+                      </a:solidFill>
+                    </a:lnT>
+                    <a:lnB w="6350">
+                      <a:solidFill>
+                        <a:srgbClr val="D6DCE2"/>
+                      </a:solidFill>
+                    </a:lnB>
+                  </a:tcPr>
+                </a:tc>
+                <a:tc>
+                  <a:txBody>
+                    <a:bodyPr wrap="square"/>
+                    <a:lstStyle/>
+                    <a:p>
+                      <a:pPr algn="l">
+                        <a:spcBef>
+                          <a:spcPts val="0"/>
+                        </a:spcBef>
+                        <a:spcAft>
+                          <a:spcPts val="0"/>
+                        </a:spcAft>
+                        <a:lnSpc>
+                          <a:spcPct val="100000"/>
+                        </a:lnSpc>
+                      </a:pPr>
+                      <a:r>
+                        <a:rPr sz="1200" b="0">
+                          <a:solidFill>
+                            <a:srgbClr val="1C242E"/>
+                          </a:solidFill>
+                          <a:latin typeface="Microsoft YaHei"/>
+                          <a:ea typeface="Microsoft YaHei"/>
+                          <a:cs typeface="Microsoft YaHei"/>
+                        </a:rPr>
+                        <a:t>5456</a:t>
+                      </a:r>
+                    </a:p>
+                  </a:txBody>
+                  <a:tcPr marL="54864" marR="54864" marT="27432" marB="18288" anchor="ctr">
+                    <a:solidFill>
+                      <a:srgbClr val="FFFFFF"/>
+                    </a:solidFill>
+                    <a:lnL w="6350">
+                      <a:solidFill>
+                        <a:srgbClr val="D6DCE2"/>
+                      </a:solidFill>
+                    </a:lnL>
+                    <a:lnR w="6350">
+                      <a:solidFill>
+                        <a:srgbClr val="D6DCE2"/>
+                      </a:solidFill>
+                    </a:lnR>
+                    <a:lnT w="6350">
+                      <a:solidFill>
+                        <a:srgbClr val="D6DCE2"/>
+                      </a:solidFill>
+                    </a:lnT>
+                    <a:lnB w="6350">
+                      <a:solidFill>
+                        <a:srgbClr val="D6DCE2"/>
+                      </a:solidFill>
+                    </a:lnB>
+                  </a:tcPr>
+                </a:tc>
+                <a:tc>
+                  <a:txBody>
+                    <a:bodyPr wrap="square"/>
+                    <a:lstStyle/>
+                    <a:p>
+                      <a:pPr algn="l">
+                        <a:spcBef>
+                          <a:spcPts val="0"/>
+                        </a:spcBef>
+                        <a:spcAft>
+                          <a:spcPts val="0"/>
+                        </a:spcAft>
+                        <a:lnSpc>
+                          <a:spcPct val="100000"/>
+                        </a:lnSpc>
+                      </a:pPr>
+                      <a:r>
+                        <a:rPr sz="1200" b="0">
+                          <a:solidFill>
+                            <a:srgbClr val="1C242E"/>
+                          </a:solidFill>
+                          <a:latin typeface="Microsoft YaHei"/>
+                          <a:ea typeface="Microsoft YaHei"/>
+                          <a:cs typeface="Microsoft YaHei"/>
+                        </a:rPr>
+                        <a:t>3.58×10^6</a:t>
+                      </a:r>
+                    </a:p>
+                  </a:txBody>
+                  <a:tcPr marL="54864" marR="54864" marT="27432" marB="18288" anchor="ctr">
+                    <a:solidFill>
+                      <a:srgbClr val="FFFFFF"/>
+                    </a:solidFill>
+                    <a:lnL w="6350">
+                      <a:solidFill>
+                        <a:srgbClr val="D6DCE2"/>
+                      </a:solidFill>
+                    </a:lnL>
+                    <a:lnR w="6350">
+                      <a:solidFill>
+                        <a:srgbClr val="D6DCE2"/>
+                      </a:solidFill>
+                    </a:lnR>
+                    <a:lnT w="6350">
+                      <a:solidFill>
+                        <a:srgbClr val="D6DCE2"/>
+                      </a:solidFill>
+                    </a:lnT>
+                    <a:lnB w="6350">
+                      <a:solidFill>
+                        <a:srgbClr val="D6DCE2"/>
+                      </a:solidFill>
+                    </a:lnB>
+                  </a:tcPr>
+                </a:tc>
+                <a:tc>
+                  <a:txBody>
+                    <a:bodyPr wrap="square"/>
+                    <a:lstStyle/>
+                    <a:p>
+                      <a:pPr algn="l">
+                        <a:spcBef>
+                          <a:spcPts val="0"/>
+                        </a:spcBef>
+                        <a:spcAft>
+                          <a:spcPts val="0"/>
+                        </a:spcAft>
+                        <a:lnSpc>
+                          <a:spcPct val="100000"/>
+                        </a:lnSpc>
+                      </a:pPr>
+                      <a:r>
+                        <a:rPr sz="1200" b="0">
+                          <a:solidFill>
+                            <a:srgbClr val="1C242E"/>
+                          </a:solidFill>
+                          <a:latin typeface="Microsoft YaHei"/>
+                          <a:ea typeface="Microsoft YaHei"/>
+                          <a:cs typeface="Microsoft YaHei"/>
+                        </a:rPr>
+                        <a:t>0.46 秒</a:t>
+                      </a:r>
+                    </a:p>
+                  </a:txBody>
+                  <a:tcPr marL="54864" marR="54864" marT="27432" marB="18288" anchor="ctr">
+                    <a:solidFill>
+                      <a:srgbClr val="FFFFFF"/>
+                    </a:solidFill>
+                    <a:lnL w="6350">
+                      <a:solidFill>
+                        <a:srgbClr val="D6DCE2"/>
+                      </a:solidFill>
+                    </a:lnL>
+                    <a:lnR w="6350">
+                      <a:solidFill>
+                        <a:srgbClr val="D6DCE2"/>
+                      </a:solidFill>
+                    </a:lnR>
+                    <a:lnT w="6350">
+                      <a:solidFill>
+                        <a:srgbClr val="D6DCE2"/>
+                      </a:solidFill>
+                    </a:lnT>
+                    <a:lnB w="6350">
+                      <a:solidFill>
+                        <a:srgbClr val="D6DCE2"/>
+                      </a:solidFill>
+                    </a:lnB>
+                  </a:tcPr>
+                </a:tc>
+                <a:tc>
+                  <a:txBody>
+                    <a:bodyPr wrap="square"/>
+                    <a:lstStyle/>
+                    <a:p>
+                      <a:pPr algn="l">
+                        <a:spcBef>
+                          <a:spcPts val="0"/>
+                        </a:spcBef>
+                        <a:spcAft>
+                          <a:spcPts val="0"/>
+                        </a:spcAft>
+                        <a:lnSpc>
+                          <a:spcPct val="100000"/>
+                        </a:lnSpc>
+                      </a:pPr>
+                      <a:r>
+                        <a:rPr sz="1200" b="0">
+                          <a:solidFill>
+                            <a:srgbClr val="1C242E"/>
+                          </a:solidFill>
+                          <a:latin typeface="Microsoft YaHei"/>
+                          <a:ea typeface="Microsoft YaHei"/>
+                          <a:cs typeface="Microsoft YaHei"/>
+                        </a:rPr>
+                        <a:t>13.4 毫秒</a:t>
+                      </a:r>
+                    </a:p>
+                  </a:txBody>
+                  <a:tcPr marL="54864" marR="54864" marT="27432" marB="18288" anchor="ctr">
+                    <a:solidFill>
+                      <a:srgbClr val="FFFFFF"/>
+                    </a:solidFill>
+                    <a:lnL w="6350">
+                      <a:solidFill>
+                        <a:srgbClr val="D6DCE2"/>
+                      </a:solidFill>
+                    </a:lnL>
+                    <a:lnR w="6350">
+                      <a:solidFill>
+                        <a:srgbClr val="D6DCE2"/>
+                      </a:solidFill>
+                    </a:lnR>
+                    <a:lnT w="6350">
+                      <a:solidFill>
+                        <a:srgbClr val="D6DCE2"/>
+                      </a:solidFill>
+                    </a:lnT>
+                    <a:lnB w="6350">
+                      <a:solidFill>
+                        <a:srgbClr val="D6DCE2"/>
+                      </a:solidFill>
+                    </a:lnB>
+                  </a:tcPr>
+                </a:tc>
+                <a:tc>
+                  <a:txBody>
+                    <a:bodyPr wrap="square"/>
+                    <a:lstStyle/>
+                    <a:p>
+                      <a:pPr algn="l">
+                        <a:spcBef>
+                          <a:spcPts val="0"/>
+                        </a:spcBef>
+                        <a:spcAft>
+                          <a:spcPts val="0"/>
+                        </a:spcAft>
+                        <a:lnSpc>
+                          <a:spcPct val="100000"/>
+                        </a:lnSpc>
+                      </a:pPr>
+                      <a:r>
+                        <a:rPr sz="1200" b="0">
+                          <a:solidFill>
+                            <a:srgbClr val="1C242E"/>
+                          </a:solidFill>
+                          <a:latin typeface="Microsoft YaHei"/>
+                          <a:ea typeface="Microsoft YaHei"/>
+                          <a:cs typeface="Microsoft YaHei"/>
+                        </a:rPr>
+                        <a:t>4.65 秒</a:t>
+                      </a:r>
+                    </a:p>
+                  </a:txBody>
+                  <a:tcPr marL="54864" marR="54864" marT="27432" marB="18288" anchor="ctr">
+                    <a:solidFill>
+                      <a:srgbClr val="FFFFFF"/>
+                    </a:solidFill>
+                    <a:lnL w="6350">
+                      <a:solidFill>
+                        <a:srgbClr val="D6DCE2"/>
+                      </a:solidFill>
+                    </a:lnL>
+                    <a:lnR w="6350">
+                      <a:solidFill>
+                        <a:srgbClr val="D6DCE2"/>
+                      </a:solidFill>
+                    </a:lnR>
+                    <a:lnT w="6350">
+                      <a:solidFill>
+                        <a:srgbClr val="D6DCE2"/>
+                      </a:solidFill>
+                    </a:lnT>
+                    <a:lnB w="6350">
+                      <a:solidFill>
+                        <a:srgbClr val="D6DCE2"/>
+                      </a:solidFill>
+                    </a:lnB>
+                  </a:tcPr>
+                </a:tc>
+                <a:tc>
+                  <a:txBody>
+                    <a:bodyPr wrap="square"/>
+                    <a:lstStyle/>
+                    <a:p>
+                      <a:pPr algn="l">
+                        <a:spcBef>
+                          <a:spcPts val="0"/>
+                        </a:spcBef>
+                        <a:spcAft>
+                          <a:spcPts val="0"/>
+                        </a:spcAft>
+                        <a:lnSpc>
+                          <a:spcPct val="100000"/>
+                        </a:lnSpc>
+                      </a:pPr>
+                      <a:r>
+                        <a:rPr sz="1200" b="0">
+                          <a:solidFill>
+                            <a:srgbClr val="1C242E"/>
+                          </a:solidFill>
+                          <a:latin typeface="Microsoft YaHei"/>
+                          <a:ea typeface="Microsoft YaHei"/>
+                          <a:cs typeface="Microsoft YaHei"/>
+                        </a:rPr>
+                        <a:t>0.46 秒</a:t>
+                      </a:r>
+                    </a:p>
+                  </a:txBody>
+                  <a:tcPr marL="54864" marR="54864" marT="27432" marB="18288" anchor="ctr">
+                    <a:solidFill>
+                      <a:srgbClr val="FFFFFF"/>
+                    </a:solidFill>
+                    <a:lnL w="6350">
+                      <a:solidFill>
+                        <a:srgbClr val="D6DCE2"/>
+                      </a:solidFill>
+                    </a:lnL>
+                    <a:lnR w="6350">
+                      <a:solidFill>
+                        <a:srgbClr val="D6DCE2"/>
+                      </a:solidFill>
+                    </a:lnR>
+                    <a:lnT w="6350">
+                      <a:solidFill>
+                        <a:srgbClr val="D6DCE2"/>
+                      </a:solidFill>
+                    </a:lnT>
+                    <a:lnB w="6350">
+                      <a:solidFill>
+                        <a:srgbClr val="D6DCE2"/>
+                      </a:solidFill>
+                    </a:lnB>
+                  </a:tcPr>
+                </a:tc>
+                <a:tc>
+                  <a:txBody>
+                    <a:bodyPr wrap="square"/>
+                    <a:lstStyle/>
+                    <a:p>
+                      <a:pPr algn="l">
+                        <a:spcBef>
+                          <a:spcPts val="0"/>
+                        </a:spcBef>
+                        <a:spcAft>
+                          <a:spcPts val="0"/>
+                        </a:spcAft>
+                        <a:lnSpc>
+                          <a:spcPct val="100000"/>
+                        </a:lnSpc>
+                      </a:pPr>
+                      <a:r>
+                        <a:rPr sz="1200" b="0">
+                          <a:solidFill>
+                            <a:srgbClr val="1C242E"/>
+                          </a:solidFill>
+                          <a:latin typeface="Microsoft YaHei"/>
+                          <a:ea typeface="Microsoft YaHei"/>
+                          <a:cs typeface="Microsoft YaHei"/>
+                        </a:rPr>
+                        <a:t>5.57 秒</a:t>
+                      </a:r>
+                    </a:p>
+                  </a:txBody>
+                  <a:tcPr marL="54864" marR="54864" marT="27432" marB="18288" anchor="ctr">
+                    <a:solidFill>
+                      <a:srgbClr val="FFFFFF"/>
+                    </a:solidFill>
+                    <a:lnL w="6350">
+                      <a:solidFill>
+                        <a:srgbClr val="D6DCE2"/>
+                      </a:solidFill>
+                    </a:lnL>
+                    <a:lnR w="6350">
+                      <a:solidFill>
+                        <a:srgbClr val="D6DCE2"/>
+                      </a:solidFill>
+                    </a:lnR>
+                    <a:lnT w="6350">
+                      <a:solidFill>
+                        <a:srgbClr val="D6DCE2"/>
+                      </a:solidFill>
+                    </a:lnT>
+                    <a:lnB w="6350">
+                      <a:solidFill>
+                        <a:srgbClr val="D6DCE2"/>
+                      </a:solidFill>
+                    </a:lnB>
+                  </a:tcPr>
+                </a:tc>
+              </a:tr>
+              <a:tr h="393192">
+                <a:tc>
+                  <a:txBody>
+                    <a:bodyPr wrap="square"/>
+                    <a:lstStyle/>
+                    <a:p>
+                      <a:pPr algn="l">
+                        <a:spcBef>
+                          <a:spcPts val="0"/>
+                        </a:spcBef>
+                        <a:spcAft>
+                          <a:spcPts val="0"/>
+                        </a:spcAft>
+                        <a:lnSpc>
+                          <a:spcPct val="100000"/>
+                        </a:lnSpc>
+                      </a:pPr>
+                      <a:r>
+                        <a:rPr sz="1200" b="1">
+                          <a:solidFill>
+                            <a:srgbClr val="0E2A47"/>
+                          </a:solidFill>
+                          <a:latin typeface="Microsoft YaHei"/>
+                          <a:ea typeface="Microsoft YaHei"/>
+                          <a:cs typeface="Microsoft YaHei"/>
+                        </a:rPr>
+                        <a:t>128K</a:t>
+                      </a:r>
+                    </a:p>
+                  </a:txBody>
+                  <a:tcPr marL="54864" marR="54864" marT="27432" marB="18288" anchor="ctr">
+                    <a:solidFill>
+                      <a:srgbClr val="F4F7FA"/>
+                    </a:solidFill>
+                    <a:lnL w="6350">
+                      <a:solidFill>
+                        <a:srgbClr val="D6DCE2"/>
+                      </a:solidFill>
+                    </a:lnL>
+                    <a:lnR w="6350">
+                      <a:solidFill>
+                        <a:srgbClr val="D6DCE2"/>
+                      </a:solidFill>
+                    </a:lnR>
+                    <a:lnT w="6350">
+                      <a:solidFill>
+                        <a:srgbClr val="D6DCE2"/>
+                      </a:solidFill>
+                    </a:lnT>
+                    <a:lnB w="6350">
+                      <a:solidFill>
+                        <a:srgbClr val="D6DCE2"/>
+                      </a:solidFill>
+                    </a:lnB>
+                  </a:tcPr>
+                </a:tc>
+                <a:tc>
+                  <a:txBody>
+                    <a:bodyPr wrap="square"/>
+                    <a:lstStyle/>
+                    <a:p>
+                      <a:pPr algn="l">
+                        <a:spcBef>
+                          <a:spcPts val="0"/>
+                        </a:spcBef>
+                        <a:spcAft>
+                          <a:spcPts val="0"/>
+                        </a:spcAft>
+                        <a:lnSpc>
+                          <a:spcPct val="100000"/>
+                        </a:lnSpc>
+                      </a:pPr>
+                      <a:r>
+                        <a:rPr sz="1200" b="0">
+                          <a:solidFill>
+                            <a:srgbClr val="1C242E"/>
+                          </a:solidFill>
+                          <a:latin typeface="Microsoft YaHei"/>
+                          <a:ea typeface="Microsoft YaHei"/>
+                          <a:cs typeface="Microsoft YaHei"/>
+                        </a:rPr>
+                        <a:t>1184</a:t>
+                      </a:r>
+                    </a:p>
+                  </a:txBody>
+                  <a:tcPr marL="54864" marR="54864" marT="27432" marB="18288" anchor="ctr">
+                    <a:solidFill>
+                      <a:srgbClr val="FFFFFF"/>
+                    </a:solidFill>
+                    <a:lnL w="6350">
+                      <a:solidFill>
+                        <a:srgbClr val="D6DCE2"/>
+                      </a:solidFill>
+                    </a:lnL>
+                    <a:lnR w="6350">
+                      <a:solidFill>
+                        <a:srgbClr val="D6DCE2"/>
+                      </a:solidFill>
+                    </a:lnR>
+                    <a:lnT w="6350">
+                      <a:solidFill>
+                        <a:srgbClr val="D6DCE2"/>
+                      </a:solidFill>
+                    </a:lnT>
+                    <a:lnB w="6350">
+                      <a:solidFill>
+                        <a:srgbClr val="D6DCE2"/>
+                      </a:solidFill>
+                    </a:lnB>
+                  </a:tcPr>
+                </a:tc>
+                <a:tc>
+                  <a:txBody>
+                    <a:bodyPr wrap="square"/>
+                    <a:lstStyle/>
+                    <a:p>
+                      <a:pPr algn="l">
+                        <a:spcBef>
+                          <a:spcPts val="0"/>
+                        </a:spcBef>
+                        <a:spcAft>
+                          <a:spcPts val="0"/>
+                        </a:spcAft>
+                        <a:lnSpc>
+                          <a:spcPct val="100000"/>
+                        </a:lnSpc>
+                      </a:pPr>
+                      <a:r>
+                        <a:rPr sz="1200" b="0">
+                          <a:solidFill>
+                            <a:srgbClr val="1C242E"/>
+                          </a:solidFill>
+                          <a:latin typeface="Microsoft YaHei"/>
+                          <a:ea typeface="Microsoft YaHei"/>
+                          <a:cs typeface="Microsoft YaHei"/>
+                        </a:rPr>
+                        <a:t>3.10×10^6</a:t>
+                      </a:r>
+                    </a:p>
+                  </a:txBody>
+                  <a:tcPr marL="54864" marR="54864" marT="27432" marB="18288" anchor="ctr">
+                    <a:solidFill>
+                      <a:srgbClr val="FFFFFF"/>
+                    </a:solidFill>
+                    <a:lnL w="6350">
+                      <a:solidFill>
+                        <a:srgbClr val="D6DCE2"/>
+                      </a:solidFill>
+                    </a:lnL>
+                    <a:lnR w="6350">
+                      <a:solidFill>
+                        <a:srgbClr val="D6DCE2"/>
+                      </a:solidFill>
+                    </a:lnR>
+                    <a:lnT w="6350">
+                      <a:solidFill>
+                        <a:srgbClr val="D6DCE2"/>
+                      </a:solidFill>
+                    </a:lnT>
+                    <a:lnB w="6350">
+                      <a:solidFill>
+                        <a:srgbClr val="D6DCE2"/>
+                      </a:solidFill>
+                    </a:lnB>
+                  </a:tcPr>
+                </a:tc>
+                <a:tc>
+                  <a:txBody>
+                    <a:bodyPr wrap="square"/>
+                    <a:lstStyle/>
+                    <a:p>
+                      <a:pPr algn="l">
+                        <a:spcBef>
+                          <a:spcPts val="0"/>
+                        </a:spcBef>
+                        <a:spcAft>
+                          <a:spcPts val="0"/>
+                        </a:spcAft>
+                        <a:lnSpc>
+                          <a:spcPct val="100000"/>
+                        </a:lnSpc>
+                      </a:pPr>
+                      <a:r>
+                        <a:rPr sz="1200" b="0">
+                          <a:solidFill>
+                            <a:srgbClr val="1C242E"/>
+                          </a:solidFill>
+                          <a:latin typeface="Microsoft YaHei"/>
+                          <a:ea typeface="Microsoft YaHei"/>
+                          <a:cs typeface="Microsoft YaHei"/>
+                        </a:rPr>
+                        <a:t>0.40 秒</a:t>
+                      </a:r>
+                    </a:p>
+                  </a:txBody>
+                  <a:tcPr marL="54864" marR="54864" marT="27432" marB="18288" anchor="ctr">
+                    <a:solidFill>
+                      <a:srgbClr val="FFFFFF"/>
+                    </a:solidFill>
+                    <a:lnL w="6350">
+                      <a:solidFill>
+                        <a:srgbClr val="D6DCE2"/>
+                      </a:solidFill>
+                    </a:lnL>
+                    <a:lnR w="6350">
+                      <a:solidFill>
+                        <a:srgbClr val="D6DCE2"/>
+                      </a:solidFill>
+                    </a:lnR>
+                    <a:lnT w="6350">
+                      <a:solidFill>
+                        <a:srgbClr val="D6DCE2"/>
+                      </a:solidFill>
+                    </a:lnT>
+                    <a:lnB w="6350">
+                      <a:solidFill>
+                        <a:srgbClr val="D6DCE2"/>
+                      </a:solidFill>
+                    </a:lnB>
+                  </a:tcPr>
+                </a:tc>
+                <a:tc>
+                  <a:txBody>
+                    <a:bodyPr wrap="square"/>
+                    <a:lstStyle/>
+                    <a:p>
+                      <a:pPr algn="l">
+                        <a:spcBef>
+                          <a:spcPts val="0"/>
+                        </a:spcBef>
+                        <a:spcAft>
+                          <a:spcPts val="0"/>
+                        </a:spcAft>
+                        <a:lnSpc>
+                          <a:spcPct val="100000"/>
+                        </a:lnSpc>
+                      </a:pPr>
+                      <a:r>
+                        <a:rPr sz="1200" b="0">
+                          <a:solidFill>
+                            <a:srgbClr val="1C242E"/>
+                          </a:solidFill>
+                          <a:latin typeface="Microsoft YaHei"/>
+                          <a:ea typeface="Microsoft YaHei"/>
+                          <a:cs typeface="Microsoft YaHei"/>
+                        </a:rPr>
+                        <a:t>13.4 毫秒</a:t>
+                      </a:r>
+                    </a:p>
+                  </a:txBody>
+                  <a:tcPr marL="54864" marR="54864" marT="27432" marB="18288" anchor="ctr">
+                    <a:solidFill>
+                      <a:srgbClr val="FFFFFF"/>
+                    </a:solidFill>
+                    <a:lnL w="6350">
+                      <a:solidFill>
+                        <a:srgbClr val="D6DCE2"/>
+                      </a:solidFill>
+                    </a:lnL>
+                    <a:lnR w="6350">
+                      <a:solidFill>
+                        <a:srgbClr val="D6DCE2"/>
+                      </a:solidFill>
+                    </a:lnR>
+                    <a:lnT w="6350">
+                      <a:solidFill>
+                        <a:srgbClr val="D6DCE2"/>
+                      </a:solidFill>
+                    </a:lnT>
+                    <a:lnB w="6350">
+                      <a:solidFill>
+                        <a:srgbClr val="D6DCE2"/>
+                      </a:solidFill>
+                    </a:lnB>
+                  </a:tcPr>
+                </a:tc>
+                <a:tc>
+                  <a:txBody>
+                    <a:bodyPr wrap="square"/>
+                    <a:lstStyle/>
+                    <a:p>
+                      <a:pPr algn="l">
+                        <a:spcBef>
+                          <a:spcPts val="0"/>
+                        </a:spcBef>
+                        <a:spcAft>
+                          <a:spcPts val="0"/>
+                        </a:spcAft>
+                        <a:lnSpc>
+                          <a:spcPct val="100000"/>
+                        </a:lnSpc>
+                      </a:pPr>
+                      <a:r>
+                        <a:rPr sz="1200" b="0">
+                          <a:solidFill>
+                            <a:srgbClr val="1C242E"/>
+                          </a:solidFill>
+                          <a:latin typeface="Microsoft YaHei"/>
+                          <a:ea typeface="Microsoft YaHei"/>
+                          <a:cs typeface="Microsoft YaHei"/>
+                        </a:rPr>
+                        <a:t>4.04 秒</a:t>
+                      </a:r>
+                    </a:p>
+                  </a:txBody>
+                  <a:tcPr marL="54864" marR="54864" marT="27432" marB="18288" anchor="ctr">
+                    <a:solidFill>
+                      <a:srgbClr val="FFFFFF"/>
+                    </a:solidFill>
+                    <a:lnL w="6350">
+                      <a:solidFill>
+                        <a:srgbClr val="D6DCE2"/>
+                      </a:solidFill>
+                    </a:lnL>
+                    <a:lnR w="6350">
+                      <a:solidFill>
+                        <a:srgbClr val="D6DCE2"/>
+                      </a:solidFill>
+                    </a:lnR>
+                    <a:lnT w="6350">
+                      <a:solidFill>
+                        <a:srgbClr val="D6DCE2"/>
+                      </a:solidFill>
+                    </a:lnT>
+                    <a:lnB w="6350">
+                      <a:solidFill>
+                        <a:srgbClr val="D6DCE2"/>
+                      </a:solidFill>
+                    </a:lnB>
+                  </a:tcPr>
+                </a:tc>
+                <a:tc>
+                  <a:txBody>
+                    <a:bodyPr wrap="square"/>
+                    <a:lstStyle/>
+                    <a:p>
+                      <a:pPr algn="l">
+                        <a:spcBef>
+                          <a:spcPts val="0"/>
+                        </a:spcBef>
+                        <a:spcAft>
+                          <a:spcPts val="0"/>
+                        </a:spcAft>
+                        <a:lnSpc>
+                          <a:spcPct val="100000"/>
+                        </a:lnSpc>
+                      </a:pPr>
+                      <a:r>
+                        <a:rPr sz="1200" b="0">
+                          <a:solidFill>
+                            <a:srgbClr val="1C242E"/>
+                          </a:solidFill>
+                          <a:latin typeface="Microsoft YaHei"/>
+                          <a:ea typeface="Microsoft YaHei"/>
+                          <a:cs typeface="Microsoft YaHei"/>
+                        </a:rPr>
+                        <a:t>0.40 秒</a:t>
+                      </a:r>
+                    </a:p>
+                  </a:txBody>
+                  <a:tcPr marL="54864" marR="54864" marT="27432" marB="18288" anchor="ctr">
+                    <a:solidFill>
+                      <a:srgbClr val="FFFFFF"/>
+                    </a:solidFill>
+                    <a:lnL w="6350">
+                      <a:solidFill>
+                        <a:srgbClr val="D6DCE2"/>
+                      </a:solidFill>
+                    </a:lnL>
+                    <a:lnR w="6350">
+                      <a:solidFill>
+                        <a:srgbClr val="D6DCE2"/>
+                      </a:solidFill>
+                    </a:lnR>
+                    <a:lnT w="6350">
+                      <a:solidFill>
+                        <a:srgbClr val="D6DCE2"/>
+                      </a:solidFill>
+                    </a:lnT>
+                    <a:lnB w="6350">
+                      <a:solidFill>
+                        <a:srgbClr val="D6DCE2"/>
+                      </a:solidFill>
+                    </a:lnB>
+                  </a:tcPr>
+                </a:tc>
+                <a:tc>
+                  <a:txBody>
+                    <a:bodyPr wrap="square"/>
+                    <a:lstStyle/>
+                    <a:p>
+                      <a:pPr algn="l">
+                        <a:spcBef>
+                          <a:spcPts val="0"/>
+                        </a:spcBef>
+                        <a:spcAft>
+                          <a:spcPts val="0"/>
+                        </a:spcAft>
+                        <a:lnSpc>
+                          <a:spcPct val="100000"/>
+                        </a:lnSpc>
+                      </a:pPr>
+                      <a:r>
+                        <a:rPr sz="1200" b="0">
+                          <a:solidFill>
+                            <a:srgbClr val="1C242E"/>
+                          </a:solidFill>
+                          <a:latin typeface="Microsoft YaHei"/>
+                          <a:ea typeface="Microsoft YaHei"/>
+                          <a:cs typeface="Microsoft YaHei"/>
+                        </a:rPr>
+                        <a:t>4.84 秒</a:t>
+                      </a:r>
+                    </a:p>
+                  </a:txBody>
+                  <a:tcPr marL="54864" marR="54864" marT="27432" marB="18288" anchor="ctr">
+                    <a:solidFill>
+                      <a:srgbClr val="FFFFFF"/>
+                    </a:solidFill>
+                    <a:lnL w="6350">
+                      <a:solidFill>
+                        <a:srgbClr val="D6DCE2"/>
+                      </a:solidFill>
+                    </a:lnL>
+                    <a:lnR w="6350">
+                      <a:solidFill>
+                        <a:srgbClr val="D6DCE2"/>
+                      </a:solidFill>
+                    </a:lnR>
+                    <a:lnT w="6350">
+                      <a:solidFill>
+                        <a:srgbClr val="D6DCE2"/>
+                      </a:solidFill>
+                    </a:lnT>
+                    <a:lnB w="6350">
+                      <a:solidFill>
+                        <a:srgbClr val="D6DCE2"/>
+                      </a:solidFill>
+                    </a:lnB>
+                  </a:tcPr>
+                </a:tc>
+              </a:tr>
+              <a:tr h="393192">
+                <a:tc>
+                  <a:txBody>
+                    <a:bodyPr wrap="square"/>
+                    <a:lstStyle/>
+                    <a:p>
+                      <a:pPr algn="l">
+                        <a:spcBef>
+                          <a:spcPts val="0"/>
+                        </a:spcBef>
+                        <a:spcAft>
+                          <a:spcPts val="0"/>
+                        </a:spcAft>
+                        <a:lnSpc>
+                          <a:spcPct val="100000"/>
+                        </a:lnSpc>
+                      </a:pPr>
+                      <a:r>
+                        <a:rPr sz="1200" b="1">
+                          <a:solidFill>
+                            <a:srgbClr val="0E2A47"/>
+                          </a:solidFill>
+                          <a:latin typeface="Microsoft YaHei"/>
+                          <a:ea typeface="Microsoft YaHei"/>
+                          <a:cs typeface="Microsoft YaHei"/>
+                        </a:rPr>
+                        <a:t>256K</a:t>
+                      </a:r>
+                    </a:p>
+                  </a:txBody>
+                  <a:tcPr marL="54864" marR="54864" marT="27432" marB="18288" anchor="ctr">
+                    <a:solidFill>
+                      <a:srgbClr val="F4F7FA"/>
+                    </a:solidFill>
+                    <a:lnL w="6350">
+                      <a:solidFill>
+                        <a:srgbClr val="D6DCE2"/>
+                      </a:solidFill>
+                    </a:lnL>
+                    <a:lnR w="6350">
+                      <a:solidFill>
+                        <a:srgbClr val="D6DCE2"/>
+                      </a:solidFill>
+                    </a:lnR>
+                    <a:lnT w="6350">
+                      <a:solidFill>
+                        <a:srgbClr val="D6DCE2"/>
+                      </a:solidFill>
+                    </a:lnT>
+                    <a:lnB w="6350">
+                      <a:solidFill>
+                        <a:srgbClr val="D6DCE2"/>
+                      </a:solidFill>
+                    </a:lnB>
+                  </a:tcPr>
+                </a:tc>
+                <a:tc>
+                  <a:txBody>
+                    <a:bodyPr wrap="square"/>
+                    <a:lstStyle/>
+                    <a:p>
+                      <a:pPr algn="l">
+                        <a:spcBef>
+                          <a:spcPts val="0"/>
+                        </a:spcBef>
+                        <a:spcAft>
+                          <a:spcPts val="0"/>
+                        </a:spcAft>
+                        <a:lnSpc>
+                          <a:spcPct val="100000"/>
+                        </a:lnSpc>
+                      </a:pPr>
+                      <a:r>
+                        <a:rPr sz="1200" b="0">
+                          <a:solidFill>
+                            <a:srgbClr val="1C242E"/>
+                          </a:solidFill>
+                          <a:latin typeface="Microsoft YaHei"/>
+                          <a:ea typeface="Microsoft YaHei"/>
+                          <a:cs typeface="Microsoft YaHei"/>
+                        </a:rPr>
+                        <a:t>498</a:t>
+                      </a:r>
+                    </a:p>
+                  </a:txBody>
+                  <a:tcPr marL="54864" marR="54864" marT="27432" marB="18288" anchor="ctr">
+                    <a:solidFill>
+                      <a:srgbClr val="FFFFFF"/>
+                    </a:solidFill>
+                    <a:lnL w="6350">
+                      <a:solidFill>
+                        <a:srgbClr val="D6DCE2"/>
+                      </a:solidFill>
+                    </a:lnL>
+                    <a:lnR w="6350">
+                      <a:solidFill>
+                        <a:srgbClr val="D6DCE2"/>
+                      </a:solidFill>
+                    </a:lnR>
+                    <a:lnT w="6350">
+                      <a:solidFill>
+                        <a:srgbClr val="D6DCE2"/>
+                      </a:solidFill>
+                    </a:lnT>
+                    <a:lnB w="6350">
+                      <a:solidFill>
+                        <a:srgbClr val="D6DCE2"/>
+                      </a:solidFill>
+                    </a:lnB>
+                  </a:tcPr>
+                </a:tc>
+                <a:tc>
+                  <a:txBody>
+                    <a:bodyPr wrap="square"/>
+                    <a:lstStyle/>
+                    <a:p>
+                      <a:pPr algn="l">
+                        <a:spcBef>
+                          <a:spcPts val="0"/>
+                        </a:spcBef>
+                        <a:spcAft>
+                          <a:spcPts val="0"/>
+                        </a:spcAft>
+                        <a:lnSpc>
+                          <a:spcPct val="100000"/>
+                        </a:lnSpc>
+                      </a:pPr>
+                      <a:r>
+                        <a:rPr sz="1200" b="0">
+                          <a:solidFill>
+                            <a:srgbClr val="1C242E"/>
+                          </a:solidFill>
+                          <a:latin typeface="Microsoft YaHei"/>
+                          <a:ea typeface="Microsoft YaHei"/>
+                          <a:cs typeface="Microsoft YaHei"/>
+                        </a:rPr>
+                        <a:t>2.61×10^6</a:t>
+                      </a:r>
+                    </a:p>
+                  </a:txBody>
+                  <a:tcPr marL="54864" marR="54864" marT="27432" marB="18288" anchor="ctr">
+                    <a:solidFill>
+                      <a:srgbClr val="FFFFFF"/>
+                    </a:solidFill>
+                    <a:lnL w="6350">
+                      <a:solidFill>
+                        <a:srgbClr val="D6DCE2"/>
+                      </a:solidFill>
+                    </a:lnL>
+                    <a:lnR w="6350">
+                      <a:solidFill>
+                        <a:srgbClr val="D6DCE2"/>
+                      </a:solidFill>
+                    </a:lnR>
+                    <a:lnT w="6350">
+                      <a:solidFill>
+                        <a:srgbClr val="D6DCE2"/>
+                      </a:solidFill>
+                    </a:lnT>
+                    <a:lnB w="6350">
+                      <a:solidFill>
+                        <a:srgbClr val="D6DCE2"/>
+                      </a:solidFill>
+                    </a:lnB>
+                  </a:tcPr>
+                </a:tc>
+                <a:tc>
+                  <a:txBody>
+                    <a:bodyPr wrap="square"/>
+                    <a:lstStyle/>
+                    <a:p>
+                      <a:pPr algn="l">
+                        <a:spcBef>
+                          <a:spcPts val="0"/>
+                        </a:spcBef>
+                        <a:spcAft>
+                          <a:spcPts val="0"/>
+                        </a:spcAft>
+                        <a:lnSpc>
+                          <a:spcPct val="100000"/>
+                        </a:lnSpc>
+                      </a:pPr>
+                      <a:r>
+                        <a:rPr sz="1200" b="0">
+                          <a:solidFill>
+                            <a:srgbClr val="1C242E"/>
+                          </a:solidFill>
+                          <a:latin typeface="Microsoft YaHei"/>
+                          <a:ea typeface="Microsoft YaHei"/>
+                          <a:cs typeface="Microsoft YaHei"/>
+                        </a:rPr>
+                        <a:t>0.34 秒</a:t>
+                      </a:r>
+                    </a:p>
+                  </a:txBody>
+                  <a:tcPr marL="54864" marR="54864" marT="27432" marB="18288" anchor="ctr">
+                    <a:solidFill>
+                      <a:srgbClr val="FFFFFF"/>
+                    </a:solidFill>
+                    <a:lnL w="6350">
+                      <a:solidFill>
+                        <a:srgbClr val="D6DCE2"/>
+                      </a:solidFill>
+                    </a:lnL>
+                    <a:lnR w="6350">
+                      <a:solidFill>
+                        <a:srgbClr val="D6DCE2"/>
+                      </a:solidFill>
+                    </a:lnR>
+                    <a:lnT w="6350">
+                      <a:solidFill>
+                        <a:srgbClr val="D6DCE2"/>
+                      </a:solidFill>
+                    </a:lnT>
+                    <a:lnB w="6350">
+                      <a:solidFill>
+                        <a:srgbClr val="D6DCE2"/>
+                      </a:solidFill>
+                    </a:lnB>
+                  </a:tcPr>
+                </a:tc>
+                <a:tc>
+                  <a:txBody>
+                    <a:bodyPr wrap="square"/>
+                    <a:lstStyle/>
+                    <a:p>
+                      <a:pPr algn="l">
+                        <a:spcBef>
+                          <a:spcPts val="0"/>
+                        </a:spcBef>
+                        <a:spcAft>
+                          <a:spcPts val="0"/>
+                        </a:spcAft>
+                        <a:lnSpc>
+                          <a:spcPct val="100000"/>
+                        </a:lnSpc>
+                      </a:pPr>
+                      <a:r>
+                        <a:rPr sz="1200" b="0">
+                          <a:solidFill>
+                            <a:srgbClr val="1C242E"/>
+                          </a:solidFill>
+                          <a:latin typeface="Microsoft YaHei"/>
+                          <a:ea typeface="Microsoft YaHei"/>
+                          <a:cs typeface="Microsoft YaHei"/>
+                        </a:rPr>
+                        <a:t>13.4 毫秒</a:t>
+                      </a:r>
+                    </a:p>
+                  </a:txBody>
+                  <a:tcPr marL="54864" marR="54864" marT="27432" marB="18288" anchor="ctr">
+                    <a:solidFill>
+                      <a:srgbClr val="FFFFFF"/>
+                    </a:solidFill>
+                    <a:lnL w="6350">
+                      <a:solidFill>
+                        <a:srgbClr val="D6DCE2"/>
+                      </a:solidFill>
+                    </a:lnL>
+                    <a:lnR w="6350">
+                      <a:solidFill>
+                        <a:srgbClr val="D6DCE2"/>
+                      </a:solidFill>
+                    </a:lnR>
+                    <a:lnT w="6350">
+                      <a:solidFill>
+                        <a:srgbClr val="D6DCE2"/>
+                      </a:solidFill>
+                    </a:lnT>
+                    <a:lnB w="6350">
+                      <a:solidFill>
+                        <a:srgbClr val="D6DCE2"/>
+                      </a:solidFill>
+                    </a:lnB>
+                  </a:tcPr>
+                </a:tc>
+                <a:tc>
+                  <a:txBody>
+                    <a:bodyPr wrap="square"/>
+                    <a:lstStyle/>
+                    <a:p>
+                      <a:pPr algn="l">
+                        <a:spcBef>
+                          <a:spcPts val="0"/>
+                        </a:spcBef>
+                        <a:spcAft>
+                          <a:spcPts val="0"/>
+                        </a:spcAft>
+                        <a:lnSpc>
+                          <a:spcPct val="100000"/>
+                        </a:lnSpc>
+                      </a:pPr>
+                      <a:r>
+                        <a:rPr sz="1200" b="0">
+                          <a:solidFill>
+                            <a:srgbClr val="1C242E"/>
+                          </a:solidFill>
+                          <a:latin typeface="Microsoft YaHei"/>
+                          <a:ea typeface="Microsoft YaHei"/>
+                          <a:cs typeface="Microsoft YaHei"/>
+                        </a:rPr>
+                        <a:t>3.40 秒</a:t>
+                      </a:r>
+                    </a:p>
+                  </a:txBody>
+                  <a:tcPr marL="54864" marR="54864" marT="27432" marB="18288" anchor="ctr">
+                    <a:solidFill>
+                      <a:srgbClr val="FFFFFF"/>
+                    </a:solidFill>
+                    <a:lnL w="6350">
+                      <a:solidFill>
+                        <a:srgbClr val="D6DCE2"/>
+                      </a:solidFill>
+                    </a:lnL>
+                    <a:lnR w="6350">
+                      <a:solidFill>
+                        <a:srgbClr val="D6DCE2"/>
+                      </a:solidFill>
+                    </a:lnR>
+                    <a:lnT w="6350">
+                      <a:solidFill>
+                        <a:srgbClr val="D6DCE2"/>
+                      </a:solidFill>
+                    </a:lnT>
+                    <a:lnB w="6350">
+                      <a:solidFill>
+                        <a:srgbClr val="D6DCE2"/>
+                      </a:solidFill>
+                    </a:lnB>
+                  </a:tcPr>
+                </a:tc>
+                <a:tc>
+                  <a:txBody>
+                    <a:bodyPr wrap="square"/>
+                    <a:lstStyle/>
+                    <a:p>
+                      <a:pPr algn="l">
+                        <a:spcBef>
+                          <a:spcPts val="0"/>
+                        </a:spcBef>
+                        <a:spcAft>
+                          <a:spcPts val="0"/>
+                        </a:spcAft>
+                        <a:lnSpc>
+                          <a:spcPct val="100000"/>
+                        </a:lnSpc>
+                      </a:pPr>
+                      <a:r>
+                        <a:rPr sz="1200" b="0">
+                          <a:solidFill>
+                            <a:srgbClr val="1C242E"/>
+                          </a:solidFill>
+                          <a:latin typeface="Microsoft YaHei"/>
+                          <a:ea typeface="Microsoft YaHei"/>
+                          <a:cs typeface="Microsoft YaHei"/>
+                        </a:rPr>
+                        <a:t>0.34 秒</a:t>
+                      </a:r>
+                    </a:p>
+                  </a:txBody>
+                  <a:tcPr marL="54864" marR="54864" marT="27432" marB="18288" anchor="ctr">
+                    <a:solidFill>
+                      <a:srgbClr val="FFFFFF"/>
+                    </a:solidFill>
+                    <a:lnL w="6350">
+                      <a:solidFill>
+                        <a:srgbClr val="D6DCE2"/>
+                      </a:solidFill>
+                    </a:lnL>
+                    <a:lnR w="6350">
+                      <a:solidFill>
+                        <a:srgbClr val="D6DCE2"/>
+                      </a:solidFill>
+                    </a:lnR>
+                    <a:lnT w="6350">
+                      <a:solidFill>
+                        <a:srgbClr val="D6DCE2"/>
+                      </a:solidFill>
+                    </a:lnT>
+                    <a:lnB w="6350">
+                      <a:solidFill>
+                        <a:srgbClr val="D6DCE2"/>
+                      </a:solidFill>
+                    </a:lnB>
+                  </a:tcPr>
+                </a:tc>
+                <a:tc>
+                  <a:txBody>
+                    <a:bodyPr wrap="square"/>
+                    <a:lstStyle/>
+                    <a:p>
+                      <a:pPr algn="l">
+                        <a:spcBef>
+                          <a:spcPts val="0"/>
+                        </a:spcBef>
+                        <a:spcAft>
+                          <a:spcPts val="0"/>
+                        </a:spcAft>
+                        <a:lnSpc>
+                          <a:spcPct val="100000"/>
+                        </a:lnSpc>
+                      </a:pPr>
+                      <a:r>
+                        <a:rPr sz="1200" b="0">
+                          <a:solidFill>
+                            <a:srgbClr val="1C242E"/>
+                          </a:solidFill>
+                          <a:latin typeface="Microsoft YaHei"/>
+                          <a:ea typeface="Microsoft YaHei"/>
+                          <a:cs typeface="Microsoft YaHei"/>
+                        </a:rPr>
+                        <a:t>4.07 秒</a:t>
+                      </a:r>
+                    </a:p>
+                  </a:txBody>
+                  <a:tcPr marL="54864" marR="54864" marT="27432" marB="18288" anchor="ctr">
+                    <a:solidFill>
+                      <a:srgbClr val="FFFFFF"/>
+                    </a:solidFill>
+                    <a:lnL w="6350">
+                      <a:solidFill>
+                        <a:srgbClr val="D6DCE2"/>
+                      </a:solidFill>
+                    </a:lnL>
+                    <a:lnR w="6350">
+                      <a:solidFill>
+                        <a:srgbClr val="D6DCE2"/>
+                      </a:solidFill>
+                    </a:lnR>
+                    <a:lnT w="6350">
+                      <a:solidFill>
+                        <a:srgbClr val="D6DCE2"/>
+                      </a:solidFill>
+                    </a:lnT>
+                    <a:lnB w="6350">
+                      <a:solidFill>
+                        <a:srgbClr val="D6DCE2"/>
+                      </a:solidFill>
+                    </a:lnB>
+                  </a:tcPr>
+                </a:tc>
+              </a:tr>
+              <a:tr h="393192">
+                <a:tc>
+                  <a:txBody>
+                    <a:bodyPr wrap="square"/>
+                    <a:lstStyle/>
+                    <a:p>
+                      <a:pPr algn="l">
+                        <a:spcBef>
+                          <a:spcPts val="0"/>
+                        </a:spcBef>
+                        <a:spcAft>
+                          <a:spcPts val="0"/>
+                        </a:spcAft>
+                        <a:lnSpc>
+                          <a:spcPct val="100000"/>
+                        </a:lnSpc>
+                      </a:pPr>
+                      <a:r>
+                        <a:rPr sz="1200" b="1">
+                          <a:solidFill>
+                            <a:srgbClr val="0E2A47"/>
+                          </a:solidFill>
+                          <a:latin typeface="Microsoft YaHei"/>
+                          <a:ea typeface="Microsoft YaHei"/>
+                          <a:cs typeface="Microsoft YaHei"/>
+                        </a:rPr>
+                        <a:t>512K</a:t>
+                      </a:r>
+                    </a:p>
+                  </a:txBody>
+                  <a:tcPr marL="54864" marR="54864" marT="27432" marB="18288" anchor="ctr">
+                    <a:solidFill>
+                      <a:srgbClr val="F4F7FA"/>
+                    </a:solidFill>
+                    <a:lnL w="6350">
+                      <a:solidFill>
+                        <a:srgbClr val="D6DCE2"/>
+                      </a:solidFill>
+                    </a:lnL>
+                    <a:lnR w="6350">
+                      <a:solidFill>
+                        <a:srgbClr val="D6DCE2"/>
+                      </a:solidFill>
+                    </a:lnR>
+                    <a:lnT w="6350">
+                      <a:solidFill>
+                        <a:srgbClr val="D6DCE2"/>
+                      </a:solidFill>
+                    </a:lnT>
+                    <a:lnB w="6350">
+                      <a:solidFill>
+                        <a:srgbClr val="D6DCE2"/>
+                      </a:solidFill>
+                    </a:lnB>
+                  </a:tcPr>
+                </a:tc>
+                <a:tc>
+                  <a:txBody>
+                    <a:bodyPr wrap="square"/>
+                    <a:lstStyle/>
+                    <a:p>
+                      <a:pPr algn="l">
+                        <a:spcBef>
+                          <a:spcPts val="0"/>
+                        </a:spcBef>
+                        <a:spcAft>
+                          <a:spcPts val="0"/>
+                        </a:spcAft>
+                        <a:lnSpc>
+                          <a:spcPct val="100000"/>
+                        </a:lnSpc>
+                      </a:pPr>
+                      <a:r>
+                        <a:rPr sz="1200" b="0">
+                          <a:solidFill>
+                            <a:srgbClr val="1C242E"/>
+                          </a:solidFill>
+                          <a:latin typeface="Microsoft YaHei"/>
+                          <a:ea typeface="Microsoft YaHei"/>
+                          <a:cs typeface="Microsoft YaHei"/>
+                        </a:rPr>
+                        <a:t>192</a:t>
+                      </a:r>
+                    </a:p>
+                  </a:txBody>
+                  <a:tcPr marL="54864" marR="54864" marT="27432" marB="18288" anchor="ctr">
+                    <a:solidFill>
+                      <a:srgbClr val="FFFFFF"/>
+                    </a:solidFill>
+                    <a:lnL w="6350">
+                      <a:solidFill>
+                        <a:srgbClr val="D6DCE2"/>
+                      </a:solidFill>
+                    </a:lnL>
+                    <a:lnR w="6350">
+                      <a:solidFill>
+                        <a:srgbClr val="D6DCE2"/>
+                      </a:solidFill>
+                    </a:lnR>
+                    <a:lnT w="6350">
+                      <a:solidFill>
+                        <a:srgbClr val="D6DCE2"/>
+                      </a:solidFill>
+                    </a:lnT>
+                    <a:lnB w="6350">
+                      <a:solidFill>
+                        <a:srgbClr val="D6DCE2"/>
+                      </a:solidFill>
+                    </a:lnB>
+                  </a:tcPr>
+                </a:tc>
+                <a:tc>
+                  <a:txBody>
+                    <a:bodyPr wrap="square"/>
+                    <a:lstStyle/>
+                    <a:p>
+                      <a:pPr algn="l">
+                        <a:spcBef>
+                          <a:spcPts val="0"/>
+                        </a:spcBef>
+                        <a:spcAft>
+                          <a:spcPts val="0"/>
+                        </a:spcAft>
+                        <a:lnSpc>
+                          <a:spcPct val="100000"/>
+                        </a:lnSpc>
+                      </a:pPr>
+                      <a:r>
+                        <a:rPr sz="1200" b="0">
+                          <a:solidFill>
+                            <a:srgbClr val="1C242E"/>
+                          </a:solidFill>
+                          <a:latin typeface="Microsoft YaHei"/>
+                          <a:ea typeface="Microsoft YaHei"/>
+                          <a:cs typeface="Microsoft YaHei"/>
+                        </a:rPr>
+                        <a:t>2.01×10^6</a:t>
+                      </a:r>
+                    </a:p>
+                  </a:txBody>
+                  <a:tcPr marL="54864" marR="54864" marT="27432" marB="18288" anchor="ctr">
+                    <a:solidFill>
+                      <a:srgbClr val="FFFFFF"/>
+                    </a:solidFill>
+                    <a:lnL w="6350">
+                      <a:solidFill>
+                        <a:srgbClr val="D6DCE2"/>
+                      </a:solidFill>
+                    </a:lnL>
+                    <a:lnR w="6350">
+                      <a:solidFill>
+                        <a:srgbClr val="D6DCE2"/>
+                      </a:solidFill>
+                    </a:lnR>
+                    <a:lnT w="6350">
+                      <a:solidFill>
+                        <a:srgbClr val="D6DCE2"/>
+                      </a:solidFill>
+                    </a:lnT>
+                    <a:lnB w="6350">
+                      <a:solidFill>
+                        <a:srgbClr val="D6DCE2"/>
+                      </a:solidFill>
+                    </a:lnB>
+                  </a:tcPr>
+                </a:tc>
+                <a:tc>
+                  <a:txBody>
+                    <a:bodyPr wrap="square"/>
+                    <a:lstStyle/>
+                    <a:p>
+                      <a:pPr algn="l">
+                        <a:spcBef>
+                          <a:spcPts val="0"/>
+                        </a:spcBef>
+                        <a:spcAft>
+                          <a:spcPts val="0"/>
+                        </a:spcAft>
+                        <a:lnSpc>
+                          <a:spcPct val="100000"/>
+                        </a:lnSpc>
+                      </a:pPr>
+                      <a:r>
+                        <a:rPr sz="1200" b="0">
+                          <a:solidFill>
+                            <a:srgbClr val="1C242E"/>
+                          </a:solidFill>
+                          <a:latin typeface="Microsoft YaHei"/>
+                          <a:ea typeface="Microsoft YaHei"/>
+                          <a:cs typeface="Microsoft YaHei"/>
+                        </a:rPr>
+                        <a:t>0.26 秒</a:t>
+                      </a:r>
+                    </a:p>
+                  </a:txBody>
+                  <a:tcPr marL="54864" marR="54864" marT="27432" marB="18288" anchor="ctr">
+                    <a:solidFill>
+                      <a:srgbClr val="FFFFFF"/>
+                    </a:solidFill>
+                    <a:lnL w="6350">
+                      <a:solidFill>
+                        <a:srgbClr val="D6DCE2"/>
+                      </a:solidFill>
+                    </a:lnL>
+                    <a:lnR w="6350">
+                      <a:solidFill>
+                        <a:srgbClr val="D6DCE2"/>
+                      </a:solidFill>
+                    </a:lnR>
+                    <a:lnT w="6350">
+                      <a:solidFill>
+                        <a:srgbClr val="D6DCE2"/>
+                      </a:solidFill>
+                    </a:lnT>
+                    <a:lnB w="6350">
+                      <a:solidFill>
+                        <a:srgbClr val="D6DCE2"/>
+                      </a:solidFill>
+                    </a:lnB>
+                  </a:tcPr>
+                </a:tc>
+                <a:tc>
+                  <a:txBody>
+                    <a:bodyPr wrap="square"/>
+                    <a:lstStyle/>
+                    <a:p>
+                      <a:pPr algn="l">
+                        <a:spcBef>
+                          <a:spcPts val="0"/>
+                        </a:spcBef>
+                        <a:spcAft>
+                          <a:spcPts val="0"/>
+                        </a:spcAft>
+                        <a:lnSpc>
+                          <a:spcPct val="100000"/>
+                        </a:lnSpc>
+                      </a:pPr>
+                      <a:r>
+                        <a:rPr sz="1200" b="0">
+                          <a:solidFill>
+                            <a:srgbClr val="1C242E"/>
+                          </a:solidFill>
+                          <a:latin typeface="Microsoft YaHei"/>
+                          <a:ea typeface="Microsoft YaHei"/>
+                          <a:cs typeface="Microsoft YaHei"/>
+                        </a:rPr>
+                        <a:t>13.4 毫秒</a:t>
+                      </a:r>
+                    </a:p>
+                  </a:txBody>
+                  <a:tcPr marL="54864" marR="54864" marT="27432" marB="18288" anchor="ctr">
+                    <a:solidFill>
+                      <a:srgbClr val="FFFFFF"/>
+                    </a:solidFill>
+                    <a:lnL w="6350">
+                      <a:solidFill>
+                        <a:srgbClr val="D6DCE2"/>
+                      </a:solidFill>
+                    </a:lnL>
+                    <a:lnR w="6350">
+                      <a:solidFill>
+                        <a:srgbClr val="D6DCE2"/>
+                      </a:solidFill>
+                    </a:lnR>
+                    <a:lnT w="6350">
+                      <a:solidFill>
+                        <a:srgbClr val="D6DCE2"/>
+                      </a:solidFill>
+                    </a:lnT>
+                    <a:lnB w="6350">
+                      <a:solidFill>
+                        <a:srgbClr val="D6DCE2"/>
+                      </a:solidFill>
+                    </a:lnB>
+                  </a:tcPr>
+                </a:tc>
+                <a:tc>
+                  <a:txBody>
+                    <a:bodyPr wrap="square"/>
+                    <a:lstStyle/>
+                    <a:p>
+                      <a:pPr algn="l">
+                        <a:spcBef>
+                          <a:spcPts val="0"/>
+                        </a:spcBef>
+                        <a:spcAft>
+                          <a:spcPts val="0"/>
+                        </a:spcAft>
+                        <a:lnSpc>
+                          <a:spcPct val="100000"/>
+                        </a:lnSpc>
+                      </a:pPr>
+                      <a:r>
+                        <a:rPr sz="1200" b="0">
+                          <a:solidFill>
+                            <a:srgbClr val="1C242E"/>
+                          </a:solidFill>
+                          <a:latin typeface="Microsoft YaHei"/>
+                          <a:ea typeface="Microsoft YaHei"/>
+                          <a:cs typeface="Microsoft YaHei"/>
+                        </a:rPr>
+                        <a:t>2.62 秒</a:t>
+                      </a:r>
+                    </a:p>
+                  </a:txBody>
+                  <a:tcPr marL="54864" marR="54864" marT="27432" marB="18288" anchor="ctr">
+                    <a:solidFill>
+                      <a:srgbClr val="FFFFFF"/>
+                    </a:solidFill>
+                    <a:lnL w="6350">
+                      <a:solidFill>
+                        <a:srgbClr val="D6DCE2"/>
+                      </a:solidFill>
+                    </a:lnL>
+                    <a:lnR w="6350">
+                      <a:solidFill>
+                        <a:srgbClr val="D6DCE2"/>
+                      </a:solidFill>
+                    </a:lnR>
+                    <a:lnT w="6350">
+                      <a:solidFill>
+                        <a:srgbClr val="D6DCE2"/>
+                      </a:solidFill>
+                    </a:lnT>
+                    <a:lnB w="6350">
+                      <a:solidFill>
+                        <a:srgbClr val="D6DCE2"/>
+                      </a:solidFill>
+                    </a:lnB>
+                  </a:tcPr>
+                </a:tc>
+                <a:tc>
+                  <a:txBody>
+                    <a:bodyPr wrap="square"/>
+                    <a:lstStyle/>
+                    <a:p>
+                      <a:pPr algn="l">
+                        <a:spcBef>
+                          <a:spcPts val="0"/>
+                        </a:spcBef>
+                        <a:spcAft>
+                          <a:spcPts val="0"/>
+                        </a:spcAft>
+                        <a:lnSpc>
+                          <a:spcPct val="100000"/>
+                        </a:lnSpc>
+                      </a:pPr>
+                      <a:r>
+                        <a:rPr sz="1200" b="0">
+                          <a:solidFill>
+                            <a:srgbClr val="1C242E"/>
+                          </a:solidFill>
+                          <a:latin typeface="Microsoft YaHei"/>
+                          <a:ea typeface="Microsoft YaHei"/>
+                          <a:cs typeface="Microsoft YaHei"/>
+                        </a:rPr>
+                        <a:t>0.26 秒</a:t>
+                      </a:r>
+                    </a:p>
+                  </a:txBody>
+                  <a:tcPr marL="54864" marR="54864" marT="27432" marB="18288" anchor="ctr">
+                    <a:solidFill>
+                      <a:srgbClr val="FFFFFF"/>
+                    </a:solidFill>
+                    <a:lnL w="6350">
+                      <a:solidFill>
+                        <a:srgbClr val="D6DCE2"/>
+                      </a:solidFill>
+                    </a:lnL>
+                    <a:lnR w="6350">
+                      <a:solidFill>
+                        <a:srgbClr val="D6DCE2"/>
+                      </a:solidFill>
+                    </a:lnR>
+                    <a:lnT w="6350">
+                      <a:solidFill>
+                        <a:srgbClr val="D6DCE2"/>
+                      </a:solidFill>
+                    </a:lnT>
+                    <a:lnB w="6350">
+                      <a:solidFill>
+                        <a:srgbClr val="D6DCE2"/>
+                      </a:solidFill>
+                    </a:lnB>
+                  </a:tcPr>
+                </a:tc>
+                <a:tc>
+                  <a:txBody>
+                    <a:bodyPr wrap="square"/>
+                    <a:lstStyle/>
+                    <a:p>
+                      <a:pPr algn="l">
+                        <a:spcBef>
+                          <a:spcPts val="0"/>
+                        </a:spcBef>
+                        <a:spcAft>
+                          <a:spcPts val="0"/>
+                        </a:spcAft>
+                        <a:lnSpc>
+                          <a:spcPct val="100000"/>
+                        </a:lnSpc>
+                      </a:pPr>
+                      <a:r>
+                        <a:rPr sz="1200" b="0">
+                          <a:solidFill>
+                            <a:srgbClr val="1C242E"/>
+                          </a:solidFill>
+                          <a:latin typeface="Microsoft YaHei"/>
+                          <a:ea typeface="Microsoft YaHei"/>
+                          <a:cs typeface="Microsoft YaHei"/>
+                        </a:rPr>
+                        <a:t>3.14 秒</a:t>
+                      </a:r>
+                    </a:p>
+                  </a:txBody>
+                  <a:tcPr marL="54864" marR="54864" marT="27432" marB="18288" anchor="ctr">
+                    <a:solidFill>
+                      <a:srgbClr val="FFFFFF"/>
+                    </a:solidFill>
+                    <a:lnL w="6350">
+                      <a:solidFill>
+                        <a:srgbClr val="D6DCE2"/>
+                      </a:solidFill>
+                    </a:lnL>
+                    <a:lnR w="6350">
+                      <a:solidFill>
+                        <a:srgbClr val="D6DCE2"/>
+                      </a:solidFill>
+                    </a:lnR>
+                    <a:lnT w="6350">
+                      <a:solidFill>
+                        <a:srgbClr val="D6DCE2"/>
+                      </a:solidFill>
+                    </a:lnT>
+                    <a:lnB w="6350">
+                      <a:solidFill>
+                        <a:srgbClr val="D6DCE2"/>
+                      </a:solidFill>
+                    </a:lnB>
+                  </a:tcPr>
+                </a:tc>
+              </a:tr>
+              <a:tr h="393192">
+                <a:tc>
+                  <a:txBody>
+                    <a:bodyPr wrap="square"/>
+                    <a:lstStyle/>
+                    <a:p>
+                      <a:pPr algn="l">
+                        <a:spcBef>
+                          <a:spcPts val="0"/>
+                        </a:spcBef>
+                        <a:spcAft>
+                          <a:spcPts val="0"/>
+                        </a:spcAft>
+                        <a:lnSpc>
+                          <a:spcPct val="100000"/>
+                        </a:lnSpc>
+                      </a:pPr>
+                      <a:r>
+                        <a:rPr sz="1200" b="1">
+                          <a:solidFill>
+                            <a:srgbClr val="0E7A76"/>
+                          </a:solidFill>
+                          <a:latin typeface="Microsoft YaHei"/>
+                          <a:ea typeface="Microsoft YaHei"/>
+                          <a:cs typeface="Microsoft YaHei"/>
+                        </a:rPr>
+                        <a:t>1M</a:t>
+                      </a:r>
+                    </a:p>
+                  </a:txBody>
+                  <a:tcPr marL="54864" marR="54864" marT="27432" marB="18288" anchor="ctr">
+                    <a:solidFill>
+                      <a:srgbClr val="F4F7FA"/>
+                    </a:solidFill>
+                    <a:lnL w="6350">
+                      <a:solidFill>
+                        <a:srgbClr val="D6DCE2"/>
+                      </a:solidFill>
+                    </a:lnL>
+                    <a:lnR w="6350">
+                      <a:solidFill>
+                        <a:srgbClr val="D6DCE2"/>
+                      </a:solidFill>
+                    </a:lnR>
+                    <a:lnT w="6350">
+                      <a:solidFill>
+                        <a:srgbClr val="D6DCE2"/>
+                      </a:solidFill>
+                    </a:lnT>
+                    <a:lnB w="6350">
+                      <a:solidFill>
+                        <a:srgbClr val="D6DCE2"/>
+                      </a:solidFill>
+                    </a:lnB>
+                  </a:tcPr>
+                </a:tc>
+                <a:tc>
+                  <a:txBody>
+                    <a:bodyPr wrap="square"/>
+                    <a:lstStyle/>
+                    <a:p>
+                      <a:pPr algn="l">
+                        <a:spcBef>
+                          <a:spcPts val="0"/>
+                        </a:spcBef>
+                        <a:spcAft>
+                          <a:spcPts val="0"/>
+                        </a:spcAft>
+                        <a:lnSpc>
+                          <a:spcPct val="100000"/>
+                        </a:lnSpc>
+                      </a:pPr>
+                      <a:r>
+                        <a:rPr sz="1200" b="1">
+                          <a:solidFill>
+                            <a:srgbClr val="0E7A76"/>
+                          </a:solidFill>
+                          <a:latin typeface="Microsoft YaHei"/>
+                          <a:ea typeface="Microsoft YaHei"/>
+                          <a:cs typeface="Microsoft YaHei"/>
+                        </a:rPr>
+                        <a:t>64</a:t>
+                      </a:r>
+                    </a:p>
+                  </a:txBody>
+                  <a:tcPr marL="54864" marR="54864" marT="27432" marB="18288" anchor="ctr">
+                    <a:solidFill>
+                      <a:srgbClr val="E7F3F2"/>
+                    </a:solidFill>
+                    <a:lnL w="6350">
+                      <a:solidFill>
+                        <a:srgbClr val="D6DCE2"/>
+                      </a:solidFill>
+                    </a:lnL>
+                    <a:lnR w="6350">
+                      <a:solidFill>
+                        <a:srgbClr val="D6DCE2"/>
+                      </a:solidFill>
+                    </a:lnR>
+                    <a:lnT w="6350">
+                      <a:solidFill>
+                        <a:srgbClr val="D6DCE2"/>
+                      </a:solidFill>
+                    </a:lnT>
+                    <a:lnB w="6350">
+                      <a:solidFill>
+                        <a:srgbClr val="D6DCE2"/>
+                      </a:solidFill>
+                    </a:lnB>
+                  </a:tcPr>
+                </a:tc>
+                <a:tc>
+                  <a:txBody>
+                    <a:bodyPr wrap="square"/>
+                    <a:lstStyle/>
+                    <a:p>
+                      <a:pPr algn="l">
+                        <a:spcBef>
+                          <a:spcPts val="0"/>
+                        </a:spcBef>
+                        <a:spcAft>
+                          <a:spcPts val="0"/>
+                        </a:spcAft>
+                        <a:lnSpc>
+                          <a:spcPct val="100000"/>
+                        </a:lnSpc>
+                      </a:pPr>
+                      <a:r>
+                        <a:rPr sz="1200" b="1">
+                          <a:solidFill>
+                            <a:srgbClr val="0E7A76"/>
+                          </a:solidFill>
+                          <a:latin typeface="Microsoft YaHei"/>
+                          <a:ea typeface="Microsoft YaHei"/>
+                          <a:cs typeface="Microsoft YaHei"/>
+                        </a:rPr>
+                        <a:t>1.34×10^6</a:t>
+                      </a:r>
+                    </a:p>
+                  </a:txBody>
+                  <a:tcPr marL="54864" marR="54864" marT="27432" marB="18288" anchor="ctr">
+                    <a:solidFill>
+                      <a:srgbClr val="E7F3F2"/>
+                    </a:solidFill>
+                    <a:lnL w="6350">
+                      <a:solidFill>
+                        <a:srgbClr val="D6DCE2"/>
+                      </a:solidFill>
+                    </a:lnL>
+                    <a:lnR w="6350">
+                      <a:solidFill>
+                        <a:srgbClr val="D6DCE2"/>
+                      </a:solidFill>
+                    </a:lnR>
+                    <a:lnT w="6350">
+                      <a:solidFill>
+                        <a:srgbClr val="D6DCE2"/>
+                      </a:solidFill>
+                    </a:lnT>
+                    <a:lnB w="6350">
+                      <a:solidFill>
+                        <a:srgbClr val="D6DCE2"/>
+                      </a:solidFill>
+                    </a:lnB>
+                  </a:tcPr>
+                </a:tc>
+                <a:tc>
+                  <a:txBody>
+                    <a:bodyPr wrap="square"/>
+                    <a:lstStyle/>
+                    <a:p>
+                      <a:pPr algn="l">
+                        <a:spcBef>
+                          <a:spcPts val="0"/>
+                        </a:spcBef>
+                        <a:spcAft>
+                          <a:spcPts val="0"/>
+                        </a:spcAft>
+                        <a:lnSpc>
+                          <a:spcPct val="100000"/>
+                        </a:lnSpc>
+                      </a:pPr>
+                      <a:r>
+                        <a:rPr sz="1200" b="1">
+                          <a:solidFill>
+                            <a:srgbClr val="0E7A76"/>
+                          </a:solidFill>
+                          <a:latin typeface="Microsoft YaHei"/>
+                          <a:ea typeface="Microsoft YaHei"/>
+                          <a:cs typeface="Microsoft YaHei"/>
+                        </a:rPr>
+                        <a:t>0.17 秒</a:t>
+                      </a:r>
+                    </a:p>
+                  </a:txBody>
+                  <a:tcPr marL="54864" marR="54864" marT="27432" marB="18288" anchor="ctr">
+                    <a:solidFill>
+                      <a:srgbClr val="E7F3F2"/>
+                    </a:solidFill>
+                    <a:lnL w="6350">
+                      <a:solidFill>
+                        <a:srgbClr val="D6DCE2"/>
+                      </a:solidFill>
+                    </a:lnL>
+                    <a:lnR w="6350">
+                      <a:solidFill>
+                        <a:srgbClr val="D6DCE2"/>
+                      </a:solidFill>
+                    </a:lnR>
+                    <a:lnT w="6350">
+                      <a:solidFill>
+                        <a:srgbClr val="D6DCE2"/>
+                      </a:solidFill>
+                    </a:lnT>
+                    <a:lnB w="6350">
+                      <a:solidFill>
+                        <a:srgbClr val="D6DCE2"/>
+                      </a:solidFill>
+                    </a:lnB>
+                  </a:tcPr>
+                </a:tc>
+                <a:tc>
+                  <a:txBody>
+                    <a:bodyPr wrap="square"/>
+                    <a:lstStyle/>
+                    <a:p>
+                      <a:pPr algn="l">
+                        <a:spcBef>
+                          <a:spcPts val="0"/>
+                        </a:spcBef>
+                        <a:spcAft>
+                          <a:spcPts val="0"/>
+                        </a:spcAft>
+                        <a:lnSpc>
+                          <a:spcPct val="100000"/>
+                        </a:lnSpc>
+                      </a:pPr>
+                      <a:r>
+                        <a:rPr sz="1200" b="1">
+                          <a:solidFill>
+                            <a:srgbClr val="0E7A76"/>
+                          </a:solidFill>
+                          <a:latin typeface="Microsoft YaHei"/>
+                          <a:ea typeface="Microsoft YaHei"/>
+                          <a:cs typeface="Microsoft YaHei"/>
+                        </a:rPr>
+                        <a:t>13.4 毫秒</a:t>
+                      </a:r>
+                    </a:p>
+                  </a:txBody>
+                  <a:tcPr marL="54864" marR="54864" marT="27432" marB="18288" anchor="ctr">
+                    <a:solidFill>
+                      <a:srgbClr val="E7F3F2"/>
+                    </a:solidFill>
+                    <a:lnL w="6350">
+                      <a:solidFill>
+                        <a:srgbClr val="D6DCE2"/>
+                      </a:solidFill>
+                    </a:lnL>
+                    <a:lnR w="6350">
+                      <a:solidFill>
+                        <a:srgbClr val="D6DCE2"/>
+                      </a:solidFill>
+                    </a:lnR>
+                    <a:lnT w="6350">
+                      <a:solidFill>
+                        <a:srgbClr val="D6DCE2"/>
+                      </a:solidFill>
+                    </a:lnT>
+                    <a:lnB w="6350">
+                      <a:solidFill>
+                        <a:srgbClr val="D6DCE2"/>
+                      </a:solidFill>
+                    </a:lnB>
+                  </a:tcPr>
+                </a:tc>
+                <a:tc>
+                  <a:txBody>
+                    <a:bodyPr wrap="square"/>
+                    <a:lstStyle/>
+                    <a:p>
+                      <a:pPr algn="l">
+                        <a:spcBef>
+                          <a:spcPts val="0"/>
+                        </a:spcBef>
+                        <a:spcAft>
+                          <a:spcPts val="0"/>
+                        </a:spcAft>
+                        <a:lnSpc>
+                          <a:spcPct val="100000"/>
+                        </a:lnSpc>
+                      </a:pPr>
+                      <a:r>
+                        <a:rPr sz="1200" b="1">
+                          <a:solidFill>
+                            <a:srgbClr val="0E7A76"/>
+                          </a:solidFill>
+                          <a:latin typeface="Microsoft YaHei"/>
+                          <a:ea typeface="Microsoft YaHei"/>
+                          <a:cs typeface="Microsoft YaHei"/>
+                        </a:rPr>
+                        <a:t>1.75 秒</a:t>
+                      </a:r>
+                    </a:p>
+                  </a:txBody>
+                  <a:tcPr marL="54864" marR="54864" marT="27432" marB="18288" anchor="ctr">
+                    <a:solidFill>
+                      <a:srgbClr val="E7F3F2"/>
+                    </a:solidFill>
+                    <a:lnL w="6350">
+                      <a:solidFill>
+                        <a:srgbClr val="D6DCE2"/>
+                      </a:solidFill>
+                    </a:lnL>
+                    <a:lnR w="6350">
+                      <a:solidFill>
+                        <a:srgbClr val="D6DCE2"/>
+                      </a:solidFill>
+                    </a:lnR>
+                    <a:lnT w="6350">
+                      <a:solidFill>
+                        <a:srgbClr val="D6DCE2"/>
+                      </a:solidFill>
+                    </a:lnT>
+                    <a:lnB w="6350">
+                      <a:solidFill>
+                        <a:srgbClr val="D6DCE2"/>
+                      </a:solidFill>
+                    </a:lnB>
+                  </a:tcPr>
+                </a:tc>
+                <a:tc>
+                  <a:txBody>
+                    <a:bodyPr wrap="square"/>
+                    <a:lstStyle/>
+                    <a:p>
+                      <a:pPr algn="l">
+                        <a:spcBef>
+                          <a:spcPts val="0"/>
+                        </a:spcBef>
+                        <a:spcAft>
+                          <a:spcPts val="0"/>
+                        </a:spcAft>
+                        <a:lnSpc>
+                          <a:spcPct val="100000"/>
+                        </a:lnSpc>
+                      </a:pPr>
+                      <a:r>
+                        <a:rPr sz="1200" b="1">
+                          <a:solidFill>
+                            <a:srgbClr val="0E7A76"/>
+                          </a:solidFill>
+                          <a:latin typeface="Microsoft YaHei"/>
+                          <a:ea typeface="Microsoft YaHei"/>
+                          <a:cs typeface="Microsoft YaHei"/>
+                        </a:rPr>
+                        <a:t>0.17 秒</a:t>
+                      </a:r>
+                    </a:p>
+                  </a:txBody>
+                  <a:tcPr marL="54864" marR="54864" marT="27432" marB="18288" anchor="ctr">
+                    <a:solidFill>
+                      <a:srgbClr val="E7F3F2"/>
+                    </a:solidFill>
+                    <a:lnL w="6350">
+                      <a:solidFill>
+                        <a:srgbClr val="D6DCE2"/>
+                      </a:solidFill>
+                    </a:lnL>
+                    <a:lnR w="6350">
+                      <a:solidFill>
+                        <a:srgbClr val="D6DCE2"/>
+                      </a:solidFill>
+                    </a:lnR>
+                    <a:lnT w="6350">
+                      <a:solidFill>
+                        <a:srgbClr val="D6DCE2"/>
+                      </a:solidFill>
+                    </a:lnT>
+                    <a:lnB w="6350">
+                      <a:solidFill>
+                        <a:srgbClr val="D6DCE2"/>
+                      </a:solidFill>
+                    </a:lnB>
+                  </a:tcPr>
+                </a:tc>
+                <a:tc>
+                  <a:txBody>
+                    <a:bodyPr wrap="square"/>
+                    <a:lstStyle/>
+                    <a:p>
+                      <a:pPr algn="l">
+                        <a:spcBef>
+                          <a:spcPts val="0"/>
+                        </a:spcBef>
+                        <a:spcAft>
+                          <a:spcPts val="0"/>
+                        </a:spcAft>
+                        <a:lnSpc>
+                          <a:spcPct val="100000"/>
+                        </a:lnSpc>
+                      </a:pPr>
+                      <a:r>
+                        <a:rPr sz="1200" b="1">
+                          <a:solidFill>
+                            <a:srgbClr val="0E7A76"/>
+                          </a:solidFill>
+                          <a:latin typeface="Microsoft YaHei"/>
+                          <a:ea typeface="Microsoft YaHei"/>
+                          <a:cs typeface="Microsoft YaHei"/>
+                        </a:rPr>
+                        <a:t>2.10 秒</a:t>
+                      </a:r>
+                    </a:p>
+                  </a:txBody>
+                  <a:tcPr marL="54864" marR="54864" marT="27432" marB="18288" anchor="ctr">
+                    <a:solidFill>
+                      <a:srgbClr val="E7F3F2"/>
+                    </a:solidFill>
+                    <a:lnL w="6350">
+                      <a:solidFill>
+                        <a:srgbClr val="D6DCE2"/>
+                      </a:solidFill>
+                    </a:lnL>
+                    <a:lnR w="6350">
+                      <a:solidFill>
+                        <a:srgbClr val="D6DCE2"/>
+                      </a:solidFill>
+                    </a:lnR>
+                    <a:lnT w="6350">
+                      <a:solidFill>
+                        <a:srgbClr val="D6DCE2"/>
+                      </a:solidFill>
+                    </a:lnT>
+                    <a:lnB w="6350">
+                      <a:solidFill>
+                        <a:srgbClr val="D6DCE2"/>
+                      </a:solidFill>
+                    </a:lnB>
+                  </a:tcPr>
+                </a:tc>
+              </a:tr>
+            </a:tbl>
+          </a:graphicData>
+        </a:graphic>
+      </p:graphicFrame>
+      <p:sp>
+        <p:nvSpPr>
+          <p:cNvPr id="11" name="Rounded Rectangle 10"/>
+          <p:cNvSpPr/>
+          <p:nvPr/>
+        </p:nvSpPr>
+        <p:spPr>
+          <a:xfrm>
+            <a:off x="384048" y="4846320"/>
+            <a:ext cx="11430000" cy="1426464"/>
+          </a:xfrm>
+          <a:prstGeom prst="roundRect">
+            <a:avLst/>
+          </a:prstGeom>
+          <a:solidFill>
+            <a:srgbClr val="F8F1E4"/>
+          </a:solidFill>
+          <a:ln>
+            <a:noFill/>
+          </a:ln>
+        </p:spPr>
+        <p:style>
+          <a:lnRef idx="1">
+            <a:schemeClr val="accent1"/>
+          </a:lnRef>
+          <a:fillRef idx="3">
+            <a:schemeClr val="accent1"/>
+          </a:fillRef>
+          <a:effectRef idx="2">
+            <a:schemeClr val="accent1"/>
+          </a:effectRef>
+          <a:fontRef idx="minor">
+            <a:schemeClr val="lt1"/>
+          </a:fontRef>
+        </p:style>
+        <p:txBody>
+          <a:bodyPr rtlCol="0" anchor="ctr"/>
+          <a:lstStyle/>
+          <a:p>
+            <a:pPr algn="ctr"/>
+          </a:p>
+        </p:txBody>
+      </p:sp>
+      <p:sp>
+        <p:nvSpPr>
+          <p:cNvPr id="12" name="TextBox 11"/>
+          <p:cNvSpPr txBox="1"/>
+          <p:nvPr/>
+        </p:nvSpPr>
+        <p:spPr>
+          <a:xfrm>
+            <a:off x="530352" y="4901184"/>
+            <a:ext cx="11137392" cy="1316736"/>
+          </a:xfrm>
+          <a:prstGeom prst="rect">
+            <a:avLst/>
+          </a:prstGeom>
+          <a:noFill/>
+        </p:spPr>
+        <p:txBody>
+          <a:bodyPr wrap="square" lIns="0" rIns="0" tIns="0" bIns="0" anchor="ctr"/>
+          <a:lstStyle/>
+          <a:p>
+            <a:pPr algn="l">
+              <a:spcBef>
+                <a:spcPts val="0"/>
+              </a:spcBef>
+              <a:spcAft>
+                <a:spcPts val="0"/>
+              </a:spcAft>
+            </a:pPr>
+            <a:r>
+              <a:rPr sz="1300" b="0">
+                <a:solidFill>
+                  <a:srgbClr val="7A541C"/>
+                </a:solidFill>
+                <a:latin typeface="Microsoft YaHei"/>
+                <a:ea typeface="Microsoft YaHei"/>
+                <a:cs typeface="Microsoft YaHei"/>
+              </a:rPr>
+              <a:t>4K：dispatch 0.48 秒 + max(权重 13.4 毫秒，GEMM 4.87 秒) + combine 0.48 秒 = 5.83 秒。</a:t>
+            </a:r>
+          </a:p>
+          <a:p>
+            <a:pPr algn="l">
+              <a:spcBef>
+                <a:spcPts val="0"/>
+              </a:spcBef>
+              <a:spcAft>
+                <a:spcPts val="0"/>
+              </a:spcAft>
+            </a:pPr>
+            <a:r>
+              <a:rPr sz="1300" b="0">
+                <a:solidFill>
+                  <a:srgbClr val="7A541C"/>
+                </a:solidFill>
+                <a:latin typeface="Microsoft YaHei"/>
+                <a:ea typeface="Microsoft YaHei"/>
+                <a:cs typeface="Microsoft YaHei"/>
+              </a:rPr>
+              <a:t>1M：dispatch 0.17 秒 + max(权重 13.4 毫秒，GEMM 1.75 秒) + combine 0.17 秒 = 2.10 秒。</a:t>
+            </a:r>
+          </a:p>
+          <a:p>
+            <a:pPr algn="l">
+              <a:spcBef>
+                <a:spcPts val="0"/>
+              </a:spcBef>
+              <a:spcAft>
+                <a:spcPts val="0"/>
+              </a:spcAft>
+            </a:pPr>
+            <a:r>
+              <a:rPr sz="1300" b="0">
+                <a:solidFill>
+                  <a:srgbClr val="7A541C"/>
+                </a:solidFill>
+                <a:latin typeface="Microsoft YaHei"/>
+                <a:ea typeface="Microsoft YaHei"/>
+                <a:cs typeface="Microsoft YaHei"/>
+              </a:rPr>
+              <a:t>所有长度都已激活每卡全部路由专家，权重读取稳定在13.4毫秒并被GEMM完全隐藏；主要开销是专家GEMM，其次是两次EP通信。</a:t>
+            </a:r>
+          </a:p>
+        </p:txBody>
+      </p:sp>
+    </p:spTree>
+  </p:cSld>
+  <p:clrMapOvr>
+    <a:masterClrMapping/>
+  </p:clrMapOvr>
+</p:sld>
+</file>
+
 <file path=ppt/slides/slide2.xml><?xml version="1.0" encoding="utf-8"?>
 <p:sld xmlns:a="http://schemas.openxmlformats.org/drawingml/2006/main" xmlns:p="http://schemas.openxmlformats.org/presentationml/2006/main" xmlns:r="http://schemas.openxmlformats.org/officeDocument/2006/relationships">
   <p:cSld>
@@ -14015,7 +18136,7 @@
                 <a:ea typeface="Microsoft YaHei"/>
                 <a:cs typeface="Microsoft YaHei"/>
               </a:rPr>
-              <a:t>2  /  13</a:t>
+              <a:t>2  /  14</a:t>
             </a:r>
           </a:p>
         </p:txBody>
@@ -16869,7 +20990,7 @@
                 <a:ea typeface="Microsoft YaHei"/>
                 <a:cs typeface="Microsoft YaHei"/>
               </a:rPr>
-              <a:t>3  /  13</a:t>
+              <a:t>3  /  14</a:t>
             </a:r>
           </a:p>
         </p:txBody>
@@ -22324,7 +26445,7 @@
                 <a:ea typeface="Microsoft YaHei"/>
                 <a:cs typeface="Microsoft YaHei"/>
               </a:rPr>
-              <a:t>4  /  13</a:t>
+              <a:t>4  /  14</a:t>
             </a:r>
           </a:p>
         </p:txBody>
@@ -25660,7 +29781,7 @@
                 <a:ea typeface="Microsoft YaHei"/>
                 <a:cs typeface="Microsoft YaHei"/>
               </a:rPr>
-              <a:t>5  /  13</a:t>
+              <a:t>5  /  14</a:t>
             </a:r>
           </a:p>
         </p:txBody>
@@ -28996,7 +33117,7 @@
                 <a:ea typeface="Microsoft YaHei"/>
                 <a:cs typeface="Microsoft YaHei"/>
               </a:rPr>
-              <a:t>6  /  13</a:t>
+              <a:t>6  /  14</a:t>
             </a:r>
           </a:p>
         </p:txBody>
@@ -33046,7 +37167,7 @@
                 <a:ea typeface="Microsoft YaHei"/>
                 <a:cs typeface="Microsoft YaHei"/>
               </a:rPr>
-              <a:t>7  /  13</a:t>
+              <a:t>7  /  14</a:t>
             </a:r>
           </a:p>
         </p:txBody>
@@ -35225,7 +39346,7 @@
                 <a:ea typeface="Microsoft YaHei"/>
                 <a:cs typeface="Microsoft YaHei"/>
               </a:rPr>
-              <a:t>8  /  13</a:t>
+              <a:t>8  /  14</a:t>
             </a:r>
           </a:p>
         </p:txBody>
@@ -39934,7 +44055,7 @@
                 <a:ea typeface="Microsoft YaHei"/>
                 <a:cs typeface="Microsoft YaHei"/>
               </a:rPr>
-              <a:t>9  /  13</a:t>
+              <a:t>9  /  14</a:t>
             </a:r>
           </a:p>
         </p:txBody>

</xml_diff>

<commit_message>
docs: route Decode DDR swaps over H2D
Co-authored-by: 69515164-rgb <69515164-rgb@users.noreply.github.com>
</commit_message>
<xml_diff>
--- a/docs/deepseek-96g-slo.pptx
+++ b/docs/deepseek-96g-slo.pptx
@@ -1481,7 +1481,7 @@
           <a:lstStyle/>
           <a:p>
             <a:r>
-              <a:t>1.6T 来自 V4-Pro 论文 arXiv:2606.19348：61 层，隐藏 7168，384 个路由专家，中间维 3072，每 token 激活 6 个，激活参数 49B。单个路由专家在全部层上是 3×7168×3072×61 = 4.030×10^9。384 个专家为 1.547×10^12，总参数 1.600×10^12 减去这一项，其余 5.260×10^10 含共享专家、注意力、mHC、词表和 MTP。10T 把专家数解成 2469，总参数 = 2469×4.030×10^9 + 5.260×10^10 = 1.000×10^13。FP4 容量 = 2469×4.030×10^9×0.5 字节 = 4.975 TB。640 GB 卡下限是 ceil(4.975 TB / 640 GB) = 8。单 token 通信量 6×3×7168×61 = 7.87×10^6 字节。每 token 仍只派 6 个专家，通信量不随专家总数变。后面几页是 96 GB、486 T 这一档。算力 486×10^12 再乘 70%，有效 340.2×10^12。注意力和专家用同一个峰值。HBM 96 GB，带宽 4 TB/s，计时取 80% 即 3.20 TB/s。H2D 是 64 GB/s（字节），80% 后 51.2 GB/s。这条链路只在 prefill 使用。权重放得进 HBM，冷的 10 秒不走 H2D。D2D 3.2 Tb/s：换算400 GB/s峰值，80%后320 GB/s。8卡fullmesh每卡有7条400 Gb/s链路：聚合350 GB/s峰值，受D2D口约束前已较低，80%后AllReduce按280 GB/s。参数面400 Gb/s，80%后40 GB/s。DDR5 的 1288.8 GB/s 和 768 GB 按一台 8 卡机器记。有效 1031 GB/s，每卡分到 128.9 GB/s 和 96 GB。H2D 只有 51.2 GB/s，主机路径被 H2D 卡住。超节点内直挂总线的 DDR 池容量不设上限，标称每卡 480 GB/s。GPU 单向口只有 400 GB/s，池的访问取两者里较慢的，80% 后 320 GB/s。换入发生在注意力阶段，专家 combine 发生在 MoE 阶段，两段各用满这条 320 GB/s。本页的池带宽按每卡，不把 480 GB/s 理解成 128 卡共享。注意力 TP=8 留在机内 fullmesh，16 台机器做 DP=16。MoE EP=128 走 D2D。每卡扣掉路由 38.86 GB、共享 4.03 GB、注意力 2.42 GB 和 6 GB 预留后，128 卡 KV 余量 5.72 TB。Prefill 与 Decode 的副本数可以按吞吐配，副本个数不改变单副本的 TTFT 和 TPOT。</a:t>
+              <a:t>1.6T 来自 V4-Pro 论文 arXiv:2606.19348：61 层，隐藏 7168，384 个路由专家，中间维 3072，每 token 激活 6 个，激活参数 49B。单个路由专家在全部层上是 3×7168×3072×61 = 4.030×10^9。384 个专家为 1.547×10^12，总参数 1.600×10^12 减去这一项，其余 5.260×10^10 含共享专家、注意力、mHC、词表和 MTP。10T 把专家数解成 2469，总参数 = 2469×4.030×10^9 + 5.260×10^10 = 1.000×10^13。FP4 容量 = 2469×4.030×10^9×0.5 字节 = 4.975 TB。640 GB 卡下限是 ceil(4.975 TB / 640 GB) = 8。单 token 通信量 6×3×7168×61 = 7.87×10^6 字节。每 token 仍只派 6 个专家，通信量不随专家总数变。后面几页是 96 GB、486 T 这一档。算力 486×10^12 再乘 70%，有效 340.2×10^12。注意力和专家用同一个峰值。HBM 96 GB，带宽 4 TB/s，计时取 80% 即 3.20 TB/s。H2D是64 GB/s（字节），80%后51.2 GB/s。Prefill主机输入和Decode的外部DDR/KV换入都走这条链路；HBM内权重与KV仍按3.20 TB/s读取。D2D 3.2 Tb/s：换算400 GB/s峰值，80%后320 GB/s。8卡fullmesh每卡有7条400 Gb/s链路：聚合350 GB/s峰值，受D2D口约束前已较低，80%后AllReduce按280 GB/s。参数面400 Gb/s，80%后40 GB/s。DDR5 的 1288.8 GB/s 和 768 GB 按一台 8 卡机器记。有效 1031 GB/s，每卡分到 128.9 GB/s 和 96 GB。H2D 只有 51.2 GB/s，主机路径被 H2D 卡住。DDR池容量不设上限、标称480 GB/s，但Decode外部访存必须经过每卡H2D：min(480×80%, 64×80%, 128.9)=51.2 GB/s。MoE dispatch/combine仍走独立D2D平面320 GB/s。本页的池带宽按每卡，不把 480 GB/s 理解成 128 卡共享。注意力 TP=8 留在机内 fullmesh，16 台机器做 DP=16。MoE EP=128 走 D2D。每卡扣掉路由 38.86 GB、共享 4.03 GB、注意力 2.42 GB 和 6 GB 预留后，128 卡 KV 余量 5.72 TB。Prefill 与 Decode 的副本数可以按吞吐配，副本个数不改变单副本的 TTFT 和 TPOT。</a:t>
             </a:r>
           </a:p>
         </p:txBody>
@@ -1761,7 +1761,7 @@
           <a:lstStyle/>
           <a:p>
             <a:r>
-              <a:t>Decode 饼图使用 30ms 最大批，按最忙活跃 GPU。HBM KV 上限 44.687 GB。4K: BS=7936, hbm_kv=1.533GB, pool=0.000GB, free=43.154GB. 256K: BS=4880, hbm_kv=44.687GB, pool=4.851GB, free=0.000GB. 1M: BS=1528, hbm_kv=44.687GB, pool=17.520GB, free=0.000GB.</a:t>
+              <a:t>Decode 饼图使用 30ms 最大批，按最忙活跃 GPU。HBM KV 上限 44.687 GB。4K: BS=7936, hbm_kv=1.533GB, pool=0.000GB, free=43.154GB. 256K: BS=4526, hbm_kv=44.687GB, pool=1.278GB, free=0.000GB. 1M: BS=1186, hbm_kv=44.687GB, pool=3.912GB, free=0.000GB.</a:t>
             </a:r>
           </a:p>
         </p:txBody>
@@ -2041,7 +2041,7 @@
           <a:lstStyle/>
           <a:p>
             <a:r>
-              <a:t>Decode 与 Prefill 用同一份 128 卡副本：注意力 TP=8、DP=16，MoE EP=128。加 Decode 节点是多副本，单副本的 TPOT 不变。Attention = SWAP + max(HBM, compute) + AR。MoE = dispatch + max(weight, GEMM) + combine。两段相加。命中率 = 1 − exp(−6×222 / 2469) = 0.4170。最忙卡激活专家 12.374。读权重 (12.374×2.015 GB + 4.030 GB) / 3.20 TB/s = 9.050 ms。机内 allreduce：ceil(222/16) = 14 条，每条7168×2字节，每层通信量2×7/8，61层除以280 GB/s = 0.077 ms。Attention 0.846 ms，MoE 9.142 ms，合计 9.988 ms。223 条是 10.007 ms。专家计算 5.069 ms，EP 双向 0.092 ms。注意力计算 0.285 ms，HBM 0.769 ms。4K – 32K 的全局批都是 222，KV 全在 HBM。2M 降到 145，存量约 0.0% 在总线内存池，池上稀疏读 0.00 ms，已经顶到 allreduce 留下的预算。1M 降到 190，0.33×10^6 降到 216。这些批的存量都放得进 HBM，池上换入是 0。H2D 只在 prefill。</a:t>
+              <a:t>Decode 与 Prefill 用同一份 128 卡副本：注意力 TP=8、DP=16，MoE EP=128。加 Decode 节点是多副本，单副本的 TPOT 不变。Attention = SWAP + max(HBM, compute) + AR。MoE = dispatch + max(weight, GEMM) + combine。两段相加。命中率 = 1 − exp(−6×222 / 2469) = 0.4170。最忙卡激活专家 12.374。读权重 (12.374×2.015 GB + 4.030 GB) / 3.20 TB/s = 9.050 ms。机内 allreduce：ceil(222/16) = 14 条，每条7168×2字节，每层通信量2×7/8，61层除以280 GB/s = 0.077 ms。Attention 0.846 ms，MoE 9.142 ms，合计 9.988 ms。223 条是 10.007 ms。专家计算 5.069 ms，EP 双向 0.092 ms。注意力计算 0.285 ms，HBM 0.769 ms。4K – 32K 的全局批都是 222，KV 全在 HBM。2M 降到 145，池上KV经H2D换入 0.00 ms。1M 降到 190，0.33×10^6 降到 216。HBM放不下的Decode KV统一走51.2 GB/s H2D。</a:t>
             </a:r>
           </a:p>
         </p:txBody>
@@ -2111,7 +2111,7 @@
           <a:lstStyle/>
           <a:p>
             <a:r>
-              <a:t>30 毫秒用的切分与 10 毫秒相同：TP=8，DP=16，EP=128，128 卡一份副本。BS=7936 时命中率 1.0000，最忙卡激活 19.289 个专家。读权重 (38.86 GB + 4.03 GB) / 3.20 TB/s = 13.404 ms。机内 allreduce：ceil(7936/16) = 496 条，每层通信量2×7/8，61层，除以280 GB/s = 2.711 ms。Attention 11.554 ms，MoE 18.382 ms，合计 29.936 ms。7937 条是 30.227 ms。EP 双向 2.243 ms，专家计算 16.139 ms，效率 0.665。注意力计算 8.843 ms。显存：每卡 96 − 38.86 − 4.03 − 2.42 − 6 = 44.69 GB，128 卡共 5.72 TB。HBM 放不下的 KV 走每卡总线内存池。标称 480 GB/s，被 3.2 Tb/s 的口卡住，有效 320 GB/s，容量不设上限。H2D 只在 prefill。256K、全局批 4880 时已有 9.8% KV 在池中，池上读 2.15 ms。512K 降到 2816，池上读 5.18 ms。1M 降到 1528，0.33×10^6 降到 4096。4K、输出 512、命中 98%：Prefill 4567.4 请求/秒。10 毫秒 Decode 43.4 请求/秒，P:D ≈ 1:105.3。30 毫秒 Decode 516.7 请求/秒，P:D ≈ 1:8.8。</a:t>
+              <a:t>30 毫秒用的切分与 10 毫秒相同：TP=8，DP=16，EP=128，128 卡一份副本。BS=7936 时命中率 1.0000，最忙卡激活 19.289 个专家。读权重 (38.86 GB + 4.03 GB) / 3.20 TB/s = 13.404 ms。机内 allreduce：ceil(7936/16) = 496 条，每层通信量2×7/8，61层，除以280 GB/s = 2.711 ms。Attention 11.554 ms，MoE 18.382 ms，合计 29.936 ms。7937 条是 30.227 ms。EP 双向 2.243 ms，专家计算 16.139 ms，效率 0.665。注意力计算 8.843 ms。显存：每卡 96 − 38.86 − 4.03 − 2.42 − 6 = 44.69 GB，128 卡共 5.72 TB。HBM放不下的Decode KV统一经每卡H2D换入。标称64 GB/s取80%为51.2 GB/s；DDR池容量不设上限。256K、全局批 4526 时已有 2.7% KV 在池中，池上读 3.49 ms。512K 降到 2327，池上读 6.49 ms。1M 降到 1186，0.33×10^6 降到 3644。4K、输出 512、命中 98%：Prefill 4567.4 请求/秒。10 毫秒 Decode 43.4 请求/秒，P:D ≈ 1:105.3。30 毫秒 Decode 516.7 请求/秒，P:D ≈ 1:8.8。</a:t>
             </a:r>
           </a:p>
         </p:txBody>
@@ -2181,7 +2181,7 @@
           <a:lstStyle/>
           <a:p>
             <a:r>
-              <a:t>BS 一律是 128 卡副本的全局批。每卡条数 = 全局批 / 128。存量 = S×4939.5 字节 + 4.50 MB。一步真正读的是压缩 indexer、最多 1024 条完整 KV 和 HCA，所以溢出比例高时，池上的读时延仍可能短于 allreduce。HBM 余量 5.72 TB。溢出进 GPU 的口是每卡总线内存池，有效 320 GB/s，容量不设上限。这个带宽是 min(480 GB/s, 3.2 Tb/s = 400 GB/s) 再取 80%。专家通信在 MoE 阶段走同一条 320 GB/s。H2D 64 GB/s 只在 prefill，decode 换入走内存池。Decode Attention = SWAP + max(HBM, compute) + AR；再加完整 MoE。S=4096 store=24.7MB cap=231300 b10=222 spill10=0.00% pool10=0.00ms b30=7936 spill30=0.00% pool30=0.00ms t30=29.94ms S=8192 store=45.0MB cap=127218 b10=222 spill10=0.00% pool10=0.00ms b30=7808 spill30=0.00% pool30=0.00ms t30=30.00ms S=32768 store=166.4MB cap=34384 b10=222 spill10=0.00% pool10=0.00ms b30=7424 spill30=0.00% pool30=0.00ms t30=29.96ms S=131072 store=651.9MB cap=8773 b10=220 spill10=0.00% pool10=0.00ms b30=6144 spill30=0.00% pool30=0.00ms t30=29.80ms S=262144 store=1299.4MB cap=4402 b10=218 spill10=0.00% pool10=0.00ms b30=4880 spill30=9.79% pool30=2.15ms t30=30.00ms S=524288 store=2594.2MB cap=2204 b10=213 spill10=0.00% pool10=0.00ms b30=2816 spill30=21.70% pool30=5.18ms t30=29.80ms S=1048576 store=5183.9MB cap=1103 b10=190 spill10=0.00% pool10=0.00ms b30=1528 spill30=27.79% pool30=7.00ms t30=29.99ms 2M 的 10 毫秒批 145，池上读 0.00 ms。4×10^6 的 10 毫秒批 72，30 毫秒批 429。0.33×10^6 的 10 毫秒批 216，30 毫秒批 4096。单条 1M、98% 命中的 TTFT 是 1.8983 秒。冷的 1M 单条是 57.689 秒。第 3 页 Prefill：4K 45674，8K 22676，32K 5456，128K 1184，256K 498，512K 192，1M 64。P:D 按 4K 进、512 出、98% 命中：Prefill 4567.4 请求/秒，10 毫秒 Decode 43.4 请求/秒（1:105.34），30 毫秒 Decode 516.7 请求/秒（1:8.84）。副本数按这个吞吐比配置，单副本时延不变。</a:t>
+              <a:t>BS 一律是 128 卡副本的全局批。每卡条数 = 全局批 / 128。存量 = S×4939.5 字节 + 4.50 MB。一步真正读的是压缩 indexer、最多 1024 条完整 KV 和 HCA，所以溢出比例高时，池上的读时延仍可能短于 allreduce。HBM余量 5.72 TB。溢出KV经每卡H2D进入GPU，有效 51.2 GB/s，DDR池容量不设上限。换入带宽=min(DDR池480×80%, H2D 64×80%, 每卡DDR有效128.9)=51.2 GB/s。专家通信仍走独立D2D 320 GB/s。Decode Attention = SWAP + max(HBM, compute) + AR；再加完整 MoE。S=4096 store=24.7MB cap=231300 b10=222 spill10=0.00% pool10=0.00ms b30=7936 spill30=0.00% pool30=0.00ms t30=29.94ms S=8192 store=45.0MB cap=127218 b10=222 spill10=0.00% pool10=0.00ms b30=7808 spill30=0.00% pool30=0.00ms t30=30.00ms S=32768 store=166.4MB cap=34384 b10=222 spill10=0.00% pool10=0.00ms b30=7424 spill30=0.00% pool30=0.00ms t30=29.96ms S=131072 store=651.9MB cap=8773 b10=220 spill10=0.00% pool10=0.00ms b30=6144 spill30=0.00% pool30=0.00ms t30=29.80ms S=262144 store=1299.4MB cap=4402 b10=218 spill10=0.00% pool10=0.00ms b30=4526 spill30=2.74% pool30=3.49ms t30=29.98ms S=524288 store=2594.2MB cap=2204 b10=213 spill10=0.00% pool10=0.00ms b30=2327 spill30=5.25% pool30=6.49ms t30=29.95ms S=1048576 store=5183.9MB cap=1103 b10=190 spill10=0.00% pool10=0.00ms b30=1186 spill30=6.96% pool30=8.57ms t30=29.91ms 2M 的 10 毫秒批 145，池上读 0.00 ms。4×10^6 的 10 毫秒批 72，30 毫秒批 315。0.33×10^6 的 10 毫秒批 216，30 毫秒批 3644。单条 1M、98% 命中的 TTFT 是 1.8983 秒。冷的 1M 单条是 57.689 秒。第 3 页 Prefill：4K 45674，8K 22676，32K 5456，128K 1184，256K 498，512K 192，1M 64。P:D 按 4K 进、512 出、98% 命中：Prefill 4567.4 请求/秒，10 毫秒 Decode 43.4 请求/秒（1:105.34），30 毫秒 Decode 516.7 请求/秒（1:8.84）。副本数按这个吞吐比配置，单副本时延不变。</a:t>
             </a:r>
           </a:p>
         </p:txBody>
@@ -2251,7 +2251,7 @@
           <a:lstStyle/>
           <a:p>
             <a:r>
-              <a:t>第 7、8 页只统计 decode KV 溢出到 DDR 池的输入长度。全在 HBM 的长度留在第 6 页，不在这里记 0。256K BS=4880 pool=689.1 MB t=2.153 ms ar=1.667 ca=11.360 step=30.000。1M BS=1528 pool=2240.1 MB t=7.000 ms step=29.991。10 毫秒曲线在本档没有溢出长度。</a:t>
+              <a:t>第 7、8 页只统计 decode KV 溢出到 DDR 池的输入长度。全在 HBM 的长度留在第 6 页，不在这里记 0。256K BS=4526 pool=178.7 MB t=3.490 ms ar=1.547 ca=10.224 step=29.983。1M BS=1186 pool=438.6 MB t=8.567 ms step=29.914。10 毫秒曲线在本档没有溢出长度。</a:t>
             </a:r>
           </a:p>
         </p:txBody>
@@ -2321,7 +2321,7 @@
           <a:lstStyle/>
           <a:p>
             <a:r>
-              <a:t>池上字节 = spill × bs × n_csa_read(S) / 128。带宽 320 GB/s。n_csa_read = 30×(S/4)×64 + 31×(S/128)×576 + 30×min(1024,S/4)×576 + 61×128×576。256K bs=4880 spill=9.79% pool=689.1MB t=2.153ms step=30.000ms 0.33×10^6 bs=4096 spill=14.31% pool=1035.1MB t=3.235ms step=29.499ms 512K bs=2816 spill=21.70% pool=1656.6MB t=5.177ms step=29.797ms 1M bs=1528 spill=27.79% pool=2240.1MB t=7.000ms step=29.991ms 口径已固化：第 7、8 页不收录换入为 0 的输入长度。</a:t>
+              <a:t>池上字节=spill×bs×n_csa_read(S)/128。换入走H2D，有效51.2 GB/s。n_csa_read = 30×(S/4)×64 + 31×(S/128)×576 + 30×min(1024,S/4)×576 + 61×128×576。256K bs=4526 spill=2.74% pool=178.7MB t=3.490ms step=29.983ms 0.33×10^6 bs=3644 spill=3.68% pool=237.2MB t=4.633ms step=29.979ms 512K bs=2327 spill=5.25% pool=332.3MB t=6.490ms step=29.955ms 1M bs=1186 spill=6.96% pool=438.6MB t=8.567ms step=29.914ms 口径已固化：第 7、8 页不收录换入为 0 的输入长度。</a:t>
             </a:r>
           </a:p>
         </p:txBody>
@@ -8064,7 +8064,7 @@
                 <a:ea typeface="Microsoft YaHei"/>
                 <a:cs typeface="Microsoft YaHei"/>
               </a:rPr>
-              <a:t>本档：96 GB HBM，4 TB/s 取 80% 为 3.20 TB/s。算力 486 T 取 70% 为 340.2 T，注意力和专家共用。H2D 每卡 64 GB/s 取 80% 为 51.2 GB/s，只在 prefill。机内 DDR5 每机 1288.8 GB/s、768 GB。</a:t>
+              <a:t>本档：96 GB HBM，4 TB/s取80%为3.20 TB/s。算力486 T取70%为340.2 T。H2D每卡64 GB/s取80%为51.2 GB/s，用于Prefill主机输入及全部Decode DDR换入。机内DDR5每机1288.8 GB/s、768 GB。</a:t>
             </a:r>
           </a:p>
           <a:p>
@@ -8085,7 +8085,7 @@
                 <a:ea typeface="Microsoft YaHei"/>
                 <a:cs typeface="Microsoft YaHei"/>
               </a:rPr>
-              <a:t>D2D 每卡 3.2 Tb/s = 400 GB/s，取 80% 为 320 GB/s。内存池标称 480 GB/s，被这条 400 GB/s 的口卡住，有效也是 320 GB/s，容量不设上限。8卡fullmesh每条链路400 Gb/s，7链路并发后取80%为280 GB/s；参数面仍为40 GB/s。</a:t>
+              <a:t>D2D每卡3.2 Tb/s取80%为320 GB/s，只承载MoE EP等GPU间通信。DDR池标称480 GB/s，但Decode访存统一经H2D进入GPU，因此换入有效带宽为51.2 GB/s。8卡fullmesh每条链路400 Gb/s，7链路并发后取80%为280 GB/s；参数面仍为40 GB/s。</a:t>
             </a:r>
           </a:p>
         </p:txBody>
@@ -10412,7 +10412,7 @@
                 <a:ea typeface="Microsoft YaHei"/>
                 <a:cs typeface="Microsoft YaHei"/>
               </a:rPr>
-              <a:t>Decode 不用 H2D。DDR 池里的 KV 必须先写回 HBM；标准执行不假设 GEMM 与 AR 融合。</a:t>
+              <a:t>Decode外部DDR/KV访存统一走H2D。KV必须先写回HBM；HBM内读取仍按3.20 TB/s，且不假设GEMM与AR融合。</a:t>
             </a:r>
           </a:p>
         </p:txBody>
@@ -11020,7 +11020,7 @@
                           <a:ea typeface="Microsoft YaHei"/>
                           <a:cs typeface="Microsoft YaHei"/>
                         </a:rPr>
-                        <a:t>f × 每卡 KV 读量 / 320 GB/s</a:t>
+                        <a:t>f × 每卡 KV 读量 / 51.2 GB/s</a:t>
                       </a:r>
                     </a:p>
                   </a:txBody>
@@ -11075,7 +11075,7 @@
                           <a:ea typeface="Microsoft YaHei"/>
                           <a:cs typeface="Microsoft YaHei"/>
                         </a:rPr>
-                        <a:t>DDR 池 → D2D → HBM；必须先完成</a:t>
+                        <a:t>DDR池 → H2D → HBM；必须先完成</a:t>
                       </a:r>
                     </a:p>
                   </a:txBody>
@@ -13586,7 +13586,7 @@
                 <a:ea typeface="Microsoft YaHei"/>
                 <a:cs typeface="Microsoft YaHei"/>
               </a:rPr>
-              <a:t>BS 4880    权重 45.31 GB    预留 6 GB</a:t>
+              <a:t>BS 4526    权重 45.31 GB    预留 6 GB</a:t>
             </a:r>
           </a:p>
           <a:p>
@@ -13649,7 +13649,7 @@
                 <a:ea typeface="Microsoft YaHei"/>
                 <a:cs typeface="Microsoft YaHei"/>
               </a:rPr>
-              <a:t>DDR 池 KV（图外）：4.85 GB / 卡</a:t>
+              <a:t>DDR 池 KV（图外）：1.28 GB / 卡</a:t>
             </a:r>
           </a:p>
         </p:txBody>
@@ -13751,7 +13751,7 @@
                 <a:ea typeface="Microsoft YaHei"/>
                 <a:cs typeface="Microsoft YaHei"/>
               </a:rPr>
-              <a:t>BS 1528    权重 45.31 GB    预留 6 GB</a:t>
+              <a:t>BS 1186    权重 45.31 GB    预留 6 GB</a:t>
             </a:r>
           </a:p>
           <a:p>
@@ -13814,7 +13814,7 @@
                 <a:ea typeface="Microsoft YaHei"/>
                 <a:cs typeface="Microsoft YaHei"/>
               </a:rPr>
-              <a:t>DDR 池 KV（图外）：17.52 GB / 卡</a:t>
+              <a:t>DDR 池 KV（图外）：3.91 GB / 卡</a:t>
             </a:r>
           </a:p>
         </p:txBody>
@@ -13899,7 +13899,7 @@
                 <a:ea typeface="Microsoft YaHei"/>
                 <a:cs typeface="Microsoft YaHei"/>
               </a:rPr>
-              <a:t>30 毫秒：256K / 1M 的最忙卡各有 4.85 / 17.52 GB KV 在 DDR 池。10 毫秒批更小，4K / 512K / 1M 的 HBM KV 仅 0.04 / 4.54 / 7.78 GB，均不进池。</a:t>
+              <a:t>30 毫秒：256K / 1M 的最忙卡各有 1.28 / 3.91 GB KV 在 DDR 池。10 毫秒批更小，4K / 512K / 1M 的 HBM KV 仅 0.04 / 4.54 / 7.78 GB，均不进池。</a:t>
             </a:r>
           </a:p>
         </p:txBody>
@@ -30763,7 +30763,7 @@
                           <a:ea typeface="Microsoft YaHei"/>
                           <a:cs typeface="Microsoft YaHei"/>
                         </a:rPr>
-                        <a:t>放不下走每卡内存池 320 GB/s</a:t>
+                        <a:t>DDR换入走H2D 51.2 GB/s</a:t>
                       </a:r>
                     </a:p>
                   </a:txBody>
@@ -32483,7 +32483,7 @@
                 <a:ea typeface="Microsoft YaHei"/>
                 <a:cs typeface="Microsoft YaHei"/>
               </a:rPr>
-              <a:t>4880</a:t>
+              <a:t>4526</a:t>
             </a:r>
           </a:p>
         </p:txBody>
@@ -32525,7 +32525,7 @@
                 <a:ea typeface="Microsoft YaHei"/>
                 <a:cs typeface="Microsoft YaHei"/>
               </a:rPr>
-              <a:t>全局批，每卡 38.1 条</a:t>
+              <a:t>全局批，每卡 35.4 条</a:t>
             </a:r>
           </a:p>
           <a:p>
@@ -32546,7 +32546,7 @@
                 <a:ea typeface="Microsoft YaHei"/>
                 <a:cs typeface="Microsoft YaHei"/>
               </a:rPr>
-              <a:t>9.8% 在总线内存池</a:t>
+              <a:t>2.7% 在 DDR 池（H2D）</a:t>
             </a:r>
           </a:p>
         </p:txBody>
@@ -32675,7 +32675,7 @@
                 <a:ea typeface="Microsoft YaHei"/>
                 <a:cs typeface="Microsoft YaHei"/>
               </a:rPr>
-              <a:t>2816</a:t>
+              <a:t>2327</a:t>
             </a:r>
           </a:p>
         </p:txBody>
@@ -32717,7 +32717,7 @@
                 <a:ea typeface="Microsoft YaHei"/>
                 <a:cs typeface="Microsoft YaHei"/>
               </a:rPr>
-              <a:t>全局批，每卡 22.0 条</a:t>
+              <a:t>全局批，每卡 18.2 条</a:t>
             </a:r>
           </a:p>
           <a:p>
@@ -32738,7 +32738,7 @@
                 <a:ea typeface="Microsoft YaHei"/>
                 <a:cs typeface="Microsoft YaHei"/>
               </a:rPr>
-              <a:t>21.7% 在总线内存池</a:t>
+              <a:t>5.2% 在 DDR 池（H2D）</a:t>
             </a:r>
           </a:p>
         </p:txBody>
@@ -32867,7 +32867,7 @@
                 <a:ea typeface="Microsoft YaHei"/>
                 <a:cs typeface="Microsoft YaHei"/>
               </a:rPr>
-              <a:t>4096</a:t>
+              <a:t>3644</a:t>
             </a:r>
           </a:p>
         </p:txBody>
@@ -32909,7 +32909,7 @@
                 <a:ea typeface="Microsoft YaHei"/>
                 <a:cs typeface="Microsoft YaHei"/>
               </a:rPr>
-              <a:t>全局批，每卡 32.0 条</a:t>
+              <a:t>全局批，每卡 28.5 条</a:t>
             </a:r>
           </a:p>
           <a:p>
@@ -32930,7 +32930,7 @@
                 <a:ea typeface="Microsoft YaHei"/>
                 <a:cs typeface="Microsoft YaHei"/>
               </a:rPr>
-              <a:t>14.3% 在总线内存池</a:t>
+              <a:t>3.7% 在 DDR 池（H2D）</a:t>
             </a:r>
           </a:p>
         </p:txBody>
@@ -33287,7 +33287,7 @@
                 <a:ea typeface="Microsoft YaHei"/>
                 <a:cs typeface="Microsoft YaHei"/>
               </a:rPr>
-              <a:t>全局批是 128 卡上的条数。放不下的 KV 进每卡总线内存池。池标称 480 GB/s，被 3.2 Tb/s 卡住，有效 320 GB/s。</a:t>
+              <a:t>全局批是128卡上的条数。放不下的Decode KV进入DDR池，并统一经每卡H2D以51.2 GB/s换回HBM。</a:t>
             </a:r>
           </a:p>
         </p:txBody>
@@ -35829,7 +35829,7 @@
                           <a:ea typeface="Microsoft YaHei"/>
                           <a:cs typeface="Microsoft YaHei"/>
                         </a:rPr>
-                        <a:t>4880</a:t>
+                        <a:t>4526</a:t>
                       </a:r>
                     </a:p>
                   </a:txBody>
@@ -35884,7 +35884,7 @@
                           <a:ea typeface="Microsoft YaHei"/>
                           <a:cs typeface="Microsoft YaHei"/>
                         </a:rPr>
-                        <a:t>38.1</a:t>
+                        <a:t>35.4</a:t>
                       </a:r>
                     </a:p>
                   </a:txBody>
@@ -35939,7 +35939,7 @@
                           <a:ea typeface="Microsoft YaHei"/>
                           <a:cs typeface="Microsoft YaHei"/>
                         </a:rPr>
-                        <a:t>9.8% 在总线内存池</a:t>
+                        <a:t>2.7% 在 DDR 池（H2D）</a:t>
                       </a:r>
                     </a:p>
                   </a:txBody>
@@ -36271,7 +36271,7 @@
                           <a:ea typeface="Microsoft YaHei"/>
                           <a:cs typeface="Microsoft YaHei"/>
                         </a:rPr>
-                        <a:t>2816</a:t>
+                        <a:t>2327</a:t>
                       </a:r>
                     </a:p>
                   </a:txBody>
@@ -36326,7 +36326,7 @@
                           <a:ea typeface="Microsoft YaHei"/>
                           <a:cs typeface="Microsoft YaHei"/>
                         </a:rPr>
-                        <a:t>22.0</a:t>
+                        <a:t>18.2</a:t>
                       </a:r>
                     </a:p>
                   </a:txBody>
@@ -36381,7 +36381,7 @@
                           <a:ea typeface="Microsoft YaHei"/>
                           <a:cs typeface="Microsoft YaHei"/>
                         </a:rPr>
-                        <a:t>21.7% 在总线内存池</a:t>
+                        <a:t>5.2% 在 DDR 池（H2D）</a:t>
                       </a:r>
                     </a:p>
                   </a:txBody>
@@ -36713,7 +36713,7 @@
                           <a:ea typeface="Microsoft YaHei"/>
                           <a:cs typeface="Microsoft YaHei"/>
                         </a:rPr>
-                        <a:t>1528</a:t>
+                        <a:t>1186</a:t>
                       </a:r>
                     </a:p>
                   </a:txBody>
@@ -36768,7 +36768,7 @@
                           <a:ea typeface="Microsoft YaHei"/>
                           <a:cs typeface="Microsoft YaHei"/>
                         </a:rPr>
-                        <a:t>11.9</a:t>
+                        <a:t>9.3</a:t>
                       </a:r>
                     </a:p>
                   </a:txBody>
@@ -36823,7 +36823,7 @@
                           <a:ea typeface="Microsoft YaHei"/>
                           <a:cs typeface="Microsoft YaHei"/>
                         </a:rPr>
-                        <a:t>27.8% 在总线内存池</a:t>
+                        <a:t>7.0% 在 DDR 池（H2D）</a:t>
                       </a:r>
                     </a:p>
                   </a:txBody>
@@ -36959,7 +36959,7 @@
                 <a:ea typeface="Microsoft YaHei"/>
                 <a:cs typeface="Microsoft YaHei"/>
               </a:rPr>
-              <a:t>30 毫秒短输入为 7936。256K 为 4880，已有 9.8% KV 在池中；Attention 15.2 毫秒，MoE 14.8 毫秒。512K 降到 2816，1M 为 1528，0.33×10^6 为 4096。</a:t>
+              <a:t>30 毫秒短输入为 7936。256K 为 4526，已有 2.7% KV 在池中；Attention 15.3 毫秒，MoE 14.7 毫秒。512K 降到 2327，1M 为 1186，0.33×10^6 为 3644。</a:t>
             </a:r>
           </a:p>
           <a:p>
@@ -37125,7 +37125,7 @@
                 <a:ea typeface="Microsoft YaHei"/>
                 <a:cs typeface="Microsoft YaHei"/>
               </a:rPr>
-              <a:t>256K 每卡换入 689.1 MB，1M 换入 2.24 GB</a:t>
+              <a:t>256K 每卡换入 178.7 MB，1M 换入 438.6 MB</a:t>
             </a:r>
           </a:p>
         </p:txBody>
@@ -37444,7 +37444,7 @@
                           <a:ea typeface="Microsoft YaHei"/>
                           <a:cs typeface="Microsoft YaHei"/>
                         </a:rPr>
-                        <a:t>256K · 批 4880 · 溢出 9.8%</a:t>
+                        <a:t>256K · 批 4526 · 溢出 2.7%</a:t>
                       </a:r>
                     </a:p>
                   </a:txBody>
@@ -37499,7 +37499,7 @@
                           <a:ea typeface="Microsoft YaHei"/>
                           <a:cs typeface="Microsoft YaHei"/>
                         </a:rPr>
-                        <a:t>1M · 批 1528 · 溢出 27.8%</a:t>
+                        <a:t>1M · 批 1186 · 溢出 7.0%</a:t>
                       </a:r>
                     </a:p>
                   </a:txBody>
@@ -37778,7 +37778,7 @@
                           <a:ea typeface="Microsoft YaHei"/>
                           <a:cs typeface="Microsoft YaHei"/>
                         </a:rPr>
-                        <a:t>466.8 MB · 1.67 毫秒</a:t>
+                        <a:t>433.1 MB · 1.55 毫秒</a:t>
                       </a:r>
                     </a:p>
                   </a:txBody>
@@ -37833,7 +37833,7 @@
                           <a:ea typeface="Microsoft YaHei"/>
                           <a:cs typeface="Microsoft YaHei"/>
                         </a:rPr>
-                        <a:t>146.9 MB · 0.52 毫秒</a:t>
+                        <a:t>114.8 MB · 0.41 毫秒</a:t>
                       </a:r>
                     </a:p>
                   </a:txBody>
@@ -37945,7 +37945,7 @@
                           <a:ea typeface="Microsoft YaHei"/>
                           <a:cs typeface="Microsoft YaHei"/>
                         </a:rPr>
-                        <a:t>效率 84% · 8.45 毫秒</a:t>
+                        <a:t>效率 78% · 8.45 毫秒</a:t>
                       </a:r>
                     </a:p>
                   </a:txBody>
@@ -38000,7 +38000,7 @@
                           <a:ea typeface="Microsoft YaHei"/>
                           <a:cs typeface="Microsoft YaHei"/>
                         </a:rPr>
-                        <a:t>效率 29% · 7.69 毫秒</a:t>
+                        <a:t>效率 23% · 7.69 毫秒</a:t>
                       </a:r>
                     </a:p>
                   </a:txBody>
@@ -38112,7 +38112,7 @@
                           <a:ea typeface="Microsoft YaHei"/>
                           <a:cs typeface="Microsoft YaHei"/>
                         </a:rPr>
-                        <a:t>452.8 MB · 1.41 毫秒</a:t>
+                        <a:t>421.8 MB · 1.32 毫秒</a:t>
                       </a:r>
                     </a:p>
                   </a:txBody>
@@ -38167,7 +38167,7 @@
                           <a:ea typeface="Microsoft YaHei"/>
                           <a:cs typeface="Microsoft YaHei"/>
                         </a:rPr>
-                        <a:t>154.8 MB · 0.48 毫秒</a:t>
+                        <a:t>123.2 MB · 0.39 毫秒</a:t>
                       </a:r>
                     </a:p>
                   </a:txBody>
@@ -38279,7 +38279,7 @@
                           <a:ea typeface="Microsoft YaHei"/>
                           <a:cs typeface="Microsoft YaHei"/>
                         </a:rPr>
-                        <a:t>11.36 毫秒</a:t>
+                        <a:t>10.22 毫秒</a:t>
                       </a:r>
                     </a:p>
                   </a:txBody>
@@ -38334,7 +38334,7 @@
                           <a:ea typeface="Microsoft YaHei"/>
                           <a:cs typeface="Microsoft YaHei"/>
                         </a:rPr>
-                        <a:t>8.58 毫秒</a:t>
+                        <a:t>7.15 毫秒</a:t>
                       </a:r>
                     </a:p>
                   </a:txBody>
@@ -38613,7 +38613,7 @@
                           <a:ea typeface="Microsoft YaHei"/>
                           <a:cs typeface="Microsoft YaHei"/>
                         </a:rPr>
-                        <a:t>9.46 GB · 2.96 毫秒</a:t>
+                        <a:t>8.95 GB · 2.80 毫秒</a:t>
                       </a:r>
                     </a:p>
                   </a:txBody>
@@ -38668,7 +38668,7 @@
                           <a:ea typeface="Microsoft YaHei"/>
                           <a:cs typeface="Microsoft YaHei"/>
                         </a:rPr>
-                        <a:t>10.48 GB · 3.28 毫秒</a:t>
+                        <a:t>8.72 GB · 2.72 毫秒</a:t>
                       </a:r>
                     </a:p>
                   </a:txBody>
@@ -38780,7 +38780,7 @@
                           <a:ea typeface="Microsoft YaHei"/>
                           <a:cs typeface="Microsoft YaHei"/>
                         </a:rPr>
-                        <a:t>689.1 MB · 2.15 毫秒</a:t>
+                        <a:t>178.7 MB · 3.49 毫秒</a:t>
                       </a:r>
                     </a:p>
                   </a:txBody>
@@ -38835,7 +38835,7 @@
                           <a:ea typeface="Microsoft YaHei"/>
                           <a:cs typeface="Microsoft YaHei"/>
                         </a:rPr>
-                        <a:t>2.24 GB · 7.00 毫秒</a:t>
+                        <a:t>438.6 MB · 8.57 毫秒</a:t>
                       </a:r>
                     </a:p>
                   </a:txBody>
@@ -38947,7 +38947,7 @@
                           <a:ea typeface="Microsoft YaHei"/>
                           <a:cs typeface="Microsoft YaHei"/>
                         </a:rPr>
-                        <a:t>换入 + 注意力计算 + AR + 读专家 · 30.00 毫秒</a:t>
+                        <a:t>换入 + 注意力计算 + AR + 读专家 · 29.98 毫秒</a:t>
                       </a:r>
                     </a:p>
                   </a:txBody>
@@ -39002,7 +39002,7 @@
                           <a:ea typeface="Microsoft YaHei"/>
                           <a:cs typeface="Microsoft YaHei"/>
                         </a:rPr>
-                        <a:t>换入 + 注意力计算 + AR + 读专家 · 29.99 毫秒</a:t>
+                        <a:t>换入 + 注意力计算 + AR + 读专家 · 29.91 毫秒</a:t>
                       </a:r>
                     </a:p>
                   </a:txBody>
@@ -39117,7 +39117,7 @@
                 <a:ea typeface="Microsoft YaHei"/>
                 <a:cs typeface="Microsoft YaHei"/>
               </a:rPr>
-              <a:t>字节按每卡。256K 溢出 9.8%，换入 689.1 MB / 320 GB/s = 2.15 毫秒，然后从 HBM 再读全部 KV；Attention 15.18 毫秒，MoE 14.82 毫秒。128 卡换入合计 88.21 GB。</a:t>
+              <a:t>字节按每卡。256K 溢出 2.7%，换入 178.7 MB / 51.2 GB/s H2D = 3.49 毫秒，然后从 HBM 再读全部 KV；Attention 15.26 毫秒，MoE 14.72 毫秒。128 卡换入合计 22.87 GB。</a:t>
             </a:r>
           </a:p>
           <a:p>
@@ -39138,7 +39138,7 @@
                 <a:ea typeface="Microsoft YaHei"/>
                 <a:cs typeface="Microsoft YaHei"/>
               </a:rPr>
-              <a:t>1M 换入 2.24 GB、7.00 毫秒；Attention 16.10 毫秒，MoE 13.89 毫秒，批 1528。128 卡换入合计 286.73 GB。</a:t>
+              <a:t>1M 换入 438.6 MB、8.57 毫秒；Attention 16.12 毫秒，MoE 13.79 毫秒，批 1186。128 卡换入合计 56.14 GB。</a:t>
             </a:r>
           </a:p>
           <a:p>
@@ -39304,7 +39304,7 @@
                 <a:ea typeface="Microsoft YaHei"/>
                 <a:cs typeface="Microsoft YaHei"/>
               </a:rPr>
-              <a:t>进池的长度从 256K 起，批从 4880 降到 1528</a:t>
+              <a:t>进池的长度从 256K 起，批从 4526 降到 1186</a:t>
             </a:r>
           </a:p>
         </p:txBody>
@@ -39516,7 +39516,7 @@
                 <a:ea typeface="Microsoft YaHei"/>
                 <a:cs typeface="Microsoft YaHei"/>
               </a:rPr>
-              <a:t>只统计 KV 换进 DDR 池的输入。换入量 = 溢出比例 × 这一步的稀疏读，每卡带宽 320 GB/s。</a:t>
+              <a:t>只统计KV换进DDR池的输入。换入量=溢出比例×这一步的稀疏读；每卡统一走H2D，有效51.2 GB/s。</a:t>
             </a:r>
           </a:p>
         </p:txBody>
@@ -40070,7 +40070,7 @@
                           <a:ea typeface="Microsoft YaHei"/>
                           <a:cs typeface="Microsoft YaHei"/>
                         </a:rPr>
-                        <a:t>4880</a:t>
+                        <a:t>4526</a:t>
                       </a:r>
                     </a:p>
                   </a:txBody>
@@ -40125,7 +40125,7 @@
                           <a:ea typeface="Microsoft YaHei"/>
                           <a:cs typeface="Microsoft YaHei"/>
                         </a:rPr>
-                        <a:t>38.1</a:t>
+                        <a:t>35.4</a:t>
                       </a:r>
                     </a:p>
                   </a:txBody>
@@ -40180,7 +40180,7 @@
                           <a:ea typeface="Microsoft YaHei"/>
                           <a:cs typeface="Microsoft YaHei"/>
                         </a:rPr>
-                        <a:t>9.8%</a:t>
+                        <a:t>2.7%</a:t>
                       </a:r>
                     </a:p>
                   </a:txBody>
@@ -40235,7 +40235,7 @@
                           <a:ea typeface="Microsoft YaHei"/>
                           <a:cs typeface="Microsoft YaHei"/>
                         </a:rPr>
-                        <a:t>689.1 MB</a:t>
+                        <a:t>178.7 MB</a:t>
                       </a:r>
                     </a:p>
                   </a:txBody>
@@ -40290,7 +40290,7 @@
                           <a:ea typeface="Microsoft YaHei"/>
                           <a:cs typeface="Microsoft YaHei"/>
                         </a:rPr>
-                        <a:t>88.21 GB</a:t>
+                        <a:t>22.87 GB</a:t>
                       </a:r>
                     </a:p>
                   </a:txBody>
@@ -40345,7 +40345,7 @@
                           <a:ea typeface="Microsoft YaHei"/>
                           <a:cs typeface="Microsoft YaHei"/>
                         </a:rPr>
-                        <a:t>2.15 毫秒</a:t>
+                        <a:t>3.49 毫秒</a:t>
                       </a:r>
                     </a:p>
                   </a:txBody>
@@ -40400,7 +40400,7 @@
                           <a:ea typeface="Microsoft YaHei"/>
                           <a:cs typeface="Microsoft YaHei"/>
                         </a:rPr>
-                        <a:t>注意力计算 11.36 毫秒</a:t>
+                        <a:t>注意力计算 10.22 毫秒</a:t>
                       </a:r>
                     </a:p>
                   </a:txBody>
@@ -40512,7 +40512,7 @@
                           <a:ea typeface="Microsoft YaHei"/>
                           <a:cs typeface="Microsoft YaHei"/>
                         </a:rPr>
-                        <a:t>4096</a:t>
+                        <a:t>3644</a:t>
                       </a:r>
                     </a:p>
                   </a:txBody>
@@ -40567,7 +40567,7 @@
                           <a:ea typeface="Microsoft YaHei"/>
                           <a:cs typeface="Microsoft YaHei"/>
                         </a:rPr>
-                        <a:t>32.0</a:t>
+                        <a:t>28.5</a:t>
                       </a:r>
                     </a:p>
                   </a:txBody>
@@ -40622,7 +40622,7 @@
                           <a:ea typeface="Microsoft YaHei"/>
                           <a:cs typeface="Microsoft YaHei"/>
                         </a:rPr>
-                        <a:t>14.3%</a:t>
+                        <a:t>3.7%</a:t>
                       </a:r>
                     </a:p>
                   </a:txBody>
@@ -40677,7 +40677,7 @@
                           <a:ea typeface="Microsoft YaHei"/>
                           <a:cs typeface="Microsoft YaHei"/>
                         </a:rPr>
-                        <a:t>1.04 GB</a:t>
+                        <a:t>237.2 MB</a:t>
                       </a:r>
                     </a:p>
                   </a:txBody>
@@ -40732,7 +40732,7 @@
                           <a:ea typeface="Microsoft YaHei"/>
                           <a:cs typeface="Microsoft YaHei"/>
                         </a:rPr>
-                        <a:t>132.49 GB</a:t>
+                        <a:t>30.37 GB</a:t>
                       </a:r>
                     </a:p>
                   </a:txBody>
@@ -40787,7 +40787,7 @@
                           <a:ea typeface="Microsoft YaHei"/>
                           <a:cs typeface="Microsoft YaHei"/>
                         </a:rPr>
-                        <a:t>3.23 毫秒</a:t>
+                        <a:t>4.63 毫秒</a:t>
                       </a:r>
                     </a:p>
                   </a:txBody>
@@ -40842,7 +40842,7 @@
                           <a:ea typeface="Microsoft YaHei"/>
                           <a:cs typeface="Microsoft YaHei"/>
                         </a:rPr>
-                        <a:t>注意力计算 10.26 毫秒</a:t>
+                        <a:t>注意力计算 9.62 毫秒</a:t>
                       </a:r>
                     </a:p>
                   </a:txBody>
@@ -40954,7 +40954,7 @@
                           <a:ea typeface="Microsoft YaHei"/>
                           <a:cs typeface="Microsoft YaHei"/>
                         </a:rPr>
-                        <a:t>2816</a:t>
+                        <a:t>2327</a:t>
                       </a:r>
                     </a:p>
                   </a:txBody>
@@ -41009,7 +41009,7 @@
                           <a:ea typeface="Microsoft YaHei"/>
                           <a:cs typeface="Microsoft YaHei"/>
                         </a:rPr>
-                        <a:t>22.0</a:t>
+                        <a:t>18.2</a:t>
                       </a:r>
                     </a:p>
                   </a:txBody>
@@ -41064,7 +41064,7 @@
                           <a:ea typeface="Microsoft YaHei"/>
                           <a:cs typeface="Microsoft YaHei"/>
                         </a:rPr>
-                        <a:t>21.7%</a:t>
+                        <a:t>5.2%</a:t>
                       </a:r>
                     </a:p>
                   </a:txBody>
@@ -41119,7 +41119,7 @@
                           <a:ea typeface="Microsoft YaHei"/>
                           <a:cs typeface="Microsoft YaHei"/>
                         </a:rPr>
-                        <a:t>1.66 GB</a:t>
+                        <a:t>332.3 MB</a:t>
                       </a:r>
                     </a:p>
                   </a:txBody>
@@ -41174,7 +41174,7 @@
                           <a:ea typeface="Microsoft YaHei"/>
                           <a:cs typeface="Microsoft YaHei"/>
                         </a:rPr>
-                        <a:t>212.05 GB</a:t>
+                        <a:t>42.53 GB</a:t>
                       </a:r>
                     </a:p>
                   </a:txBody>
@@ -41229,7 +41229,7 @@
                           <a:ea typeface="Microsoft YaHei"/>
                           <a:cs typeface="Microsoft YaHei"/>
                         </a:rPr>
-                        <a:t>5.18 毫秒</a:t>
+                        <a:t>6.49 毫秒</a:t>
                       </a:r>
                     </a:p>
                   </a:txBody>
@@ -41284,7 +41284,7 @@
                           <a:ea typeface="Microsoft YaHei"/>
                           <a:cs typeface="Microsoft YaHei"/>
                         </a:rPr>
-                        <a:t>注意力计算 9.41 毫秒</a:t>
+                        <a:t>注意力计算 8.55 毫秒</a:t>
                       </a:r>
                     </a:p>
                   </a:txBody>
@@ -41396,7 +41396,7 @@
                           <a:ea typeface="Microsoft YaHei"/>
                           <a:cs typeface="Microsoft YaHei"/>
                         </a:rPr>
-                        <a:t>1528</a:t>
+                        <a:t>1186</a:t>
                       </a:r>
                     </a:p>
                   </a:txBody>
@@ -41451,7 +41451,7 @@
                           <a:ea typeface="Microsoft YaHei"/>
                           <a:cs typeface="Microsoft YaHei"/>
                         </a:rPr>
-                        <a:t>11.9</a:t>
+                        <a:t>9.3</a:t>
                       </a:r>
                     </a:p>
                   </a:txBody>
@@ -41506,7 +41506,7 @@
                           <a:ea typeface="Microsoft YaHei"/>
                           <a:cs typeface="Microsoft YaHei"/>
                         </a:rPr>
-                        <a:t>27.8%</a:t>
+                        <a:t>7.0%</a:t>
                       </a:r>
                     </a:p>
                   </a:txBody>
@@ -41561,7 +41561,7 @@
                           <a:ea typeface="Microsoft YaHei"/>
                           <a:cs typeface="Microsoft YaHei"/>
                         </a:rPr>
-                        <a:t>2.24 GB</a:t>
+                        <a:t>438.6 MB</a:t>
                       </a:r>
                     </a:p>
                   </a:txBody>
@@ -41616,7 +41616,7 @@
                           <a:ea typeface="Microsoft YaHei"/>
                           <a:cs typeface="Microsoft YaHei"/>
                         </a:rPr>
-                        <a:t>286.73 GB</a:t>
+                        <a:t>56.14 GB</a:t>
                       </a:r>
                     </a:p>
                   </a:txBody>
@@ -41671,7 +41671,7 @@
                           <a:ea typeface="Microsoft YaHei"/>
                           <a:cs typeface="Microsoft YaHei"/>
                         </a:rPr>
-                        <a:t>7.00 毫秒</a:t>
+                        <a:t>8.57 毫秒</a:t>
                       </a:r>
                     </a:p>
                   </a:txBody>
@@ -41726,7 +41726,7 @@
                           <a:ea typeface="Microsoft YaHei"/>
                           <a:cs typeface="Microsoft YaHei"/>
                         </a:rPr>
-                        <a:t>注意力计算 8.58 毫秒</a:t>
+                        <a:t>注意力计算 7.15 毫秒</a:t>
                       </a:r>
                     </a:p>
                   </a:txBody>
@@ -42296,7 +42296,7 @@
                           <a:ea typeface="Microsoft YaHei"/>
                           <a:cs typeface="Microsoft YaHei"/>
                         </a:rPr>
-                        <a:t>2.15 毫秒</a:t>
+                        <a:t>3.49 毫秒</a:t>
                       </a:r>
                     </a:p>
                   </a:txBody>
@@ -42351,7 +42351,7 @@
                           <a:ea typeface="Microsoft YaHei"/>
                           <a:cs typeface="Microsoft YaHei"/>
                         </a:rPr>
-                        <a:t>1.67 毫秒</a:t>
+                        <a:t>1.55 毫秒</a:t>
                       </a:r>
                     </a:p>
                   </a:txBody>
@@ -42406,7 +42406,7 @@
                           <a:ea typeface="Microsoft YaHei"/>
                           <a:cs typeface="Microsoft YaHei"/>
                         </a:rPr>
-                        <a:t>11.36 毫秒</a:t>
+                        <a:t>10.22 毫秒</a:t>
                       </a:r>
                     </a:p>
                   </a:txBody>
@@ -42461,7 +42461,7 @@
                           <a:ea typeface="Microsoft YaHei"/>
                           <a:cs typeface="Microsoft YaHei"/>
                         </a:rPr>
-                        <a:t>2.96 毫秒</a:t>
+                        <a:t>2.80 毫秒</a:t>
                       </a:r>
                     </a:p>
                   </a:txBody>
@@ -42571,7 +42571,7 @@
                           <a:ea typeface="Microsoft YaHei"/>
                           <a:cs typeface="Microsoft YaHei"/>
                         </a:rPr>
-                        <a:t>30.00 毫秒</a:t>
+                        <a:t>29.98 毫秒</a:t>
                       </a:r>
                     </a:p>
                   </a:txBody>
@@ -42683,7 +42683,7 @@
                           <a:ea typeface="Microsoft YaHei"/>
                           <a:cs typeface="Microsoft YaHei"/>
                         </a:rPr>
-                        <a:t>3.23 毫秒</a:t>
+                        <a:t>4.63 毫秒</a:t>
                       </a:r>
                     </a:p>
                   </a:txBody>
@@ -42738,7 +42738,7 @@
                           <a:ea typeface="Microsoft YaHei"/>
                           <a:cs typeface="Microsoft YaHei"/>
                         </a:rPr>
-                        <a:t>1.40 毫秒</a:t>
+                        <a:t>1.25 毫秒</a:t>
                       </a:r>
                     </a:p>
                   </a:txBody>
@@ -42793,7 +42793,7 @@
                           <a:ea typeface="Microsoft YaHei"/>
                           <a:cs typeface="Microsoft YaHei"/>
                         </a:rPr>
-                        <a:t>10.26 毫秒</a:t>
+                        <a:t>9.62 毫秒</a:t>
                       </a:r>
                     </a:p>
                   </a:txBody>
@@ -42848,7 +42848,7 @@
                           <a:ea typeface="Microsoft YaHei"/>
                           <a:cs typeface="Microsoft YaHei"/>
                         </a:rPr>
-                        <a:t>3.02 毫秒</a:t>
+                        <a:t>2.77 毫秒</a:t>
                       </a:r>
                     </a:p>
                   </a:txBody>
@@ -42958,7 +42958,7 @@
                           <a:ea typeface="Microsoft YaHei"/>
                           <a:cs typeface="Microsoft YaHei"/>
                         </a:rPr>
-                        <a:t>29.50 毫秒</a:t>
+                        <a:t>29.98 毫秒</a:t>
                       </a:r>
                     </a:p>
                   </a:txBody>
@@ -43070,7 +43070,7 @@
                           <a:ea typeface="Microsoft YaHei"/>
                           <a:cs typeface="Microsoft YaHei"/>
                         </a:rPr>
-                        <a:t>5.18 毫秒</a:t>
+                        <a:t>6.49 毫秒</a:t>
                       </a:r>
                     </a:p>
                   </a:txBody>
@@ -43125,7 +43125,7 @@
                           <a:ea typeface="Microsoft YaHei"/>
                           <a:cs typeface="Microsoft YaHei"/>
                         </a:rPr>
-                        <a:t>0.96 毫秒</a:t>
+                        <a:t>0.80 毫秒</a:t>
                       </a:r>
                     </a:p>
                   </a:txBody>
@@ -43180,7 +43180,7 @@
                           <a:ea typeface="Microsoft YaHei"/>
                           <a:cs typeface="Microsoft YaHei"/>
                         </a:rPr>
-                        <a:t>9.41 毫秒</a:t>
+                        <a:t>8.55 毫秒</a:t>
                       </a:r>
                     </a:p>
                   </a:txBody>
@@ -43235,7 +43235,7 @@
                           <a:ea typeface="Microsoft YaHei"/>
                           <a:cs typeface="Microsoft YaHei"/>
                         </a:rPr>
-                        <a:t>3.14 毫秒</a:t>
+                        <a:t>2.73 毫秒</a:t>
                       </a:r>
                     </a:p>
                   </a:txBody>
@@ -43345,7 +43345,7 @@
                           <a:ea typeface="Microsoft YaHei"/>
                           <a:cs typeface="Microsoft YaHei"/>
                         </a:rPr>
-                        <a:t>29.80 毫秒</a:t>
+                        <a:t>29.95 毫秒</a:t>
                       </a:r>
                     </a:p>
                   </a:txBody>
@@ -43457,7 +43457,7 @@
                           <a:ea typeface="Microsoft YaHei"/>
                           <a:cs typeface="Microsoft YaHei"/>
                         </a:rPr>
-                        <a:t>7.00 毫秒</a:t>
+                        <a:t>8.57 毫秒</a:t>
                       </a:r>
                     </a:p>
                   </a:txBody>
@@ -43512,7 +43512,7 @@
                           <a:ea typeface="Microsoft YaHei"/>
                           <a:cs typeface="Microsoft YaHei"/>
                         </a:rPr>
-                        <a:t>0.52 毫秒</a:t>
+                        <a:t>0.41 毫秒</a:t>
                       </a:r>
                     </a:p>
                   </a:txBody>
@@ -43567,7 +43567,7 @@
                           <a:ea typeface="Microsoft YaHei"/>
                           <a:cs typeface="Microsoft YaHei"/>
                         </a:rPr>
-                        <a:t>8.58 毫秒</a:t>
+                        <a:t>7.15 毫秒</a:t>
                       </a:r>
                     </a:p>
                   </a:txBody>
@@ -43622,7 +43622,7 @@
                           <a:ea typeface="Microsoft YaHei"/>
                           <a:cs typeface="Microsoft YaHei"/>
                         </a:rPr>
-                        <a:t>3.28 毫秒</a:t>
+                        <a:t>2.72 毫秒</a:t>
                       </a:r>
                     </a:p>
                   </a:txBody>
@@ -43732,7 +43732,7 @@
                           <a:ea typeface="Microsoft YaHei"/>
                           <a:cs typeface="Microsoft YaHei"/>
                         </a:rPr>
-                        <a:t>29.99 毫秒</a:t>
+                        <a:t>29.91 毫秒</a:t>
                       </a:r>
                     </a:p>
                   </a:txBody>
@@ -43847,7 +43847,7 @@
                 <a:ea typeface="Microsoft YaHei"/>
                 <a:cs typeface="Microsoft YaHei"/>
               </a:rPr>
-              <a:t>稀疏读不是整段存量：30 层压缩 indexer、31 层 HCA、最多 1024 条完整 latent，再加 4.50 MB。带宽 320 GB/s。</a:t>
+              <a:t>稀疏读不是整段存量：30层压缩indexer、31层HCA、最多1024条完整latent，再加4.50 MB。H2D带宽51.2 GB/s。</a:t>
             </a:r>
           </a:p>
           <a:p>

</xml_diff>